<commit_message>
feat: slide 3 giới thiệu, slide 4 kiến trúc hệ thống
</commit_message>
<xml_diff>
--- a/ThuyetTrinh_PathFinderAI.pptx
+++ b/ThuyetTrinh_PathFinderAI.pptx
@@ -7,9 +7,11 @@
   <p:sldIdLst>
     <p:sldId id="256" r:id="rId2"/>
     <p:sldId id="257" r:id="rId3"/>
+    <p:sldId id="258" r:id="rId4"/>
+    <p:sldId id="259" r:id="rId5"/>
   </p:sldIdLst>
   <p:notesMasterIdLst>
-    <p:notesMasterId r:id="rId4"/>
+    <p:notesMasterId r:id="rId6"/>
   </p:notesMasterIdLst>
   <p:sldSz cx="12192000" cy="6858000"/>
   <p:notesSz cx="6858000" cy="12192000"/>
@@ -633,6 +635,182 @@
 </p:notes>
 </file>
 
+<file path=ppt/notesSlides/notesSlide3.xml><?xml version="1.0" encoding="utf-8"?>
+<p:notes xmlns:a="http://schemas.openxmlformats.org/drawingml/2006/main" xmlns:r="http://schemas.openxmlformats.org/officeDocument/2006/relationships" xmlns:p="http://schemas.openxmlformats.org/presentationml/2006/main">
+  <p:cSld>
+    <p:spTree>
+      <p:nvGrpSpPr>
+        <p:cNvPr id="1" name=""/>
+        <p:cNvGrpSpPr/>
+        <p:nvPr/>
+      </p:nvGrpSpPr>
+      <p:grpSpPr>
+        <a:xfrm>
+          <a:off x="0" y="0"/>
+          <a:ext cx="0" cy="0"/>
+          <a:chOff x="0" y="0"/>
+          <a:chExt cx="0" cy="0"/>
+        </a:xfrm>
+      </p:grpSpPr>
+      <p:sp>
+        <p:nvSpPr>
+          <p:cNvPr id="2" name="Slide Image Placeholder 1"/>
+          <p:cNvSpPr>
+            <a:spLocks noGrp="1" noRot="1" noChangeAspect="1"/>
+          </p:cNvSpPr>
+          <p:nvPr>
+            <p:ph type="sldImg"/>
+          </p:nvPr>
+        </p:nvSpPr>
+        <p:spPr/>
+      </p:sp>
+      <p:sp>
+        <p:nvSpPr>
+          <p:cNvPr id="3" name="Notes Placeholder 2"/>
+          <p:cNvSpPr>
+            <a:spLocks noGrp="1"/>
+          </p:cNvSpPr>
+          <p:nvPr>
+            <p:ph type="body" idx="1"/>
+          </p:nvPr>
+        </p:nvSpPr>
+        <p:spPr/>
+        <p:txBody>
+          <a:bodyPr/>
+          <a:lstStyle/>
+          <a:p>
+            <a:r>
+              <a:rPr lang="en-US" dirty="0"/>
+              <a:t/>
+            </a:r>
+            <a:endParaRPr lang="en-US" dirty="0"/>
+          </a:p>
+        </p:txBody>
+      </p:sp>
+      <p:sp>
+        <p:nvSpPr>
+          <p:cNvPr id="4" name="Slide Number Placeholder 3"/>
+          <p:cNvSpPr>
+            <a:spLocks noGrp="1"/>
+          </p:cNvSpPr>
+          <p:nvPr>
+            <p:ph type="sldNum" sz="quarter" idx="10"/>
+          </p:nvPr>
+        </p:nvSpPr>
+        <p:spPr/>
+        <p:txBody>
+          <a:bodyPr/>
+          <a:lstStyle/>
+          <a:p>
+            <a:fld id="{F7021451-1387-4CA6-816F-3879F97B5CBC}" type="slidenum">
+              <a:rPr lang="en-US"/>
+              <a:t>3</a:t>
+            </a:fld>
+            <a:endParaRPr lang="en-US"/>
+          </a:p>
+        </p:txBody>
+      </p:sp>
+    </p:spTree>
+    <p:extLst>
+      <p:ext uri="{BB962C8B-B14F-4D97-AF65-F5344CB8AC3E}">
+        <p14:creationId xmlns:p14="http://schemas.microsoft.com/office/powerpoint/2010/main" val="1024086991"/>
+      </p:ext>
+    </p:extLst>
+  </p:cSld>
+  <p:clrMapOvr>
+    <a:masterClrMapping/>
+  </p:clrMapOvr>
+</p:notes>
+</file>
+
+<file path=ppt/notesSlides/notesSlide4.xml><?xml version="1.0" encoding="utf-8"?>
+<p:notes xmlns:a="http://schemas.openxmlformats.org/drawingml/2006/main" xmlns:r="http://schemas.openxmlformats.org/officeDocument/2006/relationships" xmlns:p="http://schemas.openxmlformats.org/presentationml/2006/main">
+  <p:cSld>
+    <p:spTree>
+      <p:nvGrpSpPr>
+        <p:cNvPr id="1" name=""/>
+        <p:cNvGrpSpPr/>
+        <p:nvPr/>
+      </p:nvGrpSpPr>
+      <p:grpSpPr>
+        <a:xfrm>
+          <a:off x="0" y="0"/>
+          <a:ext cx="0" cy="0"/>
+          <a:chOff x="0" y="0"/>
+          <a:chExt cx="0" cy="0"/>
+        </a:xfrm>
+      </p:grpSpPr>
+      <p:sp>
+        <p:nvSpPr>
+          <p:cNvPr id="2" name="Slide Image Placeholder 1"/>
+          <p:cNvSpPr>
+            <a:spLocks noGrp="1" noRot="1" noChangeAspect="1"/>
+          </p:cNvSpPr>
+          <p:nvPr>
+            <p:ph type="sldImg"/>
+          </p:nvPr>
+        </p:nvSpPr>
+        <p:spPr/>
+      </p:sp>
+      <p:sp>
+        <p:nvSpPr>
+          <p:cNvPr id="3" name="Notes Placeholder 2"/>
+          <p:cNvSpPr>
+            <a:spLocks noGrp="1"/>
+          </p:cNvSpPr>
+          <p:nvPr>
+            <p:ph type="body" idx="1"/>
+          </p:nvPr>
+        </p:nvSpPr>
+        <p:spPr/>
+        <p:txBody>
+          <a:bodyPr/>
+          <a:lstStyle/>
+          <a:p>
+            <a:r>
+              <a:rPr lang="en-US" dirty="0"/>
+              <a:t/>
+            </a:r>
+            <a:endParaRPr lang="en-US" dirty="0"/>
+          </a:p>
+        </p:txBody>
+      </p:sp>
+      <p:sp>
+        <p:nvSpPr>
+          <p:cNvPr id="4" name="Slide Number Placeholder 3"/>
+          <p:cNvSpPr>
+            <a:spLocks noGrp="1"/>
+          </p:cNvSpPr>
+          <p:nvPr>
+            <p:ph type="sldNum" sz="quarter" idx="10"/>
+          </p:nvPr>
+        </p:nvSpPr>
+        <p:spPr/>
+        <p:txBody>
+          <a:bodyPr/>
+          <a:lstStyle/>
+          <a:p>
+            <a:fld id="{F7021451-1387-4CA6-816F-3879F97B5CBC}" type="slidenum">
+              <a:rPr lang="en-US"/>
+              <a:t>4</a:t>
+            </a:fld>
+            <a:endParaRPr lang="en-US"/>
+          </a:p>
+        </p:txBody>
+      </p:sp>
+    </p:spTree>
+    <p:extLst>
+      <p:ext uri="{BB962C8B-B14F-4D97-AF65-F5344CB8AC3E}">
+        <p14:creationId xmlns:p14="http://schemas.microsoft.com/office/powerpoint/2010/main" val="1024086991"/>
+      </p:ext>
+    </p:extLst>
+  </p:cSld>
+  <p:clrMapOvr>
+    <a:masterClrMapping/>
+  </p:clrMapOvr>
+</p:notes>
+</file>
+
 <file path=ppt/slideLayouts/slideLayout1.xml><?xml version="1.0" encoding="utf-8"?>
 <p:sldLayout xmlns:a="http://schemas.openxmlformats.org/drawingml/2006/main" xmlns:r="http://schemas.openxmlformats.org/officeDocument/2006/relationships" xmlns:p="http://schemas.openxmlformats.org/presentationml/2006/main" preserve="1">
   <p:cSld name="DEFAULT">
@@ -2924,6 +3102,2074 @@
               <a:t>Kiểm thử &amp; Kết luận</a:t>
             </a:r>
             <a:endParaRPr lang="en-US" sz="1600" dirty="0"/>
+          </a:p>
+        </p:txBody>
+      </p:sp>
+    </p:spTree>
+  </p:cSld>
+  <p:clrMapOvr>
+    <a:masterClrMapping/>
+  </p:clrMapOvr>
+</p:sld>
+</file>
+
+<file path=ppt/slides/slide3.xml><?xml version="1.0" encoding="utf-8"?>
+<p:sld xmlns:a="http://schemas.openxmlformats.org/drawingml/2006/main" xmlns:r="http://schemas.openxmlformats.org/officeDocument/2006/relationships" xmlns:p="http://schemas.openxmlformats.org/presentationml/2006/main">
+  <p:cSld name="Slide 3">
+    <p:spTree>
+      <p:nvGrpSpPr>
+        <p:cNvPr id="1" name=""/>
+        <p:cNvGrpSpPr/>
+        <p:nvPr/>
+      </p:nvGrpSpPr>
+      <p:grpSpPr>
+        <a:xfrm>
+          <a:off x="0" y="0"/>
+          <a:ext cx="0" cy="0"/>
+          <a:chOff x="0" y="0"/>
+          <a:chExt cx="0" cy="0"/>
+        </a:xfrm>
+      </p:grpSpPr>
+      <p:sp>
+        <p:nvSpPr>
+          <p:cNvPr id="2" name="Shape 0"/>
+          <p:cNvSpPr/>
+          <p:nvPr/>
+        </p:nvSpPr>
+        <p:spPr>
+          <a:xfrm>
+            <a:off x="0" y="0"/>
+            <a:ext cx="12188952" cy="6858000"/>
+          </a:xfrm>
+          <a:prstGeom prst="rect">
+            <a:avLst/>
+          </a:prstGeom>
+          <a:solidFill>
+            <a:srgbClr val="0F0C29"/>
+          </a:solidFill>
+          <a:ln w="12700">
+            <a:solidFill>
+              <a:srgbClr val="0F0C29"/>
+            </a:solidFill>
+            <a:prstDash val="solid"/>
+          </a:ln>
+        </p:spPr>
+      </p:sp>
+      <p:sp>
+        <p:nvSpPr>
+          <p:cNvPr id="3" name="Shape 1"/>
+          <p:cNvSpPr/>
+          <p:nvPr/>
+        </p:nvSpPr>
+        <p:spPr>
+          <a:xfrm>
+            <a:off x="0" y="0"/>
+            <a:ext cx="12188952" cy="4114800"/>
+          </a:xfrm>
+          <a:prstGeom prst="rect">
+            <a:avLst/>
+          </a:prstGeom>
+          <a:solidFill>
+            <a:srgbClr val="1E1B4B">
+              <a:alpha val="70000"/>
+            </a:srgbClr>
+          </a:solidFill>
+          <a:ln w="12700">
+            <a:solidFill>
+              <a:srgbClr val="1E1B4B">
+                <a:alpha val="70000"/>
+              </a:srgbClr>
+            </a:solidFill>
+            <a:prstDash val="solid"/>
+          </a:ln>
+        </p:spPr>
+      </p:sp>
+      <p:sp>
+        <p:nvSpPr>
+          <p:cNvPr id="4" name="Shape 2"/>
+          <p:cNvSpPr/>
+          <p:nvPr/>
+        </p:nvSpPr>
+        <p:spPr>
+          <a:xfrm>
+            <a:off x="5486400" y="0"/>
+            <a:ext cx="6702552" cy="6858000"/>
+          </a:xfrm>
+          <a:prstGeom prst="rect">
+            <a:avLst/>
+          </a:prstGeom>
+          <a:solidFill>
+            <a:srgbClr val="312E81">
+              <a:alpha val="50000"/>
+            </a:srgbClr>
+          </a:solidFill>
+          <a:ln w="12700">
+            <a:solidFill>
+              <a:srgbClr val="312E81">
+                <a:alpha val="50000"/>
+              </a:srgbClr>
+            </a:solidFill>
+            <a:prstDash val="solid"/>
+          </a:ln>
+        </p:spPr>
+      </p:sp>
+      <p:sp>
+        <p:nvSpPr>
+          <p:cNvPr id="5" name="Shape 3"/>
+          <p:cNvSpPr/>
+          <p:nvPr/>
+        </p:nvSpPr>
+        <p:spPr>
+          <a:xfrm>
+            <a:off x="0" y="0"/>
+            <a:ext cx="54864" cy="3429000"/>
+          </a:xfrm>
+          <a:prstGeom prst="rect">
+            <a:avLst/>
+          </a:prstGeom>
+          <a:solidFill>
+            <a:srgbClr val="818CF8"/>
+          </a:solidFill>
+          <a:ln w="12700">
+            <a:solidFill>
+              <a:srgbClr val="818CF8"/>
+            </a:solidFill>
+            <a:prstDash val="solid"/>
+          </a:ln>
+        </p:spPr>
+      </p:sp>
+      <p:sp>
+        <p:nvSpPr>
+          <p:cNvPr id="6" name="Shape 4"/>
+          <p:cNvSpPr/>
+          <p:nvPr/>
+        </p:nvSpPr>
+        <p:spPr>
+          <a:xfrm>
+            <a:off x="0" y="3429000"/>
+            <a:ext cx="54864" cy="3429000"/>
+          </a:xfrm>
+          <a:prstGeom prst="rect">
+            <a:avLst/>
+          </a:prstGeom>
+          <a:solidFill>
+            <a:srgbClr val="34D399"/>
+          </a:solidFill>
+          <a:ln w="12700">
+            <a:solidFill>
+              <a:srgbClr val="34D399"/>
+            </a:solidFill>
+            <a:prstDash val="solid"/>
+          </a:ln>
+        </p:spPr>
+      </p:sp>
+      <p:sp>
+        <p:nvSpPr>
+          <p:cNvPr id="7" name="Text 5"/>
+          <p:cNvSpPr/>
+          <p:nvPr/>
+        </p:nvSpPr>
+        <p:spPr>
+          <a:xfrm>
+            <a:off x="365760" y="274320"/>
+            <a:ext cx="11430000" cy="548640"/>
+          </a:xfrm>
+          <a:prstGeom prst="rect">
+            <a:avLst/>
+          </a:prstGeom>
+          <a:noFill/>
+          <a:ln/>
+        </p:spPr>
+        <p:txBody>
+          <a:bodyPr wrap="square" rtlCol="0" anchor="ctr"/>
+          <a:lstStyle/>
+          <a:p>
+            <a:pPr algn="l" indent="0" marL="0">
+              <a:buNone/>
+            </a:pPr>
+            <a:r>
+              <a:rPr lang="en-US" sz="2600" b="1" dirty="0">
+                <a:solidFill>
+                  <a:srgbClr val="4ECDC4"/>
+                </a:solidFill>
+                <a:latin typeface="Calibri" pitchFamily="34" charset="0"/>
+                <a:ea typeface="Calibri" pitchFamily="34" charset="-122"/>
+                <a:cs typeface="Calibri" pitchFamily="34" charset="-120"/>
+              </a:rPr>
+              <a:t>01. Giới Thiệu Đề Tài</a:t>
+            </a:r>
+            <a:endParaRPr lang="en-US" sz="2600" dirty="0"/>
+          </a:p>
+        </p:txBody>
+      </p:sp>
+      <p:sp>
+        <p:nvSpPr>
+          <p:cNvPr id="8" name="Shape 6"/>
+          <p:cNvSpPr/>
+          <p:nvPr/>
+        </p:nvSpPr>
+        <p:spPr>
+          <a:xfrm>
+            <a:off x="365760" y="868680"/>
+            <a:ext cx="11430000" cy="27432"/>
+          </a:xfrm>
+          <a:prstGeom prst="rect">
+            <a:avLst/>
+          </a:prstGeom>
+          <a:solidFill>
+            <a:srgbClr val="4ECDC4"/>
+          </a:solidFill>
+          <a:ln w="12700">
+            <a:solidFill>
+              <a:srgbClr val="4ECDC4"/>
+            </a:solidFill>
+            <a:prstDash val="solid"/>
+          </a:ln>
+        </p:spPr>
+      </p:sp>
+      <p:sp>
+        <p:nvSpPr>
+          <p:cNvPr id="9" name="Text 7"/>
+          <p:cNvSpPr/>
+          <p:nvPr/>
+        </p:nvSpPr>
+        <p:spPr>
+          <a:xfrm>
+            <a:off x="365760" y="1005840"/>
+            <a:ext cx="11430000" cy="685800"/>
+          </a:xfrm>
+          <a:prstGeom prst="rect">
+            <a:avLst/>
+          </a:prstGeom>
+          <a:noFill/>
+          <a:ln/>
+        </p:spPr>
+        <p:txBody>
+          <a:bodyPr wrap="square" rtlCol="0" anchor="ctr"/>
+          <a:lstStyle/>
+          <a:p>
+            <a:pPr indent="0" marL="0">
+              <a:buNone/>
+            </a:pPr>
+            <a:r>
+              <a:rPr lang="en-US" sz="1500" dirty="0">
+                <a:solidFill>
+                  <a:srgbClr val="6B7AB8"/>
+                </a:solidFill>
+                <a:latin typeface="Calibri" pitchFamily="34" charset="0"/>
+                <a:ea typeface="Calibri" pitchFamily="34" charset="-122"/>
+                <a:cs typeface="Calibri" pitchFamily="34" charset="-120"/>
+              </a:rPr>
+              <a:t>Bài toán tìm đường là bài toán nền tảng trong Trí tuệ Nhân tạo. PathFinder AI áp dụng 4 thuật toán trực tiếp lên bản đồ đường bộ thực của Hà Đông — không phải đồ thị lý thuyết.</a:t>
+            </a:r>
+            <a:endParaRPr lang="en-US" sz="1500" dirty="0"/>
+          </a:p>
+        </p:txBody>
+      </p:sp>
+      <p:sp>
+        <p:nvSpPr>
+          <p:cNvPr id="10" name="Shape 8"/>
+          <p:cNvSpPr/>
+          <p:nvPr/>
+        </p:nvSpPr>
+        <p:spPr>
+          <a:xfrm>
+            <a:off x="365760" y="1874520"/>
+            <a:ext cx="2743200" cy="4663440"/>
+          </a:xfrm>
+          <a:prstGeom prst="roundRect">
+            <a:avLst>
+              <a:gd name="adj" fmla="val 2667"/>
+            </a:avLst>
+          </a:prstGeom>
+          <a:solidFill>
+            <a:srgbClr val="1C1945"/>
+          </a:solidFill>
+          <a:ln w="15240">
+            <a:solidFill>
+              <a:srgbClr val="363780"/>
+            </a:solidFill>
+            <a:prstDash val="solid"/>
+          </a:ln>
+        </p:spPr>
+      </p:sp>
+      <p:sp>
+        <p:nvSpPr>
+          <p:cNvPr id="11" name="Text 9"/>
+          <p:cNvSpPr/>
+          <p:nvPr/>
+        </p:nvSpPr>
+        <p:spPr>
+          <a:xfrm>
+            <a:off x="365760" y="2011680"/>
+            <a:ext cx="2743200" cy="822960"/>
+          </a:xfrm>
+          <a:prstGeom prst="rect">
+            <a:avLst/>
+          </a:prstGeom>
+          <a:noFill/>
+          <a:ln/>
+        </p:spPr>
+        <p:txBody>
+          <a:bodyPr wrap="square" rtlCol="0" anchor="ctr"/>
+          <a:lstStyle/>
+          <a:p>
+            <a:pPr algn="ctr" indent="0" marL="0">
+              <a:buNone/>
+            </a:pPr>
+            <a:r>
+              <a:rPr lang="en-US" sz="3800" dirty="0">
+                <a:solidFill>
+                  <a:srgbClr val="000000"/>
+                </a:solidFill>
+              </a:rPr>
+              <a:t>🗺️</a:t>
+            </a:r>
+            <a:endParaRPr lang="en-US" sz="3800" dirty="0"/>
+          </a:p>
+        </p:txBody>
+      </p:sp>
+      <p:sp>
+        <p:nvSpPr>
+          <p:cNvPr id="12" name="Text 10"/>
+          <p:cNvSpPr/>
+          <p:nvPr/>
+        </p:nvSpPr>
+        <p:spPr>
+          <a:xfrm>
+            <a:off x="365760" y="2926080"/>
+            <a:ext cx="2743200" cy="457200"/>
+          </a:xfrm>
+          <a:prstGeom prst="rect">
+            <a:avLst/>
+          </a:prstGeom>
+          <a:noFill/>
+          <a:ln/>
+        </p:spPr>
+        <p:txBody>
+          <a:bodyPr wrap="square" rtlCol="0" anchor="ctr"/>
+          <a:lstStyle/>
+          <a:p>
+            <a:pPr algn="ctr" indent="0" marL="0">
+              <a:buNone/>
+            </a:pPr>
+            <a:r>
+              <a:rPr lang="en-US" sz="1500" b="1" dirty="0">
+                <a:solidFill>
+                  <a:srgbClr val="34D399"/>
+                </a:solidFill>
+                <a:latin typeface="Calibri" pitchFamily="34" charset="0"/>
+                <a:ea typeface="Calibri" pitchFamily="34" charset="-122"/>
+                <a:cs typeface="Calibri" pitchFamily="34" charset="-120"/>
+              </a:rPr>
+              <a:t>Bản đồ thực</a:t>
+            </a:r>
+            <a:endParaRPr lang="en-US" sz="1500" dirty="0"/>
+          </a:p>
+        </p:txBody>
+      </p:sp>
+      <p:sp>
+        <p:nvSpPr>
+          <p:cNvPr id="13" name="Text 11"/>
+          <p:cNvSpPr/>
+          <p:nvPr/>
+        </p:nvSpPr>
+        <p:spPr>
+          <a:xfrm>
+            <a:off x="365760" y="3429000"/>
+            <a:ext cx="2743200" cy="2926080"/>
+          </a:xfrm>
+          <a:prstGeom prst="rect">
+            <a:avLst/>
+          </a:prstGeom>
+          <a:noFill/>
+          <a:ln/>
+        </p:spPr>
+        <p:txBody>
+          <a:bodyPr wrap="square" rtlCol="0" anchor="ctr"/>
+          <a:lstStyle/>
+          <a:p>
+            <a:pPr algn="ctr" indent="0" marL="0">
+              <a:buNone/>
+            </a:pPr>
+            <a:r>
+              <a:rPr lang="en-US" sz="1300" dirty="0">
+                <a:solidFill>
+                  <a:srgbClr val="6B7AB8"/>
+                </a:solidFill>
+                <a:latin typeface="Calibri" pitchFamily="34" charset="0"/>
+                <a:ea typeface="Calibri" pitchFamily="34" charset="-122"/>
+                <a:cs typeface="Calibri" pitchFamily="34" charset="-120"/>
+              </a:rPr>
+              <a:t>1 007 nút giao thông</a:t>
+            </a:r>
+            <a:endParaRPr lang="en-US" sz="1300" dirty="0"/>
+          </a:p>
+          <a:p>
+            <a:pPr algn="ctr" indent="0" marL="0">
+              <a:buNone/>
+            </a:pPr>
+            <a:r>
+              <a:rPr lang="en-US" sz="1300" dirty="0">
+                <a:solidFill>
+                  <a:srgbClr val="6B7AB8"/>
+                </a:solidFill>
+                <a:latin typeface="Calibri" pitchFamily="34" charset="0"/>
+                <a:ea typeface="Calibri" pitchFamily="34" charset="-122"/>
+                <a:cs typeface="Calibri" pitchFamily="34" charset="-120"/>
+              </a:rPr>
+              <a:t>2 644 cạnh đường bộ</a:t>
+            </a:r>
+            <a:endParaRPr lang="en-US" sz="1300" dirty="0"/>
+          </a:p>
+          <a:p>
+            <a:pPr algn="ctr" indent="0" marL="0">
+              <a:buNone/>
+            </a:pPr>
+            <a:r>
+              <a:rPr lang="en-US" sz="1300" dirty="0">
+                <a:solidFill>
+                  <a:srgbClr val="6B7AB8"/>
+                </a:solidFill>
+                <a:latin typeface="Calibri" pitchFamily="34" charset="0"/>
+                <a:ea typeface="Calibri" pitchFamily="34" charset="-122"/>
+                <a:cs typeface="Calibri" pitchFamily="34" charset="-120"/>
+              </a:rPr>
+              <a:t>Hà Đông, Hà Nội</a:t>
+            </a:r>
+            <a:endParaRPr lang="en-US" sz="1300" dirty="0"/>
+          </a:p>
+        </p:txBody>
+      </p:sp>
+      <p:sp>
+        <p:nvSpPr>
+          <p:cNvPr id="14" name="Shape 12"/>
+          <p:cNvSpPr/>
+          <p:nvPr/>
+        </p:nvSpPr>
+        <p:spPr>
+          <a:xfrm>
+            <a:off x="3246120" y="1874520"/>
+            <a:ext cx="2743200" cy="4663440"/>
+          </a:xfrm>
+          <a:prstGeom prst="roundRect">
+            <a:avLst>
+              <a:gd name="adj" fmla="val 2667"/>
+            </a:avLst>
+          </a:prstGeom>
+          <a:solidFill>
+            <a:srgbClr val="1C1945"/>
+          </a:solidFill>
+          <a:ln w="15240">
+            <a:solidFill>
+              <a:srgbClr val="363780"/>
+            </a:solidFill>
+            <a:prstDash val="solid"/>
+          </a:ln>
+        </p:spPr>
+      </p:sp>
+      <p:sp>
+        <p:nvSpPr>
+          <p:cNvPr id="15" name="Text 13"/>
+          <p:cNvSpPr/>
+          <p:nvPr/>
+        </p:nvSpPr>
+        <p:spPr>
+          <a:xfrm>
+            <a:off x="3246120" y="2011680"/>
+            <a:ext cx="2743200" cy="822960"/>
+          </a:xfrm>
+          <a:prstGeom prst="rect">
+            <a:avLst/>
+          </a:prstGeom>
+          <a:noFill/>
+          <a:ln/>
+        </p:spPr>
+        <p:txBody>
+          <a:bodyPr wrap="square" rtlCol="0" anchor="ctr"/>
+          <a:lstStyle/>
+          <a:p>
+            <a:pPr algn="ctr" indent="0" marL="0">
+              <a:buNone/>
+            </a:pPr>
+            <a:r>
+              <a:rPr lang="en-US" sz="3800" dirty="0">
+                <a:solidFill>
+                  <a:srgbClr val="000000"/>
+                </a:solidFill>
+              </a:rPr>
+              <a:t>⚡</a:t>
+            </a:r>
+            <a:endParaRPr lang="en-US" sz="3800" dirty="0"/>
+          </a:p>
+        </p:txBody>
+      </p:sp>
+      <p:sp>
+        <p:nvSpPr>
+          <p:cNvPr id="16" name="Text 14"/>
+          <p:cNvSpPr/>
+          <p:nvPr/>
+        </p:nvSpPr>
+        <p:spPr>
+          <a:xfrm>
+            <a:off x="3246120" y="2926080"/>
+            <a:ext cx="2743200" cy="457200"/>
+          </a:xfrm>
+          <a:prstGeom prst="rect">
+            <a:avLst/>
+          </a:prstGeom>
+          <a:noFill/>
+          <a:ln/>
+        </p:spPr>
+        <p:txBody>
+          <a:bodyPr wrap="square" rtlCol="0" anchor="ctr"/>
+          <a:lstStyle/>
+          <a:p>
+            <a:pPr algn="ctr" indent="0" marL="0">
+              <a:buNone/>
+            </a:pPr>
+            <a:r>
+              <a:rPr lang="en-US" sz="1500" b="1" dirty="0">
+                <a:solidFill>
+                  <a:srgbClr val="34D399"/>
+                </a:solidFill>
+                <a:latin typeface="Calibri" pitchFamily="34" charset="0"/>
+                <a:ea typeface="Calibri" pitchFamily="34" charset="-122"/>
+                <a:cs typeface="Calibri" pitchFamily="34" charset="-120"/>
+              </a:rPr>
+              <a:t>Đồng thời</a:t>
+            </a:r>
+            <a:endParaRPr lang="en-US" sz="1500" dirty="0"/>
+          </a:p>
+        </p:txBody>
+      </p:sp>
+      <p:sp>
+        <p:nvSpPr>
+          <p:cNvPr id="17" name="Text 15"/>
+          <p:cNvSpPr/>
+          <p:nvPr/>
+        </p:nvSpPr>
+        <p:spPr>
+          <a:xfrm>
+            <a:off x="3246120" y="3429000"/>
+            <a:ext cx="2743200" cy="2926080"/>
+          </a:xfrm>
+          <a:prstGeom prst="rect">
+            <a:avLst/>
+          </a:prstGeom>
+          <a:noFill/>
+          <a:ln/>
+        </p:spPr>
+        <p:txBody>
+          <a:bodyPr wrap="square" rtlCol="0" anchor="ctr"/>
+          <a:lstStyle/>
+          <a:p>
+            <a:pPr algn="ctr" indent="0" marL="0">
+              <a:buNone/>
+            </a:pPr>
+            <a:r>
+              <a:rPr lang="en-US" sz="1300" dirty="0">
+                <a:solidFill>
+                  <a:srgbClr val="6B7AB8"/>
+                </a:solidFill>
+                <a:latin typeface="Calibri" pitchFamily="34" charset="0"/>
+                <a:ea typeface="Calibri" pitchFamily="34" charset="-122"/>
+                <a:cs typeface="Calibri" pitchFamily="34" charset="-120"/>
+              </a:rPr>
+              <a:t>Chạy song song 4 thuật toán</a:t>
+            </a:r>
+            <a:endParaRPr lang="en-US" sz="1300" dirty="0"/>
+          </a:p>
+          <a:p>
+            <a:pPr algn="ctr" indent="0" marL="0">
+              <a:buNone/>
+            </a:pPr>
+            <a:r>
+              <a:rPr lang="en-US" sz="1300" dirty="0">
+                <a:solidFill>
+                  <a:srgbClr val="6B7AB8"/>
+                </a:solidFill>
+                <a:latin typeface="Calibri" pitchFamily="34" charset="0"/>
+                <a:ea typeface="Calibri" pitchFamily="34" charset="-122"/>
+                <a:cs typeface="Calibri" pitchFamily="34" charset="-120"/>
+              </a:rPr>
+              <a:t>Hoạt ảnh từng bước khám phá</a:t>
+            </a:r>
+            <a:endParaRPr lang="en-US" sz="1300" dirty="0"/>
+          </a:p>
+        </p:txBody>
+      </p:sp>
+      <p:sp>
+        <p:nvSpPr>
+          <p:cNvPr id="18" name="Shape 16"/>
+          <p:cNvSpPr/>
+          <p:nvPr/>
+        </p:nvSpPr>
+        <p:spPr>
+          <a:xfrm>
+            <a:off x="6126480" y="1874520"/>
+            <a:ext cx="2743200" cy="4663440"/>
+          </a:xfrm>
+          <a:prstGeom prst="roundRect">
+            <a:avLst>
+              <a:gd name="adj" fmla="val 2667"/>
+            </a:avLst>
+          </a:prstGeom>
+          <a:solidFill>
+            <a:srgbClr val="1C1945"/>
+          </a:solidFill>
+          <a:ln w="15240">
+            <a:solidFill>
+              <a:srgbClr val="363780"/>
+            </a:solidFill>
+            <a:prstDash val="solid"/>
+          </a:ln>
+        </p:spPr>
+      </p:sp>
+      <p:sp>
+        <p:nvSpPr>
+          <p:cNvPr id="19" name="Text 17"/>
+          <p:cNvSpPr/>
+          <p:nvPr/>
+        </p:nvSpPr>
+        <p:spPr>
+          <a:xfrm>
+            <a:off x="6126480" y="2011680"/>
+            <a:ext cx="2743200" cy="822960"/>
+          </a:xfrm>
+          <a:prstGeom prst="rect">
+            <a:avLst/>
+          </a:prstGeom>
+          <a:noFill/>
+          <a:ln/>
+        </p:spPr>
+        <p:txBody>
+          <a:bodyPr wrap="square" rtlCol="0" anchor="ctr"/>
+          <a:lstStyle/>
+          <a:p>
+            <a:pPr algn="ctr" indent="0" marL="0">
+              <a:buNone/>
+            </a:pPr>
+            <a:r>
+              <a:rPr lang="en-US" sz="3800" dirty="0">
+                <a:solidFill>
+                  <a:srgbClr val="000000"/>
+                </a:solidFill>
+              </a:rPr>
+              <a:t>📊</a:t>
+            </a:r>
+            <a:endParaRPr lang="en-US" sz="3800" dirty="0"/>
+          </a:p>
+        </p:txBody>
+      </p:sp>
+      <p:sp>
+        <p:nvSpPr>
+          <p:cNvPr id="20" name="Text 18"/>
+          <p:cNvSpPr/>
+          <p:nvPr/>
+        </p:nvSpPr>
+        <p:spPr>
+          <a:xfrm>
+            <a:off x="6126480" y="2926080"/>
+            <a:ext cx="2743200" cy="457200"/>
+          </a:xfrm>
+          <a:prstGeom prst="rect">
+            <a:avLst/>
+          </a:prstGeom>
+          <a:noFill/>
+          <a:ln/>
+        </p:spPr>
+        <p:txBody>
+          <a:bodyPr wrap="square" rtlCol="0" anchor="ctr"/>
+          <a:lstStyle/>
+          <a:p>
+            <a:pPr algn="ctr" indent="0" marL="0">
+              <a:buNone/>
+            </a:pPr>
+            <a:r>
+              <a:rPr lang="en-US" sz="1500" b="1" dirty="0">
+                <a:solidFill>
+                  <a:srgbClr val="34D399"/>
+                </a:solidFill>
+                <a:latin typeface="Calibri" pitchFamily="34" charset="0"/>
+                <a:ea typeface="Calibri" pitchFamily="34" charset="-122"/>
+                <a:cs typeface="Calibri" pitchFamily="34" charset="-120"/>
+              </a:rPr>
+              <a:t>So sánh</a:t>
+            </a:r>
+            <a:endParaRPr lang="en-US" sz="1500" dirty="0"/>
+          </a:p>
+        </p:txBody>
+      </p:sp>
+      <p:sp>
+        <p:nvSpPr>
+          <p:cNvPr id="21" name="Text 19"/>
+          <p:cNvSpPr/>
+          <p:nvPr/>
+        </p:nvSpPr>
+        <p:spPr>
+          <a:xfrm>
+            <a:off x="6126480" y="3429000"/>
+            <a:ext cx="2743200" cy="2926080"/>
+          </a:xfrm>
+          <a:prstGeom prst="rect">
+            <a:avLst/>
+          </a:prstGeom>
+          <a:noFill/>
+          <a:ln/>
+        </p:spPr>
+        <p:txBody>
+          <a:bodyPr wrap="square" rtlCol="0" anchor="ctr"/>
+          <a:lstStyle/>
+          <a:p>
+            <a:pPr algn="ctr" indent="0" marL="0">
+              <a:buNone/>
+            </a:pPr>
+            <a:r>
+              <a:rPr lang="en-US" sz="1300" dirty="0">
+                <a:solidFill>
+                  <a:srgbClr val="6B7AB8"/>
+                </a:solidFill>
+                <a:latin typeface="Calibri" pitchFamily="34" charset="0"/>
+                <a:ea typeface="Calibri" pitchFamily="34" charset="-122"/>
+                <a:cs typeface="Calibri" pitchFamily="34" charset="-120"/>
+              </a:rPr>
+              <a:t>Số nút duyệt · Độ dài đường</a:t>
+            </a:r>
+            <a:endParaRPr lang="en-US" sz="1300" dirty="0"/>
+          </a:p>
+          <a:p>
+            <a:pPr algn="ctr" indent="0" marL="0">
+              <a:buNone/>
+            </a:pPr>
+            <a:r>
+              <a:rPr lang="en-US" sz="1300" dirty="0">
+                <a:solidFill>
+                  <a:srgbClr val="6B7AB8"/>
+                </a:solidFill>
+                <a:latin typeface="Calibri" pitchFamily="34" charset="0"/>
+                <a:ea typeface="Calibri" pitchFamily="34" charset="-122"/>
+                <a:cs typeface="Calibri" pitchFamily="34" charset="-120"/>
+              </a:rPr>
+              <a:t>Thời gian thực thi</a:t>
+            </a:r>
+            <a:endParaRPr lang="en-US" sz="1300" dirty="0"/>
+          </a:p>
+        </p:txBody>
+      </p:sp>
+      <p:sp>
+        <p:nvSpPr>
+          <p:cNvPr id="22" name="Shape 20"/>
+          <p:cNvSpPr/>
+          <p:nvPr/>
+        </p:nvSpPr>
+        <p:spPr>
+          <a:xfrm>
+            <a:off x="9006840" y="1874520"/>
+            <a:ext cx="2743200" cy="4663440"/>
+          </a:xfrm>
+          <a:prstGeom prst="roundRect">
+            <a:avLst>
+              <a:gd name="adj" fmla="val 2667"/>
+            </a:avLst>
+          </a:prstGeom>
+          <a:solidFill>
+            <a:srgbClr val="1C1945"/>
+          </a:solidFill>
+          <a:ln w="15240">
+            <a:solidFill>
+              <a:srgbClr val="363780"/>
+            </a:solidFill>
+            <a:prstDash val="solid"/>
+          </a:ln>
+        </p:spPr>
+      </p:sp>
+      <p:sp>
+        <p:nvSpPr>
+          <p:cNvPr id="23" name="Text 21"/>
+          <p:cNvSpPr/>
+          <p:nvPr/>
+        </p:nvSpPr>
+        <p:spPr>
+          <a:xfrm>
+            <a:off x="9006840" y="2011680"/>
+            <a:ext cx="2743200" cy="822960"/>
+          </a:xfrm>
+          <a:prstGeom prst="rect">
+            <a:avLst/>
+          </a:prstGeom>
+          <a:noFill/>
+          <a:ln/>
+        </p:spPr>
+        <p:txBody>
+          <a:bodyPr wrap="square" rtlCol="0" anchor="ctr"/>
+          <a:lstStyle/>
+          <a:p>
+            <a:pPr algn="ctr" indent="0" marL="0">
+              <a:buNone/>
+            </a:pPr>
+            <a:r>
+              <a:rPr lang="en-US" sz="3800" dirty="0">
+                <a:solidFill>
+                  <a:srgbClr val="000000"/>
+                </a:solidFill>
+              </a:rPr>
+              <a:t>🎛️</a:t>
+            </a:r>
+            <a:endParaRPr lang="en-US" sz="3800" dirty="0"/>
+          </a:p>
+        </p:txBody>
+      </p:sp>
+      <p:sp>
+        <p:nvSpPr>
+          <p:cNvPr id="24" name="Text 22"/>
+          <p:cNvSpPr/>
+          <p:nvPr/>
+        </p:nvSpPr>
+        <p:spPr>
+          <a:xfrm>
+            <a:off x="9006840" y="2926080"/>
+            <a:ext cx="2743200" cy="457200"/>
+          </a:xfrm>
+          <a:prstGeom prst="rect">
+            <a:avLst/>
+          </a:prstGeom>
+          <a:noFill/>
+          <a:ln/>
+        </p:spPr>
+        <p:txBody>
+          <a:bodyPr wrap="square" rtlCol="0" anchor="ctr"/>
+          <a:lstStyle/>
+          <a:p>
+            <a:pPr algn="ctr" indent="0" marL="0">
+              <a:buNone/>
+            </a:pPr>
+            <a:r>
+              <a:rPr lang="en-US" sz="1500" b="1" dirty="0">
+                <a:solidFill>
+                  <a:srgbClr val="34D399"/>
+                </a:solidFill>
+                <a:latin typeface="Calibri" pitchFamily="34" charset="0"/>
+                <a:ea typeface="Calibri" pitchFamily="34" charset="-122"/>
+                <a:cs typeface="Calibri" pitchFamily="34" charset="-120"/>
+              </a:rPr>
+              <a:t>Tương tác</a:t>
+            </a:r>
+            <a:endParaRPr lang="en-US" sz="1500" dirty="0"/>
+          </a:p>
+        </p:txBody>
+      </p:sp>
+      <p:sp>
+        <p:nvSpPr>
+          <p:cNvPr id="25" name="Text 23"/>
+          <p:cNvSpPr/>
+          <p:nvPr/>
+        </p:nvSpPr>
+        <p:spPr>
+          <a:xfrm>
+            <a:off x="9006840" y="3429000"/>
+            <a:ext cx="2743200" cy="2926080"/>
+          </a:xfrm>
+          <a:prstGeom prst="rect">
+            <a:avLst/>
+          </a:prstGeom>
+          <a:noFill/>
+          <a:ln/>
+        </p:spPr>
+        <p:txBody>
+          <a:bodyPr wrap="square" rtlCol="0" anchor="ctr"/>
+          <a:lstStyle/>
+          <a:p>
+            <a:pPr algn="ctr" indent="0" marL="0">
+              <a:buNone/>
+            </a:pPr>
+            <a:r>
+              <a:rPr lang="en-US" sz="1300" dirty="0">
+                <a:solidFill>
+                  <a:srgbClr val="6B7AB8"/>
+                </a:solidFill>
+                <a:latin typeface="Calibri" pitchFamily="34" charset="0"/>
+                <a:ea typeface="Calibri" pitchFamily="34" charset="-122"/>
+                <a:cs typeface="Calibri" pitchFamily="34" charset="-120"/>
+              </a:rPr>
+              <a:t>Click chọn điểm · Điều chỉnh tốc độ</a:t>
+            </a:r>
+            <a:endParaRPr lang="en-US" sz="1300" dirty="0"/>
+          </a:p>
+          <a:p>
+            <a:pPr algn="ctr" indent="0" marL="0">
+              <a:buNone/>
+            </a:pPr>
+            <a:r>
+              <a:rPr lang="en-US" sz="1300" dirty="0">
+                <a:solidFill>
+                  <a:srgbClr val="6B7AB8"/>
+                </a:solidFill>
+                <a:latin typeface="Calibri" pitchFamily="34" charset="0"/>
+                <a:ea typeface="Calibri" pitchFamily="34" charset="-122"/>
+                <a:cs typeface="Calibri" pitchFamily="34" charset="-120"/>
+              </a:rPr>
+              <a:t>Ẩn/hiện từng thuật toán</a:t>
+            </a:r>
+            <a:endParaRPr lang="en-US" sz="1300" dirty="0"/>
+          </a:p>
+        </p:txBody>
+      </p:sp>
+    </p:spTree>
+  </p:cSld>
+  <p:clrMapOvr>
+    <a:masterClrMapping/>
+  </p:clrMapOvr>
+</p:sld>
+</file>
+
+<file path=ppt/slides/slide4.xml><?xml version="1.0" encoding="utf-8"?>
+<p:sld xmlns:a="http://schemas.openxmlformats.org/drawingml/2006/main" xmlns:r="http://schemas.openxmlformats.org/officeDocument/2006/relationships" xmlns:p="http://schemas.openxmlformats.org/presentationml/2006/main">
+  <p:cSld name="Slide 4">
+    <p:spTree>
+      <p:nvGrpSpPr>
+        <p:cNvPr id="1" name=""/>
+        <p:cNvGrpSpPr/>
+        <p:nvPr/>
+      </p:nvGrpSpPr>
+      <p:grpSpPr>
+        <a:xfrm>
+          <a:off x="0" y="0"/>
+          <a:ext cx="0" cy="0"/>
+          <a:chOff x="0" y="0"/>
+          <a:chExt cx="0" cy="0"/>
+        </a:xfrm>
+      </p:grpSpPr>
+      <p:sp>
+        <p:nvSpPr>
+          <p:cNvPr id="2" name="Shape 0"/>
+          <p:cNvSpPr/>
+          <p:nvPr/>
+        </p:nvSpPr>
+        <p:spPr>
+          <a:xfrm>
+            <a:off x="0" y="0"/>
+            <a:ext cx="12188952" cy="6858000"/>
+          </a:xfrm>
+          <a:prstGeom prst="rect">
+            <a:avLst/>
+          </a:prstGeom>
+          <a:solidFill>
+            <a:srgbClr val="0F0C29"/>
+          </a:solidFill>
+          <a:ln w="12700">
+            <a:solidFill>
+              <a:srgbClr val="0F0C29"/>
+            </a:solidFill>
+            <a:prstDash val="solid"/>
+          </a:ln>
+        </p:spPr>
+      </p:sp>
+      <p:sp>
+        <p:nvSpPr>
+          <p:cNvPr id="3" name="Shape 1"/>
+          <p:cNvSpPr/>
+          <p:nvPr/>
+        </p:nvSpPr>
+        <p:spPr>
+          <a:xfrm>
+            <a:off x="0" y="0"/>
+            <a:ext cx="12188952" cy="4114800"/>
+          </a:xfrm>
+          <a:prstGeom prst="rect">
+            <a:avLst/>
+          </a:prstGeom>
+          <a:solidFill>
+            <a:srgbClr val="1E1B4B">
+              <a:alpha val="70000"/>
+            </a:srgbClr>
+          </a:solidFill>
+          <a:ln w="12700">
+            <a:solidFill>
+              <a:srgbClr val="1E1B4B">
+                <a:alpha val="70000"/>
+              </a:srgbClr>
+            </a:solidFill>
+            <a:prstDash val="solid"/>
+          </a:ln>
+        </p:spPr>
+      </p:sp>
+      <p:sp>
+        <p:nvSpPr>
+          <p:cNvPr id="4" name="Shape 2"/>
+          <p:cNvSpPr/>
+          <p:nvPr/>
+        </p:nvSpPr>
+        <p:spPr>
+          <a:xfrm>
+            <a:off x="5486400" y="0"/>
+            <a:ext cx="6702552" cy="6858000"/>
+          </a:xfrm>
+          <a:prstGeom prst="rect">
+            <a:avLst/>
+          </a:prstGeom>
+          <a:solidFill>
+            <a:srgbClr val="312E81">
+              <a:alpha val="50000"/>
+            </a:srgbClr>
+          </a:solidFill>
+          <a:ln w="12700">
+            <a:solidFill>
+              <a:srgbClr val="312E81">
+                <a:alpha val="50000"/>
+              </a:srgbClr>
+            </a:solidFill>
+            <a:prstDash val="solid"/>
+          </a:ln>
+        </p:spPr>
+      </p:sp>
+      <p:sp>
+        <p:nvSpPr>
+          <p:cNvPr id="5" name="Shape 3"/>
+          <p:cNvSpPr/>
+          <p:nvPr/>
+        </p:nvSpPr>
+        <p:spPr>
+          <a:xfrm>
+            <a:off x="0" y="0"/>
+            <a:ext cx="54864" cy="3429000"/>
+          </a:xfrm>
+          <a:prstGeom prst="rect">
+            <a:avLst/>
+          </a:prstGeom>
+          <a:solidFill>
+            <a:srgbClr val="818CF8"/>
+          </a:solidFill>
+          <a:ln w="12700">
+            <a:solidFill>
+              <a:srgbClr val="818CF8"/>
+            </a:solidFill>
+            <a:prstDash val="solid"/>
+          </a:ln>
+        </p:spPr>
+      </p:sp>
+      <p:sp>
+        <p:nvSpPr>
+          <p:cNvPr id="6" name="Shape 4"/>
+          <p:cNvSpPr/>
+          <p:nvPr/>
+        </p:nvSpPr>
+        <p:spPr>
+          <a:xfrm>
+            <a:off x="0" y="3429000"/>
+            <a:ext cx="54864" cy="3429000"/>
+          </a:xfrm>
+          <a:prstGeom prst="rect">
+            <a:avLst/>
+          </a:prstGeom>
+          <a:solidFill>
+            <a:srgbClr val="34D399"/>
+          </a:solidFill>
+          <a:ln w="12700">
+            <a:solidFill>
+              <a:srgbClr val="34D399"/>
+            </a:solidFill>
+            <a:prstDash val="solid"/>
+          </a:ln>
+        </p:spPr>
+      </p:sp>
+      <p:sp>
+        <p:nvSpPr>
+          <p:cNvPr id="7" name="Text 5"/>
+          <p:cNvSpPr/>
+          <p:nvPr/>
+        </p:nvSpPr>
+        <p:spPr>
+          <a:xfrm>
+            <a:off x="365760" y="274320"/>
+            <a:ext cx="11430000" cy="548640"/>
+          </a:xfrm>
+          <a:prstGeom prst="rect">
+            <a:avLst/>
+          </a:prstGeom>
+          <a:noFill/>
+          <a:ln/>
+        </p:spPr>
+        <p:txBody>
+          <a:bodyPr wrap="square" rtlCol="0" anchor="ctr"/>
+          <a:lstStyle/>
+          <a:p>
+            <a:pPr algn="l" indent="0" marL="0">
+              <a:buNone/>
+            </a:pPr>
+            <a:r>
+              <a:rPr lang="en-US" sz="2600" b="1" dirty="0">
+                <a:solidFill>
+                  <a:srgbClr val="FFD166"/>
+                </a:solidFill>
+                <a:latin typeface="Calibri" pitchFamily="34" charset="0"/>
+                <a:ea typeface="Calibri" pitchFamily="34" charset="-122"/>
+                <a:cs typeface="Calibri" pitchFamily="34" charset="-120"/>
+              </a:rPr>
+              <a:t>02. Kiến Trúc Hệ Thống</a:t>
+            </a:r>
+            <a:endParaRPr lang="en-US" sz="2600" dirty="0"/>
+          </a:p>
+        </p:txBody>
+      </p:sp>
+      <p:sp>
+        <p:nvSpPr>
+          <p:cNvPr id="8" name="Shape 6"/>
+          <p:cNvSpPr/>
+          <p:nvPr/>
+        </p:nvSpPr>
+        <p:spPr>
+          <a:xfrm>
+            <a:off x="365760" y="868680"/>
+            <a:ext cx="11430000" cy="27432"/>
+          </a:xfrm>
+          <a:prstGeom prst="rect">
+            <a:avLst/>
+          </a:prstGeom>
+          <a:solidFill>
+            <a:srgbClr val="FFD166"/>
+          </a:solidFill>
+          <a:ln w="12700">
+            <a:solidFill>
+              <a:srgbClr val="FFD166"/>
+            </a:solidFill>
+            <a:prstDash val="solid"/>
+          </a:ln>
+        </p:spPr>
+      </p:sp>
+      <p:sp>
+        <p:nvSpPr>
+          <p:cNvPr id="9" name="Shape 7"/>
+          <p:cNvSpPr/>
+          <p:nvPr/>
+        </p:nvSpPr>
+        <p:spPr>
+          <a:xfrm>
+            <a:off x="274320" y="1051560"/>
+            <a:ext cx="3383280" cy="5394960"/>
+          </a:xfrm>
+          <a:prstGeom prst="roundRect">
+            <a:avLst>
+              <a:gd name="adj" fmla="val 2162"/>
+            </a:avLst>
+          </a:prstGeom>
+          <a:solidFill>
+            <a:srgbClr val="1C1945"/>
+          </a:solidFill>
+          <a:ln w="15240">
+            <a:solidFill>
+              <a:srgbClr val="4ECDC4"/>
+            </a:solidFill>
+            <a:prstDash val="solid"/>
+          </a:ln>
+        </p:spPr>
+      </p:sp>
+      <p:sp>
+        <p:nvSpPr>
+          <p:cNvPr id="10" name="Text 8"/>
+          <p:cNvSpPr/>
+          <p:nvPr/>
+        </p:nvSpPr>
+        <p:spPr>
+          <a:xfrm>
+            <a:off x="274320" y="1051560"/>
+            <a:ext cx="3383280" cy="502920"/>
+          </a:xfrm>
+          <a:prstGeom prst="rect">
+            <a:avLst/>
+          </a:prstGeom>
+          <a:noFill/>
+          <a:ln/>
+        </p:spPr>
+        <p:txBody>
+          <a:bodyPr wrap="square" rtlCol="0" anchor="ctr"/>
+          <a:lstStyle/>
+          <a:p>
+            <a:pPr algn="ctr" indent="0" marL="0">
+              <a:buNone/>
+            </a:pPr>
+            <a:r>
+              <a:rPr lang="en-US" sz="1500" b="1" dirty="0">
+                <a:solidFill>
+                  <a:srgbClr val="4ECDC4"/>
+                </a:solidFill>
+                <a:latin typeface="Calibri" pitchFamily="34" charset="0"/>
+                <a:ea typeface="Calibri" pitchFamily="34" charset="-122"/>
+                <a:cs typeface="Calibri" pitchFamily="34" charset="-120"/>
+              </a:rPr>
+              <a:t>FRONTEND</a:t>
+            </a:r>
+            <a:endParaRPr lang="en-US" sz="1500" dirty="0"/>
+          </a:p>
+        </p:txBody>
+      </p:sp>
+      <p:sp>
+        <p:nvSpPr>
+          <p:cNvPr id="11" name="Text 9"/>
+          <p:cNvSpPr/>
+          <p:nvPr/>
+        </p:nvSpPr>
+        <p:spPr>
+          <a:xfrm>
+            <a:off x="457200" y="1691640"/>
+            <a:ext cx="3017520" cy="658368"/>
+          </a:xfrm>
+          <a:prstGeom prst="rect">
+            <a:avLst/>
+          </a:prstGeom>
+          <a:noFill/>
+          <a:ln/>
+        </p:spPr>
+        <p:txBody>
+          <a:bodyPr wrap="square" rtlCol="0" anchor="ctr"/>
+          <a:lstStyle/>
+          <a:p>
+            <a:pPr algn="ctr" indent="0" marL="0">
+              <a:buNone/>
+            </a:pPr>
+            <a:r>
+              <a:rPr lang="en-US" sz="1400" dirty="0">
+                <a:solidFill>
+                  <a:srgbClr val="E0E7FF"/>
+                </a:solidFill>
+                <a:latin typeface="Calibri" pitchFamily="34" charset="0"/>
+                <a:ea typeface="Calibri" pitchFamily="34" charset="-122"/>
+                <a:cs typeface="Calibri" pitchFamily="34" charset="-120"/>
+              </a:rPr>
+              <a:t>Vanilla JS</a:t>
+            </a:r>
+            <a:endParaRPr lang="en-US" sz="1400" dirty="0"/>
+          </a:p>
+        </p:txBody>
+      </p:sp>
+      <p:sp>
+        <p:nvSpPr>
+          <p:cNvPr id="12" name="Text 10"/>
+          <p:cNvSpPr/>
+          <p:nvPr/>
+        </p:nvSpPr>
+        <p:spPr>
+          <a:xfrm>
+            <a:off x="457200" y="2496312"/>
+            <a:ext cx="3017520" cy="658368"/>
+          </a:xfrm>
+          <a:prstGeom prst="rect">
+            <a:avLst/>
+          </a:prstGeom>
+          <a:noFill/>
+          <a:ln/>
+        </p:spPr>
+        <p:txBody>
+          <a:bodyPr wrap="square" rtlCol="0" anchor="ctr"/>
+          <a:lstStyle/>
+          <a:p>
+            <a:pPr algn="ctr" indent="0" marL="0">
+              <a:buNone/>
+            </a:pPr>
+            <a:r>
+              <a:rPr lang="en-US" sz="1400" dirty="0">
+                <a:solidFill>
+                  <a:srgbClr val="E0E7FF"/>
+                </a:solidFill>
+                <a:latin typeface="Calibri" pitchFamily="34" charset="0"/>
+                <a:ea typeface="Calibri" pitchFamily="34" charset="-122"/>
+                <a:cs typeface="Calibri" pitchFamily="34" charset="-120"/>
+              </a:rPr>
+              <a:t>Leaflet.js 1.9.4</a:t>
+            </a:r>
+            <a:endParaRPr lang="en-US" sz="1400" dirty="0"/>
+          </a:p>
+        </p:txBody>
+      </p:sp>
+      <p:sp>
+        <p:nvSpPr>
+          <p:cNvPr id="13" name="Text 11"/>
+          <p:cNvSpPr/>
+          <p:nvPr/>
+        </p:nvSpPr>
+        <p:spPr>
+          <a:xfrm>
+            <a:off x="457200" y="3300984"/>
+            <a:ext cx="3017520" cy="658368"/>
+          </a:xfrm>
+          <a:prstGeom prst="rect">
+            <a:avLst/>
+          </a:prstGeom>
+          <a:noFill/>
+          <a:ln/>
+        </p:spPr>
+        <p:txBody>
+          <a:bodyPr wrap="square" rtlCol="0" anchor="ctr"/>
+          <a:lstStyle/>
+          <a:p>
+            <a:pPr algn="ctr" indent="0" marL="0">
+              <a:buNone/>
+            </a:pPr>
+            <a:r>
+              <a:rPr lang="en-US" sz="1400" dirty="0">
+                <a:solidFill>
+                  <a:srgbClr val="E0E7FF"/>
+                </a:solidFill>
+                <a:latin typeface="Calibri" pitchFamily="34" charset="0"/>
+                <a:ea typeface="Calibri" pitchFamily="34" charset="-122"/>
+                <a:cs typeface="Calibri" pitchFamily="34" charset="-120"/>
+              </a:rPr>
+              <a:t>HTML / CSS</a:t>
+            </a:r>
+            <a:endParaRPr lang="en-US" sz="1400" dirty="0"/>
+          </a:p>
+        </p:txBody>
+      </p:sp>
+      <p:sp>
+        <p:nvSpPr>
+          <p:cNvPr id="14" name="Text 12"/>
+          <p:cNvSpPr/>
+          <p:nvPr/>
+        </p:nvSpPr>
+        <p:spPr>
+          <a:xfrm>
+            <a:off x="457200" y="4105656"/>
+            <a:ext cx="3017520" cy="658368"/>
+          </a:xfrm>
+          <a:prstGeom prst="rect">
+            <a:avLst/>
+          </a:prstGeom>
+          <a:noFill/>
+          <a:ln/>
+        </p:spPr>
+        <p:txBody>
+          <a:bodyPr wrap="square" rtlCol="0" anchor="ctr"/>
+          <a:lstStyle/>
+          <a:p>
+            <a:pPr algn="ctr" indent="0" marL="0">
+              <a:buNone/>
+            </a:pPr>
+            <a:r>
+              <a:rPr lang="en-US" sz="1400" dirty="0">
+                <a:solidFill>
+                  <a:srgbClr val="E0E7FF"/>
+                </a:solidFill>
+                <a:latin typeface="Calibri" pitchFamily="34" charset="0"/>
+                <a:ea typeface="Calibri" pitchFamily="34" charset="-122"/>
+                <a:cs typeface="Calibri" pitchFamily="34" charset="-120"/>
+              </a:rPr>
+              <a:t>Dark theme UI</a:t>
+            </a:r>
+            <a:endParaRPr lang="en-US" sz="1400" dirty="0"/>
+          </a:p>
+        </p:txBody>
+      </p:sp>
+      <p:sp>
+        <p:nvSpPr>
+          <p:cNvPr id="15" name="Text 13"/>
+          <p:cNvSpPr/>
+          <p:nvPr/>
+        </p:nvSpPr>
+        <p:spPr>
+          <a:xfrm>
+            <a:off x="457200" y="4910328"/>
+            <a:ext cx="3017520" cy="658368"/>
+          </a:xfrm>
+          <a:prstGeom prst="rect">
+            <a:avLst/>
+          </a:prstGeom>
+          <a:noFill/>
+          <a:ln/>
+        </p:spPr>
+        <p:txBody>
+          <a:bodyPr wrap="square" rtlCol="0" anchor="ctr"/>
+          <a:lstStyle/>
+          <a:p>
+            <a:pPr algn="ctr" indent="0" marL="0">
+              <a:buNone/>
+            </a:pPr>
+            <a:r>
+              <a:rPr lang="en-US" sz="1400" dirty="0">
+                <a:solidFill>
+                  <a:srgbClr val="E0E7FF"/>
+                </a:solidFill>
+                <a:latin typeface="Calibri" pitchFamily="34" charset="0"/>
+                <a:ea typeface="Calibri" pitchFamily="34" charset="-122"/>
+                <a:cs typeface="Calibri" pitchFamily="34" charset="-120"/>
+              </a:rPr>
+              <a:t>Hoạt ảnh đồng bộ</a:t>
+            </a:r>
+            <a:endParaRPr lang="en-US" sz="1400" dirty="0"/>
+          </a:p>
+        </p:txBody>
+      </p:sp>
+      <p:sp>
+        <p:nvSpPr>
+          <p:cNvPr id="16" name="Shape 14"/>
+          <p:cNvSpPr/>
+          <p:nvPr/>
+        </p:nvSpPr>
+        <p:spPr>
+          <a:xfrm>
+            <a:off x="3794760" y="3383280"/>
+            <a:ext cx="914400" cy="457200"/>
+          </a:xfrm>
+          <a:prstGeom prst="rightArrow">
+            <a:avLst/>
+          </a:prstGeom>
+          <a:solidFill>
+            <a:srgbClr val="34D399"/>
+          </a:solidFill>
+          <a:ln w="12700">
+            <a:solidFill>
+              <a:srgbClr val="34D399"/>
+            </a:solidFill>
+            <a:prstDash val="solid"/>
+          </a:ln>
+        </p:spPr>
+      </p:sp>
+      <p:sp>
+        <p:nvSpPr>
+          <p:cNvPr id="17" name="Text 15"/>
+          <p:cNvSpPr/>
+          <p:nvPr/>
+        </p:nvSpPr>
+        <p:spPr>
+          <a:xfrm>
+            <a:off x="3794760" y="3886200"/>
+            <a:ext cx="914400" cy="274320"/>
+          </a:xfrm>
+          <a:prstGeom prst="rect">
+            <a:avLst/>
+          </a:prstGeom>
+          <a:noFill/>
+          <a:ln/>
+        </p:spPr>
+        <p:txBody>
+          <a:bodyPr wrap="square" rtlCol="0" anchor="ctr"/>
+          <a:lstStyle/>
+          <a:p>
+            <a:pPr algn="ctr" indent="0" marL="0">
+              <a:buNone/>
+            </a:pPr>
+            <a:r>
+              <a:rPr lang="en-US" sz="1000" dirty="0">
+                <a:solidFill>
+                  <a:srgbClr val="34D399"/>
+                </a:solidFill>
+                <a:latin typeface="Calibri" pitchFamily="34" charset="0"/>
+                <a:ea typeface="Calibri" pitchFamily="34" charset="-122"/>
+                <a:cs typeface="Calibri" pitchFamily="34" charset="-120"/>
+              </a:rPr>
+              <a:t>REST</a:t>
+            </a:r>
+            <a:endParaRPr lang="en-US" sz="1000" dirty="0"/>
+          </a:p>
+        </p:txBody>
+      </p:sp>
+      <p:sp>
+        <p:nvSpPr>
+          <p:cNvPr id="18" name="Shape 16"/>
+          <p:cNvSpPr/>
+          <p:nvPr/>
+        </p:nvSpPr>
+        <p:spPr>
+          <a:xfrm>
+            <a:off x="3794760" y="2834640"/>
+            <a:ext cx="914400" cy="457200"/>
+          </a:xfrm>
+          <a:prstGeom prst="leftArrow">
+            <a:avLst/>
+          </a:prstGeom>
+          <a:solidFill>
+            <a:srgbClr val="6B7AB8"/>
+          </a:solidFill>
+          <a:ln w="12700">
+            <a:solidFill>
+              <a:srgbClr val="6B7AB8"/>
+            </a:solidFill>
+            <a:prstDash val="solid"/>
+          </a:ln>
+        </p:spPr>
+      </p:sp>
+      <p:sp>
+        <p:nvSpPr>
+          <p:cNvPr id="19" name="Text 17"/>
+          <p:cNvSpPr/>
+          <p:nvPr/>
+        </p:nvSpPr>
+        <p:spPr>
+          <a:xfrm>
+            <a:off x="3794760" y="2514600"/>
+            <a:ext cx="914400" cy="274320"/>
+          </a:xfrm>
+          <a:prstGeom prst="rect">
+            <a:avLst/>
+          </a:prstGeom>
+          <a:noFill/>
+          <a:ln/>
+        </p:spPr>
+        <p:txBody>
+          <a:bodyPr wrap="square" rtlCol="0" anchor="ctr"/>
+          <a:lstStyle/>
+          <a:p>
+            <a:pPr algn="ctr" indent="0" marL="0">
+              <a:buNone/>
+            </a:pPr>
+            <a:r>
+              <a:rPr lang="en-US" sz="1000" dirty="0">
+                <a:solidFill>
+                  <a:srgbClr val="6B7AB8"/>
+                </a:solidFill>
+                <a:latin typeface="Calibri" pitchFamily="34" charset="0"/>
+                <a:ea typeface="Calibri" pitchFamily="34" charset="-122"/>
+                <a:cs typeface="Calibri" pitchFamily="34" charset="-120"/>
+              </a:rPr>
+              <a:t>JSON</a:t>
+            </a:r>
+            <a:endParaRPr lang="en-US" sz="1000" dirty="0"/>
+          </a:p>
+        </p:txBody>
+      </p:sp>
+      <p:sp>
+        <p:nvSpPr>
+          <p:cNvPr id="20" name="Shape 18"/>
+          <p:cNvSpPr/>
+          <p:nvPr/>
+        </p:nvSpPr>
+        <p:spPr>
+          <a:xfrm>
+            <a:off x="4846320" y="1051560"/>
+            <a:ext cx="3383280" cy="5394960"/>
+          </a:xfrm>
+          <a:prstGeom prst="roundRect">
+            <a:avLst>
+              <a:gd name="adj" fmla="val 2162"/>
+            </a:avLst>
+          </a:prstGeom>
+          <a:solidFill>
+            <a:srgbClr val="1C1945"/>
+          </a:solidFill>
+          <a:ln w="15240">
+            <a:solidFill>
+              <a:srgbClr val="FFD166"/>
+            </a:solidFill>
+            <a:prstDash val="solid"/>
+          </a:ln>
+        </p:spPr>
+      </p:sp>
+      <p:sp>
+        <p:nvSpPr>
+          <p:cNvPr id="21" name="Text 19"/>
+          <p:cNvSpPr/>
+          <p:nvPr/>
+        </p:nvSpPr>
+        <p:spPr>
+          <a:xfrm>
+            <a:off x="4846320" y="1051560"/>
+            <a:ext cx="3383280" cy="502920"/>
+          </a:xfrm>
+          <a:prstGeom prst="rect">
+            <a:avLst/>
+          </a:prstGeom>
+          <a:noFill/>
+          <a:ln/>
+        </p:spPr>
+        <p:txBody>
+          <a:bodyPr wrap="square" rtlCol="0" anchor="ctr"/>
+          <a:lstStyle/>
+          <a:p>
+            <a:pPr algn="ctr" indent="0" marL="0">
+              <a:buNone/>
+            </a:pPr>
+            <a:r>
+              <a:rPr lang="en-US" sz="1500" b="1" dirty="0">
+                <a:solidFill>
+                  <a:srgbClr val="FFD166"/>
+                </a:solidFill>
+                <a:latin typeface="Calibri" pitchFamily="34" charset="0"/>
+                <a:ea typeface="Calibri" pitchFamily="34" charset="-122"/>
+                <a:cs typeface="Calibri" pitchFamily="34" charset="-120"/>
+              </a:rPr>
+              <a:t>BACKEND</a:t>
+            </a:r>
+            <a:endParaRPr lang="en-US" sz="1500" dirty="0"/>
+          </a:p>
+        </p:txBody>
+      </p:sp>
+      <p:sp>
+        <p:nvSpPr>
+          <p:cNvPr id="22" name="Text 20"/>
+          <p:cNvSpPr/>
+          <p:nvPr/>
+        </p:nvSpPr>
+        <p:spPr>
+          <a:xfrm>
+            <a:off x="5029200" y="1691640"/>
+            <a:ext cx="3017520" cy="658368"/>
+          </a:xfrm>
+          <a:prstGeom prst="rect">
+            <a:avLst/>
+          </a:prstGeom>
+          <a:noFill/>
+          <a:ln/>
+        </p:spPr>
+        <p:txBody>
+          <a:bodyPr wrap="square" rtlCol="0" anchor="ctr"/>
+          <a:lstStyle/>
+          <a:p>
+            <a:pPr algn="ctr" indent="0" marL="0">
+              <a:buNone/>
+            </a:pPr>
+            <a:r>
+              <a:rPr lang="en-US" sz="1400" dirty="0">
+                <a:solidFill>
+                  <a:srgbClr val="E0E7FF"/>
+                </a:solidFill>
+                <a:latin typeface="Calibri" pitchFamily="34" charset="0"/>
+                <a:ea typeface="Calibri" pitchFamily="34" charset="-122"/>
+                <a:cs typeface="Calibri" pitchFamily="34" charset="-120"/>
+              </a:rPr>
+              <a:t>Python 3.x</a:t>
+            </a:r>
+            <a:endParaRPr lang="en-US" sz="1400" dirty="0"/>
+          </a:p>
+        </p:txBody>
+      </p:sp>
+      <p:sp>
+        <p:nvSpPr>
+          <p:cNvPr id="23" name="Text 21"/>
+          <p:cNvSpPr/>
+          <p:nvPr/>
+        </p:nvSpPr>
+        <p:spPr>
+          <a:xfrm>
+            <a:off x="5029200" y="2496312"/>
+            <a:ext cx="3017520" cy="658368"/>
+          </a:xfrm>
+          <a:prstGeom prst="rect">
+            <a:avLst/>
+          </a:prstGeom>
+          <a:noFill/>
+          <a:ln/>
+        </p:spPr>
+        <p:txBody>
+          <a:bodyPr wrap="square" rtlCol="0" anchor="ctr"/>
+          <a:lstStyle/>
+          <a:p>
+            <a:pPr algn="ctr" indent="0" marL="0">
+              <a:buNone/>
+            </a:pPr>
+            <a:r>
+              <a:rPr lang="en-US" sz="1400" dirty="0">
+                <a:solidFill>
+                  <a:srgbClr val="E0E7FF"/>
+                </a:solidFill>
+                <a:latin typeface="Calibri" pitchFamily="34" charset="0"/>
+                <a:ea typeface="Calibri" pitchFamily="34" charset="-122"/>
+                <a:cs typeface="Calibri" pitchFamily="34" charset="-120"/>
+              </a:rPr>
+              <a:t>FastAPI</a:t>
+            </a:r>
+            <a:endParaRPr lang="en-US" sz="1400" dirty="0"/>
+          </a:p>
+        </p:txBody>
+      </p:sp>
+      <p:sp>
+        <p:nvSpPr>
+          <p:cNvPr id="24" name="Text 22"/>
+          <p:cNvSpPr/>
+          <p:nvPr/>
+        </p:nvSpPr>
+        <p:spPr>
+          <a:xfrm>
+            <a:off x="5029200" y="3300984"/>
+            <a:ext cx="3017520" cy="658368"/>
+          </a:xfrm>
+          <a:prstGeom prst="rect">
+            <a:avLst/>
+          </a:prstGeom>
+          <a:noFill/>
+          <a:ln/>
+        </p:spPr>
+        <p:txBody>
+          <a:bodyPr wrap="square" rtlCol="0" anchor="ctr"/>
+          <a:lstStyle/>
+          <a:p>
+            <a:pPr algn="ctr" indent="0" marL="0">
+              <a:buNone/>
+            </a:pPr>
+            <a:r>
+              <a:rPr lang="en-US" sz="1400" dirty="0">
+                <a:solidFill>
+                  <a:srgbClr val="E0E7FF"/>
+                </a:solidFill>
+                <a:latin typeface="Calibri" pitchFamily="34" charset="0"/>
+                <a:ea typeface="Calibri" pitchFamily="34" charset="-122"/>
+                <a:cs typeface="Calibri" pitchFamily="34" charset="-120"/>
+              </a:rPr>
+              <a:t>uvicorn</a:t>
+            </a:r>
+            <a:endParaRPr lang="en-US" sz="1400" dirty="0"/>
+          </a:p>
+        </p:txBody>
+      </p:sp>
+      <p:sp>
+        <p:nvSpPr>
+          <p:cNvPr id="25" name="Text 23"/>
+          <p:cNvSpPr/>
+          <p:nvPr/>
+        </p:nvSpPr>
+        <p:spPr>
+          <a:xfrm>
+            <a:off x="5029200" y="4105656"/>
+            <a:ext cx="3017520" cy="658368"/>
+          </a:xfrm>
+          <a:prstGeom prst="rect">
+            <a:avLst/>
+          </a:prstGeom>
+          <a:noFill/>
+          <a:ln/>
+        </p:spPr>
+        <p:txBody>
+          <a:bodyPr wrap="square" rtlCol="0" anchor="ctr"/>
+          <a:lstStyle/>
+          <a:p>
+            <a:pPr algn="ctr" indent="0" marL="0">
+              <a:buNone/>
+            </a:pPr>
+            <a:r>
+              <a:rPr lang="en-US" sz="1400" dirty="0">
+                <a:solidFill>
+                  <a:srgbClr val="E0E7FF"/>
+                </a:solidFill>
+                <a:latin typeface="Calibri" pitchFamily="34" charset="0"/>
+                <a:ea typeface="Calibri" pitchFamily="34" charset="-122"/>
+                <a:cs typeface="Calibri" pitchFamily="34" charset="-120"/>
+              </a:rPr>
+              <a:t>BFS / DFS</a:t>
+            </a:r>
+            <a:endParaRPr lang="en-US" sz="1400" dirty="0"/>
+          </a:p>
+        </p:txBody>
+      </p:sp>
+      <p:sp>
+        <p:nvSpPr>
+          <p:cNvPr id="26" name="Text 24"/>
+          <p:cNvSpPr/>
+          <p:nvPr/>
+        </p:nvSpPr>
+        <p:spPr>
+          <a:xfrm>
+            <a:off x="5029200" y="4910328"/>
+            <a:ext cx="3017520" cy="658368"/>
+          </a:xfrm>
+          <a:prstGeom prst="rect">
+            <a:avLst/>
+          </a:prstGeom>
+          <a:noFill/>
+          <a:ln/>
+        </p:spPr>
+        <p:txBody>
+          <a:bodyPr wrap="square" rtlCol="0" anchor="ctr"/>
+          <a:lstStyle/>
+          <a:p>
+            <a:pPr algn="ctr" indent="0" marL="0">
+              <a:buNone/>
+            </a:pPr>
+            <a:r>
+              <a:rPr lang="en-US" sz="1400" dirty="0">
+                <a:solidFill>
+                  <a:srgbClr val="E0E7FF"/>
+                </a:solidFill>
+                <a:latin typeface="Calibri" pitchFamily="34" charset="0"/>
+                <a:ea typeface="Calibri" pitchFamily="34" charset="-122"/>
+                <a:cs typeface="Calibri" pitchFamily="34" charset="-120"/>
+              </a:rPr>
+              <a:t>Dijkstra / A*</a:t>
+            </a:r>
+            <a:endParaRPr lang="en-US" sz="1400" dirty="0"/>
+          </a:p>
+        </p:txBody>
+      </p:sp>
+      <p:sp>
+        <p:nvSpPr>
+          <p:cNvPr id="27" name="Shape 25"/>
+          <p:cNvSpPr/>
+          <p:nvPr/>
+        </p:nvSpPr>
+        <p:spPr>
+          <a:xfrm>
+            <a:off x="8366760" y="3566160"/>
+            <a:ext cx="640080" cy="411480"/>
+          </a:xfrm>
+          <a:prstGeom prst="rightArrow">
+            <a:avLst/>
+          </a:prstGeom>
+          <a:solidFill>
+            <a:srgbClr val="06D6A0"/>
+          </a:solidFill>
+          <a:ln w="12700">
+            <a:solidFill>
+              <a:srgbClr val="06D6A0"/>
+            </a:solidFill>
+            <a:prstDash val="solid"/>
+          </a:ln>
+        </p:spPr>
+      </p:sp>
+      <p:sp>
+        <p:nvSpPr>
+          <p:cNvPr id="28" name="Shape 26"/>
+          <p:cNvSpPr/>
+          <p:nvPr/>
+        </p:nvSpPr>
+        <p:spPr>
+          <a:xfrm>
+            <a:off x="9098280" y="1051560"/>
+            <a:ext cx="2788920" cy="5394960"/>
+          </a:xfrm>
+          <a:prstGeom prst="roundRect">
+            <a:avLst>
+              <a:gd name="adj" fmla="val 2623"/>
+            </a:avLst>
+          </a:prstGeom>
+          <a:solidFill>
+            <a:srgbClr val="1C1945"/>
+          </a:solidFill>
+          <a:ln w="15240">
+            <a:solidFill>
+              <a:srgbClr val="06D6A0"/>
+            </a:solidFill>
+            <a:prstDash val="solid"/>
+          </a:ln>
+        </p:spPr>
+      </p:sp>
+      <p:sp>
+        <p:nvSpPr>
+          <p:cNvPr id="29" name="Text 27"/>
+          <p:cNvSpPr/>
+          <p:nvPr/>
+        </p:nvSpPr>
+        <p:spPr>
+          <a:xfrm>
+            <a:off x="9098280" y="1051560"/>
+            <a:ext cx="2788920" cy="502920"/>
+          </a:xfrm>
+          <a:prstGeom prst="rect">
+            <a:avLst/>
+          </a:prstGeom>
+          <a:noFill/>
+          <a:ln/>
+        </p:spPr>
+        <p:txBody>
+          <a:bodyPr wrap="square" rtlCol="0" anchor="ctr"/>
+          <a:lstStyle/>
+          <a:p>
+            <a:pPr algn="ctr" indent="0" marL="0">
+              <a:buNone/>
+            </a:pPr>
+            <a:r>
+              <a:rPr lang="en-US" sz="1500" b="1" dirty="0">
+                <a:solidFill>
+                  <a:srgbClr val="06D6A0"/>
+                </a:solidFill>
+                <a:latin typeface="Calibri" pitchFamily="34" charset="0"/>
+                <a:ea typeface="Calibri" pitchFamily="34" charset="-122"/>
+                <a:cs typeface="Calibri" pitchFamily="34" charset="-120"/>
+              </a:rPr>
+              <a:t>DỮ LIỆU</a:t>
+            </a:r>
+            <a:endParaRPr lang="en-US" sz="1500" dirty="0"/>
+          </a:p>
+        </p:txBody>
+      </p:sp>
+      <p:sp>
+        <p:nvSpPr>
+          <p:cNvPr id="30" name="Text 28"/>
+          <p:cNvSpPr/>
+          <p:nvPr/>
+        </p:nvSpPr>
+        <p:spPr>
+          <a:xfrm>
+            <a:off x="9098280" y="1691640"/>
+            <a:ext cx="2788920" cy="658368"/>
+          </a:xfrm>
+          <a:prstGeom prst="rect">
+            <a:avLst/>
+          </a:prstGeom>
+          <a:noFill/>
+          <a:ln/>
+        </p:spPr>
+        <p:txBody>
+          <a:bodyPr wrap="square" rtlCol="0" anchor="ctr"/>
+          <a:lstStyle/>
+          <a:p>
+            <a:pPr algn="ctr" indent="0" marL="0">
+              <a:buNone/>
+            </a:pPr>
+            <a:r>
+              <a:rPr lang="en-US" sz="1400" dirty="0">
+                <a:solidFill>
+                  <a:srgbClr val="E0E7FF"/>
+                </a:solidFill>
+                <a:latin typeface="Calibri" pitchFamily="34" charset="0"/>
+                <a:ea typeface="Calibri" pitchFamily="34" charset="-122"/>
+                <a:cs typeface="Calibri" pitchFamily="34" charset="-120"/>
+              </a:rPr>
+              <a:t>nodes.json</a:t>
+            </a:r>
+            <a:endParaRPr lang="en-US" sz="1400" dirty="0"/>
+          </a:p>
+        </p:txBody>
+      </p:sp>
+      <p:sp>
+        <p:nvSpPr>
+          <p:cNvPr id="31" name="Text 29"/>
+          <p:cNvSpPr/>
+          <p:nvPr/>
+        </p:nvSpPr>
+        <p:spPr>
+          <a:xfrm>
+            <a:off x="9098280" y="2496312"/>
+            <a:ext cx="2788920" cy="658368"/>
+          </a:xfrm>
+          <a:prstGeom prst="rect">
+            <a:avLst/>
+          </a:prstGeom>
+          <a:noFill/>
+          <a:ln/>
+        </p:spPr>
+        <p:txBody>
+          <a:bodyPr wrap="square" rtlCol="0" anchor="ctr"/>
+          <a:lstStyle/>
+          <a:p>
+            <a:pPr algn="ctr" indent="0" marL="0">
+              <a:buNone/>
+            </a:pPr>
+            <a:r>
+              <a:rPr lang="en-US" sz="1400" dirty="0">
+                <a:solidFill>
+                  <a:srgbClr val="E0E7FF"/>
+                </a:solidFill>
+                <a:latin typeface="Calibri" pitchFamily="34" charset="0"/>
+                <a:ea typeface="Calibri" pitchFamily="34" charset="-122"/>
+                <a:cs typeface="Calibri" pitchFamily="34" charset="-120"/>
+              </a:rPr>
+              <a:t>1 007 nút</a:t>
+            </a:r>
+            <a:endParaRPr lang="en-US" sz="1400" dirty="0"/>
+          </a:p>
+        </p:txBody>
+      </p:sp>
+      <p:sp>
+        <p:nvSpPr>
+          <p:cNvPr id="32" name="Text 30"/>
+          <p:cNvSpPr/>
+          <p:nvPr/>
+        </p:nvSpPr>
+        <p:spPr>
+          <a:xfrm>
+            <a:off x="9098280" y="3300984"/>
+            <a:ext cx="2788920" cy="658368"/>
+          </a:xfrm>
+          <a:prstGeom prst="rect">
+            <a:avLst/>
+          </a:prstGeom>
+          <a:noFill/>
+          <a:ln/>
+        </p:spPr>
+        <p:txBody>
+          <a:bodyPr wrap="square" rtlCol="0" anchor="ctr"/>
+          <a:lstStyle/>
+          <a:p>
+            <a:pPr algn="ctr" indent="0" marL="0">
+              <a:buNone/>
+            </a:pPr>
+            <a:r>
+              <a:rPr lang="en-US" sz="1400" dirty="0">
+                <a:solidFill>
+                  <a:srgbClr val="E0E7FF"/>
+                </a:solidFill>
+                <a:latin typeface="Calibri" pitchFamily="34" charset="0"/>
+                <a:ea typeface="Calibri" pitchFamily="34" charset="-122"/>
+                <a:cs typeface="Calibri" pitchFamily="34" charset="-120"/>
+              </a:rPr>
+              <a:t>edges.json</a:t>
+            </a:r>
+            <a:endParaRPr lang="en-US" sz="1400" dirty="0"/>
+          </a:p>
+        </p:txBody>
+      </p:sp>
+      <p:sp>
+        <p:nvSpPr>
+          <p:cNvPr id="33" name="Text 31"/>
+          <p:cNvSpPr/>
+          <p:nvPr/>
+        </p:nvSpPr>
+        <p:spPr>
+          <a:xfrm>
+            <a:off x="9098280" y="4105656"/>
+            <a:ext cx="2788920" cy="658368"/>
+          </a:xfrm>
+          <a:prstGeom prst="rect">
+            <a:avLst/>
+          </a:prstGeom>
+          <a:noFill/>
+          <a:ln/>
+        </p:spPr>
+        <p:txBody>
+          <a:bodyPr wrap="square" rtlCol="0" anchor="ctr"/>
+          <a:lstStyle/>
+          <a:p>
+            <a:pPr algn="ctr" indent="0" marL="0">
+              <a:buNone/>
+            </a:pPr>
+            <a:r>
+              <a:rPr lang="en-US" sz="1400" dirty="0">
+                <a:solidFill>
+                  <a:srgbClr val="E0E7FF"/>
+                </a:solidFill>
+                <a:latin typeface="Calibri" pitchFamily="34" charset="0"/>
+                <a:ea typeface="Calibri" pitchFamily="34" charset="-122"/>
+                <a:cs typeface="Calibri" pitchFamily="34" charset="-120"/>
+              </a:rPr>
+              <a:t>2 644 cạnh</a:t>
+            </a:r>
+            <a:endParaRPr lang="en-US" sz="1400" dirty="0"/>
+          </a:p>
+        </p:txBody>
+      </p:sp>
+      <p:sp>
+        <p:nvSpPr>
+          <p:cNvPr id="34" name="Text 32"/>
+          <p:cNvSpPr/>
+          <p:nvPr/>
+        </p:nvSpPr>
+        <p:spPr>
+          <a:xfrm>
+            <a:off x="9098280" y="4910328"/>
+            <a:ext cx="2788920" cy="658368"/>
+          </a:xfrm>
+          <a:prstGeom prst="rect">
+            <a:avLst/>
+          </a:prstGeom>
+          <a:noFill/>
+          <a:ln/>
+        </p:spPr>
+        <p:txBody>
+          <a:bodyPr wrap="square" rtlCol="0" anchor="ctr"/>
+          <a:lstStyle/>
+          <a:p>
+            <a:pPr algn="ctr" indent="0" marL="0">
+              <a:buNone/>
+            </a:pPr>
+            <a:r>
+              <a:rPr lang="en-US" sz="1400" dirty="0">
+                <a:solidFill>
+                  <a:srgbClr val="E0E7FF"/>
+                </a:solidFill>
+                <a:latin typeface="Calibri" pitchFamily="34" charset="0"/>
+                <a:ea typeface="Calibri" pitchFamily="34" charset="-122"/>
+                <a:cs typeface="Calibri" pitchFamily="34" charset="-120"/>
+              </a:rPr>
+              <a:t>osmnx export</a:t>
+            </a:r>
+            <a:endParaRPr lang="en-US" sz="1400" dirty="0"/>
           </a:p>
         </p:txBody>
       </p:sp>

</xml_diff>

<commit_message>
feat: slide 5-6 thuật toán BFS/DFS và Dijkstra/A*
</commit_message>
<xml_diff>
--- a/ThuyetTrinh_PathFinderAI.pptx
+++ b/ThuyetTrinh_PathFinderAI.pptx
@@ -9,9 +9,11 @@
     <p:sldId id="257" r:id="rId3"/>
     <p:sldId id="258" r:id="rId4"/>
     <p:sldId id="259" r:id="rId5"/>
+    <p:sldId id="260" r:id="rId6"/>
+    <p:sldId id="261" r:id="rId7"/>
   </p:sldIdLst>
   <p:notesMasterIdLst>
-    <p:notesMasterId r:id="rId6"/>
+    <p:notesMasterId r:id="rId8"/>
   </p:notesMasterIdLst>
   <p:sldSz cx="12192000" cy="6858000"/>
   <p:notesSz cx="6858000" cy="12192000"/>
@@ -811,6 +813,182 @@
 </p:notes>
 </file>
 
+<file path=ppt/notesSlides/notesSlide5.xml><?xml version="1.0" encoding="utf-8"?>
+<p:notes xmlns:a="http://schemas.openxmlformats.org/drawingml/2006/main" xmlns:r="http://schemas.openxmlformats.org/officeDocument/2006/relationships" xmlns:p="http://schemas.openxmlformats.org/presentationml/2006/main">
+  <p:cSld>
+    <p:spTree>
+      <p:nvGrpSpPr>
+        <p:cNvPr id="1" name=""/>
+        <p:cNvGrpSpPr/>
+        <p:nvPr/>
+      </p:nvGrpSpPr>
+      <p:grpSpPr>
+        <a:xfrm>
+          <a:off x="0" y="0"/>
+          <a:ext cx="0" cy="0"/>
+          <a:chOff x="0" y="0"/>
+          <a:chExt cx="0" cy="0"/>
+        </a:xfrm>
+      </p:grpSpPr>
+      <p:sp>
+        <p:nvSpPr>
+          <p:cNvPr id="2" name="Slide Image Placeholder 1"/>
+          <p:cNvSpPr>
+            <a:spLocks noGrp="1" noRot="1" noChangeAspect="1"/>
+          </p:cNvSpPr>
+          <p:nvPr>
+            <p:ph type="sldImg"/>
+          </p:nvPr>
+        </p:nvSpPr>
+        <p:spPr/>
+      </p:sp>
+      <p:sp>
+        <p:nvSpPr>
+          <p:cNvPr id="3" name="Notes Placeholder 2"/>
+          <p:cNvSpPr>
+            <a:spLocks noGrp="1"/>
+          </p:cNvSpPr>
+          <p:nvPr>
+            <p:ph type="body" idx="1"/>
+          </p:nvPr>
+        </p:nvSpPr>
+        <p:spPr/>
+        <p:txBody>
+          <a:bodyPr/>
+          <a:lstStyle/>
+          <a:p>
+            <a:r>
+              <a:rPr lang="en-US" dirty="0"/>
+              <a:t/>
+            </a:r>
+            <a:endParaRPr lang="en-US" dirty="0"/>
+          </a:p>
+        </p:txBody>
+      </p:sp>
+      <p:sp>
+        <p:nvSpPr>
+          <p:cNvPr id="4" name="Slide Number Placeholder 3"/>
+          <p:cNvSpPr>
+            <a:spLocks noGrp="1"/>
+          </p:cNvSpPr>
+          <p:nvPr>
+            <p:ph type="sldNum" sz="quarter" idx="10"/>
+          </p:nvPr>
+        </p:nvSpPr>
+        <p:spPr/>
+        <p:txBody>
+          <a:bodyPr/>
+          <a:lstStyle/>
+          <a:p>
+            <a:fld id="{F7021451-1387-4CA6-816F-3879F97B5CBC}" type="slidenum">
+              <a:rPr lang="en-US"/>
+              <a:t>5</a:t>
+            </a:fld>
+            <a:endParaRPr lang="en-US"/>
+          </a:p>
+        </p:txBody>
+      </p:sp>
+    </p:spTree>
+    <p:extLst>
+      <p:ext uri="{BB962C8B-B14F-4D97-AF65-F5344CB8AC3E}">
+        <p14:creationId xmlns:p14="http://schemas.microsoft.com/office/powerpoint/2010/main" val="1024086991"/>
+      </p:ext>
+    </p:extLst>
+  </p:cSld>
+  <p:clrMapOvr>
+    <a:masterClrMapping/>
+  </p:clrMapOvr>
+</p:notes>
+</file>
+
+<file path=ppt/notesSlides/notesSlide6.xml><?xml version="1.0" encoding="utf-8"?>
+<p:notes xmlns:a="http://schemas.openxmlformats.org/drawingml/2006/main" xmlns:r="http://schemas.openxmlformats.org/officeDocument/2006/relationships" xmlns:p="http://schemas.openxmlformats.org/presentationml/2006/main">
+  <p:cSld>
+    <p:spTree>
+      <p:nvGrpSpPr>
+        <p:cNvPr id="1" name=""/>
+        <p:cNvGrpSpPr/>
+        <p:nvPr/>
+      </p:nvGrpSpPr>
+      <p:grpSpPr>
+        <a:xfrm>
+          <a:off x="0" y="0"/>
+          <a:ext cx="0" cy="0"/>
+          <a:chOff x="0" y="0"/>
+          <a:chExt cx="0" cy="0"/>
+        </a:xfrm>
+      </p:grpSpPr>
+      <p:sp>
+        <p:nvSpPr>
+          <p:cNvPr id="2" name="Slide Image Placeholder 1"/>
+          <p:cNvSpPr>
+            <a:spLocks noGrp="1" noRot="1" noChangeAspect="1"/>
+          </p:cNvSpPr>
+          <p:nvPr>
+            <p:ph type="sldImg"/>
+          </p:nvPr>
+        </p:nvSpPr>
+        <p:spPr/>
+      </p:sp>
+      <p:sp>
+        <p:nvSpPr>
+          <p:cNvPr id="3" name="Notes Placeholder 2"/>
+          <p:cNvSpPr>
+            <a:spLocks noGrp="1"/>
+          </p:cNvSpPr>
+          <p:nvPr>
+            <p:ph type="body" idx="1"/>
+          </p:nvPr>
+        </p:nvSpPr>
+        <p:spPr/>
+        <p:txBody>
+          <a:bodyPr/>
+          <a:lstStyle/>
+          <a:p>
+            <a:r>
+              <a:rPr lang="en-US" dirty="0"/>
+              <a:t/>
+            </a:r>
+            <a:endParaRPr lang="en-US" dirty="0"/>
+          </a:p>
+        </p:txBody>
+      </p:sp>
+      <p:sp>
+        <p:nvSpPr>
+          <p:cNvPr id="4" name="Slide Number Placeholder 3"/>
+          <p:cNvSpPr>
+            <a:spLocks noGrp="1"/>
+          </p:cNvSpPr>
+          <p:nvPr>
+            <p:ph type="sldNum" sz="quarter" idx="10"/>
+          </p:nvPr>
+        </p:nvSpPr>
+        <p:spPr/>
+        <p:txBody>
+          <a:bodyPr/>
+          <a:lstStyle/>
+          <a:p>
+            <a:fld id="{F7021451-1387-4CA6-816F-3879F97B5CBC}" type="slidenum">
+              <a:rPr lang="en-US"/>
+              <a:t>6</a:t>
+            </a:fld>
+            <a:endParaRPr lang="en-US"/>
+          </a:p>
+        </p:txBody>
+      </p:sp>
+    </p:spTree>
+    <p:extLst>
+      <p:ext uri="{BB962C8B-B14F-4D97-AF65-F5344CB8AC3E}">
+        <p14:creationId xmlns:p14="http://schemas.microsoft.com/office/powerpoint/2010/main" val="1024086991"/>
+      </p:ext>
+    </p:extLst>
+  </p:cSld>
+  <p:clrMapOvr>
+    <a:masterClrMapping/>
+  </p:clrMapOvr>
+</p:notes>
+</file>
+
 <file path=ppt/slideLayouts/slideLayout1.xml><?xml version="1.0" encoding="utf-8"?>
 <p:sldLayout xmlns:a="http://schemas.openxmlformats.org/drawingml/2006/main" xmlns:r="http://schemas.openxmlformats.org/officeDocument/2006/relationships" xmlns:p="http://schemas.openxmlformats.org/presentationml/2006/main" preserve="1">
   <p:cSld name="DEFAULT">
@@ -5170,6 +5348,1820 @@
               <a:t>osmnx export</a:t>
             </a:r>
             <a:endParaRPr lang="en-US" sz="1400" dirty="0"/>
+          </a:p>
+        </p:txBody>
+      </p:sp>
+    </p:spTree>
+  </p:cSld>
+  <p:clrMapOvr>
+    <a:masterClrMapping/>
+  </p:clrMapOvr>
+</p:sld>
+</file>
+
+<file path=ppt/slides/slide5.xml><?xml version="1.0" encoding="utf-8"?>
+<p:sld xmlns:a="http://schemas.openxmlformats.org/drawingml/2006/main" xmlns:r="http://schemas.openxmlformats.org/officeDocument/2006/relationships" xmlns:p="http://schemas.openxmlformats.org/presentationml/2006/main">
+  <p:cSld name="Slide 5">
+    <p:spTree>
+      <p:nvGrpSpPr>
+        <p:cNvPr id="1" name=""/>
+        <p:cNvGrpSpPr/>
+        <p:nvPr/>
+      </p:nvGrpSpPr>
+      <p:grpSpPr>
+        <a:xfrm>
+          <a:off x="0" y="0"/>
+          <a:ext cx="0" cy="0"/>
+          <a:chOff x="0" y="0"/>
+          <a:chExt cx="0" cy="0"/>
+        </a:xfrm>
+      </p:grpSpPr>
+      <p:sp>
+        <p:nvSpPr>
+          <p:cNvPr id="2" name="Shape 0"/>
+          <p:cNvSpPr/>
+          <p:nvPr/>
+        </p:nvSpPr>
+        <p:spPr>
+          <a:xfrm>
+            <a:off x="0" y="0"/>
+            <a:ext cx="12188952" cy="6858000"/>
+          </a:xfrm>
+          <a:prstGeom prst="rect">
+            <a:avLst/>
+          </a:prstGeom>
+          <a:solidFill>
+            <a:srgbClr val="0F0C29"/>
+          </a:solidFill>
+          <a:ln w="12700">
+            <a:solidFill>
+              <a:srgbClr val="0F0C29"/>
+            </a:solidFill>
+            <a:prstDash val="solid"/>
+          </a:ln>
+        </p:spPr>
+      </p:sp>
+      <p:sp>
+        <p:nvSpPr>
+          <p:cNvPr id="3" name="Shape 1"/>
+          <p:cNvSpPr/>
+          <p:nvPr/>
+        </p:nvSpPr>
+        <p:spPr>
+          <a:xfrm>
+            <a:off x="0" y="0"/>
+            <a:ext cx="12188952" cy="4114800"/>
+          </a:xfrm>
+          <a:prstGeom prst="rect">
+            <a:avLst/>
+          </a:prstGeom>
+          <a:solidFill>
+            <a:srgbClr val="1E1B4B">
+              <a:alpha val="70000"/>
+            </a:srgbClr>
+          </a:solidFill>
+          <a:ln w="12700">
+            <a:solidFill>
+              <a:srgbClr val="1E1B4B">
+                <a:alpha val="70000"/>
+              </a:srgbClr>
+            </a:solidFill>
+            <a:prstDash val="solid"/>
+          </a:ln>
+        </p:spPr>
+      </p:sp>
+      <p:sp>
+        <p:nvSpPr>
+          <p:cNvPr id="4" name="Shape 2"/>
+          <p:cNvSpPr/>
+          <p:nvPr/>
+        </p:nvSpPr>
+        <p:spPr>
+          <a:xfrm>
+            <a:off x="5486400" y="0"/>
+            <a:ext cx="6702552" cy="6858000"/>
+          </a:xfrm>
+          <a:prstGeom prst="rect">
+            <a:avLst/>
+          </a:prstGeom>
+          <a:solidFill>
+            <a:srgbClr val="312E81">
+              <a:alpha val="50000"/>
+            </a:srgbClr>
+          </a:solidFill>
+          <a:ln w="12700">
+            <a:solidFill>
+              <a:srgbClr val="312E81">
+                <a:alpha val="50000"/>
+              </a:srgbClr>
+            </a:solidFill>
+            <a:prstDash val="solid"/>
+          </a:ln>
+        </p:spPr>
+      </p:sp>
+      <p:sp>
+        <p:nvSpPr>
+          <p:cNvPr id="5" name="Shape 3"/>
+          <p:cNvSpPr/>
+          <p:nvPr/>
+        </p:nvSpPr>
+        <p:spPr>
+          <a:xfrm>
+            <a:off x="0" y="0"/>
+            <a:ext cx="54864" cy="3429000"/>
+          </a:xfrm>
+          <a:prstGeom prst="rect">
+            <a:avLst/>
+          </a:prstGeom>
+          <a:solidFill>
+            <a:srgbClr val="818CF8"/>
+          </a:solidFill>
+          <a:ln w="12700">
+            <a:solidFill>
+              <a:srgbClr val="818CF8"/>
+            </a:solidFill>
+            <a:prstDash val="solid"/>
+          </a:ln>
+        </p:spPr>
+      </p:sp>
+      <p:sp>
+        <p:nvSpPr>
+          <p:cNvPr id="6" name="Shape 4"/>
+          <p:cNvSpPr/>
+          <p:nvPr/>
+        </p:nvSpPr>
+        <p:spPr>
+          <a:xfrm>
+            <a:off x="0" y="3429000"/>
+            <a:ext cx="54864" cy="3429000"/>
+          </a:xfrm>
+          <a:prstGeom prst="rect">
+            <a:avLst/>
+          </a:prstGeom>
+          <a:solidFill>
+            <a:srgbClr val="34D399"/>
+          </a:solidFill>
+          <a:ln w="12700">
+            <a:solidFill>
+              <a:srgbClr val="34D399"/>
+            </a:solidFill>
+            <a:prstDash val="solid"/>
+          </a:ln>
+        </p:spPr>
+      </p:sp>
+      <p:sp>
+        <p:nvSpPr>
+          <p:cNvPr id="7" name="Text 5"/>
+          <p:cNvSpPr/>
+          <p:nvPr/>
+        </p:nvSpPr>
+        <p:spPr>
+          <a:xfrm>
+            <a:off x="365760" y="274320"/>
+            <a:ext cx="11430000" cy="548640"/>
+          </a:xfrm>
+          <a:prstGeom prst="rect">
+            <a:avLst/>
+          </a:prstGeom>
+          <a:noFill/>
+          <a:ln/>
+        </p:spPr>
+        <p:txBody>
+          <a:bodyPr wrap="square" rtlCol="0" anchor="ctr"/>
+          <a:lstStyle/>
+          <a:p>
+            <a:pPr algn="l" indent="0" marL="0">
+              <a:buNone/>
+            </a:pPr>
+            <a:r>
+              <a:rPr lang="en-US" sz="2600" b="1" dirty="0">
+                <a:solidFill>
+                  <a:srgbClr val="4ECDC4"/>
+                </a:solidFill>
+                <a:latin typeface="Calibri" pitchFamily="34" charset="0"/>
+                <a:ea typeface="Calibri" pitchFamily="34" charset="-122"/>
+                <a:cs typeface="Calibri" pitchFamily="34" charset="-120"/>
+              </a:rPr>
+              <a:t>03. Thuật Toán — BFS &amp; DFS</a:t>
+            </a:r>
+            <a:endParaRPr lang="en-US" sz="2600" dirty="0"/>
+          </a:p>
+        </p:txBody>
+      </p:sp>
+      <p:sp>
+        <p:nvSpPr>
+          <p:cNvPr id="8" name="Shape 6"/>
+          <p:cNvSpPr/>
+          <p:nvPr/>
+        </p:nvSpPr>
+        <p:spPr>
+          <a:xfrm>
+            <a:off x="365760" y="868680"/>
+            <a:ext cx="11430000" cy="27432"/>
+          </a:xfrm>
+          <a:prstGeom prst="rect">
+            <a:avLst/>
+          </a:prstGeom>
+          <a:solidFill>
+            <a:srgbClr val="4ECDC4"/>
+          </a:solidFill>
+          <a:ln w="12700">
+            <a:solidFill>
+              <a:srgbClr val="4ECDC4"/>
+            </a:solidFill>
+            <a:prstDash val="solid"/>
+          </a:ln>
+        </p:spPr>
+      </p:sp>
+      <p:sp>
+        <p:nvSpPr>
+          <p:cNvPr id="9" name="Shape 7"/>
+          <p:cNvSpPr/>
+          <p:nvPr/>
+        </p:nvSpPr>
+        <p:spPr>
+          <a:xfrm>
+            <a:off x="320040" y="1051560"/>
+            <a:ext cx="5440680" cy="5394960"/>
+          </a:xfrm>
+          <a:prstGeom prst="roundRect">
+            <a:avLst>
+              <a:gd name="adj" fmla="val 1356"/>
+            </a:avLst>
+          </a:prstGeom>
+          <a:solidFill>
+            <a:srgbClr val="1C1945"/>
+          </a:solidFill>
+          <a:ln w="15240">
+            <a:solidFill>
+              <a:srgbClr val="4ECDC4"/>
+            </a:solidFill>
+            <a:prstDash val="solid"/>
+          </a:ln>
+        </p:spPr>
+      </p:sp>
+      <p:sp>
+        <p:nvSpPr>
+          <p:cNvPr id="10" name="Shape 8"/>
+          <p:cNvSpPr/>
+          <p:nvPr/>
+        </p:nvSpPr>
+        <p:spPr>
+          <a:xfrm>
+            <a:off x="320040" y="1051560"/>
+            <a:ext cx="5440680" cy="548640"/>
+          </a:xfrm>
+          <a:prstGeom prst="roundRect">
+            <a:avLst>
+              <a:gd name="adj" fmla="val 13333"/>
+            </a:avLst>
+          </a:prstGeom>
+          <a:solidFill>
+            <a:srgbClr val="4ECDC4">
+              <a:alpha val="25000"/>
+            </a:srgbClr>
+          </a:solidFill>
+          <a:ln w="12700">
+            <a:solidFill>
+              <a:srgbClr val="4ECDC4"/>
+            </a:solidFill>
+            <a:prstDash val="solid"/>
+          </a:ln>
+        </p:spPr>
+      </p:sp>
+      <p:sp>
+        <p:nvSpPr>
+          <p:cNvPr id="11" name="Text 9"/>
+          <p:cNvSpPr/>
+          <p:nvPr/>
+        </p:nvSpPr>
+        <p:spPr>
+          <a:xfrm>
+            <a:off x="320040" y="1051560"/>
+            <a:ext cx="5440680" cy="548640"/>
+          </a:xfrm>
+          <a:prstGeom prst="rect">
+            <a:avLst/>
+          </a:prstGeom>
+          <a:noFill/>
+          <a:ln/>
+        </p:spPr>
+        <p:txBody>
+          <a:bodyPr wrap="square" rtlCol="0" anchor="ctr"/>
+          <a:lstStyle/>
+          <a:p>
+            <a:pPr algn="ctr" indent="0" marL="0">
+              <a:buNone/>
+            </a:pPr>
+            <a:r>
+              <a:rPr lang="en-US" sz="1700" b="1" dirty="0">
+                <a:solidFill>
+                  <a:srgbClr val="4ECDC4"/>
+                </a:solidFill>
+                <a:latin typeface="Calibri" pitchFamily="34" charset="0"/>
+                <a:ea typeface="Calibri" pitchFamily="34" charset="-122"/>
+                <a:cs typeface="Calibri" pitchFamily="34" charset="-120"/>
+              </a:rPr>
+              <a:t>BFS  Breadth-First Search</a:t>
+            </a:r>
+            <a:endParaRPr lang="en-US" sz="1700" dirty="0"/>
+          </a:p>
+        </p:txBody>
+      </p:sp>
+      <p:sp>
+        <p:nvSpPr>
+          <p:cNvPr id="12" name="Text 10"/>
+          <p:cNvSpPr/>
+          <p:nvPr/>
+        </p:nvSpPr>
+        <p:spPr>
+          <a:xfrm>
+            <a:off x="548640" y="1783080"/>
+            <a:ext cx="4983480" cy="594360"/>
+          </a:xfrm>
+          <a:prstGeom prst="rect">
+            <a:avLst/>
+          </a:prstGeom>
+          <a:noFill/>
+          <a:ln/>
+        </p:spPr>
+        <p:txBody>
+          <a:bodyPr wrap="square" rtlCol="0" anchor="ctr"/>
+          <a:lstStyle/>
+          <a:p>
+            <a:pPr indent="0" marL="0">
+              <a:buNone/>
+            </a:pPr>
+            <a:r>
+              <a:rPr lang="en-US" sz="1500" dirty="0">
+                <a:solidFill>
+                  <a:srgbClr val="E0E7FF"/>
+                </a:solidFill>
+                <a:latin typeface="Calibri" pitchFamily="34" charset="0"/>
+                <a:ea typeface="Calibri" pitchFamily="34" charset="-122"/>
+                <a:cs typeface="Calibri" pitchFamily="34" charset="-120"/>
+              </a:rPr>
+              <a:t>•  Duyệt theo chiều rộng</a:t>
+            </a:r>
+            <a:endParaRPr lang="en-US" sz="1500" dirty="0"/>
+          </a:p>
+        </p:txBody>
+      </p:sp>
+      <p:sp>
+        <p:nvSpPr>
+          <p:cNvPr id="13" name="Text 11"/>
+          <p:cNvSpPr/>
+          <p:nvPr/>
+        </p:nvSpPr>
+        <p:spPr>
+          <a:xfrm>
+            <a:off x="548640" y="2496312"/>
+            <a:ext cx="4983480" cy="594360"/>
+          </a:xfrm>
+          <a:prstGeom prst="rect">
+            <a:avLst/>
+          </a:prstGeom>
+          <a:noFill/>
+          <a:ln/>
+        </p:spPr>
+        <p:txBody>
+          <a:bodyPr wrap="square" rtlCol="0" anchor="ctr"/>
+          <a:lstStyle/>
+          <a:p>
+            <a:pPr indent="0" marL="0">
+              <a:buNone/>
+            </a:pPr>
+            <a:r>
+              <a:rPr lang="en-US" sz="1500" dirty="0">
+                <a:solidFill>
+                  <a:srgbClr val="E0E7FF"/>
+                </a:solidFill>
+                <a:latin typeface="Calibri" pitchFamily="34" charset="0"/>
+                <a:ea typeface="Calibri" pitchFamily="34" charset="-122"/>
+                <a:cs typeface="Calibri" pitchFamily="34" charset="-120"/>
+              </a:rPr>
+              <a:t>•  Hàng đợi (Queue)</a:t>
+            </a:r>
+            <a:endParaRPr lang="en-US" sz="1500" dirty="0"/>
+          </a:p>
+        </p:txBody>
+      </p:sp>
+      <p:sp>
+        <p:nvSpPr>
+          <p:cNvPr id="14" name="Text 12"/>
+          <p:cNvSpPr/>
+          <p:nvPr/>
+        </p:nvSpPr>
+        <p:spPr>
+          <a:xfrm>
+            <a:off x="548640" y="3209544"/>
+            <a:ext cx="4983480" cy="594360"/>
+          </a:xfrm>
+          <a:prstGeom prst="rect">
+            <a:avLst/>
+          </a:prstGeom>
+          <a:noFill/>
+          <a:ln/>
+        </p:spPr>
+        <p:txBody>
+          <a:bodyPr wrap="square" rtlCol="0" anchor="ctr"/>
+          <a:lstStyle/>
+          <a:p>
+            <a:pPr indent="0" marL="0">
+              <a:buNone/>
+            </a:pPr>
+            <a:r>
+              <a:rPr lang="en-US" sz="1500" dirty="0">
+                <a:solidFill>
+                  <a:srgbClr val="E0E7FF"/>
+                </a:solidFill>
+                <a:latin typeface="Calibri" pitchFamily="34" charset="0"/>
+                <a:ea typeface="Calibri" pitchFamily="34" charset="-122"/>
+                <a:cs typeface="Calibri" pitchFamily="34" charset="-120"/>
+              </a:rPr>
+              <a:t>•  Tìm đường ÍT BƯỚC nhất</a:t>
+            </a:r>
+            <a:endParaRPr lang="en-US" sz="1500" dirty="0"/>
+          </a:p>
+        </p:txBody>
+      </p:sp>
+      <p:sp>
+        <p:nvSpPr>
+          <p:cNvPr id="15" name="Text 13"/>
+          <p:cNvSpPr/>
+          <p:nvPr/>
+        </p:nvSpPr>
+        <p:spPr>
+          <a:xfrm>
+            <a:off x="548640" y="3922776"/>
+            <a:ext cx="4983480" cy="594360"/>
+          </a:xfrm>
+          <a:prstGeom prst="rect">
+            <a:avLst/>
+          </a:prstGeom>
+          <a:noFill/>
+          <a:ln/>
+        </p:spPr>
+        <p:txBody>
+          <a:bodyPr wrap="square" rtlCol="0" anchor="ctr"/>
+          <a:lstStyle/>
+          <a:p>
+            <a:pPr indent="0" marL="0">
+              <a:buNone/>
+            </a:pPr>
+            <a:r>
+              <a:rPr lang="en-US" sz="1500" dirty="0">
+                <a:solidFill>
+                  <a:srgbClr val="E0E7FF"/>
+                </a:solidFill>
+                <a:latin typeface="Calibri" pitchFamily="34" charset="0"/>
+                <a:ea typeface="Calibri" pitchFamily="34" charset="-122"/>
+                <a:cs typeface="Calibri" pitchFamily="34" charset="-120"/>
+              </a:rPr>
+              <a:t>•  Không tối ưu khoảng cách thực</a:t>
+            </a:r>
+            <a:endParaRPr lang="en-US" sz="1500" dirty="0"/>
+          </a:p>
+        </p:txBody>
+      </p:sp>
+      <p:sp>
+        <p:nvSpPr>
+          <p:cNvPr id="16" name="Text 14"/>
+          <p:cNvSpPr/>
+          <p:nvPr/>
+        </p:nvSpPr>
+        <p:spPr>
+          <a:xfrm>
+            <a:off x="548640" y="4636008"/>
+            <a:ext cx="4983480" cy="594360"/>
+          </a:xfrm>
+          <a:prstGeom prst="rect">
+            <a:avLst/>
+          </a:prstGeom>
+          <a:noFill/>
+          <a:ln/>
+        </p:spPr>
+        <p:txBody>
+          <a:bodyPr wrap="square" rtlCol="0" anchor="ctr"/>
+          <a:lstStyle/>
+          <a:p>
+            <a:pPr indent="0" marL="0">
+              <a:buNone/>
+            </a:pPr>
+            <a:r>
+              <a:rPr lang="en-US" sz="1500" dirty="0">
+                <a:solidFill>
+                  <a:srgbClr val="E0E7FF"/>
+                </a:solidFill>
+                <a:latin typeface="Calibri" pitchFamily="34" charset="0"/>
+                <a:ea typeface="Calibri" pitchFamily="34" charset="-122"/>
+                <a:cs typeface="Calibri" pitchFamily="34" charset="-120"/>
+              </a:rPr>
+              <a:t>•  Độ phức tạp: O(V + E)</a:t>
+            </a:r>
+            <a:endParaRPr lang="en-US" sz="1500" dirty="0"/>
+          </a:p>
+        </p:txBody>
+      </p:sp>
+      <p:sp>
+        <p:nvSpPr>
+          <p:cNvPr id="17" name="Shape 15"/>
+          <p:cNvSpPr/>
+          <p:nvPr/>
+        </p:nvSpPr>
+        <p:spPr>
+          <a:xfrm>
+            <a:off x="6400800" y="1051560"/>
+            <a:ext cx="5440680" cy="5394960"/>
+          </a:xfrm>
+          <a:prstGeom prst="roundRect">
+            <a:avLst>
+              <a:gd name="adj" fmla="val 1356"/>
+            </a:avLst>
+          </a:prstGeom>
+          <a:solidFill>
+            <a:srgbClr val="1C1945"/>
+          </a:solidFill>
+          <a:ln w="15240">
+            <a:solidFill>
+              <a:srgbClr val="FF6B6B"/>
+            </a:solidFill>
+            <a:prstDash val="solid"/>
+          </a:ln>
+        </p:spPr>
+      </p:sp>
+      <p:sp>
+        <p:nvSpPr>
+          <p:cNvPr id="18" name="Shape 16"/>
+          <p:cNvSpPr/>
+          <p:nvPr/>
+        </p:nvSpPr>
+        <p:spPr>
+          <a:xfrm>
+            <a:off x="6400800" y="1051560"/>
+            <a:ext cx="5440680" cy="548640"/>
+          </a:xfrm>
+          <a:prstGeom prst="roundRect">
+            <a:avLst>
+              <a:gd name="adj" fmla="val 13333"/>
+            </a:avLst>
+          </a:prstGeom>
+          <a:solidFill>
+            <a:srgbClr val="FF6B6B">
+              <a:alpha val="25000"/>
+            </a:srgbClr>
+          </a:solidFill>
+          <a:ln w="12700">
+            <a:solidFill>
+              <a:srgbClr val="FF6B6B"/>
+            </a:solidFill>
+            <a:prstDash val="solid"/>
+          </a:ln>
+        </p:spPr>
+      </p:sp>
+      <p:sp>
+        <p:nvSpPr>
+          <p:cNvPr id="19" name="Text 17"/>
+          <p:cNvSpPr/>
+          <p:nvPr/>
+        </p:nvSpPr>
+        <p:spPr>
+          <a:xfrm>
+            <a:off x="6400800" y="1051560"/>
+            <a:ext cx="5440680" cy="548640"/>
+          </a:xfrm>
+          <a:prstGeom prst="rect">
+            <a:avLst/>
+          </a:prstGeom>
+          <a:noFill/>
+          <a:ln/>
+        </p:spPr>
+        <p:txBody>
+          <a:bodyPr wrap="square" rtlCol="0" anchor="ctr"/>
+          <a:lstStyle/>
+          <a:p>
+            <a:pPr algn="ctr" indent="0" marL="0">
+              <a:buNone/>
+            </a:pPr>
+            <a:r>
+              <a:rPr lang="en-US" sz="1700" b="1" dirty="0">
+                <a:solidFill>
+                  <a:srgbClr val="FF6B6B"/>
+                </a:solidFill>
+                <a:latin typeface="Calibri" pitchFamily="34" charset="0"/>
+                <a:ea typeface="Calibri" pitchFamily="34" charset="-122"/>
+                <a:cs typeface="Calibri" pitchFamily="34" charset="-120"/>
+              </a:rPr>
+              <a:t>DFS  Depth-First Search</a:t>
+            </a:r>
+            <a:endParaRPr lang="en-US" sz="1700" dirty="0"/>
+          </a:p>
+        </p:txBody>
+      </p:sp>
+      <p:sp>
+        <p:nvSpPr>
+          <p:cNvPr id="20" name="Text 18"/>
+          <p:cNvSpPr/>
+          <p:nvPr/>
+        </p:nvSpPr>
+        <p:spPr>
+          <a:xfrm>
+            <a:off x="6629400" y="1783080"/>
+            <a:ext cx="4983480" cy="594360"/>
+          </a:xfrm>
+          <a:prstGeom prst="rect">
+            <a:avLst/>
+          </a:prstGeom>
+          <a:noFill/>
+          <a:ln/>
+        </p:spPr>
+        <p:txBody>
+          <a:bodyPr wrap="square" rtlCol="0" anchor="ctr"/>
+          <a:lstStyle/>
+          <a:p>
+            <a:pPr indent="0" marL="0">
+              <a:buNone/>
+            </a:pPr>
+            <a:r>
+              <a:rPr lang="en-US" sz="1500" dirty="0">
+                <a:solidFill>
+                  <a:srgbClr val="E0E7FF"/>
+                </a:solidFill>
+                <a:latin typeface="Calibri" pitchFamily="34" charset="0"/>
+                <a:ea typeface="Calibri" pitchFamily="34" charset="-122"/>
+                <a:cs typeface="Calibri" pitchFamily="34" charset="-120"/>
+              </a:rPr>
+              <a:t>•  Duyệt theo chiều sâu</a:t>
+            </a:r>
+            <a:endParaRPr lang="en-US" sz="1500" dirty="0"/>
+          </a:p>
+        </p:txBody>
+      </p:sp>
+      <p:sp>
+        <p:nvSpPr>
+          <p:cNvPr id="21" name="Text 19"/>
+          <p:cNvSpPr/>
+          <p:nvPr/>
+        </p:nvSpPr>
+        <p:spPr>
+          <a:xfrm>
+            <a:off x="6629400" y="2496312"/>
+            <a:ext cx="4983480" cy="594360"/>
+          </a:xfrm>
+          <a:prstGeom prst="rect">
+            <a:avLst/>
+          </a:prstGeom>
+          <a:noFill/>
+          <a:ln/>
+        </p:spPr>
+        <p:txBody>
+          <a:bodyPr wrap="square" rtlCol="0" anchor="ctr"/>
+          <a:lstStyle/>
+          <a:p>
+            <a:pPr indent="0" marL="0">
+              <a:buNone/>
+            </a:pPr>
+            <a:r>
+              <a:rPr lang="en-US" sz="1500" dirty="0">
+                <a:solidFill>
+                  <a:srgbClr val="E0E7FF"/>
+                </a:solidFill>
+                <a:latin typeface="Calibri" pitchFamily="34" charset="0"/>
+                <a:ea typeface="Calibri" pitchFamily="34" charset="-122"/>
+                <a:cs typeface="Calibri" pitchFamily="34" charset="-120"/>
+              </a:rPr>
+              <a:t>•  Ngăn xếp (Stack)</a:t>
+            </a:r>
+            <a:endParaRPr lang="en-US" sz="1500" dirty="0"/>
+          </a:p>
+        </p:txBody>
+      </p:sp>
+      <p:sp>
+        <p:nvSpPr>
+          <p:cNvPr id="22" name="Text 20"/>
+          <p:cNvSpPr/>
+          <p:nvPr/>
+        </p:nvSpPr>
+        <p:spPr>
+          <a:xfrm>
+            <a:off x="6629400" y="3209544"/>
+            <a:ext cx="4983480" cy="594360"/>
+          </a:xfrm>
+          <a:prstGeom prst="rect">
+            <a:avLst/>
+          </a:prstGeom>
+          <a:noFill/>
+          <a:ln/>
+        </p:spPr>
+        <p:txBody>
+          <a:bodyPr wrap="square" rtlCol="0" anchor="ctr"/>
+          <a:lstStyle/>
+          <a:p>
+            <a:pPr indent="0" marL="0">
+              <a:buNone/>
+            </a:pPr>
+            <a:r>
+              <a:rPr lang="en-US" sz="1500" dirty="0">
+                <a:solidFill>
+                  <a:srgbClr val="E0E7FF"/>
+                </a:solidFill>
+                <a:latin typeface="Calibri" pitchFamily="34" charset="0"/>
+                <a:ea typeface="Calibri" pitchFamily="34" charset="-122"/>
+                <a:cs typeface="Calibri" pitchFamily="34" charset="-120"/>
+              </a:rPr>
+              <a:t>•  KHÔNG đảm bảo tối ưu</a:t>
+            </a:r>
+            <a:endParaRPr lang="en-US" sz="1500" dirty="0"/>
+          </a:p>
+        </p:txBody>
+      </p:sp>
+      <p:sp>
+        <p:nvSpPr>
+          <p:cNvPr id="23" name="Text 21"/>
+          <p:cNvSpPr/>
+          <p:nvPr/>
+        </p:nvSpPr>
+        <p:spPr>
+          <a:xfrm>
+            <a:off x="6629400" y="3922776"/>
+            <a:ext cx="4983480" cy="594360"/>
+          </a:xfrm>
+          <a:prstGeom prst="rect">
+            <a:avLst/>
+          </a:prstGeom>
+          <a:noFill/>
+          <a:ln/>
+        </p:spPr>
+        <p:txBody>
+          <a:bodyPr wrap="square" rtlCol="0" anchor="ctr"/>
+          <a:lstStyle/>
+          <a:p>
+            <a:pPr indent="0" marL="0">
+              <a:buNone/>
+            </a:pPr>
+            <a:r>
+              <a:rPr lang="en-US" sz="1500" dirty="0">
+                <a:solidFill>
+                  <a:srgbClr val="E0E7FF"/>
+                </a:solidFill>
+                <a:latin typeface="Calibri" pitchFamily="34" charset="0"/>
+                <a:ea typeface="Calibri" pitchFamily="34" charset="-122"/>
+                <a:cs typeface="Calibri" pitchFamily="34" charset="-120"/>
+              </a:rPr>
+              <a:t>•  Đường đi có thể rất dài</a:t>
+            </a:r>
+            <a:endParaRPr lang="en-US" sz="1500" dirty="0"/>
+          </a:p>
+        </p:txBody>
+      </p:sp>
+      <p:sp>
+        <p:nvSpPr>
+          <p:cNvPr id="24" name="Text 22"/>
+          <p:cNvSpPr/>
+          <p:nvPr/>
+        </p:nvSpPr>
+        <p:spPr>
+          <a:xfrm>
+            <a:off x="6629400" y="4636008"/>
+            <a:ext cx="4983480" cy="594360"/>
+          </a:xfrm>
+          <a:prstGeom prst="rect">
+            <a:avLst/>
+          </a:prstGeom>
+          <a:noFill/>
+          <a:ln/>
+        </p:spPr>
+        <p:txBody>
+          <a:bodyPr wrap="square" rtlCol="0" anchor="ctr"/>
+          <a:lstStyle/>
+          <a:p>
+            <a:pPr indent="0" marL="0">
+              <a:buNone/>
+            </a:pPr>
+            <a:r>
+              <a:rPr lang="en-US" sz="1500" dirty="0">
+                <a:solidFill>
+                  <a:srgbClr val="E0E7FF"/>
+                </a:solidFill>
+                <a:latin typeface="Calibri" pitchFamily="34" charset="0"/>
+                <a:ea typeface="Calibri" pitchFamily="34" charset="-122"/>
+                <a:cs typeface="Calibri" pitchFamily="34" charset="-120"/>
+              </a:rPr>
+              <a:t>•  Độ phức tạp: O(V + E)</a:t>
+            </a:r>
+            <a:endParaRPr lang="en-US" sz="1500" dirty="0"/>
+          </a:p>
+        </p:txBody>
+      </p:sp>
+      <p:sp>
+        <p:nvSpPr>
+          <p:cNvPr id="25" name="Text 23"/>
+          <p:cNvSpPr/>
+          <p:nvPr/>
+        </p:nvSpPr>
+        <p:spPr>
+          <a:xfrm>
+            <a:off x="5705856" y="3474720"/>
+            <a:ext cx="777240" cy="594360"/>
+          </a:xfrm>
+          <a:prstGeom prst="rect">
+            <a:avLst/>
+          </a:prstGeom>
+          <a:noFill/>
+          <a:ln/>
+        </p:spPr>
+        <p:txBody>
+          <a:bodyPr wrap="square" rtlCol="0" anchor="ctr"/>
+          <a:lstStyle/>
+          <a:p>
+            <a:pPr algn="ctr" indent="0" marL="0">
+              <a:buNone/>
+            </a:pPr>
+            <a:r>
+              <a:rPr lang="en-US" sz="2200" b="1" dirty="0">
+                <a:solidFill>
+                  <a:srgbClr val="818CF8"/>
+                </a:solidFill>
+                <a:latin typeface="Calibri" pitchFamily="34" charset="0"/>
+                <a:ea typeface="Calibri" pitchFamily="34" charset="-122"/>
+                <a:cs typeface="Calibri" pitchFamily="34" charset="-120"/>
+              </a:rPr>
+              <a:t>VS</a:t>
+            </a:r>
+            <a:endParaRPr lang="en-US" sz="2200" dirty="0"/>
+          </a:p>
+        </p:txBody>
+      </p:sp>
+      <p:sp>
+        <p:nvSpPr>
+          <p:cNvPr id="26" name="Shape 24"/>
+          <p:cNvSpPr/>
+          <p:nvPr/>
+        </p:nvSpPr>
+        <p:spPr>
+          <a:xfrm>
+            <a:off x="320040" y="6446520"/>
+            <a:ext cx="11521440" cy="301752"/>
+          </a:xfrm>
+          <a:prstGeom prst="roundRect">
+            <a:avLst>
+              <a:gd name="adj" fmla="val 15152"/>
+            </a:avLst>
+          </a:prstGeom>
+          <a:solidFill>
+            <a:srgbClr val="1C1945"/>
+          </a:solidFill>
+          <a:ln w="12700">
+            <a:solidFill>
+              <a:srgbClr val="363780"/>
+            </a:solidFill>
+            <a:prstDash val="solid"/>
+          </a:ln>
+        </p:spPr>
+      </p:sp>
+      <p:sp>
+        <p:nvSpPr>
+          <p:cNvPr id="27" name="Text 25"/>
+          <p:cNvSpPr/>
+          <p:nvPr/>
+        </p:nvSpPr>
+        <p:spPr>
+          <a:xfrm>
+            <a:off x="457200" y="6446520"/>
+            <a:ext cx="11247120" cy="301752"/>
+          </a:xfrm>
+          <a:prstGeom prst="rect">
+            <a:avLst/>
+          </a:prstGeom>
+          <a:noFill/>
+          <a:ln/>
+        </p:spPr>
+        <p:txBody>
+          <a:bodyPr wrap="square" rtlCol="0" anchor="ctr"/>
+          <a:lstStyle/>
+          <a:p>
+            <a:pPr indent="0" marL="0">
+              <a:buNone/>
+            </a:pPr>
+            <a:r>
+              <a:rPr lang="en-US" sz="1100" i="1" dirty="0">
+                <a:solidFill>
+                  <a:srgbClr val="6B7AB8"/>
+                </a:solidFill>
+                <a:latin typeface="Calibri" pitchFamily="34" charset="0"/>
+                <a:ea typeface="Calibri" pitchFamily="34" charset="-122"/>
+                <a:cs typeface="Calibri" pitchFamily="34" charset="-120"/>
+              </a:rPr>
+              <a:t>BFS đảm bảo đường ÍT CẠNH nhất · DFS nhanh hơn trong nhiều trường hợp nhưng không tối ưu trên bản đồ có trọng số</a:t>
+            </a:r>
+            <a:endParaRPr lang="en-US" sz="1100" dirty="0"/>
+          </a:p>
+        </p:txBody>
+      </p:sp>
+    </p:spTree>
+  </p:cSld>
+  <p:clrMapOvr>
+    <a:masterClrMapping/>
+  </p:clrMapOvr>
+</p:sld>
+</file>
+
+<file path=ppt/slides/slide6.xml><?xml version="1.0" encoding="utf-8"?>
+<p:sld xmlns:a="http://schemas.openxmlformats.org/drawingml/2006/main" xmlns:r="http://schemas.openxmlformats.org/officeDocument/2006/relationships" xmlns:p="http://schemas.openxmlformats.org/presentationml/2006/main">
+  <p:cSld name="Slide 6">
+    <p:spTree>
+      <p:nvGrpSpPr>
+        <p:cNvPr id="1" name=""/>
+        <p:cNvGrpSpPr/>
+        <p:nvPr/>
+      </p:nvGrpSpPr>
+      <p:grpSpPr>
+        <a:xfrm>
+          <a:off x="0" y="0"/>
+          <a:ext cx="0" cy="0"/>
+          <a:chOff x="0" y="0"/>
+          <a:chExt cx="0" cy="0"/>
+        </a:xfrm>
+      </p:grpSpPr>
+      <p:sp>
+        <p:nvSpPr>
+          <p:cNvPr id="2" name="Shape 0"/>
+          <p:cNvSpPr/>
+          <p:nvPr/>
+        </p:nvSpPr>
+        <p:spPr>
+          <a:xfrm>
+            <a:off x="0" y="0"/>
+            <a:ext cx="12188952" cy="6858000"/>
+          </a:xfrm>
+          <a:prstGeom prst="rect">
+            <a:avLst/>
+          </a:prstGeom>
+          <a:solidFill>
+            <a:srgbClr val="0F0C29"/>
+          </a:solidFill>
+          <a:ln w="12700">
+            <a:solidFill>
+              <a:srgbClr val="0F0C29"/>
+            </a:solidFill>
+            <a:prstDash val="solid"/>
+          </a:ln>
+        </p:spPr>
+      </p:sp>
+      <p:sp>
+        <p:nvSpPr>
+          <p:cNvPr id="3" name="Shape 1"/>
+          <p:cNvSpPr/>
+          <p:nvPr/>
+        </p:nvSpPr>
+        <p:spPr>
+          <a:xfrm>
+            <a:off x="0" y="0"/>
+            <a:ext cx="12188952" cy="4114800"/>
+          </a:xfrm>
+          <a:prstGeom prst="rect">
+            <a:avLst/>
+          </a:prstGeom>
+          <a:solidFill>
+            <a:srgbClr val="1E1B4B">
+              <a:alpha val="70000"/>
+            </a:srgbClr>
+          </a:solidFill>
+          <a:ln w="12700">
+            <a:solidFill>
+              <a:srgbClr val="1E1B4B">
+                <a:alpha val="70000"/>
+              </a:srgbClr>
+            </a:solidFill>
+            <a:prstDash val="solid"/>
+          </a:ln>
+        </p:spPr>
+      </p:sp>
+      <p:sp>
+        <p:nvSpPr>
+          <p:cNvPr id="4" name="Shape 2"/>
+          <p:cNvSpPr/>
+          <p:nvPr/>
+        </p:nvSpPr>
+        <p:spPr>
+          <a:xfrm>
+            <a:off x="5486400" y="0"/>
+            <a:ext cx="6702552" cy="6858000"/>
+          </a:xfrm>
+          <a:prstGeom prst="rect">
+            <a:avLst/>
+          </a:prstGeom>
+          <a:solidFill>
+            <a:srgbClr val="312E81">
+              <a:alpha val="50000"/>
+            </a:srgbClr>
+          </a:solidFill>
+          <a:ln w="12700">
+            <a:solidFill>
+              <a:srgbClr val="312E81">
+                <a:alpha val="50000"/>
+              </a:srgbClr>
+            </a:solidFill>
+            <a:prstDash val="solid"/>
+          </a:ln>
+        </p:spPr>
+      </p:sp>
+      <p:sp>
+        <p:nvSpPr>
+          <p:cNvPr id="5" name="Shape 3"/>
+          <p:cNvSpPr/>
+          <p:nvPr/>
+        </p:nvSpPr>
+        <p:spPr>
+          <a:xfrm>
+            <a:off x="0" y="0"/>
+            <a:ext cx="54864" cy="3429000"/>
+          </a:xfrm>
+          <a:prstGeom prst="rect">
+            <a:avLst/>
+          </a:prstGeom>
+          <a:solidFill>
+            <a:srgbClr val="818CF8"/>
+          </a:solidFill>
+          <a:ln w="12700">
+            <a:solidFill>
+              <a:srgbClr val="818CF8"/>
+            </a:solidFill>
+            <a:prstDash val="solid"/>
+          </a:ln>
+        </p:spPr>
+      </p:sp>
+      <p:sp>
+        <p:nvSpPr>
+          <p:cNvPr id="6" name="Shape 4"/>
+          <p:cNvSpPr/>
+          <p:nvPr/>
+        </p:nvSpPr>
+        <p:spPr>
+          <a:xfrm>
+            <a:off x="0" y="3429000"/>
+            <a:ext cx="54864" cy="3429000"/>
+          </a:xfrm>
+          <a:prstGeom prst="rect">
+            <a:avLst/>
+          </a:prstGeom>
+          <a:solidFill>
+            <a:srgbClr val="34D399"/>
+          </a:solidFill>
+          <a:ln w="12700">
+            <a:solidFill>
+              <a:srgbClr val="34D399"/>
+            </a:solidFill>
+            <a:prstDash val="solid"/>
+          </a:ln>
+        </p:spPr>
+      </p:sp>
+      <p:sp>
+        <p:nvSpPr>
+          <p:cNvPr id="7" name="Text 5"/>
+          <p:cNvSpPr/>
+          <p:nvPr/>
+        </p:nvSpPr>
+        <p:spPr>
+          <a:xfrm>
+            <a:off x="365760" y="274320"/>
+            <a:ext cx="11430000" cy="548640"/>
+          </a:xfrm>
+          <a:prstGeom prst="rect">
+            <a:avLst/>
+          </a:prstGeom>
+          <a:noFill/>
+          <a:ln/>
+        </p:spPr>
+        <p:txBody>
+          <a:bodyPr wrap="square" rtlCol="0" anchor="ctr"/>
+          <a:lstStyle/>
+          <a:p>
+            <a:pPr algn="l" indent="0" marL="0">
+              <a:buNone/>
+            </a:pPr>
+            <a:r>
+              <a:rPr lang="en-US" sz="2600" b="1" dirty="0">
+                <a:solidFill>
+                  <a:srgbClr val="06D6A0"/>
+                </a:solidFill>
+                <a:latin typeface="Calibri" pitchFamily="34" charset="0"/>
+                <a:ea typeface="Calibri" pitchFamily="34" charset="-122"/>
+                <a:cs typeface="Calibri" pitchFamily="34" charset="-120"/>
+              </a:rPr>
+              <a:t>04. Thuật Toán — Dijkstra &amp; A*</a:t>
+            </a:r>
+            <a:endParaRPr lang="en-US" sz="2600" dirty="0"/>
+          </a:p>
+        </p:txBody>
+      </p:sp>
+      <p:sp>
+        <p:nvSpPr>
+          <p:cNvPr id="8" name="Shape 6"/>
+          <p:cNvSpPr/>
+          <p:nvPr/>
+        </p:nvSpPr>
+        <p:spPr>
+          <a:xfrm>
+            <a:off x="365760" y="868680"/>
+            <a:ext cx="11430000" cy="27432"/>
+          </a:xfrm>
+          <a:prstGeom prst="rect">
+            <a:avLst/>
+          </a:prstGeom>
+          <a:solidFill>
+            <a:srgbClr val="06D6A0"/>
+          </a:solidFill>
+          <a:ln w="12700">
+            <a:solidFill>
+              <a:srgbClr val="06D6A0"/>
+            </a:solidFill>
+            <a:prstDash val="solid"/>
+          </a:ln>
+        </p:spPr>
+      </p:sp>
+      <p:sp>
+        <p:nvSpPr>
+          <p:cNvPr id="9" name="Shape 7"/>
+          <p:cNvSpPr/>
+          <p:nvPr/>
+        </p:nvSpPr>
+        <p:spPr>
+          <a:xfrm>
+            <a:off x="320040" y="1051560"/>
+            <a:ext cx="5440680" cy="5394960"/>
+          </a:xfrm>
+          <a:prstGeom prst="roundRect">
+            <a:avLst>
+              <a:gd name="adj" fmla="val 1356"/>
+            </a:avLst>
+          </a:prstGeom>
+          <a:solidFill>
+            <a:srgbClr val="1C1945"/>
+          </a:solidFill>
+          <a:ln w="15240">
+            <a:solidFill>
+              <a:srgbClr val="FFD166"/>
+            </a:solidFill>
+            <a:prstDash val="solid"/>
+          </a:ln>
+        </p:spPr>
+      </p:sp>
+      <p:sp>
+        <p:nvSpPr>
+          <p:cNvPr id="10" name="Shape 8"/>
+          <p:cNvSpPr/>
+          <p:nvPr/>
+        </p:nvSpPr>
+        <p:spPr>
+          <a:xfrm>
+            <a:off x="320040" y="1051560"/>
+            <a:ext cx="5440680" cy="548640"/>
+          </a:xfrm>
+          <a:prstGeom prst="roundRect">
+            <a:avLst>
+              <a:gd name="adj" fmla="val 13333"/>
+            </a:avLst>
+          </a:prstGeom>
+          <a:solidFill>
+            <a:srgbClr val="FFD166">
+              <a:alpha val="25000"/>
+            </a:srgbClr>
+          </a:solidFill>
+          <a:ln w="12700">
+            <a:solidFill>
+              <a:srgbClr val="FFD166"/>
+            </a:solidFill>
+            <a:prstDash val="solid"/>
+          </a:ln>
+        </p:spPr>
+      </p:sp>
+      <p:sp>
+        <p:nvSpPr>
+          <p:cNvPr id="11" name="Text 9"/>
+          <p:cNvSpPr/>
+          <p:nvPr/>
+        </p:nvSpPr>
+        <p:spPr>
+          <a:xfrm>
+            <a:off x="320040" y="1051560"/>
+            <a:ext cx="5440680" cy="548640"/>
+          </a:xfrm>
+          <a:prstGeom prst="rect">
+            <a:avLst/>
+          </a:prstGeom>
+          <a:noFill/>
+          <a:ln/>
+        </p:spPr>
+        <p:txBody>
+          <a:bodyPr wrap="square" rtlCol="0" anchor="ctr"/>
+          <a:lstStyle/>
+          <a:p>
+            <a:pPr algn="ctr" indent="0" marL="0">
+              <a:buNone/>
+            </a:pPr>
+            <a:r>
+              <a:rPr lang="en-US" sz="1700" b="1" dirty="0">
+                <a:solidFill>
+                  <a:srgbClr val="FFD166"/>
+                </a:solidFill>
+                <a:latin typeface="Calibri" pitchFamily="34" charset="0"/>
+                <a:ea typeface="Calibri" pitchFamily="34" charset="-122"/>
+                <a:cs typeface="Calibri" pitchFamily="34" charset="-120"/>
+              </a:rPr>
+              <a:t>Dijkstra</a:t>
+            </a:r>
+            <a:endParaRPr lang="en-US" sz="1700" dirty="0"/>
+          </a:p>
+        </p:txBody>
+      </p:sp>
+      <p:sp>
+        <p:nvSpPr>
+          <p:cNvPr id="12" name="Text 10"/>
+          <p:cNvSpPr/>
+          <p:nvPr/>
+        </p:nvSpPr>
+        <p:spPr>
+          <a:xfrm>
+            <a:off x="548640" y="1783080"/>
+            <a:ext cx="4983480" cy="594360"/>
+          </a:xfrm>
+          <a:prstGeom prst="rect">
+            <a:avLst/>
+          </a:prstGeom>
+          <a:noFill/>
+          <a:ln/>
+        </p:spPr>
+        <p:txBody>
+          <a:bodyPr wrap="square" rtlCol="0" anchor="ctr"/>
+          <a:lstStyle/>
+          <a:p>
+            <a:pPr indent="0" marL="0">
+              <a:buNone/>
+            </a:pPr>
+            <a:r>
+              <a:rPr lang="en-US" sz="1500" dirty="0">
+                <a:solidFill>
+                  <a:srgbClr val="E0E7FF"/>
+                </a:solidFill>
+                <a:latin typeface="Calibri" pitchFamily="34" charset="0"/>
+                <a:ea typeface="Calibri" pitchFamily="34" charset="-122"/>
+                <a:cs typeface="Calibri" pitchFamily="34" charset="-120"/>
+              </a:rPr>
+              <a:t>•  Tìm đường NGẮN NHẤT tuyệt đối</a:t>
+            </a:r>
+            <a:endParaRPr lang="en-US" sz="1500" dirty="0"/>
+          </a:p>
+        </p:txBody>
+      </p:sp>
+      <p:sp>
+        <p:nvSpPr>
+          <p:cNvPr id="13" name="Text 11"/>
+          <p:cNvSpPr/>
+          <p:nvPr/>
+        </p:nvSpPr>
+        <p:spPr>
+          <a:xfrm>
+            <a:off x="548640" y="2496312"/>
+            <a:ext cx="4983480" cy="594360"/>
+          </a:xfrm>
+          <a:prstGeom prst="rect">
+            <a:avLst/>
+          </a:prstGeom>
+          <a:noFill/>
+          <a:ln/>
+        </p:spPr>
+        <p:txBody>
+          <a:bodyPr wrap="square" rtlCol="0" anchor="ctr"/>
+          <a:lstStyle/>
+          <a:p>
+            <a:pPr indent="0" marL="0">
+              <a:buNone/>
+            </a:pPr>
+            <a:r>
+              <a:rPr lang="en-US" sz="1500" dirty="0">
+                <a:solidFill>
+                  <a:srgbClr val="E0E7FF"/>
+                </a:solidFill>
+                <a:latin typeface="Calibri" pitchFamily="34" charset="0"/>
+                <a:ea typeface="Calibri" pitchFamily="34" charset="-122"/>
+                <a:cs typeface="Calibri" pitchFamily="34" charset="-120"/>
+              </a:rPr>
+              <a:t>•  Min-heap (priority queue)</a:t>
+            </a:r>
+            <a:endParaRPr lang="en-US" sz="1500" dirty="0"/>
+          </a:p>
+        </p:txBody>
+      </p:sp>
+      <p:sp>
+        <p:nvSpPr>
+          <p:cNvPr id="14" name="Text 12"/>
+          <p:cNvSpPr/>
+          <p:nvPr/>
+        </p:nvSpPr>
+        <p:spPr>
+          <a:xfrm>
+            <a:off x="548640" y="3209544"/>
+            <a:ext cx="4983480" cy="594360"/>
+          </a:xfrm>
+          <a:prstGeom prst="rect">
+            <a:avLst/>
+          </a:prstGeom>
+          <a:noFill/>
+          <a:ln/>
+        </p:spPr>
+        <p:txBody>
+          <a:bodyPr wrap="square" rtlCol="0" anchor="ctr"/>
+          <a:lstStyle/>
+          <a:p>
+            <a:pPr indent="0" marL="0">
+              <a:buNone/>
+            </a:pPr>
+            <a:r>
+              <a:rPr lang="en-US" sz="1500" dirty="0">
+                <a:solidFill>
+                  <a:srgbClr val="E0E7FF"/>
+                </a:solidFill>
+                <a:latin typeface="Calibri" pitchFamily="34" charset="0"/>
+                <a:ea typeface="Calibri" pitchFamily="34" charset="-122"/>
+                <a:cs typeface="Calibri" pitchFamily="34" charset="-120"/>
+              </a:rPr>
+              <a:t>•  Mở rộng nút gần nguồn nhất</a:t>
+            </a:r>
+            <a:endParaRPr lang="en-US" sz="1500" dirty="0"/>
+          </a:p>
+        </p:txBody>
+      </p:sp>
+      <p:sp>
+        <p:nvSpPr>
+          <p:cNvPr id="15" name="Text 13"/>
+          <p:cNvSpPr/>
+          <p:nvPr/>
+        </p:nvSpPr>
+        <p:spPr>
+          <a:xfrm>
+            <a:off x="548640" y="3922776"/>
+            <a:ext cx="4983480" cy="594360"/>
+          </a:xfrm>
+          <a:prstGeom prst="rect">
+            <a:avLst/>
+          </a:prstGeom>
+          <a:noFill/>
+          <a:ln/>
+        </p:spPr>
+        <p:txBody>
+          <a:bodyPr wrap="square" rtlCol="0" anchor="ctr"/>
+          <a:lstStyle/>
+          <a:p>
+            <a:pPr indent="0" marL="0">
+              <a:buNone/>
+            </a:pPr>
+            <a:r>
+              <a:rPr lang="en-US" sz="1500" dirty="0">
+                <a:solidFill>
+                  <a:srgbClr val="E0E7FF"/>
+                </a:solidFill>
+                <a:latin typeface="Calibri" pitchFamily="34" charset="0"/>
+                <a:ea typeface="Calibri" pitchFamily="34" charset="-122"/>
+                <a:cs typeface="Calibri" pitchFamily="34" charset="-120"/>
+              </a:rPr>
+              <a:t>•  Tối ưu trên đồ thị trọng số ≥ 0</a:t>
+            </a:r>
+            <a:endParaRPr lang="en-US" sz="1500" dirty="0"/>
+          </a:p>
+        </p:txBody>
+      </p:sp>
+      <p:sp>
+        <p:nvSpPr>
+          <p:cNvPr id="16" name="Text 14"/>
+          <p:cNvSpPr/>
+          <p:nvPr/>
+        </p:nvSpPr>
+        <p:spPr>
+          <a:xfrm>
+            <a:off x="548640" y="4636008"/>
+            <a:ext cx="4983480" cy="594360"/>
+          </a:xfrm>
+          <a:prstGeom prst="rect">
+            <a:avLst/>
+          </a:prstGeom>
+          <a:noFill/>
+          <a:ln/>
+        </p:spPr>
+        <p:txBody>
+          <a:bodyPr wrap="square" rtlCol="0" anchor="ctr"/>
+          <a:lstStyle/>
+          <a:p>
+            <a:pPr indent="0" marL="0">
+              <a:buNone/>
+            </a:pPr>
+            <a:r>
+              <a:rPr lang="en-US" sz="1500" dirty="0">
+                <a:solidFill>
+                  <a:srgbClr val="E0E7FF"/>
+                </a:solidFill>
+                <a:latin typeface="Calibri" pitchFamily="34" charset="0"/>
+                <a:ea typeface="Calibri" pitchFamily="34" charset="-122"/>
+                <a:cs typeface="Calibri" pitchFamily="34" charset="-120"/>
+              </a:rPr>
+              <a:t>•  Độ phức tạp: O((V+E) log V)</a:t>
+            </a:r>
+            <a:endParaRPr lang="en-US" sz="1500" dirty="0"/>
+          </a:p>
+        </p:txBody>
+      </p:sp>
+      <p:sp>
+        <p:nvSpPr>
+          <p:cNvPr id="17" name="Shape 15"/>
+          <p:cNvSpPr/>
+          <p:nvPr/>
+        </p:nvSpPr>
+        <p:spPr>
+          <a:xfrm>
+            <a:off x="6400800" y="1051560"/>
+            <a:ext cx="5440680" cy="5394960"/>
+          </a:xfrm>
+          <a:prstGeom prst="roundRect">
+            <a:avLst>
+              <a:gd name="adj" fmla="val 1356"/>
+            </a:avLst>
+          </a:prstGeom>
+          <a:solidFill>
+            <a:srgbClr val="1C1945"/>
+          </a:solidFill>
+          <a:ln w="15240">
+            <a:solidFill>
+              <a:srgbClr val="06D6A0"/>
+            </a:solidFill>
+            <a:prstDash val="solid"/>
+          </a:ln>
+        </p:spPr>
+      </p:sp>
+      <p:sp>
+        <p:nvSpPr>
+          <p:cNvPr id="18" name="Shape 16"/>
+          <p:cNvSpPr/>
+          <p:nvPr/>
+        </p:nvSpPr>
+        <p:spPr>
+          <a:xfrm>
+            <a:off x="6400800" y="1051560"/>
+            <a:ext cx="5440680" cy="548640"/>
+          </a:xfrm>
+          <a:prstGeom prst="roundRect">
+            <a:avLst>
+              <a:gd name="adj" fmla="val 13333"/>
+            </a:avLst>
+          </a:prstGeom>
+          <a:solidFill>
+            <a:srgbClr val="06D6A0">
+              <a:alpha val="25000"/>
+            </a:srgbClr>
+          </a:solidFill>
+          <a:ln w="12700">
+            <a:solidFill>
+              <a:srgbClr val="06D6A0"/>
+            </a:solidFill>
+            <a:prstDash val="solid"/>
+          </a:ln>
+        </p:spPr>
+      </p:sp>
+      <p:sp>
+        <p:nvSpPr>
+          <p:cNvPr id="19" name="Text 17"/>
+          <p:cNvSpPr/>
+          <p:nvPr/>
+        </p:nvSpPr>
+        <p:spPr>
+          <a:xfrm>
+            <a:off x="6400800" y="1051560"/>
+            <a:ext cx="5440680" cy="548640"/>
+          </a:xfrm>
+          <a:prstGeom prst="rect">
+            <a:avLst/>
+          </a:prstGeom>
+          <a:noFill/>
+          <a:ln/>
+        </p:spPr>
+        <p:txBody>
+          <a:bodyPr wrap="square" rtlCol="0" anchor="ctr"/>
+          <a:lstStyle/>
+          <a:p>
+            <a:pPr algn="ctr" indent="0" marL="0">
+              <a:buNone/>
+            </a:pPr>
+            <a:r>
+              <a:rPr lang="en-US" sz="1700" b="1" dirty="0">
+                <a:solidFill>
+                  <a:srgbClr val="06D6A0"/>
+                </a:solidFill>
+                <a:latin typeface="Calibri" pitchFamily="34" charset="0"/>
+                <a:ea typeface="Calibri" pitchFamily="34" charset="-122"/>
+                <a:cs typeface="Calibri" pitchFamily="34" charset="-120"/>
+              </a:rPr>
+              <a:t>A*  (A-Star)</a:t>
+            </a:r>
+            <a:endParaRPr lang="en-US" sz="1700" dirty="0"/>
+          </a:p>
+        </p:txBody>
+      </p:sp>
+      <p:sp>
+        <p:nvSpPr>
+          <p:cNvPr id="20" name="Text 18"/>
+          <p:cNvSpPr/>
+          <p:nvPr/>
+        </p:nvSpPr>
+        <p:spPr>
+          <a:xfrm>
+            <a:off x="6629400" y="1783080"/>
+            <a:ext cx="4983480" cy="594360"/>
+          </a:xfrm>
+          <a:prstGeom prst="rect">
+            <a:avLst/>
+          </a:prstGeom>
+          <a:noFill/>
+          <a:ln/>
+        </p:spPr>
+        <p:txBody>
+          <a:bodyPr wrap="square" rtlCol="0" anchor="ctr"/>
+          <a:lstStyle/>
+          <a:p>
+            <a:pPr indent="0" marL="0">
+              <a:buNone/>
+            </a:pPr>
+            <a:r>
+              <a:rPr lang="en-US" sz="1500" dirty="0">
+                <a:solidFill>
+                  <a:srgbClr val="E0E7FF"/>
+                </a:solidFill>
+                <a:latin typeface="Calibri" pitchFamily="34" charset="0"/>
+                <a:ea typeface="Calibri" pitchFamily="34" charset="-122"/>
+                <a:cs typeface="Calibri" pitchFamily="34" charset="-120"/>
+              </a:rPr>
+              <a:t>•  Dijkstra + heuristic dẫn hướng</a:t>
+            </a:r>
+            <a:endParaRPr lang="en-US" sz="1500" dirty="0"/>
+          </a:p>
+        </p:txBody>
+      </p:sp>
+      <p:sp>
+        <p:nvSpPr>
+          <p:cNvPr id="21" name="Text 19"/>
+          <p:cNvSpPr/>
+          <p:nvPr/>
+        </p:nvSpPr>
+        <p:spPr>
+          <a:xfrm>
+            <a:off x="6629400" y="2496312"/>
+            <a:ext cx="4983480" cy="594360"/>
+          </a:xfrm>
+          <a:prstGeom prst="rect">
+            <a:avLst/>
+          </a:prstGeom>
+          <a:noFill/>
+          <a:ln/>
+        </p:spPr>
+        <p:txBody>
+          <a:bodyPr wrap="square" rtlCol="0" anchor="ctr"/>
+          <a:lstStyle/>
+          <a:p>
+            <a:pPr indent="0" marL="0">
+              <a:buNone/>
+            </a:pPr>
+            <a:r>
+              <a:rPr lang="en-US" sz="1500" dirty="0">
+                <a:solidFill>
+                  <a:srgbClr val="E0E7FF"/>
+                </a:solidFill>
+                <a:latin typeface="Calibri" pitchFamily="34" charset="0"/>
+                <a:ea typeface="Calibri" pitchFamily="34" charset="-122"/>
+                <a:cs typeface="Calibri" pitchFamily="34" charset="-120"/>
+              </a:rPr>
+              <a:t>•  f(n) = g(n) + h(n)</a:t>
+            </a:r>
+            <a:endParaRPr lang="en-US" sz="1500" dirty="0"/>
+          </a:p>
+        </p:txBody>
+      </p:sp>
+      <p:sp>
+        <p:nvSpPr>
+          <p:cNvPr id="22" name="Text 20"/>
+          <p:cNvSpPr/>
+          <p:nvPr/>
+        </p:nvSpPr>
+        <p:spPr>
+          <a:xfrm>
+            <a:off x="6629400" y="3209544"/>
+            <a:ext cx="4983480" cy="594360"/>
+          </a:xfrm>
+          <a:prstGeom prst="rect">
+            <a:avLst/>
+          </a:prstGeom>
+          <a:noFill/>
+          <a:ln/>
+        </p:spPr>
+        <p:txBody>
+          <a:bodyPr wrap="square" rtlCol="0" anchor="ctr"/>
+          <a:lstStyle/>
+          <a:p>
+            <a:pPr indent="0" marL="0">
+              <a:buNone/>
+            </a:pPr>
+            <a:r>
+              <a:rPr lang="en-US" sz="1500" dirty="0">
+                <a:solidFill>
+                  <a:srgbClr val="E0E7FF"/>
+                </a:solidFill>
+                <a:latin typeface="Calibri" pitchFamily="34" charset="0"/>
+                <a:ea typeface="Calibri" pitchFamily="34" charset="-122"/>
+                <a:cs typeface="Calibri" pitchFamily="34" charset="-120"/>
+              </a:rPr>
+              <a:t>•  h(n) = khoảng cách Haversine</a:t>
+            </a:r>
+            <a:endParaRPr lang="en-US" sz="1500" dirty="0"/>
+          </a:p>
+        </p:txBody>
+      </p:sp>
+      <p:sp>
+        <p:nvSpPr>
+          <p:cNvPr id="23" name="Text 21"/>
+          <p:cNvSpPr/>
+          <p:nvPr/>
+        </p:nvSpPr>
+        <p:spPr>
+          <a:xfrm>
+            <a:off x="6629400" y="3922776"/>
+            <a:ext cx="4983480" cy="594360"/>
+          </a:xfrm>
+          <a:prstGeom prst="rect">
+            <a:avLst/>
+          </a:prstGeom>
+          <a:noFill/>
+          <a:ln/>
+        </p:spPr>
+        <p:txBody>
+          <a:bodyPr wrap="square" rtlCol="0" anchor="ctr"/>
+          <a:lstStyle/>
+          <a:p>
+            <a:pPr indent="0" marL="0">
+              <a:buNone/>
+            </a:pPr>
+            <a:r>
+              <a:rPr lang="en-US" sz="1500" dirty="0">
+                <a:solidFill>
+                  <a:srgbClr val="E0E7FF"/>
+                </a:solidFill>
+                <a:latin typeface="Calibri" pitchFamily="34" charset="0"/>
+                <a:ea typeface="Calibri" pitchFamily="34" charset="-122"/>
+                <a:cs typeface="Calibri" pitchFamily="34" charset="-120"/>
+              </a:rPr>
+              <a:t>•  Tối ưu VÀ nhanh hơn Dijkstra</a:t>
+            </a:r>
+            <a:endParaRPr lang="en-US" sz="1500" dirty="0"/>
+          </a:p>
+        </p:txBody>
+      </p:sp>
+      <p:sp>
+        <p:nvSpPr>
+          <p:cNvPr id="24" name="Text 22"/>
+          <p:cNvSpPr/>
+          <p:nvPr/>
+        </p:nvSpPr>
+        <p:spPr>
+          <a:xfrm>
+            <a:off x="6629400" y="4636008"/>
+            <a:ext cx="4983480" cy="594360"/>
+          </a:xfrm>
+          <a:prstGeom prst="rect">
+            <a:avLst/>
+          </a:prstGeom>
+          <a:noFill/>
+          <a:ln/>
+        </p:spPr>
+        <p:txBody>
+          <a:bodyPr wrap="square" rtlCol="0" anchor="ctr"/>
+          <a:lstStyle/>
+          <a:p>
+            <a:pPr indent="0" marL="0">
+              <a:buNone/>
+            </a:pPr>
+            <a:r>
+              <a:rPr lang="en-US" sz="1500" dirty="0">
+                <a:solidFill>
+                  <a:srgbClr val="E0E7FF"/>
+                </a:solidFill>
+                <a:latin typeface="Calibri" pitchFamily="34" charset="0"/>
+                <a:ea typeface="Calibri" pitchFamily="34" charset="-122"/>
+                <a:cs typeface="Calibri" pitchFamily="34" charset="-120"/>
+              </a:rPr>
+              <a:t>•  Duyệt ít nút hơn đáng kể</a:t>
+            </a:r>
+            <a:endParaRPr lang="en-US" sz="1500" dirty="0"/>
+          </a:p>
+        </p:txBody>
+      </p:sp>
+      <p:sp>
+        <p:nvSpPr>
+          <p:cNvPr id="25" name="Text 23"/>
+          <p:cNvSpPr/>
+          <p:nvPr/>
+        </p:nvSpPr>
+        <p:spPr>
+          <a:xfrm>
+            <a:off x="5705856" y="3474720"/>
+            <a:ext cx="777240" cy="594360"/>
+          </a:xfrm>
+          <a:prstGeom prst="rect">
+            <a:avLst/>
+          </a:prstGeom>
+          <a:noFill/>
+          <a:ln/>
+        </p:spPr>
+        <p:txBody>
+          <a:bodyPr wrap="square" rtlCol="0" anchor="ctr"/>
+          <a:lstStyle/>
+          <a:p>
+            <a:pPr algn="ctr" indent="0" marL="0">
+              <a:buNone/>
+            </a:pPr>
+            <a:r>
+              <a:rPr lang="en-US" sz="2200" b="1" dirty="0">
+                <a:solidFill>
+                  <a:srgbClr val="818CF8"/>
+                </a:solidFill>
+                <a:latin typeface="Calibri" pitchFamily="34" charset="0"/>
+                <a:ea typeface="Calibri" pitchFamily="34" charset="-122"/>
+                <a:cs typeface="Calibri" pitchFamily="34" charset="-120"/>
+              </a:rPr>
+              <a:t>VS</a:t>
+            </a:r>
+            <a:endParaRPr lang="en-US" sz="2200" dirty="0"/>
+          </a:p>
+        </p:txBody>
+      </p:sp>
+      <p:sp>
+        <p:nvSpPr>
+          <p:cNvPr id="26" name="Shape 24"/>
+          <p:cNvSpPr/>
+          <p:nvPr/>
+        </p:nvSpPr>
+        <p:spPr>
+          <a:xfrm>
+            <a:off x="320040" y="6446520"/>
+            <a:ext cx="11521440" cy="301752"/>
+          </a:xfrm>
+          <a:prstGeom prst="roundRect">
+            <a:avLst>
+              <a:gd name="adj" fmla="val 15152"/>
+            </a:avLst>
+          </a:prstGeom>
+          <a:solidFill>
+            <a:srgbClr val="1C1945"/>
+          </a:solidFill>
+          <a:ln w="12700">
+            <a:solidFill>
+              <a:srgbClr val="363780"/>
+            </a:solidFill>
+            <a:prstDash val="solid"/>
+          </a:ln>
+        </p:spPr>
+      </p:sp>
+      <p:sp>
+        <p:nvSpPr>
+          <p:cNvPr id="27" name="Text 25"/>
+          <p:cNvSpPr/>
+          <p:nvPr/>
+        </p:nvSpPr>
+        <p:spPr>
+          <a:xfrm>
+            <a:off x="457200" y="6446520"/>
+            <a:ext cx="11247120" cy="301752"/>
+          </a:xfrm>
+          <a:prstGeom prst="rect">
+            <a:avLst/>
+          </a:prstGeom>
+          <a:noFill/>
+          <a:ln/>
+        </p:spPr>
+        <p:txBody>
+          <a:bodyPr wrap="square" rtlCol="0" anchor="ctr"/>
+          <a:lstStyle/>
+          <a:p>
+            <a:pPr indent="0" marL="0">
+              <a:buNone/>
+            </a:pPr>
+            <a:r>
+              <a:rPr lang="en-US" sz="1100" i="1" dirty="0">
+                <a:solidFill>
+                  <a:srgbClr val="6B7AB8"/>
+                </a:solidFill>
+                <a:latin typeface="Calibri" pitchFamily="34" charset="0"/>
+                <a:ea typeface="Calibri" pitchFamily="34" charset="-122"/>
+                <a:cs typeface="Calibri" pitchFamily="34" charset="-120"/>
+              </a:rPr>
+              <a:t>h(n) ≤ khoảng cách thực  →  Admissible heuristic  →  A* đảm bảo kết quả tối ưu như Dijkstra</a:t>
+            </a:r>
+            <a:endParaRPr lang="en-US" sz="1100" dirty="0"/>
           </a:p>
         </p:txBody>
       </p:sp>

</xml_diff>

<commit_message>
feat: slide 7 giao diện tính năng, slide 8 demo (mới)
</commit_message>
<xml_diff>
--- a/ThuyetTrinh_PathFinderAI.pptx
+++ b/ThuyetTrinh_PathFinderAI.pptx
@@ -11,9 +11,11 @@
     <p:sldId id="259" r:id="rId5"/>
     <p:sldId id="260" r:id="rId6"/>
     <p:sldId id="261" r:id="rId7"/>
+    <p:sldId id="262" r:id="rId8"/>
+    <p:sldId id="263" r:id="rId9"/>
   </p:sldIdLst>
   <p:notesMasterIdLst>
-    <p:notesMasterId r:id="rId8"/>
+    <p:notesMasterId r:id="rId10"/>
   </p:notesMasterIdLst>
   <p:sldSz cx="12192000" cy="6858000"/>
   <p:notesSz cx="6858000" cy="12192000"/>
@@ -989,6 +991,182 @@
 </p:notes>
 </file>
 
+<file path=ppt/notesSlides/notesSlide7.xml><?xml version="1.0" encoding="utf-8"?>
+<p:notes xmlns:a="http://schemas.openxmlformats.org/drawingml/2006/main" xmlns:r="http://schemas.openxmlformats.org/officeDocument/2006/relationships" xmlns:p="http://schemas.openxmlformats.org/presentationml/2006/main">
+  <p:cSld>
+    <p:spTree>
+      <p:nvGrpSpPr>
+        <p:cNvPr id="1" name=""/>
+        <p:cNvGrpSpPr/>
+        <p:nvPr/>
+      </p:nvGrpSpPr>
+      <p:grpSpPr>
+        <a:xfrm>
+          <a:off x="0" y="0"/>
+          <a:ext cx="0" cy="0"/>
+          <a:chOff x="0" y="0"/>
+          <a:chExt cx="0" cy="0"/>
+        </a:xfrm>
+      </p:grpSpPr>
+      <p:sp>
+        <p:nvSpPr>
+          <p:cNvPr id="2" name="Slide Image Placeholder 1"/>
+          <p:cNvSpPr>
+            <a:spLocks noGrp="1" noRot="1" noChangeAspect="1"/>
+          </p:cNvSpPr>
+          <p:nvPr>
+            <p:ph type="sldImg"/>
+          </p:nvPr>
+        </p:nvSpPr>
+        <p:spPr/>
+      </p:sp>
+      <p:sp>
+        <p:nvSpPr>
+          <p:cNvPr id="3" name="Notes Placeholder 2"/>
+          <p:cNvSpPr>
+            <a:spLocks noGrp="1"/>
+          </p:cNvSpPr>
+          <p:nvPr>
+            <p:ph type="body" idx="1"/>
+          </p:nvPr>
+        </p:nvSpPr>
+        <p:spPr/>
+        <p:txBody>
+          <a:bodyPr/>
+          <a:lstStyle/>
+          <a:p>
+            <a:r>
+              <a:rPr lang="en-US" dirty="0"/>
+              <a:t/>
+            </a:r>
+            <a:endParaRPr lang="en-US" dirty="0"/>
+          </a:p>
+        </p:txBody>
+      </p:sp>
+      <p:sp>
+        <p:nvSpPr>
+          <p:cNvPr id="4" name="Slide Number Placeholder 3"/>
+          <p:cNvSpPr>
+            <a:spLocks noGrp="1"/>
+          </p:cNvSpPr>
+          <p:nvPr>
+            <p:ph type="sldNum" sz="quarter" idx="10"/>
+          </p:nvPr>
+        </p:nvSpPr>
+        <p:spPr/>
+        <p:txBody>
+          <a:bodyPr/>
+          <a:lstStyle/>
+          <a:p>
+            <a:fld id="{F7021451-1387-4CA6-816F-3879F97B5CBC}" type="slidenum">
+              <a:rPr lang="en-US"/>
+              <a:t>7</a:t>
+            </a:fld>
+            <a:endParaRPr lang="en-US"/>
+          </a:p>
+        </p:txBody>
+      </p:sp>
+    </p:spTree>
+    <p:extLst>
+      <p:ext uri="{BB962C8B-B14F-4D97-AF65-F5344CB8AC3E}">
+        <p14:creationId xmlns:p14="http://schemas.microsoft.com/office/powerpoint/2010/main" val="1024086991"/>
+      </p:ext>
+    </p:extLst>
+  </p:cSld>
+  <p:clrMapOvr>
+    <a:masterClrMapping/>
+  </p:clrMapOvr>
+</p:notes>
+</file>
+
+<file path=ppt/notesSlides/notesSlide8.xml><?xml version="1.0" encoding="utf-8"?>
+<p:notes xmlns:a="http://schemas.openxmlformats.org/drawingml/2006/main" xmlns:r="http://schemas.openxmlformats.org/officeDocument/2006/relationships" xmlns:p="http://schemas.openxmlformats.org/presentationml/2006/main">
+  <p:cSld>
+    <p:spTree>
+      <p:nvGrpSpPr>
+        <p:cNvPr id="1" name=""/>
+        <p:cNvGrpSpPr/>
+        <p:nvPr/>
+      </p:nvGrpSpPr>
+      <p:grpSpPr>
+        <a:xfrm>
+          <a:off x="0" y="0"/>
+          <a:ext cx="0" cy="0"/>
+          <a:chOff x="0" y="0"/>
+          <a:chExt cx="0" cy="0"/>
+        </a:xfrm>
+      </p:grpSpPr>
+      <p:sp>
+        <p:nvSpPr>
+          <p:cNvPr id="2" name="Slide Image Placeholder 1"/>
+          <p:cNvSpPr>
+            <a:spLocks noGrp="1" noRot="1" noChangeAspect="1"/>
+          </p:cNvSpPr>
+          <p:nvPr>
+            <p:ph type="sldImg"/>
+          </p:nvPr>
+        </p:nvSpPr>
+        <p:spPr/>
+      </p:sp>
+      <p:sp>
+        <p:nvSpPr>
+          <p:cNvPr id="3" name="Notes Placeholder 2"/>
+          <p:cNvSpPr>
+            <a:spLocks noGrp="1"/>
+          </p:cNvSpPr>
+          <p:nvPr>
+            <p:ph type="body" idx="1"/>
+          </p:nvPr>
+        </p:nvSpPr>
+        <p:spPr/>
+        <p:txBody>
+          <a:bodyPr/>
+          <a:lstStyle/>
+          <a:p>
+            <a:r>
+              <a:rPr lang="en-US" dirty="0"/>
+              <a:t/>
+            </a:r>
+            <a:endParaRPr lang="en-US" dirty="0"/>
+          </a:p>
+        </p:txBody>
+      </p:sp>
+      <p:sp>
+        <p:nvSpPr>
+          <p:cNvPr id="4" name="Slide Number Placeholder 3"/>
+          <p:cNvSpPr>
+            <a:spLocks noGrp="1"/>
+          </p:cNvSpPr>
+          <p:nvPr>
+            <p:ph type="sldNum" sz="quarter" idx="10"/>
+          </p:nvPr>
+        </p:nvSpPr>
+        <p:spPr/>
+        <p:txBody>
+          <a:bodyPr/>
+          <a:lstStyle/>
+          <a:p>
+            <a:fld id="{F7021451-1387-4CA6-816F-3879F97B5CBC}" type="slidenum">
+              <a:rPr lang="en-US"/>
+              <a:t>8</a:t>
+            </a:fld>
+            <a:endParaRPr lang="en-US"/>
+          </a:p>
+        </p:txBody>
+      </p:sp>
+    </p:spTree>
+    <p:extLst>
+      <p:ext uri="{BB962C8B-B14F-4D97-AF65-F5344CB8AC3E}">
+        <p14:creationId xmlns:p14="http://schemas.microsoft.com/office/powerpoint/2010/main" val="1024086991"/>
+      </p:ext>
+    </p:extLst>
+  </p:cSld>
+  <p:clrMapOvr>
+    <a:masterClrMapping/>
+  </p:clrMapOvr>
+</p:notes>
+</file>
+
 <file path=ppt/slideLayouts/slideLayout1.xml><?xml version="1.0" encoding="utf-8"?>
 <p:sldLayout xmlns:a="http://schemas.openxmlformats.org/drawingml/2006/main" xmlns:r="http://schemas.openxmlformats.org/officeDocument/2006/relationships" xmlns:p="http://schemas.openxmlformats.org/presentationml/2006/main" preserve="1">
   <p:cSld name="DEFAULT">
@@ -7162,6 +7340,2006 @@
               <a:t>h(n) ≤ khoảng cách thực  →  Admissible heuristic  →  A* đảm bảo kết quả tối ưu như Dijkstra</a:t>
             </a:r>
             <a:endParaRPr lang="en-US" sz="1100" dirty="0"/>
+          </a:p>
+        </p:txBody>
+      </p:sp>
+    </p:spTree>
+  </p:cSld>
+  <p:clrMapOvr>
+    <a:masterClrMapping/>
+  </p:clrMapOvr>
+</p:sld>
+</file>
+
+<file path=ppt/slides/slide7.xml><?xml version="1.0" encoding="utf-8"?>
+<p:sld xmlns:a="http://schemas.openxmlformats.org/drawingml/2006/main" xmlns:r="http://schemas.openxmlformats.org/officeDocument/2006/relationships" xmlns:p="http://schemas.openxmlformats.org/presentationml/2006/main">
+  <p:cSld name="Slide 7">
+    <p:spTree>
+      <p:nvGrpSpPr>
+        <p:cNvPr id="1" name=""/>
+        <p:cNvGrpSpPr/>
+        <p:nvPr/>
+      </p:nvGrpSpPr>
+      <p:grpSpPr>
+        <a:xfrm>
+          <a:off x="0" y="0"/>
+          <a:ext cx="0" cy="0"/>
+          <a:chOff x="0" y="0"/>
+          <a:chExt cx="0" cy="0"/>
+        </a:xfrm>
+      </p:grpSpPr>
+      <p:sp>
+        <p:nvSpPr>
+          <p:cNvPr id="2" name="Shape 0"/>
+          <p:cNvSpPr/>
+          <p:nvPr/>
+        </p:nvSpPr>
+        <p:spPr>
+          <a:xfrm>
+            <a:off x="0" y="0"/>
+            <a:ext cx="12188952" cy="6858000"/>
+          </a:xfrm>
+          <a:prstGeom prst="rect">
+            <a:avLst/>
+          </a:prstGeom>
+          <a:solidFill>
+            <a:srgbClr val="0F0C29"/>
+          </a:solidFill>
+          <a:ln w="12700">
+            <a:solidFill>
+              <a:srgbClr val="0F0C29"/>
+            </a:solidFill>
+            <a:prstDash val="solid"/>
+          </a:ln>
+        </p:spPr>
+      </p:sp>
+      <p:sp>
+        <p:nvSpPr>
+          <p:cNvPr id="3" name="Shape 1"/>
+          <p:cNvSpPr/>
+          <p:nvPr/>
+        </p:nvSpPr>
+        <p:spPr>
+          <a:xfrm>
+            <a:off x="0" y="0"/>
+            <a:ext cx="12188952" cy="4114800"/>
+          </a:xfrm>
+          <a:prstGeom prst="rect">
+            <a:avLst/>
+          </a:prstGeom>
+          <a:solidFill>
+            <a:srgbClr val="1E1B4B">
+              <a:alpha val="70000"/>
+            </a:srgbClr>
+          </a:solidFill>
+          <a:ln w="12700">
+            <a:solidFill>
+              <a:srgbClr val="1E1B4B">
+                <a:alpha val="70000"/>
+              </a:srgbClr>
+            </a:solidFill>
+            <a:prstDash val="solid"/>
+          </a:ln>
+        </p:spPr>
+      </p:sp>
+      <p:sp>
+        <p:nvSpPr>
+          <p:cNvPr id="4" name="Shape 2"/>
+          <p:cNvSpPr/>
+          <p:nvPr/>
+        </p:nvSpPr>
+        <p:spPr>
+          <a:xfrm>
+            <a:off x="5486400" y="0"/>
+            <a:ext cx="6702552" cy="6858000"/>
+          </a:xfrm>
+          <a:prstGeom prst="rect">
+            <a:avLst/>
+          </a:prstGeom>
+          <a:solidFill>
+            <a:srgbClr val="312E81">
+              <a:alpha val="50000"/>
+            </a:srgbClr>
+          </a:solidFill>
+          <a:ln w="12700">
+            <a:solidFill>
+              <a:srgbClr val="312E81">
+                <a:alpha val="50000"/>
+              </a:srgbClr>
+            </a:solidFill>
+            <a:prstDash val="solid"/>
+          </a:ln>
+        </p:spPr>
+      </p:sp>
+      <p:sp>
+        <p:nvSpPr>
+          <p:cNvPr id="5" name="Shape 3"/>
+          <p:cNvSpPr/>
+          <p:nvPr/>
+        </p:nvSpPr>
+        <p:spPr>
+          <a:xfrm>
+            <a:off x="0" y="0"/>
+            <a:ext cx="54864" cy="3429000"/>
+          </a:xfrm>
+          <a:prstGeom prst="rect">
+            <a:avLst/>
+          </a:prstGeom>
+          <a:solidFill>
+            <a:srgbClr val="818CF8"/>
+          </a:solidFill>
+          <a:ln w="12700">
+            <a:solidFill>
+              <a:srgbClr val="818CF8"/>
+            </a:solidFill>
+            <a:prstDash val="solid"/>
+          </a:ln>
+        </p:spPr>
+      </p:sp>
+      <p:sp>
+        <p:nvSpPr>
+          <p:cNvPr id="6" name="Shape 4"/>
+          <p:cNvSpPr/>
+          <p:nvPr/>
+        </p:nvSpPr>
+        <p:spPr>
+          <a:xfrm>
+            <a:off x="0" y="3429000"/>
+            <a:ext cx="54864" cy="3429000"/>
+          </a:xfrm>
+          <a:prstGeom prst="rect">
+            <a:avLst/>
+          </a:prstGeom>
+          <a:solidFill>
+            <a:srgbClr val="34D399"/>
+          </a:solidFill>
+          <a:ln w="12700">
+            <a:solidFill>
+              <a:srgbClr val="34D399"/>
+            </a:solidFill>
+            <a:prstDash val="solid"/>
+          </a:ln>
+        </p:spPr>
+      </p:sp>
+      <p:sp>
+        <p:nvSpPr>
+          <p:cNvPr id="7" name="Text 5"/>
+          <p:cNvSpPr/>
+          <p:nvPr/>
+        </p:nvSpPr>
+        <p:spPr>
+          <a:xfrm>
+            <a:off x="365760" y="274320"/>
+            <a:ext cx="11430000" cy="548640"/>
+          </a:xfrm>
+          <a:prstGeom prst="rect">
+            <a:avLst/>
+          </a:prstGeom>
+          <a:noFill/>
+          <a:ln/>
+        </p:spPr>
+        <p:txBody>
+          <a:bodyPr wrap="square" rtlCol="0" anchor="ctr"/>
+          <a:lstStyle/>
+          <a:p>
+            <a:pPr algn="l" indent="0" marL="0">
+              <a:buNone/>
+            </a:pPr>
+            <a:r>
+              <a:rPr lang="en-US" sz="2600" b="1" dirty="0">
+                <a:solidFill>
+                  <a:srgbClr val="818CF8"/>
+                </a:solidFill>
+                <a:latin typeface="Calibri" pitchFamily="34" charset="0"/>
+                <a:ea typeface="Calibri" pitchFamily="34" charset="-122"/>
+                <a:cs typeface="Calibri" pitchFamily="34" charset="-120"/>
+              </a:rPr>
+              <a:t>05. Giao Diện và Tính Năng</a:t>
+            </a:r>
+            <a:endParaRPr lang="en-US" sz="2600" dirty="0"/>
+          </a:p>
+        </p:txBody>
+      </p:sp>
+      <p:sp>
+        <p:nvSpPr>
+          <p:cNvPr id="8" name="Shape 6"/>
+          <p:cNvSpPr/>
+          <p:nvPr/>
+        </p:nvSpPr>
+        <p:spPr>
+          <a:xfrm>
+            <a:off x="365760" y="868680"/>
+            <a:ext cx="11430000" cy="27432"/>
+          </a:xfrm>
+          <a:prstGeom prst="rect">
+            <a:avLst/>
+          </a:prstGeom>
+          <a:solidFill>
+            <a:srgbClr val="818CF8"/>
+          </a:solidFill>
+          <a:ln w="12700">
+            <a:solidFill>
+              <a:srgbClr val="818CF8"/>
+            </a:solidFill>
+            <a:prstDash val="solid"/>
+          </a:ln>
+        </p:spPr>
+      </p:sp>
+      <p:sp>
+        <p:nvSpPr>
+          <p:cNvPr id="9" name="Shape 7"/>
+          <p:cNvSpPr/>
+          <p:nvPr/>
+        </p:nvSpPr>
+        <p:spPr>
+          <a:xfrm>
+            <a:off x="320040" y="1051560"/>
+            <a:ext cx="6309360" cy="987552"/>
+          </a:xfrm>
+          <a:prstGeom prst="roundRect">
+            <a:avLst>
+              <a:gd name="adj" fmla="val 7407"/>
+            </a:avLst>
+          </a:prstGeom>
+          <a:solidFill>
+            <a:srgbClr val="1C1945"/>
+          </a:solidFill>
+          <a:ln w="15240">
+            <a:solidFill>
+              <a:srgbClr val="363780"/>
+            </a:solidFill>
+            <a:prstDash val="solid"/>
+          </a:ln>
+        </p:spPr>
+      </p:sp>
+      <p:sp>
+        <p:nvSpPr>
+          <p:cNvPr id="10" name="Text 8"/>
+          <p:cNvSpPr/>
+          <p:nvPr/>
+        </p:nvSpPr>
+        <p:spPr>
+          <a:xfrm>
+            <a:off x="502920" y="1078992"/>
+            <a:ext cx="5943600" cy="384048"/>
+          </a:xfrm>
+          <a:prstGeom prst="rect">
+            <a:avLst/>
+          </a:prstGeom>
+          <a:noFill/>
+          <a:ln/>
+        </p:spPr>
+        <p:txBody>
+          <a:bodyPr wrap="square" rtlCol="0" anchor="ctr"/>
+          <a:lstStyle/>
+          <a:p>
+            <a:pPr indent="0" marL="0">
+              <a:buNone/>
+            </a:pPr>
+            <a:r>
+              <a:rPr lang="en-US" sz="1500" b="1" dirty="0">
+                <a:solidFill>
+                  <a:srgbClr val="34D399"/>
+                </a:solidFill>
+                <a:latin typeface="Calibri" pitchFamily="34" charset="0"/>
+                <a:ea typeface="Calibri" pitchFamily="34" charset="-122"/>
+                <a:cs typeface="Calibri" pitchFamily="34" charset="-120"/>
+              </a:rPr>
+              <a:t>🖱️ Chọn điểm</a:t>
+            </a:r>
+            <a:endParaRPr lang="en-US" sz="1500" dirty="0"/>
+          </a:p>
+        </p:txBody>
+      </p:sp>
+      <p:sp>
+        <p:nvSpPr>
+          <p:cNvPr id="11" name="Text 9"/>
+          <p:cNvSpPr/>
+          <p:nvPr/>
+        </p:nvSpPr>
+        <p:spPr>
+          <a:xfrm>
+            <a:off x="502920" y="1463040"/>
+            <a:ext cx="5943600" cy="502920"/>
+          </a:xfrm>
+          <a:prstGeom prst="rect">
+            <a:avLst/>
+          </a:prstGeom>
+          <a:noFill/>
+          <a:ln/>
+        </p:spPr>
+        <p:txBody>
+          <a:bodyPr wrap="square" rtlCol="0" anchor="ctr"/>
+          <a:lstStyle/>
+          <a:p>
+            <a:pPr indent="0" marL="0">
+              <a:buNone/>
+            </a:pPr>
+            <a:r>
+              <a:rPr lang="en-US" sz="1300" dirty="0">
+                <a:solidFill>
+                  <a:srgbClr val="6B7AB8"/>
+                </a:solidFill>
+                <a:latin typeface="Calibri" pitchFamily="34" charset="0"/>
+                <a:ea typeface="Calibri" pitchFamily="34" charset="-122"/>
+                <a:cs typeface="Calibri" pitchFamily="34" charset="-120"/>
+              </a:rPr>
+              <a:t>Click bản đồ, tự snap đến nút giao thông gần nhất.</a:t>
+            </a:r>
+            <a:endParaRPr lang="en-US" sz="1300" dirty="0"/>
+          </a:p>
+        </p:txBody>
+      </p:sp>
+      <p:sp>
+        <p:nvSpPr>
+          <p:cNvPr id="12" name="Shape 10"/>
+          <p:cNvSpPr/>
+          <p:nvPr/>
+        </p:nvSpPr>
+        <p:spPr>
+          <a:xfrm>
+            <a:off x="320040" y="2148840"/>
+            <a:ext cx="6309360" cy="987552"/>
+          </a:xfrm>
+          <a:prstGeom prst="roundRect">
+            <a:avLst>
+              <a:gd name="adj" fmla="val 7407"/>
+            </a:avLst>
+          </a:prstGeom>
+          <a:solidFill>
+            <a:srgbClr val="1C1945"/>
+          </a:solidFill>
+          <a:ln w="15240">
+            <a:solidFill>
+              <a:srgbClr val="363780"/>
+            </a:solidFill>
+            <a:prstDash val="solid"/>
+          </a:ln>
+        </p:spPr>
+      </p:sp>
+      <p:sp>
+        <p:nvSpPr>
+          <p:cNvPr id="13" name="Text 11"/>
+          <p:cNvSpPr/>
+          <p:nvPr/>
+        </p:nvSpPr>
+        <p:spPr>
+          <a:xfrm>
+            <a:off x="502920" y="2176272"/>
+            <a:ext cx="5943600" cy="384048"/>
+          </a:xfrm>
+          <a:prstGeom prst="rect">
+            <a:avLst/>
+          </a:prstGeom>
+          <a:noFill/>
+          <a:ln/>
+        </p:spPr>
+        <p:txBody>
+          <a:bodyPr wrap="square" rtlCol="0" anchor="ctr"/>
+          <a:lstStyle/>
+          <a:p>
+            <a:pPr indent="0" marL="0">
+              <a:buNone/>
+            </a:pPr>
+            <a:r>
+              <a:rPr lang="en-US" sz="1500" b="1" dirty="0">
+                <a:solidFill>
+                  <a:srgbClr val="34D399"/>
+                </a:solidFill>
+                <a:latin typeface="Calibri" pitchFamily="34" charset="0"/>
+                <a:ea typeface="Calibri" pitchFamily="34" charset="-122"/>
+                <a:cs typeface="Calibri" pitchFamily="34" charset="-120"/>
+              </a:rPr>
+              <a:t>▶  Chạy đồng thời</a:t>
+            </a:r>
+            <a:endParaRPr lang="en-US" sz="1500" dirty="0"/>
+          </a:p>
+        </p:txBody>
+      </p:sp>
+      <p:sp>
+        <p:nvSpPr>
+          <p:cNvPr id="14" name="Text 12"/>
+          <p:cNvSpPr/>
+          <p:nvPr/>
+        </p:nvSpPr>
+        <p:spPr>
+          <a:xfrm>
+            <a:off x="502920" y="2560320"/>
+            <a:ext cx="5943600" cy="502920"/>
+          </a:xfrm>
+          <a:prstGeom prst="rect">
+            <a:avLst/>
+          </a:prstGeom>
+          <a:noFill/>
+          <a:ln/>
+        </p:spPr>
+        <p:txBody>
+          <a:bodyPr wrap="square" rtlCol="0" anchor="ctr"/>
+          <a:lstStyle/>
+          <a:p>
+            <a:pPr indent="0" marL="0">
+              <a:buNone/>
+            </a:pPr>
+            <a:r>
+              <a:rPr lang="en-US" sz="1300" dirty="0">
+                <a:solidFill>
+                  <a:srgbClr val="6B7AB8"/>
+                </a:solidFill>
+                <a:latin typeface="Calibri" pitchFamily="34" charset="0"/>
+                <a:ea typeface="Calibri" pitchFamily="34" charset="-122"/>
+                <a:cs typeface="Calibri" pitchFamily="34" charset="-120"/>
+              </a:rPr>
+              <a:t>Bốn thuật toán chạy song song, hoạt ảnh từng bước đồng bộ.</a:t>
+            </a:r>
+            <a:endParaRPr lang="en-US" sz="1300" dirty="0"/>
+          </a:p>
+        </p:txBody>
+      </p:sp>
+      <p:sp>
+        <p:nvSpPr>
+          <p:cNvPr id="15" name="Shape 13"/>
+          <p:cNvSpPr/>
+          <p:nvPr/>
+        </p:nvSpPr>
+        <p:spPr>
+          <a:xfrm>
+            <a:off x="320040" y="3246120"/>
+            <a:ext cx="6309360" cy="987552"/>
+          </a:xfrm>
+          <a:prstGeom prst="roundRect">
+            <a:avLst>
+              <a:gd name="adj" fmla="val 7407"/>
+            </a:avLst>
+          </a:prstGeom>
+          <a:solidFill>
+            <a:srgbClr val="1C1945"/>
+          </a:solidFill>
+          <a:ln w="15240">
+            <a:solidFill>
+              <a:srgbClr val="363780"/>
+            </a:solidFill>
+            <a:prstDash val="solid"/>
+          </a:ln>
+        </p:spPr>
+      </p:sp>
+      <p:sp>
+        <p:nvSpPr>
+          <p:cNvPr id="16" name="Text 14"/>
+          <p:cNvSpPr/>
+          <p:nvPr/>
+        </p:nvSpPr>
+        <p:spPr>
+          <a:xfrm>
+            <a:off x="502920" y="3273552"/>
+            <a:ext cx="5943600" cy="384048"/>
+          </a:xfrm>
+          <a:prstGeom prst="rect">
+            <a:avLst/>
+          </a:prstGeom>
+          <a:noFill/>
+          <a:ln/>
+        </p:spPr>
+        <p:txBody>
+          <a:bodyPr wrap="square" rtlCol="0" anchor="ctr"/>
+          <a:lstStyle/>
+          <a:p>
+            <a:pPr indent="0" marL="0">
+              <a:buNone/>
+            </a:pPr>
+            <a:r>
+              <a:rPr lang="en-US" sz="1500" b="1" dirty="0">
+                <a:solidFill>
+                  <a:srgbClr val="34D399"/>
+                </a:solidFill>
+                <a:latin typeface="Calibri" pitchFamily="34" charset="0"/>
+                <a:ea typeface="Calibri" pitchFamily="34" charset="-122"/>
+                <a:cs typeface="Calibri" pitchFamily="34" charset="-120"/>
+              </a:rPr>
+              <a:t>⚙️ Điều chỉnh tốc độ</a:t>
+            </a:r>
+            <a:endParaRPr lang="en-US" sz="1500" dirty="0"/>
+          </a:p>
+        </p:txBody>
+      </p:sp>
+      <p:sp>
+        <p:nvSpPr>
+          <p:cNvPr id="17" name="Text 15"/>
+          <p:cNvSpPr/>
+          <p:nvPr/>
+        </p:nvSpPr>
+        <p:spPr>
+          <a:xfrm>
+            <a:off x="502920" y="3657600"/>
+            <a:ext cx="5943600" cy="502920"/>
+          </a:xfrm>
+          <a:prstGeom prst="rect">
+            <a:avLst/>
+          </a:prstGeom>
+          <a:noFill/>
+          <a:ln/>
+        </p:spPr>
+        <p:txBody>
+          <a:bodyPr wrap="square" rtlCol="0" anchor="ctr"/>
+          <a:lstStyle/>
+          <a:p>
+            <a:pPr indent="0" marL="0">
+              <a:buNone/>
+            </a:pPr>
+            <a:r>
+              <a:rPr lang="en-US" sz="1300" dirty="0">
+                <a:solidFill>
+                  <a:srgbClr val="6B7AB8"/>
+                </a:solidFill>
+                <a:latin typeface="Calibri" pitchFamily="34" charset="0"/>
+                <a:ea typeface="Calibri" pitchFamily="34" charset="-122"/>
+                <a:cs typeface="Calibri" pitchFamily="34" charset="-120"/>
+              </a:rPr>
+              <a:t>Thanh kéo 50ms–500ms điều chỉnh tốc độ hoạt ảnh theo thời gian thực.</a:t>
+            </a:r>
+            <a:endParaRPr lang="en-US" sz="1300" dirty="0"/>
+          </a:p>
+        </p:txBody>
+      </p:sp>
+      <p:sp>
+        <p:nvSpPr>
+          <p:cNvPr id="18" name="Shape 16"/>
+          <p:cNvSpPr/>
+          <p:nvPr/>
+        </p:nvSpPr>
+        <p:spPr>
+          <a:xfrm>
+            <a:off x="320040" y="4343400"/>
+            <a:ext cx="6309360" cy="987552"/>
+          </a:xfrm>
+          <a:prstGeom prst="roundRect">
+            <a:avLst>
+              <a:gd name="adj" fmla="val 7407"/>
+            </a:avLst>
+          </a:prstGeom>
+          <a:solidFill>
+            <a:srgbClr val="1C1945"/>
+          </a:solidFill>
+          <a:ln w="15240">
+            <a:solidFill>
+              <a:srgbClr val="363780"/>
+            </a:solidFill>
+            <a:prstDash val="solid"/>
+          </a:ln>
+        </p:spPr>
+      </p:sp>
+      <p:sp>
+        <p:nvSpPr>
+          <p:cNvPr id="19" name="Text 17"/>
+          <p:cNvSpPr/>
+          <p:nvPr/>
+        </p:nvSpPr>
+        <p:spPr>
+          <a:xfrm>
+            <a:off x="502920" y="4370832"/>
+            <a:ext cx="5943600" cy="384048"/>
+          </a:xfrm>
+          <a:prstGeom prst="rect">
+            <a:avLst/>
+          </a:prstGeom>
+          <a:noFill/>
+          <a:ln/>
+        </p:spPr>
+        <p:txBody>
+          <a:bodyPr wrap="square" rtlCol="0" anchor="ctr"/>
+          <a:lstStyle/>
+          <a:p>
+            <a:pPr indent="0" marL="0">
+              <a:buNone/>
+            </a:pPr>
+            <a:r>
+              <a:rPr lang="en-US" sz="1500" b="1" dirty="0">
+                <a:solidFill>
+                  <a:srgbClr val="34D399"/>
+                </a:solidFill>
+                <a:latin typeface="Calibri" pitchFamily="34" charset="0"/>
+                <a:ea typeface="Calibri" pitchFamily="34" charset="-122"/>
+                <a:cs typeface="Calibri" pitchFamily="34" charset="-120"/>
+              </a:rPr>
+              <a:t>👁  Toggle ẩn/hiện</a:t>
+            </a:r>
+            <a:endParaRPr lang="en-US" sz="1500" dirty="0"/>
+          </a:p>
+        </p:txBody>
+      </p:sp>
+      <p:sp>
+        <p:nvSpPr>
+          <p:cNvPr id="20" name="Text 18"/>
+          <p:cNvSpPr/>
+          <p:nvPr/>
+        </p:nvSpPr>
+        <p:spPr>
+          <a:xfrm>
+            <a:off x="502920" y="4754880"/>
+            <a:ext cx="5943600" cy="502920"/>
+          </a:xfrm>
+          <a:prstGeom prst="rect">
+            <a:avLst/>
+          </a:prstGeom>
+          <a:noFill/>
+          <a:ln/>
+        </p:spPr>
+        <p:txBody>
+          <a:bodyPr wrap="square" rtlCol="0" anchor="ctr"/>
+          <a:lstStyle/>
+          <a:p>
+            <a:pPr indent="0" marL="0">
+              <a:buNone/>
+            </a:pPr>
+            <a:r>
+              <a:rPr lang="en-US" sz="1300" dirty="0">
+                <a:solidFill>
+                  <a:srgbClr val="6B7AB8"/>
+                </a:solidFill>
+                <a:latin typeface="Calibri" pitchFamily="34" charset="0"/>
+                <a:ea typeface="Calibri" pitchFamily="34" charset="-122"/>
+                <a:cs typeface="Calibri" pitchFamily="34" charset="-120"/>
+              </a:rPr>
+              <a:t>Click thẻ thống kê để ẩn/hiện đường đi từng thuật toán.</a:t>
+            </a:r>
+            <a:endParaRPr lang="en-US" sz="1300" dirty="0"/>
+          </a:p>
+        </p:txBody>
+      </p:sp>
+      <p:sp>
+        <p:nvSpPr>
+          <p:cNvPr id="21" name="Shape 19"/>
+          <p:cNvSpPr/>
+          <p:nvPr/>
+        </p:nvSpPr>
+        <p:spPr>
+          <a:xfrm>
+            <a:off x="320040" y="5440680"/>
+            <a:ext cx="6309360" cy="987552"/>
+          </a:xfrm>
+          <a:prstGeom prst="roundRect">
+            <a:avLst>
+              <a:gd name="adj" fmla="val 7407"/>
+            </a:avLst>
+          </a:prstGeom>
+          <a:solidFill>
+            <a:srgbClr val="1C1945"/>
+          </a:solidFill>
+          <a:ln w="15240">
+            <a:solidFill>
+              <a:srgbClr val="363780"/>
+            </a:solidFill>
+            <a:prstDash val="solid"/>
+          </a:ln>
+        </p:spPr>
+      </p:sp>
+      <p:sp>
+        <p:nvSpPr>
+          <p:cNvPr id="22" name="Text 20"/>
+          <p:cNvSpPr/>
+          <p:nvPr/>
+        </p:nvSpPr>
+        <p:spPr>
+          <a:xfrm>
+            <a:off x="502920" y="5468112"/>
+            <a:ext cx="5943600" cy="384048"/>
+          </a:xfrm>
+          <a:prstGeom prst="rect">
+            <a:avLst/>
+          </a:prstGeom>
+          <a:noFill/>
+          <a:ln/>
+        </p:spPr>
+        <p:txBody>
+          <a:bodyPr wrap="square" rtlCol="0" anchor="ctr"/>
+          <a:lstStyle/>
+          <a:p>
+            <a:pPr indent="0" marL="0">
+              <a:buNone/>
+            </a:pPr>
+            <a:r>
+              <a:rPr lang="en-US" sz="1500" b="1" dirty="0">
+                <a:solidFill>
+                  <a:srgbClr val="34D399"/>
+                </a:solidFill>
+                <a:latin typeface="Calibri" pitchFamily="34" charset="0"/>
+                <a:ea typeface="Calibri" pitchFamily="34" charset="-122"/>
+                <a:cs typeface="Calibri" pitchFamily="34" charset="-120"/>
+              </a:rPr>
+              <a:t>🔄 Concentric Rings</a:t>
+            </a:r>
+            <a:endParaRPr lang="en-US" sz="1500" dirty="0"/>
+          </a:p>
+        </p:txBody>
+      </p:sp>
+      <p:sp>
+        <p:nvSpPr>
+          <p:cNvPr id="23" name="Text 21"/>
+          <p:cNvSpPr/>
+          <p:nvPr/>
+        </p:nvSpPr>
+        <p:spPr>
+          <a:xfrm>
+            <a:off x="502920" y="5852160"/>
+            <a:ext cx="5943600" cy="502920"/>
+          </a:xfrm>
+          <a:prstGeom prst="rect">
+            <a:avLst/>
+          </a:prstGeom>
+          <a:noFill/>
+          <a:ln/>
+        </p:spPr>
+        <p:txBody>
+          <a:bodyPr wrap="square" rtlCol="0" anchor="ctr"/>
+          <a:lstStyle/>
+          <a:p>
+            <a:pPr indent="0" marL="0">
+              <a:buNone/>
+            </a:pPr>
+            <a:r>
+              <a:rPr lang="en-US" sz="1300" dirty="0">
+                <a:solidFill>
+                  <a:srgbClr val="6B7AB8"/>
+                </a:solidFill>
+                <a:latin typeface="Calibri" pitchFamily="34" charset="0"/>
+                <a:ea typeface="Calibri" pitchFamily="34" charset="-122"/>
+                <a:cs typeface="Calibri" pitchFamily="34" charset="-120"/>
+              </a:rPr>
+              <a:t>BFS 8px · DFS 6px · Dijkstra 4px · A* 2px — thấy cả 4 cùng lúc.</a:t>
+            </a:r>
+            <a:endParaRPr lang="en-US" sz="1300" dirty="0"/>
+          </a:p>
+        </p:txBody>
+      </p:sp>
+      <p:sp>
+        <p:nvSpPr>
+          <p:cNvPr id="24" name="Shape 22"/>
+          <p:cNvSpPr/>
+          <p:nvPr/>
+        </p:nvSpPr>
+        <p:spPr>
+          <a:xfrm>
+            <a:off x="6995160" y="1051560"/>
+            <a:ext cx="4846320" cy="5486400"/>
+          </a:xfrm>
+          <a:prstGeom prst="roundRect">
+            <a:avLst>
+              <a:gd name="adj" fmla="val 1509"/>
+            </a:avLst>
+          </a:prstGeom>
+          <a:solidFill>
+            <a:srgbClr val="1C1945"/>
+          </a:solidFill>
+          <a:ln w="15240">
+            <a:solidFill>
+              <a:srgbClr val="363780"/>
+            </a:solidFill>
+            <a:prstDash val="solid"/>
+          </a:ln>
+        </p:spPr>
+      </p:sp>
+      <p:sp>
+        <p:nvSpPr>
+          <p:cNvPr id="25" name="Text 23"/>
+          <p:cNvSpPr/>
+          <p:nvPr/>
+        </p:nvSpPr>
+        <p:spPr>
+          <a:xfrm>
+            <a:off x="6995160" y="1097280"/>
+            <a:ext cx="4846320" cy="411480"/>
+          </a:xfrm>
+          <a:prstGeom prst="rect">
+            <a:avLst/>
+          </a:prstGeom>
+          <a:noFill/>
+          <a:ln/>
+        </p:spPr>
+        <p:txBody>
+          <a:bodyPr wrap="square" rtlCol="0" anchor="ctr"/>
+          <a:lstStyle/>
+          <a:p>
+            <a:pPr algn="ctr" indent="0" marL="0">
+              <a:buNone/>
+            </a:pPr>
+            <a:r>
+              <a:rPr lang="en-US" sz="1400" b="1" dirty="0">
+                <a:solidFill>
+                  <a:srgbClr val="6B7AB8"/>
+                </a:solidFill>
+                <a:latin typeface="Calibri" pitchFamily="34" charset="0"/>
+                <a:ea typeface="Calibri" pitchFamily="34" charset="-122"/>
+                <a:cs typeface="Calibri" pitchFamily="34" charset="-120"/>
+              </a:rPr>
+              <a:t>Bảng màu thuật toán</a:t>
+            </a:r>
+            <a:endParaRPr lang="en-US" sz="1400" dirty="0"/>
+          </a:p>
+        </p:txBody>
+      </p:sp>
+      <p:sp>
+        <p:nvSpPr>
+          <p:cNvPr id="26" name="Shape 24"/>
+          <p:cNvSpPr/>
+          <p:nvPr/>
+        </p:nvSpPr>
+        <p:spPr>
+          <a:xfrm>
+            <a:off x="7178040" y="1645920"/>
+            <a:ext cx="4480560" cy="960120"/>
+          </a:xfrm>
+          <a:prstGeom prst="roundRect">
+            <a:avLst>
+              <a:gd name="adj" fmla="val 7619"/>
+            </a:avLst>
+          </a:prstGeom>
+          <a:solidFill>
+            <a:srgbClr val="1C1945"/>
+          </a:solidFill>
+          <a:ln w="15240">
+            <a:solidFill>
+              <a:srgbClr val="4ECDC4"/>
+            </a:solidFill>
+            <a:prstDash val="solid"/>
+          </a:ln>
+        </p:spPr>
+      </p:sp>
+      <p:sp>
+        <p:nvSpPr>
+          <p:cNvPr id="27" name="Shape 25"/>
+          <p:cNvSpPr/>
+          <p:nvPr/>
+        </p:nvSpPr>
+        <p:spPr>
+          <a:xfrm>
+            <a:off x="7223760" y="1755648"/>
+            <a:ext cx="146304" cy="731520"/>
+          </a:xfrm>
+          <a:prstGeom prst="rect">
+            <a:avLst/>
+          </a:prstGeom>
+          <a:solidFill>
+            <a:srgbClr val="4ECDC4"/>
+          </a:solidFill>
+          <a:ln w="12700">
+            <a:solidFill>
+              <a:srgbClr val="4ECDC4"/>
+            </a:solidFill>
+            <a:prstDash val="solid"/>
+          </a:ln>
+        </p:spPr>
+      </p:sp>
+      <p:sp>
+        <p:nvSpPr>
+          <p:cNvPr id="28" name="Text 26"/>
+          <p:cNvSpPr/>
+          <p:nvPr/>
+        </p:nvSpPr>
+        <p:spPr>
+          <a:xfrm>
+            <a:off x="7516368" y="1700784"/>
+            <a:ext cx="3931920" cy="402336"/>
+          </a:xfrm>
+          <a:prstGeom prst="rect">
+            <a:avLst/>
+          </a:prstGeom>
+          <a:noFill/>
+          <a:ln/>
+        </p:spPr>
+        <p:txBody>
+          <a:bodyPr wrap="square" rtlCol="0" anchor="ctr"/>
+          <a:lstStyle/>
+          <a:p>
+            <a:pPr indent="0" marL="0">
+              <a:buNone/>
+            </a:pPr>
+            <a:r>
+              <a:rPr lang="en-US" sz="1800" b="1" dirty="0">
+                <a:solidFill>
+                  <a:srgbClr val="4ECDC4"/>
+                </a:solidFill>
+                <a:latin typeface="Calibri" pitchFamily="34" charset="0"/>
+                <a:ea typeface="Calibri" pitchFamily="34" charset="-122"/>
+                <a:cs typeface="Calibri" pitchFamily="34" charset="-120"/>
+              </a:rPr>
+              <a:t>BFS</a:t>
+            </a:r>
+            <a:endParaRPr lang="en-US" sz="1800" dirty="0"/>
+          </a:p>
+        </p:txBody>
+      </p:sp>
+      <p:sp>
+        <p:nvSpPr>
+          <p:cNvPr id="29" name="Text 27"/>
+          <p:cNvSpPr/>
+          <p:nvPr/>
+        </p:nvSpPr>
+        <p:spPr>
+          <a:xfrm>
+            <a:off x="7516368" y="2139696"/>
+            <a:ext cx="3931920" cy="347472"/>
+          </a:xfrm>
+          <a:prstGeom prst="rect">
+            <a:avLst/>
+          </a:prstGeom>
+          <a:noFill/>
+          <a:ln/>
+        </p:spPr>
+        <p:txBody>
+          <a:bodyPr wrap="square" rtlCol="0" anchor="ctr"/>
+          <a:lstStyle/>
+          <a:p>
+            <a:pPr indent="0" marL="0">
+              <a:buNone/>
+            </a:pPr>
+            <a:r>
+              <a:rPr lang="en-US" sz="1200" dirty="0">
+                <a:solidFill>
+                  <a:srgbClr val="6B7AB8"/>
+                </a:solidFill>
+                <a:latin typeface="Calibri" pitchFamily="34" charset="0"/>
+                <a:ea typeface="Calibri" pitchFamily="34" charset="-122"/>
+                <a:cs typeface="Calibri" pitchFamily="34" charset="-120"/>
+              </a:rPr>
+              <a:t>8px — ngoài cùng</a:t>
+            </a:r>
+            <a:endParaRPr lang="en-US" sz="1200" dirty="0"/>
+          </a:p>
+        </p:txBody>
+      </p:sp>
+      <p:sp>
+        <p:nvSpPr>
+          <p:cNvPr id="30" name="Shape 28"/>
+          <p:cNvSpPr/>
+          <p:nvPr/>
+        </p:nvSpPr>
+        <p:spPr>
+          <a:xfrm>
+            <a:off x="7178040" y="2743200"/>
+            <a:ext cx="4480560" cy="960120"/>
+          </a:xfrm>
+          <a:prstGeom prst="roundRect">
+            <a:avLst>
+              <a:gd name="adj" fmla="val 7619"/>
+            </a:avLst>
+          </a:prstGeom>
+          <a:solidFill>
+            <a:srgbClr val="1C1945"/>
+          </a:solidFill>
+          <a:ln w="15240">
+            <a:solidFill>
+              <a:srgbClr val="FF6B6B"/>
+            </a:solidFill>
+            <a:prstDash val="solid"/>
+          </a:ln>
+        </p:spPr>
+      </p:sp>
+      <p:sp>
+        <p:nvSpPr>
+          <p:cNvPr id="31" name="Shape 29"/>
+          <p:cNvSpPr/>
+          <p:nvPr/>
+        </p:nvSpPr>
+        <p:spPr>
+          <a:xfrm>
+            <a:off x="7223760" y="2852928"/>
+            <a:ext cx="146304" cy="731520"/>
+          </a:xfrm>
+          <a:prstGeom prst="rect">
+            <a:avLst/>
+          </a:prstGeom>
+          <a:solidFill>
+            <a:srgbClr val="FF6B6B"/>
+          </a:solidFill>
+          <a:ln w="12700">
+            <a:solidFill>
+              <a:srgbClr val="FF6B6B"/>
+            </a:solidFill>
+            <a:prstDash val="solid"/>
+          </a:ln>
+        </p:spPr>
+      </p:sp>
+      <p:sp>
+        <p:nvSpPr>
+          <p:cNvPr id="32" name="Text 30"/>
+          <p:cNvSpPr/>
+          <p:nvPr/>
+        </p:nvSpPr>
+        <p:spPr>
+          <a:xfrm>
+            <a:off x="7516368" y="2798064"/>
+            <a:ext cx="3931920" cy="402336"/>
+          </a:xfrm>
+          <a:prstGeom prst="rect">
+            <a:avLst/>
+          </a:prstGeom>
+          <a:noFill/>
+          <a:ln/>
+        </p:spPr>
+        <p:txBody>
+          <a:bodyPr wrap="square" rtlCol="0" anchor="ctr"/>
+          <a:lstStyle/>
+          <a:p>
+            <a:pPr indent="0" marL="0">
+              <a:buNone/>
+            </a:pPr>
+            <a:r>
+              <a:rPr lang="en-US" sz="1800" b="1" dirty="0">
+                <a:solidFill>
+                  <a:srgbClr val="FF6B6B"/>
+                </a:solidFill>
+                <a:latin typeface="Calibri" pitchFamily="34" charset="0"/>
+                <a:ea typeface="Calibri" pitchFamily="34" charset="-122"/>
+                <a:cs typeface="Calibri" pitchFamily="34" charset="-120"/>
+              </a:rPr>
+              <a:t>DFS</a:t>
+            </a:r>
+            <a:endParaRPr lang="en-US" sz="1800" dirty="0"/>
+          </a:p>
+        </p:txBody>
+      </p:sp>
+      <p:sp>
+        <p:nvSpPr>
+          <p:cNvPr id="33" name="Text 31"/>
+          <p:cNvSpPr/>
+          <p:nvPr/>
+        </p:nvSpPr>
+        <p:spPr>
+          <a:xfrm>
+            <a:off x="7516368" y="3236976"/>
+            <a:ext cx="3931920" cy="347472"/>
+          </a:xfrm>
+          <a:prstGeom prst="rect">
+            <a:avLst/>
+          </a:prstGeom>
+          <a:noFill/>
+          <a:ln/>
+        </p:spPr>
+        <p:txBody>
+          <a:bodyPr wrap="square" rtlCol="0" anchor="ctr"/>
+          <a:lstStyle/>
+          <a:p>
+            <a:pPr indent="0" marL="0">
+              <a:buNone/>
+            </a:pPr>
+            <a:r>
+              <a:rPr lang="en-US" sz="1200" dirty="0">
+                <a:solidFill>
+                  <a:srgbClr val="6B7AB8"/>
+                </a:solidFill>
+                <a:latin typeface="Calibri" pitchFamily="34" charset="0"/>
+                <a:ea typeface="Calibri" pitchFamily="34" charset="-122"/>
+                <a:cs typeface="Calibri" pitchFamily="34" charset="-120"/>
+              </a:rPr>
+              <a:t>6px</a:t>
+            </a:r>
+            <a:endParaRPr lang="en-US" sz="1200" dirty="0"/>
+          </a:p>
+        </p:txBody>
+      </p:sp>
+      <p:sp>
+        <p:nvSpPr>
+          <p:cNvPr id="34" name="Shape 32"/>
+          <p:cNvSpPr/>
+          <p:nvPr/>
+        </p:nvSpPr>
+        <p:spPr>
+          <a:xfrm>
+            <a:off x="7178040" y="3840480"/>
+            <a:ext cx="4480560" cy="960120"/>
+          </a:xfrm>
+          <a:prstGeom prst="roundRect">
+            <a:avLst>
+              <a:gd name="adj" fmla="val 7619"/>
+            </a:avLst>
+          </a:prstGeom>
+          <a:solidFill>
+            <a:srgbClr val="1C1945"/>
+          </a:solidFill>
+          <a:ln w="15240">
+            <a:solidFill>
+              <a:srgbClr val="FFD166"/>
+            </a:solidFill>
+            <a:prstDash val="solid"/>
+          </a:ln>
+        </p:spPr>
+      </p:sp>
+      <p:sp>
+        <p:nvSpPr>
+          <p:cNvPr id="35" name="Shape 33"/>
+          <p:cNvSpPr/>
+          <p:nvPr/>
+        </p:nvSpPr>
+        <p:spPr>
+          <a:xfrm>
+            <a:off x="7223760" y="3950208"/>
+            <a:ext cx="146304" cy="731520"/>
+          </a:xfrm>
+          <a:prstGeom prst="rect">
+            <a:avLst/>
+          </a:prstGeom>
+          <a:solidFill>
+            <a:srgbClr val="FFD166"/>
+          </a:solidFill>
+          <a:ln w="12700">
+            <a:solidFill>
+              <a:srgbClr val="FFD166"/>
+            </a:solidFill>
+            <a:prstDash val="solid"/>
+          </a:ln>
+        </p:spPr>
+      </p:sp>
+      <p:sp>
+        <p:nvSpPr>
+          <p:cNvPr id="36" name="Text 34"/>
+          <p:cNvSpPr/>
+          <p:nvPr/>
+        </p:nvSpPr>
+        <p:spPr>
+          <a:xfrm>
+            <a:off x="7516368" y="3895344"/>
+            <a:ext cx="3931920" cy="402336"/>
+          </a:xfrm>
+          <a:prstGeom prst="rect">
+            <a:avLst/>
+          </a:prstGeom>
+          <a:noFill/>
+          <a:ln/>
+        </p:spPr>
+        <p:txBody>
+          <a:bodyPr wrap="square" rtlCol="0" anchor="ctr"/>
+          <a:lstStyle/>
+          <a:p>
+            <a:pPr indent="0" marL="0">
+              <a:buNone/>
+            </a:pPr>
+            <a:r>
+              <a:rPr lang="en-US" sz="1800" b="1" dirty="0">
+                <a:solidFill>
+                  <a:srgbClr val="FFD166"/>
+                </a:solidFill>
+                <a:latin typeface="Calibri" pitchFamily="34" charset="0"/>
+                <a:ea typeface="Calibri" pitchFamily="34" charset="-122"/>
+                <a:cs typeface="Calibri" pitchFamily="34" charset="-120"/>
+              </a:rPr>
+              <a:t>Dijkstra</a:t>
+            </a:r>
+            <a:endParaRPr lang="en-US" sz="1800" dirty="0"/>
+          </a:p>
+        </p:txBody>
+      </p:sp>
+      <p:sp>
+        <p:nvSpPr>
+          <p:cNvPr id="37" name="Text 35"/>
+          <p:cNvSpPr/>
+          <p:nvPr/>
+        </p:nvSpPr>
+        <p:spPr>
+          <a:xfrm>
+            <a:off x="7516368" y="4334256"/>
+            <a:ext cx="3931920" cy="347472"/>
+          </a:xfrm>
+          <a:prstGeom prst="rect">
+            <a:avLst/>
+          </a:prstGeom>
+          <a:noFill/>
+          <a:ln/>
+        </p:spPr>
+        <p:txBody>
+          <a:bodyPr wrap="square" rtlCol="0" anchor="ctr"/>
+          <a:lstStyle/>
+          <a:p>
+            <a:pPr indent="0" marL="0">
+              <a:buNone/>
+            </a:pPr>
+            <a:r>
+              <a:rPr lang="en-US" sz="1200" dirty="0">
+                <a:solidFill>
+                  <a:srgbClr val="6B7AB8"/>
+                </a:solidFill>
+                <a:latin typeface="Calibri" pitchFamily="34" charset="0"/>
+                <a:ea typeface="Calibri" pitchFamily="34" charset="-122"/>
+                <a:cs typeface="Calibri" pitchFamily="34" charset="-120"/>
+              </a:rPr>
+              <a:t>4px</a:t>
+            </a:r>
+            <a:endParaRPr lang="en-US" sz="1200" dirty="0"/>
+          </a:p>
+        </p:txBody>
+      </p:sp>
+      <p:sp>
+        <p:nvSpPr>
+          <p:cNvPr id="38" name="Shape 36"/>
+          <p:cNvSpPr/>
+          <p:nvPr/>
+        </p:nvSpPr>
+        <p:spPr>
+          <a:xfrm>
+            <a:off x="7178040" y="4937760"/>
+            <a:ext cx="4480560" cy="960120"/>
+          </a:xfrm>
+          <a:prstGeom prst="roundRect">
+            <a:avLst>
+              <a:gd name="adj" fmla="val 7619"/>
+            </a:avLst>
+          </a:prstGeom>
+          <a:solidFill>
+            <a:srgbClr val="1C1945"/>
+          </a:solidFill>
+          <a:ln w="15240">
+            <a:solidFill>
+              <a:srgbClr val="06D6A0"/>
+            </a:solidFill>
+            <a:prstDash val="solid"/>
+          </a:ln>
+        </p:spPr>
+      </p:sp>
+      <p:sp>
+        <p:nvSpPr>
+          <p:cNvPr id="39" name="Shape 37"/>
+          <p:cNvSpPr/>
+          <p:nvPr/>
+        </p:nvSpPr>
+        <p:spPr>
+          <a:xfrm>
+            <a:off x="7223760" y="5047488"/>
+            <a:ext cx="146304" cy="731520"/>
+          </a:xfrm>
+          <a:prstGeom prst="rect">
+            <a:avLst/>
+          </a:prstGeom>
+          <a:solidFill>
+            <a:srgbClr val="06D6A0"/>
+          </a:solidFill>
+          <a:ln w="12700">
+            <a:solidFill>
+              <a:srgbClr val="06D6A0"/>
+            </a:solidFill>
+            <a:prstDash val="solid"/>
+          </a:ln>
+        </p:spPr>
+      </p:sp>
+      <p:sp>
+        <p:nvSpPr>
+          <p:cNvPr id="40" name="Text 38"/>
+          <p:cNvSpPr/>
+          <p:nvPr/>
+        </p:nvSpPr>
+        <p:spPr>
+          <a:xfrm>
+            <a:off x="7516368" y="4992624"/>
+            <a:ext cx="3931920" cy="402336"/>
+          </a:xfrm>
+          <a:prstGeom prst="rect">
+            <a:avLst/>
+          </a:prstGeom>
+          <a:noFill/>
+          <a:ln/>
+        </p:spPr>
+        <p:txBody>
+          <a:bodyPr wrap="square" rtlCol="0" anchor="ctr"/>
+          <a:lstStyle/>
+          <a:p>
+            <a:pPr indent="0" marL="0">
+              <a:buNone/>
+            </a:pPr>
+            <a:r>
+              <a:rPr lang="en-US" sz="1800" b="1" dirty="0">
+                <a:solidFill>
+                  <a:srgbClr val="06D6A0"/>
+                </a:solidFill>
+                <a:latin typeface="Calibri" pitchFamily="34" charset="0"/>
+                <a:ea typeface="Calibri" pitchFamily="34" charset="-122"/>
+                <a:cs typeface="Calibri" pitchFamily="34" charset="-120"/>
+              </a:rPr>
+              <a:t>A*</a:t>
+            </a:r>
+            <a:endParaRPr lang="en-US" sz="1800" dirty="0"/>
+          </a:p>
+        </p:txBody>
+      </p:sp>
+      <p:sp>
+        <p:nvSpPr>
+          <p:cNvPr id="41" name="Text 39"/>
+          <p:cNvSpPr/>
+          <p:nvPr/>
+        </p:nvSpPr>
+        <p:spPr>
+          <a:xfrm>
+            <a:off x="7516368" y="5431536"/>
+            <a:ext cx="3931920" cy="347472"/>
+          </a:xfrm>
+          <a:prstGeom prst="rect">
+            <a:avLst/>
+          </a:prstGeom>
+          <a:noFill/>
+          <a:ln/>
+        </p:spPr>
+        <p:txBody>
+          <a:bodyPr wrap="square" rtlCol="0" anchor="ctr"/>
+          <a:lstStyle/>
+          <a:p>
+            <a:pPr indent="0" marL="0">
+              <a:buNone/>
+            </a:pPr>
+            <a:r>
+              <a:rPr lang="en-US" sz="1200" dirty="0">
+                <a:solidFill>
+                  <a:srgbClr val="6B7AB8"/>
+                </a:solidFill>
+                <a:latin typeface="Calibri" pitchFamily="34" charset="0"/>
+                <a:ea typeface="Calibri" pitchFamily="34" charset="-122"/>
+                <a:cs typeface="Calibri" pitchFamily="34" charset="-120"/>
+              </a:rPr>
+              <a:t>2px — trong cùng</a:t>
+            </a:r>
+            <a:endParaRPr lang="en-US" sz="1200" dirty="0"/>
+          </a:p>
+        </p:txBody>
+      </p:sp>
+    </p:spTree>
+  </p:cSld>
+  <p:clrMapOvr>
+    <a:masterClrMapping/>
+  </p:clrMapOvr>
+</p:sld>
+</file>
+
+<file path=ppt/slides/slide8.xml><?xml version="1.0" encoding="utf-8"?>
+<p:sld xmlns:a="http://schemas.openxmlformats.org/drawingml/2006/main" xmlns:r="http://schemas.openxmlformats.org/officeDocument/2006/relationships" xmlns:p="http://schemas.openxmlformats.org/presentationml/2006/main">
+  <p:cSld name="Slide 8">
+    <p:spTree>
+      <p:nvGrpSpPr>
+        <p:cNvPr id="1" name=""/>
+        <p:cNvGrpSpPr/>
+        <p:nvPr/>
+      </p:nvGrpSpPr>
+      <p:grpSpPr>
+        <a:xfrm>
+          <a:off x="0" y="0"/>
+          <a:ext cx="0" cy="0"/>
+          <a:chOff x="0" y="0"/>
+          <a:chExt cx="0" cy="0"/>
+        </a:xfrm>
+      </p:grpSpPr>
+      <p:sp>
+        <p:nvSpPr>
+          <p:cNvPr id="2" name="Shape 0"/>
+          <p:cNvSpPr/>
+          <p:nvPr/>
+        </p:nvSpPr>
+        <p:spPr>
+          <a:xfrm>
+            <a:off x="0" y="0"/>
+            <a:ext cx="12188952" cy="6858000"/>
+          </a:xfrm>
+          <a:prstGeom prst="rect">
+            <a:avLst/>
+          </a:prstGeom>
+          <a:solidFill>
+            <a:srgbClr val="0F0C29"/>
+          </a:solidFill>
+          <a:ln w="12700">
+            <a:solidFill>
+              <a:srgbClr val="0F0C29"/>
+            </a:solidFill>
+            <a:prstDash val="solid"/>
+          </a:ln>
+        </p:spPr>
+      </p:sp>
+      <p:sp>
+        <p:nvSpPr>
+          <p:cNvPr id="3" name="Shape 1"/>
+          <p:cNvSpPr/>
+          <p:nvPr/>
+        </p:nvSpPr>
+        <p:spPr>
+          <a:xfrm>
+            <a:off x="0" y="0"/>
+            <a:ext cx="12188952" cy="4114800"/>
+          </a:xfrm>
+          <a:prstGeom prst="rect">
+            <a:avLst/>
+          </a:prstGeom>
+          <a:solidFill>
+            <a:srgbClr val="1E1B4B">
+              <a:alpha val="70000"/>
+            </a:srgbClr>
+          </a:solidFill>
+          <a:ln w="12700">
+            <a:solidFill>
+              <a:srgbClr val="1E1B4B">
+                <a:alpha val="70000"/>
+              </a:srgbClr>
+            </a:solidFill>
+            <a:prstDash val="solid"/>
+          </a:ln>
+        </p:spPr>
+      </p:sp>
+      <p:sp>
+        <p:nvSpPr>
+          <p:cNvPr id="4" name="Shape 2"/>
+          <p:cNvSpPr/>
+          <p:nvPr/>
+        </p:nvSpPr>
+        <p:spPr>
+          <a:xfrm>
+            <a:off x="5486400" y="0"/>
+            <a:ext cx="6702552" cy="6858000"/>
+          </a:xfrm>
+          <a:prstGeom prst="rect">
+            <a:avLst/>
+          </a:prstGeom>
+          <a:solidFill>
+            <a:srgbClr val="312E81">
+              <a:alpha val="50000"/>
+            </a:srgbClr>
+          </a:solidFill>
+          <a:ln w="12700">
+            <a:solidFill>
+              <a:srgbClr val="312E81">
+                <a:alpha val="50000"/>
+              </a:srgbClr>
+            </a:solidFill>
+            <a:prstDash val="solid"/>
+          </a:ln>
+        </p:spPr>
+      </p:sp>
+      <p:sp>
+        <p:nvSpPr>
+          <p:cNvPr id="5" name="Shape 3"/>
+          <p:cNvSpPr/>
+          <p:nvPr/>
+        </p:nvSpPr>
+        <p:spPr>
+          <a:xfrm>
+            <a:off x="0" y="0"/>
+            <a:ext cx="54864" cy="3429000"/>
+          </a:xfrm>
+          <a:prstGeom prst="rect">
+            <a:avLst/>
+          </a:prstGeom>
+          <a:solidFill>
+            <a:srgbClr val="818CF8"/>
+          </a:solidFill>
+          <a:ln w="12700">
+            <a:solidFill>
+              <a:srgbClr val="818CF8"/>
+            </a:solidFill>
+            <a:prstDash val="solid"/>
+          </a:ln>
+        </p:spPr>
+      </p:sp>
+      <p:sp>
+        <p:nvSpPr>
+          <p:cNvPr id="6" name="Shape 4"/>
+          <p:cNvSpPr/>
+          <p:nvPr/>
+        </p:nvSpPr>
+        <p:spPr>
+          <a:xfrm>
+            <a:off x="0" y="3429000"/>
+            <a:ext cx="54864" cy="3429000"/>
+          </a:xfrm>
+          <a:prstGeom prst="rect">
+            <a:avLst/>
+          </a:prstGeom>
+          <a:solidFill>
+            <a:srgbClr val="34D399"/>
+          </a:solidFill>
+          <a:ln w="12700">
+            <a:solidFill>
+              <a:srgbClr val="34D399"/>
+            </a:solidFill>
+            <a:prstDash val="solid"/>
+          </a:ln>
+        </p:spPr>
+      </p:sp>
+      <p:sp>
+        <p:nvSpPr>
+          <p:cNvPr id="7" name="Text 5"/>
+          <p:cNvSpPr/>
+          <p:nvPr/>
+        </p:nvSpPr>
+        <p:spPr>
+          <a:xfrm>
+            <a:off x="365760" y="274320"/>
+            <a:ext cx="11430000" cy="548640"/>
+          </a:xfrm>
+          <a:prstGeom prst="rect">
+            <a:avLst/>
+          </a:prstGeom>
+          <a:noFill/>
+          <a:ln/>
+        </p:spPr>
+        <p:txBody>
+          <a:bodyPr wrap="square" rtlCol="0" anchor="ctr"/>
+          <a:lstStyle/>
+          <a:p>
+            <a:pPr algn="l" indent="0" marL="0">
+              <a:buNone/>
+            </a:pPr>
+            <a:r>
+              <a:rPr lang="en-US" sz="2600" b="1" dirty="0">
+                <a:solidFill>
+                  <a:srgbClr val="34D399"/>
+                </a:solidFill>
+                <a:latin typeface="Calibri" pitchFamily="34" charset="0"/>
+                <a:ea typeface="Calibri" pitchFamily="34" charset="-122"/>
+                <a:cs typeface="Calibri" pitchFamily="34" charset="-120"/>
+              </a:rPr>
+              <a:t>06. Demo — Giao Diện Thực Tế</a:t>
+            </a:r>
+            <a:endParaRPr lang="en-US" sz="2600" dirty="0"/>
+          </a:p>
+        </p:txBody>
+      </p:sp>
+      <p:sp>
+        <p:nvSpPr>
+          <p:cNvPr id="8" name="Shape 6"/>
+          <p:cNvSpPr/>
+          <p:nvPr/>
+        </p:nvSpPr>
+        <p:spPr>
+          <a:xfrm>
+            <a:off x="365760" y="868680"/>
+            <a:ext cx="11430000" cy="27432"/>
+          </a:xfrm>
+          <a:prstGeom prst="rect">
+            <a:avLst/>
+          </a:prstGeom>
+          <a:solidFill>
+            <a:srgbClr val="34D399"/>
+          </a:solidFill>
+          <a:ln w="12700">
+            <a:solidFill>
+              <a:srgbClr val="34D399"/>
+            </a:solidFill>
+            <a:prstDash val="solid"/>
+          </a:ln>
+        </p:spPr>
+      </p:sp>
+      <p:sp>
+        <p:nvSpPr>
+          <p:cNvPr id="9" name="Shape 7"/>
+          <p:cNvSpPr/>
+          <p:nvPr/>
+        </p:nvSpPr>
+        <p:spPr>
+          <a:xfrm>
+            <a:off x="320040" y="1051560"/>
+            <a:ext cx="7680960" cy="5486400"/>
+          </a:xfrm>
+          <a:prstGeom prst="roundRect">
+            <a:avLst>
+              <a:gd name="adj" fmla="val 1333"/>
+            </a:avLst>
+          </a:prstGeom>
+          <a:solidFill>
+            <a:srgbClr val="1C1945"/>
+          </a:solidFill>
+          <a:ln w="15240">
+            <a:solidFill>
+              <a:srgbClr val="34D399"/>
+            </a:solidFill>
+            <a:prstDash val="solid"/>
+          </a:ln>
+        </p:spPr>
+      </p:sp>
+      <p:sp>
+        <p:nvSpPr>
+          <p:cNvPr id="10" name="Text 8"/>
+          <p:cNvSpPr/>
+          <p:nvPr/>
+        </p:nvSpPr>
+        <p:spPr>
+          <a:xfrm>
+            <a:off x="320040" y="1051560"/>
+            <a:ext cx="7680960" cy="2926080"/>
+          </a:xfrm>
+          <a:prstGeom prst="rect">
+            <a:avLst/>
+          </a:prstGeom>
+          <a:noFill/>
+          <a:ln/>
+        </p:spPr>
+        <p:txBody>
+          <a:bodyPr wrap="square" rtlCol="0" anchor="ctr"/>
+          <a:lstStyle/>
+          <a:p>
+            <a:pPr algn="ctr" indent="0" marL="0">
+              <a:buNone/>
+            </a:pPr>
+            <a:r>
+              <a:rPr lang="en-US" sz="5600" dirty="0">
+                <a:solidFill>
+                  <a:srgbClr val="000000"/>
+                </a:solidFill>
+              </a:rPr>
+              <a:t>🗺️</a:t>
+            </a:r>
+            <a:endParaRPr lang="en-US" sz="5600" dirty="0"/>
+          </a:p>
+        </p:txBody>
+      </p:sp>
+      <p:sp>
+        <p:nvSpPr>
+          <p:cNvPr id="11" name="Text 9"/>
+          <p:cNvSpPr/>
+          <p:nvPr/>
+        </p:nvSpPr>
+        <p:spPr>
+          <a:xfrm>
+            <a:off x="320040" y="3977640"/>
+            <a:ext cx="7680960" cy="457200"/>
+          </a:xfrm>
+          <a:prstGeom prst="rect">
+            <a:avLst/>
+          </a:prstGeom>
+          <a:noFill/>
+          <a:ln/>
+        </p:spPr>
+        <p:txBody>
+          <a:bodyPr wrap="square" rtlCol="0" anchor="ctr"/>
+          <a:lstStyle/>
+          <a:p>
+            <a:pPr algn="ctr" indent="0" marL="0">
+              <a:buNone/>
+            </a:pPr>
+            <a:r>
+              <a:rPr lang="en-US" sz="1300" dirty="0">
+                <a:solidFill>
+                  <a:srgbClr val="6B7AB8"/>
+                </a:solidFill>
+                <a:latin typeface="Calibri" pitchFamily="34" charset="0"/>
+                <a:ea typeface="Calibri" pitchFamily="34" charset="-122"/>
+                <a:cs typeface="Calibri" pitchFamily="34" charset="-120"/>
+              </a:rPr>
+              <a:t>Screenshot bản đồ — hoạt ảnh 4 thuật toán</a:t>
+            </a:r>
+            <a:endParaRPr lang="en-US" sz="1300" dirty="0"/>
+          </a:p>
+        </p:txBody>
+      </p:sp>
+      <p:sp>
+        <p:nvSpPr>
+          <p:cNvPr id="12" name="Shape 10"/>
+          <p:cNvSpPr/>
+          <p:nvPr/>
+        </p:nvSpPr>
+        <p:spPr>
+          <a:xfrm>
+            <a:off x="2286000" y="4480560"/>
+            <a:ext cx="822960" cy="164592"/>
+          </a:xfrm>
+          <a:prstGeom prst="rect">
+            <a:avLst/>
+          </a:prstGeom>
+          <a:solidFill>
+            <a:srgbClr val="4ECDC4"/>
+          </a:solidFill>
+          <a:ln w="12700">
+            <a:solidFill>
+              <a:srgbClr val="4ECDC4"/>
+            </a:solidFill>
+            <a:prstDash val="solid"/>
+          </a:ln>
+        </p:spPr>
+      </p:sp>
+      <p:sp>
+        <p:nvSpPr>
+          <p:cNvPr id="13" name="Shape 11"/>
+          <p:cNvSpPr/>
+          <p:nvPr/>
+        </p:nvSpPr>
+        <p:spPr>
+          <a:xfrm>
+            <a:off x="3291840" y="4480560"/>
+            <a:ext cx="822960" cy="164592"/>
+          </a:xfrm>
+          <a:prstGeom prst="rect">
+            <a:avLst/>
+          </a:prstGeom>
+          <a:solidFill>
+            <a:srgbClr val="FF6B6B"/>
+          </a:solidFill>
+          <a:ln w="12700">
+            <a:solidFill>
+              <a:srgbClr val="FF6B6B"/>
+            </a:solidFill>
+            <a:prstDash val="solid"/>
+          </a:ln>
+        </p:spPr>
+      </p:sp>
+      <p:sp>
+        <p:nvSpPr>
+          <p:cNvPr id="14" name="Shape 12"/>
+          <p:cNvSpPr/>
+          <p:nvPr/>
+        </p:nvSpPr>
+        <p:spPr>
+          <a:xfrm>
+            <a:off x="4297680" y="4480560"/>
+            <a:ext cx="822960" cy="164592"/>
+          </a:xfrm>
+          <a:prstGeom prst="rect">
+            <a:avLst/>
+          </a:prstGeom>
+          <a:solidFill>
+            <a:srgbClr val="FFD166"/>
+          </a:solidFill>
+          <a:ln w="12700">
+            <a:solidFill>
+              <a:srgbClr val="FFD166"/>
+            </a:solidFill>
+            <a:prstDash val="solid"/>
+          </a:ln>
+        </p:spPr>
+      </p:sp>
+      <p:sp>
+        <p:nvSpPr>
+          <p:cNvPr id="15" name="Shape 13"/>
+          <p:cNvSpPr/>
+          <p:nvPr/>
+        </p:nvSpPr>
+        <p:spPr>
+          <a:xfrm>
+            <a:off x="5303520" y="4480560"/>
+            <a:ext cx="822960" cy="164592"/>
+          </a:xfrm>
+          <a:prstGeom prst="rect">
+            <a:avLst/>
+          </a:prstGeom>
+          <a:solidFill>
+            <a:srgbClr val="06D6A0"/>
+          </a:solidFill>
+          <a:ln w="12700">
+            <a:solidFill>
+              <a:srgbClr val="06D6A0"/>
+            </a:solidFill>
+            <a:prstDash val="solid"/>
+          </a:ln>
+        </p:spPr>
+      </p:sp>
+      <p:sp>
+        <p:nvSpPr>
+          <p:cNvPr id="16" name="Shape 14"/>
+          <p:cNvSpPr/>
+          <p:nvPr/>
+        </p:nvSpPr>
+        <p:spPr>
+          <a:xfrm>
+            <a:off x="8229600" y="1051560"/>
+            <a:ext cx="3657600" cy="2560320"/>
+          </a:xfrm>
+          <a:prstGeom prst="roundRect">
+            <a:avLst>
+              <a:gd name="adj" fmla="val 2857"/>
+            </a:avLst>
+          </a:prstGeom>
+          <a:solidFill>
+            <a:srgbClr val="1C1945"/>
+          </a:solidFill>
+          <a:ln w="15240">
+            <a:solidFill>
+              <a:srgbClr val="818CF8"/>
+            </a:solidFill>
+            <a:prstDash val="solid"/>
+          </a:ln>
+        </p:spPr>
+      </p:sp>
+      <p:sp>
+        <p:nvSpPr>
+          <p:cNvPr id="17" name="Text 15"/>
+          <p:cNvSpPr/>
+          <p:nvPr/>
+        </p:nvSpPr>
+        <p:spPr>
+          <a:xfrm>
+            <a:off x="8229600" y="1051560"/>
+            <a:ext cx="3657600" cy="1371600"/>
+          </a:xfrm>
+          <a:prstGeom prst="rect">
+            <a:avLst/>
+          </a:prstGeom>
+          <a:noFill/>
+          <a:ln/>
+        </p:spPr>
+        <p:txBody>
+          <a:bodyPr wrap="square" rtlCol="0" anchor="ctr"/>
+          <a:lstStyle/>
+          <a:p>
+            <a:pPr algn="ctr" indent="0" marL="0">
+              <a:buNone/>
+            </a:pPr>
+            <a:r>
+              <a:rPr lang="en-US" sz="3600" dirty="0">
+                <a:solidFill>
+                  <a:srgbClr val="000000"/>
+                </a:solidFill>
+              </a:rPr>
+              <a:t>📊</a:t>
+            </a:r>
+            <a:endParaRPr lang="en-US" sz="3600" dirty="0"/>
+          </a:p>
+        </p:txBody>
+      </p:sp>
+      <p:sp>
+        <p:nvSpPr>
+          <p:cNvPr id="18" name="Text 16"/>
+          <p:cNvSpPr/>
+          <p:nvPr/>
+        </p:nvSpPr>
+        <p:spPr>
+          <a:xfrm>
+            <a:off x="8229600" y="2423160"/>
+            <a:ext cx="3657600" cy="457200"/>
+          </a:xfrm>
+          <a:prstGeom prst="rect">
+            <a:avLst/>
+          </a:prstGeom>
+          <a:noFill/>
+          <a:ln/>
+        </p:spPr>
+        <p:txBody>
+          <a:bodyPr wrap="square" rtlCol="0" anchor="ctr"/>
+          <a:lstStyle/>
+          <a:p>
+            <a:pPr algn="ctr" indent="0" marL="0">
+              <a:buNone/>
+            </a:pPr>
+            <a:r>
+              <a:rPr lang="en-US" sz="1200" dirty="0">
+                <a:solidFill>
+                  <a:srgbClr val="6B7AB8"/>
+                </a:solidFill>
+                <a:latin typeface="Calibri" pitchFamily="34" charset="0"/>
+                <a:ea typeface="Calibri" pitchFamily="34" charset="-122"/>
+                <a:cs typeface="Calibri" pitchFamily="34" charset="-120"/>
+              </a:rPr>
+              <a:t>Bảng thống kê so sánh</a:t>
+            </a:r>
+            <a:endParaRPr lang="en-US" sz="1200" dirty="0"/>
+          </a:p>
+        </p:txBody>
+      </p:sp>
+      <p:sp>
+        <p:nvSpPr>
+          <p:cNvPr id="19" name="Shape 17"/>
+          <p:cNvSpPr/>
+          <p:nvPr/>
+        </p:nvSpPr>
+        <p:spPr>
+          <a:xfrm>
+            <a:off x="8229600" y="3840480"/>
+            <a:ext cx="3657600" cy="2697480"/>
+          </a:xfrm>
+          <a:prstGeom prst="roundRect">
+            <a:avLst>
+              <a:gd name="adj" fmla="val 2712"/>
+            </a:avLst>
+          </a:prstGeom>
+          <a:solidFill>
+            <a:srgbClr val="1C1945"/>
+          </a:solidFill>
+          <a:ln w="15240">
+            <a:solidFill>
+              <a:srgbClr val="818CF8"/>
+            </a:solidFill>
+            <a:prstDash val="solid"/>
+          </a:ln>
+        </p:spPr>
+      </p:sp>
+      <p:sp>
+        <p:nvSpPr>
+          <p:cNvPr id="20" name="Text 18"/>
+          <p:cNvSpPr/>
+          <p:nvPr/>
+        </p:nvSpPr>
+        <p:spPr>
+          <a:xfrm>
+            <a:off x="8229600" y="3840480"/>
+            <a:ext cx="3657600" cy="1371600"/>
+          </a:xfrm>
+          <a:prstGeom prst="rect">
+            <a:avLst/>
+          </a:prstGeom>
+          <a:noFill/>
+          <a:ln/>
+        </p:spPr>
+        <p:txBody>
+          <a:bodyPr wrap="square" rtlCol="0" anchor="ctr"/>
+          <a:lstStyle/>
+          <a:p>
+            <a:pPr algn="ctr" indent="0" marL="0">
+              <a:buNone/>
+            </a:pPr>
+            <a:r>
+              <a:rPr lang="en-US" sz="3600" dirty="0">
+                <a:solidFill>
+                  <a:srgbClr val="000000"/>
+                </a:solidFill>
+              </a:rPr>
+              <a:t>⚙️</a:t>
+            </a:r>
+            <a:endParaRPr lang="en-US" sz="3600" dirty="0"/>
+          </a:p>
+        </p:txBody>
+      </p:sp>
+      <p:sp>
+        <p:nvSpPr>
+          <p:cNvPr id="21" name="Text 19"/>
+          <p:cNvSpPr/>
+          <p:nvPr/>
+        </p:nvSpPr>
+        <p:spPr>
+          <a:xfrm>
+            <a:off x="8229600" y="5212080"/>
+            <a:ext cx="3657600" cy="457200"/>
+          </a:xfrm>
+          <a:prstGeom prst="rect">
+            <a:avLst/>
+          </a:prstGeom>
+          <a:noFill/>
+          <a:ln/>
+        </p:spPr>
+        <p:txBody>
+          <a:bodyPr wrap="square" rtlCol="0" anchor="ctr"/>
+          <a:lstStyle/>
+          <a:p>
+            <a:pPr algn="ctr" indent="0" marL="0">
+              <a:buNone/>
+            </a:pPr>
+            <a:r>
+              <a:rPr lang="en-US" sz="1200" dirty="0">
+                <a:solidFill>
+                  <a:srgbClr val="6B7AB8"/>
+                </a:solidFill>
+                <a:latin typeface="Calibri" pitchFamily="34" charset="0"/>
+                <a:ea typeface="Calibri" pitchFamily="34" charset="-122"/>
+                <a:cs typeface="Calibri" pitchFamily="34" charset="-120"/>
+              </a:rPr>
+              <a:t>Control panel · điều chỉnh tốc độ</a:t>
+            </a:r>
+            <a:endParaRPr lang="en-US" sz="1200" dirty="0"/>
+          </a:p>
+        </p:txBody>
+      </p:sp>
+      <p:sp>
+        <p:nvSpPr>
+          <p:cNvPr id="22" name="Text 20"/>
+          <p:cNvSpPr/>
+          <p:nvPr/>
+        </p:nvSpPr>
+        <p:spPr>
+          <a:xfrm>
+            <a:off x="320040" y="6537960"/>
+            <a:ext cx="11521440" cy="256032"/>
+          </a:xfrm>
+          <a:prstGeom prst="rect">
+            <a:avLst/>
+          </a:prstGeom>
+          <a:noFill/>
+          <a:ln/>
+        </p:spPr>
+        <p:txBody>
+          <a:bodyPr wrap="square" rtlCol="0" anchor="ctr"/>
+          <a:lstStyle/>
+          <a:p>
+            <a:pPr algn="ctr" indent="0" marL="0">
+              <a:buNone/>
+            </a:pPr>
+            <a:r>
+              <a:rPr lang="en-US" sz="1000" i="1" dirty="0">
+                <a:solidFill>
+                  <a:srgbClr val="6B7AB8"/>
+                </a:solidFill>
+                <a:latin typeface="Calibri" pitchFamily="34" charset="0"/>
+                <a:ea typeface="Calibri" pitchFamily="34" charset="-122"/>
+                <a:cs typeface="Calibri" pitchFamily="34" charset="-120"/>
+              </a:rPr>
+              <a:t>* Thay bằng ảnh chụp màn hình thực tế khi in/xuất file</a:t>
+            </a:r>
+            <a:endParaRPr lang="en-US" sz="1000" dirty="0"/>
           </a:p>
         </p:txBody>
       </p:sp>

</xml_diff>

<commit_message>
feat: slide 9 so sánh (bảng + nhận xét), slide 10 kiểm thử
</commit_message>
<xml_diff>
--- a/ThuyetTrinh_PathFinderAI.pptx
+++ b/ThuyetTrinh_PathFinderAI.pptx
@@ -13,9 +13,11 @@
     <p:sldId id="261" r:id="rId7"/>
     <p:sldId id="262" r:id="rId8"/>
     <p:sldId id="263" r:id="rId9"/>
+    <p:sldId id="264" r:id="rId10"/>
+    <p:sldId id="265" r:id="rId11"/>
   </p:sldIdLst>
   <p:notesMasterIdLst>
-    <p:notesMasterId r:id="rId10"/>
+    <p:notesMasterId r:id="rId12"/>
   </p:notesMasterIdLst>
   <p:sldSz cx="12192000" cy="6858000"/>
   <p:notesSz cx="6858000" cy="12192000"/>
@@ -551,6 +553,94 @@
 </p:notes>
 </file>
 
+<file path=ppt/notesSlides/notesSlide10.xml><?xml version="1.0" encoding="utf-8"?>
+<p:notes xmlns:a="http://schemas.openxmlformats.org/drawingml/2006/main" xmlns:r="http://schemas.openxmlformats.org/officeDocument/2006/relationships" xmlns:p="http://schemas.openxmlformats.org/presentationml/2006/main">
+  <p:cSld>
+    <p:spTree>
+      <p:nvGrpSpPr>
+        <p:cNvPr id="1" name=""/>
+        <p:cNvGrpSpPr/>
+        <p:nvPr/>
+      </p:nvGrpSpPr>
+      <p:grpSpPr>
+        <a:xfrm>
+          <a:off x="0" y="0"/>
+          <a:ext cx="0" cy="0"/>
+          <a:chOff x="0" y="0"/>
+          <a:chExt cx="0" cy="0"/>
+        </a:xfrm>
+      </p:grpSpPr>
+      <p:sp>
+        <p:nvSpPr>
+          <p:cNvPr id="2" name="Slide Image Placeholder 1"/>
+          <p:cNvSpPr>
+            <a:spLocks noGrp="1" noRot="1" noChangeAspect="1"/>
+          </p:cNvSpPr>
+          <p:nvPr>
+            <p:ph type="sldImg"/>
+          </p:nvPr>
+        </p:nvSpPr>
+        <p:spPr/>
+      </p:sp>
+      <p:sp>
+        <p:nvSpPr>
+          <p:cNvPr id="3" name="Notes Placeholder 2"/>
+          <p:cNvSpPr>
+            <a:spLocks noGrp="1"/>
+          </p:cNvSpPr>
+          <p:nvPr>
+            <p:ph type="body" idx="1"/>
+          </p:nvPr>
+        </p:nvSpPr>
+        <p:spPr/>
+        <p:txBody>
+          <a:bodyPr/>
+          <a:lstStyle/>
+          <a:p>
+            <a:r>
+              <a:rPr lang="en-US" dirty="0"/>
+              <a:t/>
+            </a:r>
+            <a:endParaRPr lang="en-US" dirty="0"/>
+          </a:p>
+        </p:txBody>
+      </p:sp>
+      <p:sp>
+        <p:nvSpPr>
+          <p:cNvPr id="4" name="Slide Number Placeholder 3"/>
+          <p:cNvSpPr>
+            <a:spLocks noGrp="1"/>
+          </p:cNvSpPr>
+          <p:nvPr>
+            <p:ph type="sldNum" sz="quarter" idx="10"/>
+          </p:nvPr>
+        </p:nvSpPr>
+        <p:spPr/>
+        <p:txBody>
+          <a:bodyPr/>
+          <a:lstStyle/>
+          <a:p>
+            <a:fld id="{F7021451-1387-4CA6-816F-3879F97B5CBC}" type="slidenum">
+              <a:rPr lang="en-US"/>
+              <a:t>10</a:t>
+            </a:fld>
+            <a:endParaRPr lang="en-US"/>
+          </a:p>
+        </p:txBody>
+      </p:sp>
+    </p:spTree>
+    <p:extLst>
+      <p:ext uri="{BB962C8B-B14F-4D97-AF65-F5344CB8AC3E}">
+        <p14:creationId xmlns:p14="http://schemas.microsoft.com/office/powerpoint/2010/main" val="1024086991"/>
+      </p:ext>
+    </p:extLst>
+  </p:cSld>
+  <p:clrMapOvr>
+    <a:masterClrMapping/>
+  </p:clrMapOvr>
+</p:notes>
+</file>
+
 <file path=ppt/notesSlides/notesSlide2.xml><?xml version="1.0" encoding="utf-8"?>
 <p:notes xmlns:a="http://schemas.openxmlformats.org/drawingml/2006/main" xmlns:r="http://schemas.openxmlformats.org/officeDocument/2006/relationships" xmlns:p="http://schemas.openxmlformats.org/presentationml/2006/main">
   <p:cSld>
@@ -1149,6 +1239,94 @@
             <a:fld id="{F7021451-1387-4CA6-816F-3879F97B5CBC}" type="slidenum">
               <a:rPr lang="en-US"/>
               <a:t>8</a:t>
+            </a:fld>
+            <a:endParaRPr lang="en-US"/>
+          </a:p>
+        </p:txBody>
+      </p:sp>
+    </p:spTree>
+    <p:extLst>
+      <p:ext uri="{BB962C8B-B14F-4D97-AF65-F5344CB8AC3E}">
+        <p14:creationId xmlns:p14="http://schemas.microsoft.com/office/powerpoint/2010/main" val="1024086991"/>
+      </p:ext>
+    </p:extLst>
+  </p:cSld>
+  <p:clrMapOvr>
+    <a:masterClrMapping/>
+  </p:clrMapOvr>
+</p:notes>
+</file>
+
+<file path=ppt/notesSlides/notesSlide9.xml><?xml version="1.0" encoding="utf-8"?>
+<p:notes xmlns:a="http://schemas.openxmlformats.org/drawingml/2006/main" xmlns:r="http://schemas.openxmlformats.org/officeDocument/2006/relationships" xmlns:p="http://schemas.openxmlformats.org/presentationml/2006/main">
+  <p:cSld>
+    <p:spTree>
+      <p:nvGrpSpPr>
+        <p:cNvPr id="1" name=""/>
+        <p:cNvGrpSpPr/>
+        <p:nvPr/>
+      </p:nvGrpSpPr>
+      <p:grpSpPr>
+        <a:xfrm>
+          <a:off x="0" y="0"/>
+          <a:ext cx="0" cy="0"/>
+          <a:chOff x="0" y="0"/>
+          <a:chExt cx="0" cy="0"/>
+        </a:xfrm>
+      </p:grpSpPr>
+      <p:sp>
+        <p:nvSpPr>
+          <p:cNvPr id="2" name="Slide Image Placeholder 1"/>
+          <p:cNvSpPr>
+            <a:spLocks noGrp="1" noRot="1" noChangeAspect="1"/>
+          </p:cNvSpPr>
+          <p:nvPr>
+            <p:ph type="sldImg"/>
+          </p:nvPr>
+        </p:nvSpPr>
+        <p:spPr/>
+      </p:sp>
+      <p:sp>
+        <p:nvSpPr>
+          <p:cNvPr id="3" name="Notes Placeholder 2"/>
+          <p:cNvSpPr>
+            <a:spLocks noGrp="1"/>
+          </p:cNvSpPr>
+          <p:nvPr>
+            <p:ph type="body" idx="1"/>
+          </p:nvPr>
+        </p:nvSpPr>
+        <p:spPr/>
+        <p:txBody>
+          <a:bodyPr/>
+          <a:lstStyle/>
+          <a:p>
+            <a:r>
+              <a:rPr lang="en-US" dirty="0"/>
+              <a:t/>
+            </a:r>
+            <a:endParaRPr lang="en-US" dirty="0"/>
+          </a:p>
+        </p:txBody>
+      </p:sp>
+      <p:sp>
+        <p:nvSpPr>
+          <p:cNvPr id="4" name="Slide Number Placeholder 3"/>
+          <p:cNvSpPr>
+            <a:spLocks noGrp="1"/>
+          </p:cNvSpPr>
+          <p:nvPr>
+            <p:ph type="sldNum" sz="quarter" idx="10"/>
+          </p:nvPr>
+        </p:nvSpPr>
+        <p:spPr/>
+        <p:txBody>
+          <a:bodyPr/>
+          <a:lstStyle/>
+          <a:p>
+            <a:fld id="{F7021451-1387-4CA6-816F-3879F97B5CBC}" type="slidenum">
+              <a:rPr lang="en-US"/>
+              <a:t>9</a:t>
             </a:fld>
             <a:endParaRPr lang="en-US"/>
           </a:p>
@@ -2323,6 +2501,1317 @@
 </p:sld>
 </file>
 
+<file path=ppt/slides/slide10.xml><?xml version="1.0" encoding="utf-8"?>
+<p:sld xmlns:a="http://schemas.openxmlformats.org/drawingml/2006/main" xmlns:r="http://schemas.openxmlformats.org/officeDocument/2006/relationships" xmlns:p="http://schemas.openxmlformats.org/presentationml/2006/main">
+  <p:cSld name="Slide 10">
+    <p:spTree>
+      <p:nvGrpSpPr>
+        <p:cNvPr id="1" name=""/>
+        <p:cNvGrpSpPr/>
+        <p:nvPr/>
+      </p:nvGrpSpPr>
+      <p:grpSpPr>
+        <a:xfrm>
+          <a:off x="0" y="0"/>
+          <a:ext cx="0" cy="0"/>
+          <a:chOff x="0" y="0"/>
+          <a:chExt cx="0" cy="0"/>
+        </a:xfrm>
+      </p:grpSpPr>
+      <p:sp>
+        <p:nvSpPr>
+          <p:cNvPr id="2" name="Shape 0"/>
+          <p:cNvSpPr/>
+          <p:nvPr/>
+        </p:nvSpPr>
+        <p:spPr>
+          <a:xfrm>
+            <a:off x="0" y="0"/>
+            <a:ext cx="12188952" cy="6858000"/>
+          </a:xfrm>
+          <a:prstGeom prst="rect">
+            <a:avLst/>
+          </a:prstGeom>
+          <a:solidFill>
+            <a:srgbClr val="0F0C29"/>
+          </a:solidFill>
+          <a:ln w="12700">
+            <a:solidFill>
+              <a:srgbClr val="0F0C29"/>
+            </a:solidFill>
+            <a:prstDash val="solid"/>
+          </a:ln>
+        </p:spPr>
+      </p:sp>
+      <p:sp>
+        <p:nvSpPr>
+          <p:cNvPr id="3" name="Shape 1"/>
+          <p:cNvSpPr/>
+          <p:nvPr/>
+        </p:nvSpPr>
+        <p:spPr>
+          <a:xfrm>
+            <a:off x="0" y="0"/>
+            <a:ext cx="12188952" cy="4114800"/>
+          </a:xfrm>
+          <a:prstGeom prst="rect">
+            <a:avLst/>
+          </a:prstGeom>
+          <a:solidFill>
+            <a:srgbClr val="1E1B4B">
+              <a:alpha val="70000"/>
+            </a:srgbClr>
+          </a:solidFill>
+          <a:ln w="12700">
+            <a:solidFill>
+              <a:srgbClr val="1E1B4B">
+                <a:alpha val="70000"/>
+              </a:srgbClr>
+            </a:solidFill>
+            <a:prstDash val="solid"/>
+          </a:ln>
+        </p:spPr>
+      </p:sp>
+      <p:sp>
+        <p:nvSpPr>
+          <p:cNvPr id="4" name="Shape 2"/>
+          <p:cNvSpPr/>
+          <p:nvPr/>
+        </p:nvSpPr>
+        <p:spPr>
+          <a:xfrm>
+            <a:off x="5486400" y="0"/>
+            <a:ext cx="6702552" cy="6858000"/>
+          </a:xfrm>
+          <a:prstGeom prst="rect">
+            <a:avLst/>
+          </a:prstGeom>
+          <a:solidFill>
+            <a:srgbClr val="312E81">
+              <a:alpha val="50000"/>
+            </a:srgbClr>
+          </a:solidFill>
+          <a:ln w="12700">
+            <a:solidFill>
+              <a:srgbClr val="312E81">
+                <a:alpha val="50000"/>
+              </a:srgbClr>
+            </a:solidFill>
+            <a:prstDash val="solid"/>
+          </a:ln>
+        </p:spPr>
+      </p:sp>
+      <p:sp>
+        <p:nvSpPr>
+          <p:cNvPr id="5" name="Shape 3"/>
+          <p:cNvSpPr/>
+          <p:nvPr/>
+        </p:nvSpPr>
+        <p:spPr>
+          <a:xfrm>
+            <a:off x="0" y="0"/>
+            <a:ext cx="54864" cy="3429000"/>
+          </a:xfrm>
+          <a:prstGeom prst="rect">
+            <a:avLst/>
+          </a:prstGeom>
+          <a:solidFill>
+            <a:srgbClr val="818CF8"/>
+          </a:solidFill>
+          <a:ln w="12700">
+            <a:solidFill>
+              <a:srgbClr val="818CF8"/>
+            </a:solidFill>
+            <a:prstDash val="solid"/>
+          </a:ln>
+        </p:spPr>
+      </p:sp>
+      <p:sp>
+        <p:nvSpPr>
+          <p:cNvPr id="6" name="Shape 4"/>
+          <p:cNvSpPr/>
+          <p:nvPr/>
+        </p:nvSpPr>
+        <p:spPr>
+          <a:xfrm>
+            <a:off x="0" y="3429000"/>
+            <a:ext cx="54864" cy="3429000"/>
+          </a:xfrm>
+          <a:prstGeom prst="rect">
+            <a:avLst/>
+          </a:prstGeom>
+          <a:solidFill>
+            <a:srgbClr val="34D399"/>
+          </a:solidFill>
+          <a:ln w="12700">
+            <a:solidFill>
+              <a:srgbClr val="34D399"/>
+            </a:solidFill>
+            <a:prstDash val="solid"/>
+          </a:ln>
+        </p:spPr>
+      </p:sp>
+      <p:sp>
+        <p:nvSpPr>
+          <p:cNvPr id="7" name="Text 5"/>
+          <p:cNvSpPr/>
+          <p:nvPr/>
+        </p:nvSpPr>
+        <p:spPr>
+          <a:xfrm>
+            <a:off x="365760" y="274320"/>
+            <a:ext cx="11430000" cy="548640"/>
+          </a:xfrm>
+          <a:prstGeom prst="rect">
+            <a:avLst/>
+          </a:prstGeom>
+          <a:noFill/>
+          <a:ln/>
+        </p:spPr>
+        <p:txBody>
+          <a:bodyPr wrap="square" rtlCol="0" anchor="ctr"/>
+          <a:lstStyle/>
+          <a:p>
+            <a:pPr algn="l" indent="0" marL="0">
+              <a:buNone/>
+            </a:pPr>
+            <a:r>
+              <a:rPr lang="en-US" sz="2600" b="1" dirty="0">
+                <a:solidFill>
+                  <a:srgbClr val="A5B4FC"/>
+                </a:solidFill>
+                <a:latin typeface="Calibri" pitchFamily="34" charset="0"/>
+                <a:ea typeface="Calibri" pitchFamily="34" charset="-122"/>
+                <a:cs typeface="Calibri" pitchFamily="34" charset="-120"/>
+              </a:rPr>
+              <a:t>08. Kiểm Thử</a:t>
+            </a:r>
+            <a:endParaRPr lang="en-US" sz="2600" dirty="0"/>
+          </a:p>
+        </p:txBody>
+      </p:sp>
+      <p:sp>
+        <p:nvSpPr>
+          <p:cNvPr id="8" name="Shape 6"/>
+          <p:cNvSpPr/>
+          <p:nvPr/>
+        </p:nvSpPr>
+        <p:spPr>
+          <a:xfrm>
+            <a:off x="365760" y="868680"/>
+            <a:ext cx="11430000" cy="27432"/>
+          </a:xfrm>
+          <a:prstGeom prst="rect">
+            <a:avLst/>
+          </a:prstGeom>
+          <a:solidFill>
+            <a:srgbClr val="A5B4FC"/>
+          </a:solidFill>
+          <a:ln w="12700">
+            <a:solidFill>
+              <a:srgbClr val="A5B4FC"/>
+            </a:solidFill>
+            <a:prstDash val="solid"/>
+          </a:ln>
+        </p:spPr>
+      </p:sp>
+      <p:sp>
+        <p:nvSpPr>
+          <p:cNvPr id="9" name="Shape 7"/>
+          <p:cNvSpPr/>
+          <p:nvPr/>
+        </p:nvSpPr>
+        <p:spPr>
+          <a:xfrm>
+            <a:off x="320040" y="1051560"/>
+            <a:ext cx="2743200" cy="1920240"/>
+          </a:xfrm>
+          <a:prstGeom prst="roundRect">
+            <a:avLst>
+              <a:gd name="adj" fmla="val 3810"/>
+            </a:avLst>
+          </a:prstGeom>
+          <a:solidFill>
+            <a:srgbClr val="1C1945"/>
+          </a:solidFill>
+          <a:ln w="15240">
+            <a:solidFill>
+              <a:srgbClr val="4ECDC4"/>
+            </a:solidFill>
+            <a:prstDash val="solid"/>
+          </a:ln>
+        </p:spPr>
+      </p:sp>
+      <p:sp>
+        <p:nvSpPr>
+          <p:cNvPr id="10" name="Text 8"/>
+          <p:cNvSpPr/>
+          <p:nvPr/>
+        </p:nvSpPr>
+        <p:spPr>
+          <a:xfrm>
+            <a:off x="320040" y="1143000"/>
+            <a:ext cx="2743200" cy="1005840"/>
+          </a:xfrm>
+          <a:prstGeom prst="rect">
+            <a:avLst/>
+          </a:prstGeom>
+          <a:noFill/>
+          <a:ln/>
+        </p:spPr>
+        <p:txBody>
+          <a:bodyPr wrap="square" rtlCol="0" anchor="ctr"/>
+          <a:lstStyle/>
+          <a:p>
+            <a:pPr algn="ctr" indent="0" marL="0">
+              <a:buNone/>
+            </a:pPr>
+            <a:r>
+              <a:rPr lang="en-US" sz="3800" b="1" dirty="0">
+                <a:solidFill>
+                  <a:srgbClr val="4ECDC4"/>
+                </a:solidFill>
+                <a:latin typeface="Calibri" pitchFamily="34" charset="0"/>
+                <a:ea typeface="Calibri" pitchFamily="34" charset="-122"/>
+                <a:cs typeface="Calibri" pitchFamily="34" charset="-120"/>
+              </a:rPr>
+              <a:t>34</a:t>
+            </a:r>
+            <a:endParaRPr lang="en-US" sz="3800" dirty="0"/>
+          </a:p>
+        </p:txBody>
+      </p:sp>
+      <p:sp>
+        <p:nvSpPr>
+          <p:cNvPr id="11" name="Text 9"/>
+          <p:cNvSpPr/>
+          <p:nvPr/>
+        </p:nvSpPr>
+        <p:spPr>
+          <a:xfrm>
+            <a:off x="320040" y="2194560"/>
+            <a:ext cx="2743200" cy="548640"/>
+          </a:xfrm>
+          <a:prstGeom prst="rect">
+            <a:avLst/>
+          </a:prstGeom>
+          <a:noFill/>
+          <a:ln/>
+        </p:spPr>
+        <p:txBody>
+          <a:bodyPr wrap="square" rtlCol="0" anchor="ctr"/>
+          <a:lstStyle/>
+          <a:p>
+            <a:pPr algn="ctr" indent="0" marL="0">
+              <a:buNone/>
+            </a:pPr>
+            <a:r>
+              <a:rPr lang="en-US" sz="1400" dirty="0">
+                <a:solidFill>
+                  <a:srgbClr val="6B7AB8"/>
+                </a:solidFill>
+                <a:latin typeface="Calibri" pitchFamily="34" charset="0"/>
+                <a:ea typeface="Calibri" pitchFamily="34" charset="-122"/>
+                <a:cs typeface="Calibri" pitchFamily="34" charset="-120"/>
+              </a:rPr>
+              <a:t>Unit Tests</a:t>
+            </a:r>
+            <a:endParaRPr lang="en-US" sz="1400" dirty="0"/>
+          </a:p>
+        </p:txBody>
+      </p:sp>
+      <p:sp>
+        <p:nvSpPr>
+          <p:cNvPr id="12" name="Shape 10"/>
+          <p:cNvSpPr/>
+          <p:nvPr/>
+        </p:nvSpPr>
+        <p:spPr>
+          <a:xfrm>
+            <a:off x="3200400" y="1051560"/>
+            <a:ext cx="2743200" cy="1920240"/>
+          </a:xfrm>
+          <a:prstGeom prst="roundRect">
+            <a:avLst>
+              <a:gd name="adj" fmla="val 3810"/>
+            </a:avLst>
+          </a:prstGeom>
+          <a:solidFill>
+            <a:srgbClr val="1C1945"/>
+          </a:solidFill>
+          <a:ln w="15240">
+            <a:solidFill>
+              <a:srgbClr val="06D6A0"/>
+            </a:solidFill>
+            <a:prstDash val="solid"/>
+          </a:ln>
+        </p:spPr>
+      </p:sp>
+      <p:sp>
+        <p:nvSpPr>
+          <p:cNvPr id="13" name="Text 11"/>
+          <p:cNvSpPr/>
+          <p:nvPr/>
+        </p:nvSpPr>
+        <p:spPr>
+          <a:xfrm>
+            <a:off x="3200400" y="1143000"/>
+            <a:ext cx="2743200" cy="1005840"/>
+          </a:xfrm>
+          <a:prstGeom prst="rect">
+            <a:avLst/>
+          </a:prstGeom>
+          <a:noFill/>
+          <a:ln/>
+        </p:spPr>
+        <p:txBody>
+          <a:bodyPr wrap="square" rtlCol="0" anchor="ctr"/>
+          <a:lstStyle/>
+          <a:p>
+            <a:pPr algn="ctr" indent="0" marL="0">
+              <a:buNone/>
+            </a:pPr>
+            <a:r>
+              <a:rPr lang="en-US" sz="3800" b="1" dirty="0">
+                <a:solidFill>
+                  <a:srgbClr val="06D6A0"/>
+                </a:solidFill>
+                <a:latin typeface="Calibri" pitchFamily="34" charset="0"/>
+                <a:ea typeface="Calibri" pitchFamily="34" charset="-122"/>
+                <a:cs typeface="Calibri" pitchFamily="34" charset="-120"/>
+              </a:rPr>
+              <a:t>100%</a:t>
+            </a:r>
+            <a:endParaRPr lang="en-US" sz="3800" dirty="0"/>
+          </a:p>
+        </p:txBody>
+      </p:sp>
+      <p:sp>
+        <p:nvSpPr>
+          <p:cNvPr id="14" name="Text 12"/>
+          <p:cNvSpPr/>
+          <p:nvPr/>
+        </p:nvSpPr>
+        <p:spPr>
+          <a:xfrm>
+            <a:off x="3200400" y="2194560"/>
+            <a:ext cx="2743200" cy="548640"/>
+          </a:xfrm>
+          <a:prstGeom prst="rect">
+            <a:avLst/>
+          </a:prstGeom>
+          <a:noFill/>
+          <a:ln/>
+        </p:spPr>
+        <p:txBody>
+          <a:bodyPr wrap="square" rtlCol="0" anchor="ctr"/>
+          <a:lstStyle/>
+          <a:p>
+            <a:pPr algn="ctr" indent="0" marL="0">
+              <a:buNone/>
+            </a:pPr>
+            <a:r>
+              <a:rPr lang="en-US" sz="1400" dirty="0">
+                <a:solidFill>
+                  <a:srgbClr val="6B7AB8"/>
+                </a:solidFill>
+                <a:latin typeface="Calibri" pitchFamily="34" charset="0"/>
+                <a:ea typeface="Calibri" pitchFamily="34" charset="-122"/>
+                <a:cs typeface="Calibri" pitchFamily="34" charset="-120"/>
+              </a:rPr>
+              <a:t>Pass Rate</a:t>
+            </a:r>
+            <a:endParaRPr lang="en-US" sz="1400" dirty="0"/>
+          </a:p>
+        </p:txBody>
+      </p:sp>
+      <p:sp>
+        <p:nvSpPr>
+          <p:cNvPr id="15" name="Shape 13"/>
+          <p:cNvSpPr/>
+          <p:nvPr/>
+        </p:nvSpPr>
+        <p:spPr>
+          <a:xfrm>
+            <a:off x="6080760" y="1051560"/>
+            <a:ext cx="2743200" cy="1920240"/>
+          </a:xfrm>
+          <a:prstGeom prst="roundRect">
+            <a:avLst>
+              <a:gd name="adj" fmla="val 3810"/>
+            </a:avLst>
+          </a:prstGeom>
+          <a:solidFill>
+            <a:srgbClr val="1C1945"/>
+          </a:solidFill>
+          <a:ln w="15240">
+            <a:solidFill>
+              <a:srgbClr val="FFD166"/>
+            </a:solidFill>
+            <a:prstDash val="solid"/>
+          </a:ln>
+        </p:spPr>
+      </p:sp>
+      <p:sp>
+        <p:nvSpPr>
+          <p:cNvPr id="16" name="Text 14"/>
+          <p:cNvSpPr/>
+          <p:nvPr/>
+        </p:nvSpPr>
+        <p:spPr>
+          <a:xfrm>
+            <a:off x="6080760" y="1143000"/>
+            <a:ext cx="2743200" cy="1005840"/>
+          </a:xfrm>
+          <a:prstGeom prst="rect">
+            <a:avLst/>
+          </a:prstGeom>
+          <a:noFill/>
+          <a:ln/>
+        </p:spPr>
+        <p:txBody>
+          <a:bodyPr wrap="square" rtlCol="0" anchor="ctr"/>
+          <a:lstStyle/>
+          <a:p>
+            <a:pPr algn="ctr" indent="0" marL="0">
+              <a:buNone/>
+            </a:pPr>
+            <a:r>
+              <a:rPr lang="en-US" sz="3800" b="1" dirty="0">
+                <a:solidFill>
+                  <a:srgbClr val="FFD166"/>
+                </a:solidFill>
+                <a:latin typeface="Calibri" pitchFamily="34" charset="0"/>
+                <a:ea typeface="Calibri" pitchFamily="34" charset="-122"/>
+                <a:cs typeface="Calibri" pitchFamily="34" charset="-120"/>
+              </a:rPr>
+              <a:t>&lt; 5s</a:t>
+            </a:r>
+            <a:endParaRPr lang="en-US" sz="3800" dirty="0"/>
+          </a:p>
+        </p:txBody>
+      </p:sp>
+      <p:sp>
+        <p:nvSpPr>
+          <p:cNvPr id="17" name="Text 15"/>
+          <p:cNvSpPr/>
+          <p:nvPr/>
+        </p:nvSpPr>
+        <p:spPr>
+          <a:xfrm>
+            <a:off x="6080760" y="2194560"/>
+            <a:ext cx="2743200" cy="548640"/>
+          </a:xfrm>
+          <a:prstGeom prst="rect">
+            <a:avLst/>
+          </a:prstGeom>
+          <a:noFill/>
+          <a:ln/>
+        </p:spPr>
+        <p:txBody>
+          <a:bodyPr wrap="square" rtlCol="0" anchor="ctr"/>
+          <a:lstStyle/>
+          <a:p>
+            <a:pPr algn="ctr" indent="0" marL="0">
+              <a:buNone/>
+            </a:pPr>
+            <a:r>
+              <a:rPr lang="en-US" sz="1400" dirty="0">
+                <a:solidFill>
+                  <a:srgbClr val="6B7AB8"/>
+                </a:solidFill>
+                <a:latin typeface="Calibri" pitchFamily="34" charset="0"/>
+                <a:ea typeface="Calibri" pitchFamily="34" charset="-122"/>
+                <a:cs typeface="Calibri" pitchFamily="34" charset="-120"/>
+              </a:rPr>
+              <a:t>Thời gian chạy</a:t>
+            </a:r>
+            <a:endParaRPr lang="en-US" sz="1400" dirty="0"/>
+          </a:p>
+        </p:txBody>
+      </p:sp>
+      <p:sp>
+        <p:nvSpPr>
+          <p:cNvPr id="18" name="Shape 16"/>
+          <p:cNvSpPr/>
+          <p:nvPr/>
+        </p:nvSpPr>
+        <p:spPr>
+          <a:xfrm>
+            <a:off x="8961120" y="1051560"/>
+            <a:ext cx="2743200" cy="1920240"/>
+          </a:xfrm>
+          <a:prstGeom prst="roundRect">
+            <a:avLst>
+              <a:gd name="adj" fmla="val 3810"/>
+            </a:avLst>
+          </a:prstGeom>
+          <a:solidFill>
+            <a:srgbClr val="1C1945"/>
+          </a:solidFill>
+          <a:ln w="15240">
+            <a:solidFill>
+              <a:srgbClr val="818CF8"/>
+            </a:solidFill>
+            <a:prstDash val="solid"/>
+          </a:ln>
+        </p:spPr>
+      </p:sp>
+      <p:sp>
+        <p:nvSpPr>
+          <p:cNvPr id="19" name="Text 17"/>
+          <p:cNvSpPr/>
+          <p:nvPr/>
+        </p:nvSpPr>
+        <p:spPr>
+          <a:xfrm>
+            <a:off x="8961120" y="1143000"/>
+            <a:ext cx="2743200" cy="1005840"/>
+          </a:xfrm>
+          <a:prstGeom prst="rect">
+            <a:avLst/>
+          </a:prstGeom>
+          <a:noFill/>
+          <a:ln/>
+        </p:spPr>
+        <p:txBody>
+          <a:bodyPr wrap="square" rtlCol="0" anchor="ctr"/>
+          <a:lstStyle/>
+          <a:p>
+            <a:pPr algn="ctr" indent="0" marL="0">
+              <a:buNone/>
+            </a:pPr>
+            <a:r>
+              <a:rPr lang="en-US" sz="3800" b="1" dirty="0">
+                <a:solidFill>
+                  <a:srgbClr val="818CF8"/>
+                </a:solidFill>
+                <a:latin typeface="Calibri" pitchFamily="34" charset="0"/>
+                <a:ea typeface="Calibri" pitchFamily="34" charset="-122"/>
+                <a:cs typeface="Calibri" pitchFamily="34" charset="-120"/>
+              </a:rPr>
+              <a:t>TDD</a:t>
+            </a:r>
+            <a:endParaRPr lang="en-US" sz="3800" dirty="0"/>
+          </a:p>
+        </p:txBody>
+      </p:sp>
+      <p:sp>
+        <p:nvSpPr>
+          <p:cNvPr id="20" name="Text 18"/>
+          <p:cNvSpPr/>
+          <p:nvPr/>
+        </p:nvSpPr>
+        <p:spPr>
+          <a:xfrm>
+            <a:off x="8961120" y="2194560"/>
+            <a:ext cx="2743200" cy="548640"/>
+          </a:xfrm>
+          <a:prstGeom prst="rect">
+            <a:avLst/>
+          </a:prstGeom>
+          <a:noFill/>
+          <a:ln/>
+        </p:spPr>
+        <p:txBody>
+          <a:bodyPr wrap="square" rtlCol="0" anchor="ctr"/>
+          <a:lstStyle/>
+          <a:p>
+            <a:pPr algn="ctr" indent="0" marL="0">
+              <a:buNone/>
+            </a:pPr>
+            <a:r>
+              <a:rPr lang="en-US" sz="1400" dirty="0">
+                <a:solidFill>
+                  <a:srgbClr val="6B7AB8"/>
+                </a:solidFill>
+                <a:latin typeface="Calibri" pitchFamily="34" charset="0"/>
+                <a:ea typeface="Calibri" pitchFamily="34" charset="-122"/>
+                <a:cs typeface="Calibri" pitchFamily="34" charset="-120"/>
+              </a:rPr>
+              <a:t>Phương pháp</a:t>
+            </a:r>
+            <a:endParaRPr lang="en-US" sz="1400" dirty="0"/>
+          </a:p>
+        </p:txBody>
+      </p:sp>
+      <p:sp>
+        <p:nvSpPr>
+          <p:cNvPr id="21" name="Text 19"/>
+          <p:cNvSpPr/>
+          <p:nvPr/>
+        </p:nvSpPr>
+        <p:spPr>
+          <a:xfrm>
+            <a:off x="320040" y="3200400"/>
+            <a:ext cx="11430000" cy="411480"/>
+          </a:xfrm>
+          <a:prstGeom prst="rect">
+            <a:avLst/>
+          </a:prstGeom>
+          <a:noFill/>
+          <a:ln/>
+        </p:spPr>
+        <p:txBody>
+          <a:bodyPr wrap="square" rtlCol="0" anchor="ctr"/>
+          <a:lstStyle/>
+          <a:p>
+            <a:pPr indent="0" marL="0">
+              <a:buNone/>
+            </a:pPr>
+            <a:r>
+              <a:rPr lang="en-US" sz="1600" b="1" dirty="0">
+                <a:solidFill>
+                  <a:srgbClr val="E0E7FF"/>
+                </a:solidFill>
+                <a:latin typeface="Calibri" pitchFamily="34" charset="0"/>
+                <a:ea typeface="Calibri" pitchFamily="34" charset="-122"/>
+                <a:cs typeface="Calibri" pitchFamily="34" charset="-120"/>
+              </a:rPr>
+              <a:t>Phạm vi kiểm thử:</a:t>
+            </a:r>
+            <a:endParaRPr lang="en-US" sz="1600" dirty="0"/>
+          </a:p>
+        </p:txBody>
+      </p:sp>
+      <p:sp>
+        <p:nvSpPr>
+          <p:cNvPr id="22" name="Shape 20"/>
+          <p:cNvSpPr/>
+          <p:nvPr/>
+        </p:nvSpPr>
+        <p:spPr>
+          <a:xfrm>
+            <a:off x="320040" y="3703320"/>
+            <a:ext cx="5623560" cy="731520"/>
+          </a:xfrm>
+          <a:prstGeom prst="roundRect">
+            <a:avLst>
+              <a:gd name="adj" fmla="val 10000"/>
+            </a:avLst>
+          </a:prstGeom>
+          <a:solidFill>
+            <a:srgbClr val="1C1945"/>
+          </a:solidFill>
+          <a:ln w="15240">
+            <a:solidFill>
+              <a:srgbClr val="363780"/>
+            </a:solidFill>
+            <a:prstDash val="solid"/>
+          </a:ln>
+        </p:spPr>
+      </p:sp>
+      <p:sp>
+        <p:nvSpPr>
+          <p:cNvPr id="23" name="Text 21"/>
+          <p:cNvSpPr/>
+          <p:nvPr/>
+        </p:nvSpPr>
+        <p:spPr>
+          <a:xfrm>
+            <a:off x="457200" y="3703320"/>
+            <a:ext cx="2011680" cy="731520"/>
+          </a:xfrm>
+          <a:prstGeom prst="rect">
+            <a:avLst/>
+          </a:prstGeom>
+          <a:noFill/>
+          <a:ln/>
+        </p:spPr>
+        <p:txBody>
+          <a:bodyPr wrap="square" rtlCol="0" anchor="ctr"/>
+          <a:lstStyle/>
+          <a:p>
+            <a:pPr indent="0" marL="0">
+              <a:buNone/>
+            </a:pPr>
+            <a:r>
+              <a:rPr lang="en-US" sz="1300" b="1" dirty="0">
+                <a:solidFill>
+                  <a:srgbClr val="06D6A0"/>
+                </a:solidFill>
+                <a:latin typeface="Calibri" pitchFamily="34" charset="0"/>
+                <a:ea typeface="Calibri" pitchFamily="34" charset="-122"/>
+                <a:cs typeface="Calibri" pitchFamily="34" charset="-120"/>
+              </a:rPr>
+              <a:t>✔  Graph module:</a:t>
+            </a:r>
+            <a:endParaRPr lang="en-US" sz="1300" dirty="0"/>
+          </a:p>
+        </p:txBody>
+      </p:sp>
+      <p:sp>
+        <p:nvSpPr>
+          <p:cNvPr id="24" name="Text 22"/>
+          <p:cNvSpPr/>
+          <p:nvPr/>
+        </p:nvSpPr>
+        <p:spPr>
+          <a:xfrm>
+            <a:off x="2423160" y="3703320"/>
+            <a:ext cx="3383280" cy="731520"/>
+          </a:xfrm>
+          <a:prstGeom prst="rect">
+            <a:avLst/>
+          </a:prstGeom>
+          <a:noFill/>
+          <a:ln/>
+        </p:spPr>
+        <p:txBody>
+          <a:bodyPr wrap="square" rtlCol="0" anchor="ctr"/>
+          <a:lstStyle/>
+          <a:p>
+            <a:pPr indent="0" marL="0">
+              <a:buNone/>
+            </a:pPr>
+            <a:r>
+              <a:rPr lang="en-US" sz="1200" dirty="0">
+                <a:solidFill>
+                  <a:srgbClr val="E0E7FF"/>
+                </a:solidFill>
+                <a:latin typeface="Calibri" pitchFamily="34" charset="0"/>
+                <a:ea typeface="Calibri" pitchFamily="34" charset="-122"/>
+                <a:cs typeface="Calibri" pitchFamily="34" charset="-120"/>
+              </a:rPr>
+              <a:t>Nạp đúng 1 007 nút, 2 644 cạnh từ JSON</a:t>
+            </a:r>
+            <a:endParaRPr lang="en-US" sz="1200" dirty="0"/>
+          </a:p>
+        </p:txBody>
+      </p:sp>
+      <p:sp>
+        <p:nvSpPr>
+          <p:cNvPr id="25" name="Shape 23"/>
+          <p:cNvSpPr/>
+          <p:nvPr/>
+        </p:nvSpPr>
+        <p:spPr>
+          <a:xfrm>
+            <a:off x="6172200" y="3703320"/>
+            <a:ext cx="5623560" cy="731520"/>
+          </a:xfrm>
+          <a:prstGeom prst="roundRect">
+            <a:avLst>
+              <a:gd name="adj" fmla="val 10000"/>
+            </a:avLst>
+          </a:prstGeom>
+          <a:solidFill>
+            <a:srgbClr val="1C1945"/>
+          </a:solidFill>
+          <a:ln w="15240">
+            <a:solidFill>
+              <a:srgbClr val="363780"/>
+            </a:solidFill>
+            <a:prstDash val="solid"/>
+          </a:ln>
+        </p:spPr>
+      </p:sp>
+      <p:sp>
+        <p:nvSpPr>
+          <p:cNvPr id="26" name="Text 24"/>
+          <p:cNvSpPr/>
+          <p:nvPr/>
+        </p:nvSpPr>
+        <p:spPr>
+          <a:xfrm>
+            <a:off x="6309360" y="3703320"/>
+            <a:ext cx="2011680" cy="731520"/>
+          </a:xfrm>
+          <a:prstGeom prst="rect">
+            <a:avLst/>
+          </a:prstGeom>
+          <a:noFill/>
+          <a:ln/>
+        </p:spPr>
+        <p:txBody>
+          <a:bodyPr wrap="square" rtlCol="0" anchor="ctr"/>
+          <a:lstStyle/>
+          <a:p>
+            <a:pPr indent="0" marL="0">
+              <a:buNone/>
+            </a:pPr>
+            <a:r>
+              <a:rPr lang="en-US" sz="1300" b="1" dirty="0">
+                <a:solidFill>
+                  <a:srgbClr val="06D6A0"/>
+                </a:solidFill>
+                <a:latin typeface="Calibri" pitchFamily="34" charset="0"/>
+                <a:ea typeface="Calibri" pitchFamily="34" charset="-122"/>
+                <a:cs typeface="Calibri" pitchFamily="34" charset="-120"/>
+              </a:rPr>
+              <a:t>✔  BFS / DFS:</a:t>
+            </a:r>
+            <a:endParaRPr lang="en-US" sz="1300" dirty="0"/>
+          </a:p>
+        </p:txBody>
+      </p:sp>
+      <p:sp>
+        <p:nvSpPr>
+          <p:cNvPr id="27" name="Text 25"/>
+          <p:cNvSpPr/>
+          <p:nvPr/>
+        </p:nvSpPr>
+        <p:spPr>
+          <a:xfrm>
+            <a:off x="8275320" y="3703320"/>
+            <a:ext cx="3383280" cy="731520"/>
+          </a:xfrm>
+          <a:prstGeom prst="rect">
+            <a:avLst/>
+          </a:prstGeom>
+          <a:noFill/>
+          <a:ln/>
+        </p:spPr>
+        <p:txBody>
+          <a:bodyPr wrap="square" rtlCol="0" anchor="ctr"/>
+          <a:lstStyle/>
+          <a:p>
+            <a:pPr indent="0" marL="0">
+              <a:buNone/>
+            </a:pPr>
+            <a:r>
+              <a:rPr lang="en-US" sz="1200" dirty="0">
+                <a:solidFill>
+                  <a:srgbClr val="E0E7FF"/>
+                </a:solidFill>
+                <a:latin typeface="Calibri" pitchFamily="34" charset="0"/>
+                <a:ea typeface="Calibri" pitchFamily="34" charset="-122"/>
+                <a:cs typeface="Calibri" pitchFamily="34" charset="-120"/>
+              </a:rPr>
+              <a:t>Trả về explored list và path hợp lệ</a:t>
+            </a:r>
+            <a:endParaRPr lang="en-US" sz="1200" dirty="0"/>
+          </a:p>
+        </p:txBody>
+      </p:sp>
+      <p:sp>
+        <p:nvSpPr>
+          <p:cNvPr id="28" name="Shape 26"/>
+          <p:cNvSpPr/>
+          <p:nvPr/>
+        </p:nvSpPr>
+        <p:spPr>
+          <a:xfrm>
+            <a:off x="320040" y="4526280"/>
+            <a:ext cx="5623560" cy="731520"/>
+          </a:xfrm>
+          <a:prstGeom prst="roundRect">
+            <a:avLst>
+              <a:gd name="adj" fmla="val 10000"/>
+            </a:avLst>
+          </a:prstGeom>
+          <a:solidFill>
+            <a:srgbClr val="1C1945"/>
+          </a:solidFill>
+          <a:ln w="15240">
+            <a:solidFill>
+              <a:srgbClr val="363780"/>
+            </a:solidFill>
+            <a:prstDash val="solid"/>
+          </a:ln>
+        </p:spPr>
+      </p:sp>
+      <p:sp>
+        <p:nvSpPr>
+          <p:cNvPr id="29" name="Text 27"/>
+          <p:cNvSpPr/>
+          <p:nvPr/>
+        </p:nvSpPr>
+        <p:spPr>
+          <a:xfrm>
+            <a:off x="457200" y="4526280"/>
+            <a:ext cx="2011680" cy="731520"/>
+          </a:xfrm>
+          <a:prstGeom prst="rect">
+            <a:avLst/>
+          </a:prstGeom>
+          <a:noFill/>
+          <a:ln/>
+        </p:spPr>
+        <p:txBody>
+          <a:bodyPr wrap="square" rtlCol="0" anchor="ctr"/>
+          <a:lstStyle/>
+          <a:p>
+            <a:pPr indent="0" marL="0">
+              <a:buNone/>
+            </a:pPr>
+            <a:r>
+              <a:rPr lang="en-US" sz="1300" b="1" dirty="0">
+                <a:solidFill>
+                  <a:srgbClr val="06D6A0"/>
+                </a:solidFill>
+                <a:latin typeface="Calibri" pitchFamily="34" charset="0"/>
+                <a:ea typeface="Calibri" pitchFamily="34" charset="-122"/>
+                <a:cs typeface="Calibri" pitchFamily="34" charset="-120"/>
+              </a:rPr>
+              <a:t>✔  Dijkstra / A*:</a:t>
+            </a:r>
+            <a:endParaRPr lang="en-US" sz="1300" dirty="0"/>
+          </a:p>
+        </p:txBody>
+      </p:sp>
+      <p:sp>
+        <p:nvSpPr>
+          <p:cNvPr id="30" name="Text 28"/>
+          <p:cNvSpPr/>
+          <p:nvPr/>
+        </p:nvSpPr>
+        <p:spPr>
+          <a:xfrm>
+            <a:off x="2423160" y="4526280"/>
+            <a:ext cx="3383280" cy="731520"/>
+          </a:xfrm>
+          <a:prstGeom prst="rect">
+            <a:avLst/>
+          </a:prstGeom>
+          <a:noFill/>
+          <a:ln/>
+        </p:spPr>
+        <p:txBody>
+          <a:bodyPr wrap="square" rtlCol="0" anchor="ctr"/>
+          <a:lstStyle/>
+          <a:p>
+            <a:pPr indent="0" marL="0">
+              <a:buNone/>
+            </a:pPr>
+            <a:r>
+              <a:rPr lang="en-US" sz="1200" dirty="0">
+                <a:solidFill>
+                  <a:srgbClr val="E0E7FF"/>
+                </a:solidFill>
+                <a:latin typeface="Calibri" pitchFamily="34" charset="0"/>
+                <a:ea typeface="Calibri" pitchFamily="34" charset="-122"/>
+                <a:cs typeface="Calibri" pitchFamily="34" charset="-120"/>
+              </a:rPr>
+              <a:t>Khoảng cách tối ưu, length_m chính xác</a:t>
+            </a:r>
+            <a:endParaRPr lang="en-US" sz="1200" dirty="0"/>
+          </a:p>
+        </p:txBody>
+      </p:sp>
+      <p:sp>
+        <p:nvSpPr>
+          <p:cNvPr id="31" name="Shape 29"/>
+          <p:cNvSpPr/>
+          <p:nvPr/>
+        </p:nvSpPr>
+        <p:spPr>
+          <a:xfrm>
+            <a:off x="6172200" y="4526280"/>
+            <a:ext cx="5623560" cy="731520"/>
+          </a:xfrm>
+          <a:prstGeom prst="roundRect">
+            <a:avLst>
+              <a:gd name="adj" fmla="val 10000"/>
+            </a:avLst>
+          </a:prstGeom>
+          <a:solidFill>
+            <a:srgbClr val="1C1945"/>
+          </a:solidFill>
+          <a:ln w="15240">
+            <a:solidFill>
+              <a:srgbClr val="363780"/>
+            </a:solidFill>
+            <a:prstDash val="solid"/>
+          </a:ln>
+        </p:spPr>
+      </p:sp>
+      <p:sp>
+        <p:nvSpPr>
+          <p:cNvPr id="32" name="Text 30"/>
+          <p:cNvSpPr/>
+          <p:nvPr/>
+        </p:nvSpPr>
+        <p:spPr>
+          <a:xfrm>
+            <a:off x="6309360" y="4526280"/>
+            <a:ext cx="2011680" cy="731520"/>
+          </a:xfrm>
+          <a:prstGeom prst="rect">
+            <a:avLst/>
+          </a:prstGeom>
+          <a:noFill/>
+          <a:ln/>
+        </p:spPr>
+        <p:txBody>
+          <a:bodyPr wrap="square" rtlCol="0" anchor="ctr"/>
+          <a:lstStyle/>
+          <a:p>
+            <a:pPr indent="0" marL="0">
+              <a:buNone/>
+            </a:pPr>
+            <a:r>
+              <a:rPr lang="en-US" sz="1300" b="1" dirty="0">
+                <a:solidFill>
+                  <a:srgbClr val="06D6A0"/>
+                </a:solidFill>
+                <a:latin typeface="Calibri" pitchFamily="34" charset="0"/>
+                <a:ea typeface="Calibri" pitchFamily="34" charset="-122"/>
+                <a:cs typeface="Calibri" pitchFamily="34" charset="-120"/>
+              </a:rPr>
+              <a:t>✔  API /nodes:</a:t>
+            </a:r>
+            <a:endParaRPr lang="en-US" sz="1300" dirty="0"/>
+          </a:p>
+        </p:txBody>
+      </p:sp>
+      <p:sp>
+        <p:nvSpPr>
+          <p:cNvPr id="33" name="Text 31"/>
+          <p:cNvSpPr/>
+          <p:nvPr/>
+        </p:nvSpPr>
+        <p:spPr>
+          <a:xfrm>
+            <a:off x="8275320" y="4526280"/>
+            <a:ext cx="3383280" cy="731520"/>
+          </a:xfrm>
+          <a:prstGeom prst="rect">
+            <a:avLst/>
+          </a:prstGeom>
+          <a:noFill/>
+          <a:ln/>
+        </p:spPr>
+        <p:txBody>
+          <a:bodyPr wrap="square" rtlCol="0" anchor="ctr"/>
+          <a:lstStyle/>
+          <a:p>
+            <a:pPr indent="0" marL="0">
+              <a:buNone/>
+            </a:pPr>
+            <a:r>
+              <a:rPr lang="en-US" sz="1200" dirty="0">
+                <a:solidFill>
+                  <a:srgbClr val="E0E7FF"/>
+                </a:solidFill>
+                <a:latin typeface="Calibri" pitchFamily="34" charset="0"/>
+                <a:ea typeface="Calibri" pitchFamily="34" charset="-122"/>
+                <a:cs typeface="Calibri" pitchFamily="34" charset="-120"/>
+              </a:rPr>
+              <a:t>Đúng định dạng, đủ số lượng</a:t>
+            </a:r>
+            <a:endParaRPr lang="en-US" sz="1200" dirty="0"/>
+          </a:p>
+        </p:txBody>
+      </p:sp>
+      <p:sp>
+        <p:nvSpPr>
+          <p:cNvPr id="34" name="Shape 32"/>
+          <p:cNvSpPr/>
+          <p:nvPr/>
+        </p:nvSpPr>
+        <p:spPr>
+          <a:xfrm>
+            <a:off x="320040" y="5349240"/>
+            <a:ext cx="5623560" cy="731520"/>
+          </a:xfrm>
+          <a:prstGeom prst="roundRect">
+            <a:avLst>
+              <a:gd name="adj" fmla="val 10000"/>
+            </a:avLst>
+          </a:prstGeom>
+          <a:solidFill>
+            <a:srgbClr val="1C1945"/>
+          </a:solidFill>
+          <a:ln w="15240">
+            <a:solidFill>
+              <a:srgbClr val="363780"/>
+            </a:solidFill>
+            <a:prstDash val="solid"/>
+          </a:ln>
+        </p:spPr>
+      </p:sp>
+      <p:sp>
+        <p:nvSpPr>
+          <p:cNvPr id="35" name="Text 33"/>
+          <p:cNvSpPr/>
+          <p:nvPr/>
+        </p:nvSpPr>
+        <p:spPr>
+          <a:xfrm>
+            <a:off x="457200" y="5349240"/>
+            <a:ext cx="2011680" cy="731520"/>
+          </a:xfrm>
+          <a:prstGeom prst="rect">
+            <a:avLst/>
+          </a:prstGeom>
+          <a:noFill/>
+          <a:ln/>
+        </p:spPr>
+        <p:txBody>
+          <a:bodyPr wrap="square" rtlCol="0" anchor="ctr"/>
+          <a:lstStyle/>
+          <a:p>
+            <a:pPr indent="0" marL="0">
+              <a:buNone/>
+            </a:pPr>
+            <a:r>
+              <a:rPr lang="en-US" sz="1300" b="1" dirty="0">
+                <a:solidFill>
+                  <a:srgbClr val="06D6A0"/>
+                </a:solidFill>
+                <a:latin typeface="Calibri" pitchFamily="34" charset="0"/>
+                <a:ea typeface="Calibri" pitchFamily="34" charset="-122"/>
+                <a:cs typeface="Calibri" pitchFamily="34" charset="-120"/>
+              </a:rPr>
+              <a:t>✔  API /pathfind:</a:t>
+            </a:r>
+            <a:endParaRPr lang="en-US" sz="1300" dirty="0"/>
+          </a:p>
+        </p:txBody>
+      </p:sp>
+      <p:sp>
+        <p:nvSpPr>
+          <p:cNvPr id="36" name="Text 34"/>
+          <p:cNvSpPr/>
+          <p:nvPr/>
+        </p:nvSpPr>
+        <p:spPr>
+          <a:xfrm>
+            <a:off x="2423160" y="5349240"/>
+            <a:ext cx="3383280" cy="731520"/>
+          </a:xfrm>
+          <a:prstGeom prst="rect">
+            <a:avLst/>
+          </a:prstGeom>
+          <a:noFill/>
+          <a:ln/>
+        </p:spPr>
+        <p:txBody>
+          <a:bodyPr wrap="square" rtlCol="0" anchor="ctr"/>
+          <a:lstStyle/>
+          <a:p>
+            <a:pPr indent="0" marL="0">
+              <a:buNone/>
+            </a:pPr>
+            <a:r>
+              <a:rPr lang="en-US" sz="1200" dirty="0">
+                <a:solidFill>
+                  <a:srgbClr val="E0E7FF"/>
+                </a:solidFill>
+                <a:latin typeface="Calibri" pitchFamily="34" charset="0"/>
+                <a:ea typeface="Calibri" pitchFamily="34" charset="-122"/>
+                <a:cs typeface="Calibri" pitchFamily="34" charset="-120"/>
+              </a:rPr>
+              <a:t>Đúng 4 thuật toán, xử lý input sai</a:t>
+            </a:r>
+            <a:endParaRPr lang="en-US" sz="1200" dirty="0"/>
+          </a:p>
+        </p:txBody>
+      </p:sp>
+      <p:sp>
+        <p:nvSpPr>
+          <p:cNvPr id="37" name="Shape 35"/>
+          <p:cNvSpPr/>
+          <p:nvPr/>
+        </p:nvSpPr>
+        <p:spPr>
+          <a:xfrm>
+            <a:off x="6172200" y="5349240"/>
+            <a:ext cx="5623560" cy="731520"/>
+          </a:xfrm>
+          <a:prstGeom prst="roundRect">
+            <a:avLst>
+              <a:gd name="adj" fmla="val 10000"/>
+            </a:avLst>
+          </a:prstGeom>
+          <a:solidFill>
+            <a:srgbClr val="1C1945"/>
+          </a:solidFill>
+          <a:ln w="15240">
+            <a:solidFill>
+              <a:srgbClr val="363780"/>
+            </a:solidFill>
+            <a:prstDash val="solid"/>
+          </a:ln>
+        </p:spPr>
+      </p:sp>
+      <p:sp>
+        <p:nvSpPr>
+          <p:cNvPr id="38" name="Text 36"/>
+          <p:cNvSpPr/>
+          <p:nvPr/>
+        </p:nvSpPr>
+        <p:spPr>
+          <a:xfrm>
+            <a:off x="6309360" y="5349240"/>
+            <a:ext cx="2011680" cy="731520"/>
+          </a:xfrm>
+          <a:prstGeom prst="rect">
+            <a:avLst/>
+          </a:prstGeom>
+          <a:noFill/>
+          <a:ln/>
+        </p:spPr>
+        <p:txBody>
+          <a:bodyPr wrap="square" rtlCol="0" anchor="ctr"/>
+          <a:lstStyle/>
+          <a:p>
+            <a:pPr indent="0" marL="0">
+              <a:buNone/>
+            </a:pPr>
+            <a:r>
+              <a:rPr lang="en-US" sz="1300" b="1" dirty="0">
+                <a:solidFill>
+                  <a:srgbClr val="06D6A0"/>
+                </a:solidFill>
+                <a:latin typeface="Calibri" pitchFamily="34" charset="0"/>
+                <a:ea typeface="Calibri" pitchFamily="34" charset="-122"/>
+                <a:cs typeface="Calibri" pitchFamily="34" charset="-120"/>
+              </a:rPr>
+              <a:t>✔  Edge cases:</a:t>
+            </a:r>
+            <a:endParaRPr lang="en-US" sz="1300" dirty="0"/>
+          </a:p>
+        </p:txBody>
+      </p:sp>
+      <p:sp>
+        <p:nvSpPr>
+          <p:cNvPr id="39" name="Text 37"/>
+          <p:cNvSpPr/>
+          <p:nvPr/>
+        </p:nvSpPr>
+        <p:spPr>
+          <a:xfrm>
+            <a:off x="8275320" y="5349240"/>
+            <a:ext cx="3383280" cy="731520"/>
+          </a:xfrm>
+          <a:prstGeom prst="rect">
+            <a:avLst/>
+          </a:prstGeom>
+          <a:noFill/>
+          <a:ln/>
+        </p:spPr>
+        <p:txBody>
+          <a:bodyPr wrap="square" rtlCol="0" anchor="ctr"/>
+          <a:lstStyle/>
+          <a:p>
+            <a:pPr indent="0" marL="0">
+              <a:buNone/>
+            </a:pPr>
+            <a:r>
+              <a:rPr lang="en-US" sz="1200" dirty="0">
+                <a:solidFill>
+                  <a:srgbClr val="E0E7FF"/>
+                </a:solidFill>
+                <a:latin typeface="Calibri" pitchFamily="34" charset="0"/>
+                <a:ea typeface="Calibri" pitchFamily="34" charset="-122"/>
+                <a:cs typeface="Calibri" pitchFamily="34" charset="-120"/>
+              </a:rPr>
+              <a:t>start==end, không có đường, node không tồn tại</a:t>
+            </a:r>
+            <a:endParaRPr lang="en-US" sz="1200" dirty="0"/>
+          </a:p>
+        </p:txBody>
+      </p:sp>
+    </p:spTree>
+  </p:cSld>
+  <p:clrMapOvr>
+    <a:masterClrMapping/>
+  </p:clrMapOvr>
+</p:sld>
+</file>
+
 <file path=ppt/slides/slide2.xml><?xml version="1.0" encoding="utf-8"?>
 <p:sld xmlns:a="http://schemas.openxmlformats.org/drawingml/2006/main" xmlns:r="http://schemas.openxmlformats.org/officeDocument/2006/relationships" xmlns:p="http://schemas.openxmlformats.org/presentationml/2006/main">
   <p:cSld name="Slide 2">
@@ -9340,6 +10829,1967 @@
               <a:t>* Thay bằng ảnh chụp màn hình thực tế khi in/xuất file</a:t>
             </a:r>
             <a:endParaRPr lang="en-US" sz="1000" dirty="0"/>
+          </a:p>
+        </p:txBody>
+      </p:sp>
+    </p:spTree>
+  </p:cSld>
+  <p:clrMapOvr>
+    <a:masterClrMapping/>
+  </p:clrMapOvr>
+</p:sld>
+</file>
+
+<file path=ppt/slides/slide9.xml><?xml version="1.0" encoding="utf-8"?>
+<p:sld xmlns:a="http://schemas.openxmlformats.org/drawingml/2006/main" xmlns:r="http://schemas.openxmlformats.org/officeDocument/2006/relationships" xmlns:p="http://schemas.openxmlformats.org/presentationml/2006/main">
+  <p:cSld name="Slide 9">
+    <p:spTree>
+      <p:nvGrpSpPr>
+        <p:cNvPr id="1" name=""/>
+        <p:cNvGrpSpPr/>
+        <p:nvPr/>
+      </p:nvGrpSpPr>
+      <p:grpSpPr>
+        <a:xfrm>
+          <a:off x="0" y="0"/>
+          <a:ext cx="0" cy="0"/>
+          <a:chOff x="0" y="0"/>
+          <a:chExt cx="0" cy="0"/>
+        </a:xfrm>
+      </p:grpSpPr>
+      <p:sp>
+        <p:nvSpPr>
+          <p:cNvPr id="2" name="Shape 0"/>
+          <p:cNvSpPr/>
+          <p:nvPr/>
+        </p:nvSpPr>
+        <p:spPr>
+          <a:xfrm>
+            <a:off x="0" y="0"/>
+            <a:ext cx="12188952" cy="6858000"/>
+          </a:xfrm>
+          <a:prstGeom prst="rect">
+            <a:avLst/>
+          </a:prstGeom>
+          <a:solidFill>
+            <a:srgbClr val="0F0C29"/>
+          </a:solidFill>
+          <a:ln w="12700">
+            <a:solidFill>
+              <a:srgbClr val="0F0C29"/>
+            </a:solidFill>
+            <a:prstDash val="solid"/>
+          </a:ln>
+        </p:spPr>
+      </p:sp>
+      <p:sp>
+        <p:nvSpPr>
+          <p:cNvPr id="3" name="Shape 1"/>
+          <p:cNvSpPr/>
+          <p:nvPr/>
+        </p:nvSpPr>
+        <p:spPr>
+          <a:xfrm>
+            <a:off x="0" y="0"/>
+            <a:ext cx="12188952" cy="4114800"/>
+          </a:xfrm>
+          <a:prstGeom prst="rect">
+            <a:avLst/>
+          </a:prstGeom>
+          <a:solidFill>
+            <a:srgbClr val="1E1B4B">
+              <a:alpha val="70000"/>
+            </a:srgbClr>
+          </a:solidFill>
+          <a:ln w="12700">
+            <a:solidFill>
+              <a:srgbClr val="1E1B4B">
+                <a:alpha val="70000"/>
+              </a:srgbClr>
+            </a:solidFill>
+            <a:prstDash val="solid"/>
+          </a:ln>
+        </p:spPr>
+      </p:sp>
+      <p:sp>
+        <p:nvSpPr>
+          <p:cNvPr id="4" name="Shape 2"/>
+          <p:cNvSpPr/>
+          <p:nvPr/>
+        </p:nvSpPr>
+        <p:spPr>
+          <a:xfrm>
+            <a:off x="5486400" y="0"/>
+            <a:ext cx="6702552" cy="6858000"/>
+          </a:xfrm>
+          <a:prstGeom prst="rect">
+            <a:avLst/>
+          </a:prstGeom>
+          <a:solidFill>
+            <a:srgbClr val="312E81">
+              <a:alpha val="50000"/>
+            </a:srgbClr>
+          </a:solidFill>
+          <a:ln w="12700">
+            <a:solidFill>
+              <a:srgbClr val="312E81">
+                <a:alpha val="50000"/>
+              </a:srgbClr>
+            </a:solidFill>
+            <a:prstDash val="solid"/>
+          </a:ln>
+        </p:spPr>
+      </p:sp>
+      <p:sp>
+        <p:nvSpPr>
+          <p:cNvPr id="5" name="Shape 3"/>
+          <p:cNvSpPr/>
+          <p:nvPr/>
+        </p:nvSpPr>
+        <p:spPr>
+          <a:xfrm>
+            <a:off x="0" y="0"/>
+            <a:ext cx="54864" cy="3429000"/>
+          </a:xfrm>
+          <a:prstGeom prst="rect">
+            <a:avLst/>
+          </a:prstGeom>
+          <a:solidFill>
+            <a:srgbClr val="818CF8"/>
+          </a:solidFill>
+          <a:ln w="12700">
+            <a:solidFill>
+              <a:srgbClr val="818CF8"/>
+            </a:solidFill>
+            <a:prstDash val="solid"/>
+          </a:ln>
+        </p:spPr>
+      </p:sp>
+      <p:sp>
+        <p:nvSpPr>
+          <p:cNvPr id="6" name="Shape 4"/>
+          <p:cNvSpPr/>
+          <p:nvPr/>
+        </p:nvSpPr>
+        <p:spPr>
+          <a:xfrm>
+            <a:off x="0" y="3429000"/>
+            <a:ext cx="54864" cy="3429000"/>
+          </a:xfrm>
+          <a:prstGeom prst="rect">
+            <a:avLst/>
+          </a:prstGeom>
+          <a:solidFill>
+            <a:srgbClr val="34D399"/>
+          </a:solidFill>
+          <a:ln w="12700">
+            <a:solidFill>
+              <a:srgbClr val="34D399"/>
+            </a:solidFill>
+            <a:prstDash val="solid"/>
+          </a:ln>
+        </p:spPr>
+      </p:sp>
+      <p:sp>
+        <p:nvSpPr>
+          <p:cNvPr id="7" name="Text 5"/>
+          <p:cNvSpPr/>
+          <p:nvPr/>
+        </p:nvSpPr>
+        <p:spPr>
+          <a:xfrm>
+            <a:off x="365760" y="274320"/>
+            <a:ext cx="11430000" cy="548640"/>
+          </a:xfrm>
+          <a:prstGeom prst="rect">
+            <a:avLst/>
+          </a:prstGeom>
+          <a:noFill/>
+          <a:ln/>
+        </p:spPr>
+        <p:txBody>
+          <a:bodyPr wrap="square" rtlCol="0" anchor="ctr"/>
+          <a:lstStyle/>
+          <a:p>
+            <a:pPr algn="l" indent="0" marL="0">
+              <a:buNone/>
+            </a:pPr>
+            <a:r>
+              <a:rPr lang="en-US" sz="2600" b="1" dirty="0">
+                <a:solidFill>
+                  <a:srgbClr val="34D399"/>
+                </a:solidFill>
+                <a:latin typeface="Calibri" pitchFamily="34" charset="0"/>
+                <a:ea typeface="Calibri" pitchFamily="34" charset="-122"/>
+                <a:cs typeface="Calibri" pitchFamily="34" charset="-120"/>
+              </a:rPr>
+              <a:t>07. Kết Quả So Sánh</a:t>
+            </a:r>
+            <a:endParaRPr lang="en-US" sz="2600" dirty="0"/>
+          </a:p>
+        </p:txBody>
+      </p:sp>
+      <p:sp>
+        <p:nvSpPr>
+          <p:cNvPr id="8" name="Shape 6"/>
+          <p:cNvSpPr/>
+          <p:nvPr/>
+        </p:nvSpPr>
+        <p:spPr>
+          <a:xfrm>
+            <a:off x="365760" y="868680"/>
+            <a:ext cx="11430000" cy="27432"/>
+          </a:xfrm>
+          <a:prstGeom prst="rect">
+            <a:avLst/>
+          </a:prstGeom>
+          <a:solidFill>
+            <a:srgbClr val="34D399"/>
+          </a:solidFill>
+          <a:ln w="12700">
+            <a:solidFill>
+              <a:srgbClr val="34D399"/>
+            </a:solidFill>
+            <a:prstDash val="solid"/>
+          </a:ln>
+        </p:spPr>
+      </p:sp>
+      <p:sp>
+        <p:nvSpPr>
+          <p:cNvPr id="9" name="Text 7"/>
+          <p:cNvSpPr/>
+          <p:nvPr/>
+        </p:nvSpPr>
+        <p:spPr>
+          <a:xfrm>
+            <a:off x="365760" y="960120"/>
+            <a:ext cx="11430000" cy="320040"/>
+          </a:xfrm>
+          <a:prstGeom prst="rect">
+            <a:avLst/>
+          </a:prstGeom>
+          <a:noFill/>
+          <a:ln/>
+        </p:spPr>
+        <p:txBody>
+          <a:bodyPr wrap="square" rtlCol="0" anchor="ctr"/>
+          <a:lstStyle/>
+          <a:p>
+            <a:pPr indent="0" marL="0">
+              <a:buNone/>
+            </a:pPr>
+            <a:r>
+              <a:rPr lang="en-US" sz="1200" i="1" dirty="0">
+                <a:solidFill>
+                  <a:srgbClr val="6B7AB8"/>
+                </a:solidFill>
+                <a:latin typeface="Calibri" pitchFamily="34" charset="0"/>
+                <a:ea typeface="Calibri" pitchFamily="34" charset="-122"/>
+                <a:cs typeface="Calibri" pitchFamily="34" charset="-120"/>
+              </a:rPr>
+              <a:t>PTIT → Vincom Hà Đông (~3km) — kết quả điển hình</a:t>
+            </a:r>
+            <a:endParaRPr lang="en-US" sz="1200" dirty="0"/>
+          </a:p>
+        </p:txBody>
+      </p:sp>
+      <p:sp>
+        <p:nvSpPr>
+          <p:cNvPr id="10" name="Shape 8"/>
+          <p:cNvSpPr/>
+          <p:nvPr/>
+        </p:nvSpPr>
+        <p:spPr>
+          <a:xfrm>
+            <a:off x="320040" y="1371600"/>
+            <a:ext cx="2011680" cy="640080"/>
+          </a:xfrm>
+          <a:prstGeom prst="rect">
+            <a:avLst/>
+          </a:prstGeom>
+          <a:solidFill>
+            <a:srgbClr val="1E1B4B"/>
+          </a:solidFill>
+          <a:ln w="12700">
+            <a:solidFill>
+              <a:srgbClr val="363780"/>
+            </a:solidFill>
+            <a:prstDash val="solid"/>
+          </a:ln>
+        </p:spPr>
+      </p:sp>
+      <p:sp>
+        <p:nvSpPr>
+          <p:cNvPr id="11" name="Text 9"/>
+          <p:cNvSpPr/>
+          <p:nvPr/>
+        </p:nvSpPr>
+        <p:spPr>
+          <a:xfrm>
+            <a:off x="320040" y="1371600"/>
+            <a:ext cx="2011680" cy="640080"/>
+          </a:xfrm>
+          <a:prstGeom prst="rect">
+            <a:avLst/>
+          </a:prstGeom>
+          <a:noFill/>
+          <a:ln/>
+        </p:spPr>
+        <p:txBody>
+          <a:bodyPr wrap="square" rtlCol="0" anchor="ctr"/>
+          <a:lstStyle/>
+          <a:p>
+            <a:pPr algn="ctr" indent="0" marL="0">
+              <a:buNone/>
+            </a:pPr>
+            <a:r>
+              <a:rPr lang="en-US" sz="1300" b="1" dirty="0">
+                <a:solidFill>
+                  <a:srgbClr val="A5B4FC"/>
+                </a:solidFill>
+                <a:latin typeface="Calibri" pitchFamily="34" charset="0"/>
+                <a:ea typeface="Calibri" pitchFamily="34" charset="-122"/>
+                <a:cs typeface="Calibri" pitchFamily="34" charset="-120"/>
+              </a:rPr>
+              <a:t>Thuật toán</a:t>
+            </a:r>
+            <a:endParaRPr lang="en-US" sz="1300" dirty="0"/>
+          </a:p>
+        </p:txBody>
+      </p:sp>
+      <p:sp>
+        <p:nvSpPr>
+          <p:cNvPr id="12" name="Shape 10"/>
+          <p:cNvSpPr/>
+          <p:nvPr/>
+        </p:nvSpPr>
+        <p:spPr>
+          <a:xfrm>
+            <a:off x="2331720" y="1371600"/>
+            <a:ext cx="1645920" cy="640080"/>
+          </a:xfrm>
+          <a:prstGeom prst="rect">
+            <a:avLst/>
+          </a:prstGeom>
+          <a:solidFill>
+            <a:srgbClr val="1E1B4B"/>
+          </a:solidFill>
+          <a:ln w="12700">
+            <a:solidFill>
+              <a:srgbClr val="363780"/>
+            </a:solidFill>
+            <a:prstDash val="solid"/>
+          </a:ln>
+        </p:spPr>
+      </p:sp>
+      <p:sp>
+        <p:nvSpPr>
+          <p:cNvPr id="13" name="Text 11"/>
+          <p:cNvSpPr/>
+          <p:nvPr/>
+        </p:nvSpPr>
+        <p:spPr>
+          <a:xfrm>
+            <a:off x="2331720" y="1371600"/>
+            <a:ext cx="1645920" cy="640080"/>
+          </a:xfrm>
+          <a:prstGeom prst="rect">
+            <a:avLst/>
+          </a:prstGeom>
+          <a:noFill/>
+          <a:ln/>
+        </p:spPr>
+        <p:txBody>
+          <a:bodyPr wrap="square" rtlCol="0" anchor="ctr"/>
+          <a:lstStyle/>
+          <a:p>
+            <a:pPr algn="ctr" indent="0" marL="0">
+              <a:buNone/>
+            </a:pPr>
+            <a:r>
+              <a:rPr lang="en-US" sz="1300" b="1" dirty="0">
+                <a:solidFill>
+                  <a:srgbClr val="A5B4FC"/>
+                </a:solidFill>
+                <a:latin typeface="Calibri" pitchFamily="34" charset="0"/>
+                <a:ea typeface="Calibri" pitchFamily="34" charset="-122"/>
+                <a:cs typeface="Calibri" pitchFamily="34" charset="-120"/>
+              </a:rPr>
+              <a:t>Nút duyệt</a:t>
+            </a:r>
+            <a:endParaRPr lang="en-US" sz="1300" dirty="0"/>
+          </a:p>
+        </p:txBody>
+      </p:sp>
+      <p:sp>
+        <p:nvSpPr>
+          <p:cNvPr id="14" name="Shape 12"/>
+          <p:cNvSpPr/>
+          <p:nvPr/>
+        </p:nvSpPr>
+        <p:spPr>
+          <a:xfrm>
+            <a:off x="3977640" y="1371600"/>
+            <a:ext cx="1737360" cy="640080"/>
+          </a:xfrm>
+          <a:prstGeom prst="rect">
+            <a:avLst/>
+          </a:prstGeom>
+          <a:solidFill>
+            <a:srgbClr val="1E1B4B"/>
+          </a:solidFill>
+          <a:ln w="12700">
+            <a:solidFill>
+              <a:srgbClr val="363780"/>
+            </a:solidFill>
+            <a:prstDash val="solid"/>
+          </a:ln>
+        </p:spPr>
+      </p:sp>
+      <p:sp>
+        <p:nvSpPr>
+          <p:cNvPr id="15" name="Text 13"/>
+          <p:cNvSpPr/>
+          <p:nvPr/>
+        </p:nvSpPr>
+        <p:spPr>
+          <a:xfrm>
+            <a:off x="3977640" y="1371600"/>
+            <a:ext cx="1737360" cy="640080"/>
+          </a:xfrm>
+          <a:prstGeom prst="rect">
+            <a:avLst/>
+          </a:prstGeom>
+          <a:noFill/>
+          <a:ln/>
+        </p:spPr>
+        <p:txBody>
+          <a:bodyPr wrap="square" rtlCol="0" anchor="ctr"/>
+          <a:lstStyle/>
+          <a:p>
+            <a:pPr algn="ctr" indent="0" marL="0">
+              <a:buNone/>
+            </a:pPr>
+            <a:r>
+              <a:rPr lang="en-US" sz="1300" b="1" dirty="0">
+                <a:solidFill>
+                  <a:srgbClr val="A5B4FC"/>
+                </a:solidFill>
+                <a:latin typeface="Calibri" pitchFamily="34" charset="0"/>
+                <a:ea typeface="Calibri" pitchFamily="34" charset="-122"/>
+                <a:cs typeface="Calibri" pitchFamily="34" charset="-120"/>
+              </a:rPr>
+              <a:t>Độ dài</a:t>
+            </a:r>
+            <a:endParaRPr lang="en-US" sz="1300" dirty="0"/>
+          </a:p>
+        </p:txBody>
+      </p:sp>
+      <p:sp>
+        <p:nvSpPr>
+          <p:cNvPr id="16" name="Shape 14"/>
+          <p:cNvSpPr/>
+          <p:nvPr/>
+        </p:nvSpPr>
+        <p:spPr>
+          <a:xfrm>
+            <a:off x="5715000" y="1371600"/>
+            <a:ext cx="1737360" cy="640080"/>
+          </a:xfrm>
+          <a:prstGeom prst="rect">
+            <a:avLst/>
+          </a:prstGeom>
+          <a:solidFill>
+            <a:srgbClr val="1E1B4B"/>
+          </a:solidFill>
+          <a:ln w="12700">
+            <a:solidFill>
+              <a:srgbClr val="363780"/>
+            </a:solidFill>
+            <a:prstDash val="solid"/>
+          </a:ln>
+        </p:spPr>
+      </p:sp>
+      <p:sp>
+        <p:nvSpPr>
+          <p:cNvPr id="17" name="Text 15"/>
+          <p:cNvSpPr/>
+          <p:nvPr/>
+        </p:nvSpPr>
+        <p:spPr>
+          <a:xfrm>
+            <a:off x="5715000" y="1371600"/>
+            <a:ext cx="1737360" cy="640080"/>
+          </a:xfrm>
+          <a:prstGeom prst="rect">
+            <a:avLst/>
+          </a:prstGeom>
+          <a:noFill/>
+          <a:ln/>
+        </p:spPr>
+        <p:txBody>
+          <a:bodyPr wrap="square" rtlCol="0" anchor="ctr"/>
+          <a:lstStyle/>
+          <a:p>
+            <a:pPr algn="ctr" indent="0" marL="0">
+              <a:buNone/>
+            </a:pPr>
+            <a:r>
+              <a:rPr lang="en-US" sz="1300" b="1" dirty="0">
+                <a:solidFill>
+                  <a:srgbClr val="A5B4FC"/>
+                </a:solidFill>
+                <a:latin typeface="Calibri" pitchFamily="34" charset="0"/>
+                <a:ea typeface="Calibri" pitchFamily="34" charset="-122"/>
+                <a:cs typeface="Calibri" pitchFamily="34" charset="-120"/>
+              </a:rPr>
+              <a:t>Thời gian</a:t>
+            </a:r>
+            <a:endParaRPr lang="en-US" sz="1300" dirty="0"/>
+          </a:p>
+        </p:txBody>
+      </p:sp>
+      <p:sp>
+        <p:nvSpPr>
+          <p:cNvPr id="18" name="Shape 16"/>
+          <p:cNvSpPr/>
+          <p:nvPr/>
+        </p:nvSpPr>
+        <p:spPr>
+          <a:xfrm>
+            <a:off x="320040" y="2011680"/>
+            <a:ext cx="2011680" cy="640080"/>
+          </a:xfrm>
+          <a:prstGeom prst="rect">
+            <a:avLst/>
+          </a:prstGeom>
+          <a:solidFill>
+            <a:srgbClr val="1E1B4B"/>
+          </a:solidFill>
+          <a:ln w="12700">
+            <a:solidFill>
+              <a:srgbClr val="363780"/>
+            </a:solidFill>
+            <a:prstDash val="solid"/>
+          </a:ln>
+        </p:spPr>
+      </p:sp>
+      <p:sp>
+        <p:nvSpPr>
+          <p:cNvPr id="19" name="Text 17"/>
+          <p:cNvSpPr/>
+          <p:nvPr/>
+        </p:nvSpPr>
+        <p:spPr>
+          <a:xfrm>
+            <a:off x="320040" y="2011680"/>
+            <a:ext cx="2011680" cy="640080"/>
+          </a:xfrm>
+          <a:prstGeom prst="rect">
+            <a:avLst/>
+          </a:prstGeom>
+          <a:noFill/>
+          <a:ln/>
+        </p:spPr>
+        <p:txBody>
+          <a:bodyPr wrap="square" rtlCol="0" anchor="ctr"/>
+          <a:lstStyle/>
+          <a:p>
+            <a:pPr algn="l" indent="0" marL="0">
+              <a:buNone/>
+            </a:pPr>
+            <a:r>
+              <a:rPr lang="en-US" sz="1400" b="1" dirty="0">
+                <a:solidFill>
+                  <a:srgbClr val="4ECDC4"/>
+                </a:solidFill>
+                <a:latin typeface="Calibri" pitchFamily="34" charset="0"/>
+                <a:ea typeface="Calibri" pitchFamily="34" charset="-122"/>
+                <a:cs typeface="Calibri" pitchFamily="34" charset="-120"/>
+              </a:rPr>
+              <a:t>● BFS</a:t>
+            </a:r>
+            <a:endParaRPr lang="en-US" sz="1400" dirty="0"/>
+          </a:p>
+        </p:txBody>
+      </p:sp>
+      <p:sp>
+        <p:nvSpPr>
+          <p:cNvPr id="20" name="Shape 18"/>
+          <p:cNvSpPr/>
+          <p:nvPr/>
+        </p:nvSpPr>
+        <p:spPr>
+          <a:xfrm>
+            <a:off x="2331720" y="2011680"/>
+            <a:ext cx="1645920" cy="640080"/>
+          </a:xfrm>
+          <a:prstGeom prst="rect">
+            <a:avLst/>
+          </a:prstGeom>
+          <a:solidFill>
+            <a:srgbClr val="1E1B4B"/>
+          </a:solidFill>
+          <a:ln w="12700">
+            <a:solidFill>
+              <a:srgbClr val="363780"/>
+            </a:solidFill>
+            <a:prstDash val="solid"/>
+          </a:ln>
+        </p:spPr>
+      </p:sp>
+      <p:sp>
+        <p:nvSpPr>
+          <p:cNvPr id="21" name="Text 19"/>
+          <p:cNvSpPr/>
+          <p:nvPr/>
+        </p:nvSpPr>
+        <p:spPr>
+          <a:xfrm>
+            <a:off x="2331720" y="2011680"/>
+            <a:ext cx="1645920" cy="640080"/>
+          </a:xfrm>
+          <a:prstGeom prst="rect">
+            <a:avLst/>
+          </a:prstGeom>
+          <a:noFill/>
+          <a:ln/>
+        </p:spPr>
+        <p:txBody>
+          <a:bodyPr wrap="square" rtlCol="0" anchor="ctr"/>
+          <a:lstStyle/>
+          <a:p>
+            <a:pPr algn="ctr" indent="0" marL="0">
+              <a:buNone/>
+            </a:pPr>
+            <a:r>
+              <a:rPr lang="en-US" sz="1400" dirty="0">
+                <a:solidFill>
+                  <a:srgbClr val="E0E7FF"/>
+                </a:solidFill>
+                <a:latin typeface="Calibri" pitchFamily="34" charset="0"/>
+                <a:ea typeface="Calibri" pitchFamily="34" charset="-122"/>
+                <a:cs typeface="Calibri" pitchFamily="34" charset="-120"/>
+              </a:rPr>
+              <a:t>~180</a:t>
+            </a:r>
+            <a:endParaRPr lang="en-US" sz="1400" dirty="0"/>
+          </a:p>
+        </p:txBody>
+      </p:sp>
+      <p:sp>
+        <p:nvSpPr>
+          <p:cNvPr id="22" name="Shape 20"/>
+          <p:cNvSpPr/>
+          <p:nvPr/>
+        </p:nvSpPr>
+        <p:spPr>
+          <a:xfrm>
+            <a:off x="3977640" y="2011680"/>
+            <a:ext cx="1737360" cy="640080"/>
+          </a:xfrm>
+          <a:prstGeom prst="rect">
+            <a:avLst/>
+          </a:prstGeom>
+          <a:solidFill>
+            <a:srgbClr val="1E1B4B"/>
+          </a:solidFill>
+          <a:ln w="12700">
+            <a:solidFill>
+              <a:srgbClr val="363780"/>
+            </a:solidFill>
+            <a:prstDash val="solid"/>
+          </a:ln>
+        </p:spPr>
+      </p:sp>
+      <p:sp>
+        <p:nvSpPr>
+          <p:cNvPr id="23" name="Text 21"/>
+          <p:cNvSpPr/>
+          <p:nvPr/>
+        </p:nvSpPr>
+        <p:spPr>
+          <a:xfrm>
+            <a:off x="3977640" y="2011680"/>
+            <a:ext cx="1737360" cy="640080"/>
+          </a:xfrm>
+          <a:prstGeom prst="rect">
+            <a:avLst/>
+          </a:prstGeom>
+          <a:noFill/>
+          <a:ln/>
+        </p:spPr>
+        <p:txBody>
+          <a:bodyPr wrap="square" rtlCol="0" anchor="ctr"/>
+          <a:lstStyle/>
+          <a:p>
+            <a:pPr algn="ctr" indent="0" marL="0">
+              <a:buNone/>
+            </a:pPr>
+            <a:r>
+              <a:rPr lang="en-US" sz="1400" dirty="0">
+                <a:solidFill>
+                  <a:srgbClr val="E0E7FF"/>
+                </a:solidFill>
+                <a:latin typeface="Calibri" pitchFamily="34" charset="0"/>
+                <a:ea typeface="Calibri" pitchFamily="34" charset="-122"/>
+                <a:cs typeface="Calibri" pitchFamily="34" charset="-120"/>
+              </a:rPr>
+              <a:t>~2 400m</a:t>
+            </a:r>
+            <a:endParaRPr lang="en-US" sz="1400" dirty="0"/>
+          </a:p>
+        </p:txBody>
+      </p:sp>
+      <p:sp>
+        <p:nvSpPr>
+          <p:cNvPr id="24" name="Shape 22"/>
+          <p:cNvSpPr/>
+          <p:nvPr/>
+        </p:nvSpPr>
+        <p:spPr>
+          <a:xfrm>
+            <a:off x="5715000" y="2011680"/>
+            <a:ext cx="1737360" cy="640080"/>
+          </a:xfrm>
+          <a:prstGeom prst="rect">
+            <a:avLst/>
+          </a:prstGeom>
+          <a:solidFill>
+            <a:srgbClr val="1E1B4B"/>
+          </a:solidFill>
+          <a:ln w="12700">
+            <a:solidFill>
+              <a:srgbClr val="363780"/>
+            </a:solidFill>
+            <a:prstDash val="solid"/>
+          </a:ln>
+        </p:spPr>
+      </p:sp>
+      <p:sp>
+        <p:nvSpPr>
+          <p:cNvPr id="25" name="Text 23"/>
+          <p:cNvSpPr/>
+          <p:nvPr/>
+        </p:nvSpPr>
+        <p:spPr>
+          <a:xfrm>
+            <a:off x="5715000" y="2011680"/>
+            <a:ext cx="1737360" cy="640080"/>
+          </a:xfrm>
+          <a:prstGeom prst="rect">
+            <a:avLst/>
+          </a:prstGeom>
+          <a:noFill/>
+          <a:ln/>
+        </p:spPr>
+        <p:txBody>
+          <a:bodyPr wrap="square" rtlCol="0" anchor="ctr"/>
+          <a:lstStyle/>
+          <a:p>
+            <a:pPr algn="ctr" indent="0" marL="0">
+              <a:buNone/>
+            </a:pPr>
+            <a:r>
+              <a:rPr lang="en-US" sz="1400" dirty="0">
+                <a:solidFill>
+                  <a:srgbClr val="E0E7FF"/>
+                </a:solidFill>
+                <a:latin typeface="Calibri" pitchFamily="34" charset="0"/>
+                <a:ea typeface="Calibri" pitchFamily="34" charset="-122"/>
+                <a:cs typeface="Calibri" pitchFamily="34" charset="-120"/>
+              </a:rPr>
+              <a:t>~18ms</a:t>
+            </a:r>
+            <a:endParaRPr lang="en-US" sz="1400" dirty="0"/>
+          </a:p>
+        </p:txBody>
+      </p:sp>
+      <p:sp>
+        <p:nvSpPr>
+          <p:cNvPr id="26" name="Shape 24"/>
+          <p:cNvSpPr/>
+          <p:nvPr/>
+        </p:nvSpPr>
+        <p:spPr>
+          <a:xfrm>
+            <a:off x="320040" y="2651760"/>
+            <a:ext cx="2011680" cy="640080"/>
+          </a:xfrm>
+          <a:prstGeom prst="rect">
+            <a:avLst/>
+          </a:prstGeom>
+          <a:solidFill>
+            <a:srgbClr val="1C1945"/>
+          </a:solidFill>
+          <a:ln w="12700">
+            <a:solidFill>
+              <a:srgbClr val="363780"/>
+            </a:solidFill>
+            <a:prstDash val="solid"/>
+          </a:ln>
+        </p:spPr>
+      </p:sp>
+      <p:sp>
+        <p:nvSpPr>
+          <p:cNvPr id="27" name="Text 25"/>
+          <p:cNvSpPr/>
+          <p:nvPr/>
+        </p:nvSpPr>
+        <p:spPr>
+          <a:xfrm>
+            <a:off x="320040" y="2651760"/>
+            <a:ext cx="2011680" cy="640080"/>
+          </a:xfrm>
+          <a:prstGeom prst="rect">
+            <a:avLst/>
+          </a:prstGeom>
+          <a:noFill/>
+          <a:ln/>
+        </p:spPr>
+        <p:txBody>
+          <a:bodyPr wrap="square" rtlCol="0" anchor="ctr"/>
+          <a:lstStyle/>
+          <a:p>
+            <a:pPr algn="l" indent="0" marL="0">
+              <a:buNone/>
+            </a:pPr>
+            <a:r>
+              <a:rPr lang="en-US" sz="1400" b="1" dirty="0">
+                <a:solidFill>
+                  <a:srgbClr val="FF6B6B"/>
+                </a:solidFill>
+                <a:latin typeface="Calibri" pitchFamily="34" charset="0"/>
+                <a:ea typeface="Calibri" pitchFamily="34" charset="-122"/>
+                <a:cs typeface="Calibri" pitchFamily="34" charset="-120"/>
+              </a:rPr>
+              <a:t>● DFS</a:t>
+            </a:r>
+            <a:endParaRPr lang="en-US" sz="1400" dirty="0"/>
+          </a:p>
+        </p:txBody>
+      </p:sp>
+      <p:sp>
+        <p:nvSpPr>
+          <p:cNvPr id="28" name="Shape 26"/>
+          <p:cNvSpPr/>
+          <p:nvPr/>
+        </p:nvSpPr>
+        <p:spPr>
+          <a:xfrm>
+            <a:off x="2331720" y="2651760"/>
+            <a:ext cx="1645920" cy="640080"/>
+          </a:xfrm>
+          <a:prstGeom prst="rect">
+            <a:avLst/>
+          </a:prstGeom>
+          <a:solidFill>
+            <a:srgbClr val="1C1945"/>
+          </a:solidFill>
+          <a:ln w="12700">
+            <a:solidFill>
+              <a:srgbClr val="363780"/>
+            </a:solidFill>
+            <a:prstDash val="solid"/>
+          </a:ln>
+        </p:spPr>
+      </p:sp>
+      <p:sp>
+        <p:nvSpPr>
+          <p:cNvPr id="29" name="Text 27"/>
+          <p:cNvSpPr/>
+          <p:nvPr/>
+        </p:nvSpPr>
+        <p:spPr>
+          <a:xfrm>
+            <a:off x="2331720" y="2651760"/>
+            <a:ext cx="1645920" cy="640080"/>
+          </a:xfrm>
+          <a:prstGeom prst="rect">
+            <a:avLst/>
+          </a:prstGeom>
+          <a:noFill/>
+          <a:ln/>
+        </p:spPr>
+        <p:txBody>
+          <a:bodyPr wrap="square" rtlCol="0" anchor="ctr"/>
+          <a:lstStyle/>
+          <a:p>
+            <a:pPr algn="ctr" indent="0" marL="0">
+              <a:buNone/>
+            </a:pPr>
+            <a:r>
+              <a:rPr lang="en-US" sz="1400" dirty="0">
+                <a:solidFill>
+                  <a:srgbClr val="E0E7FF"/>
+                </a:solidFill>
+                <a:latin typeface="Calibri" pitchFamily="34" charset="0"/>
+                <a:ea typeface="Calibri" pitchFamily="34" charset="-122"/>
+                <a:cs typeface="Calibri" pitchFamily="34" charset="-120"/>
+              </a:rPr>
+              <a:t>~320</a:t>
+            </a:r>
+            <a:endParaRPr lang="en-US" sz="1400" dirty="0"/>
+          </a:p>
+        </p:txBody>
+      </p:sp>
+      <p:sp>
+        <p:nvSpPr>
+          <p:cNvPr id="30" name="Shape 28"/>
+          <p:cNvSpPr/>
+          <p:nvPr/>
+        </p:nvSpPr>
+        <p:spPr>
+          <a:xfrm>
+            <a:off x="3977640" y="2651760"/>
+            <a:ext cx="1737360" cy="640080"/>
+          </a:xfrm>
+          <a:prstGeom prst="rect">
+            <a:avLst/>
+          </a:prstGeom>
+          <a:solidFill>
+            <a:srgbClr val="1C1945"/>
+          </a:solidFill>
+          <a:ln w="12700">
+            <a:solidFill>
+              <a:srgbClr val="363780"/>
+            </a:solidFill>
+            <a:prstDash val="solid"/>
+          </a:ln>
+        </p:spPr>
+      </p:sp>
+      <p:sp>
+        <p:nvSpPr>
+          <p:cNvPr id="31" name="Text 29"/>
+          <p:cNvSpPr/>
+          <p:nvPr/>
+        </p:nvSpPr>
+        <p:spPr>
+          <a:xfrm>
+            <a:off x="3977640" y="2651760"/>
+            <a:ext cx="1737360" cy="640080"/>
+          </a:xfrm>
+          <a:prstGeom prst="rect">
+            <a:avLst/>
+          </a:prstGeom>
+          <a:noFill/>
+          <a:ln/>
+        </p:spPr>
+        <p:txBody>
+          <a:bodyPr wrap="square" rtlCol="0" anchor="ctr"/>
+          <a:lstStyle/>
+          <a:p>
+            <a:pPr algn="ctr" indent="0" marL="0">
+              <a:buNone/>
+            </a:pPr>
+            <a:r>
+              <a:rPr lang="en-US" sz="1400" dirty="0">
+                <a:solidFill>
+                  <a:srgbClr val="E0E7FF"/>
+                </a:solidFill>
+                <a:latin typeface="Calibri" pitchFamily="34" charset="0"/>
+                <a:ea typeface="Calibri" pitchFamily="34" charset="-122"/>
+                <a:cs typeface="Calibri" pitchFamily="34" charset="-120"/>
+              </a:rPr>
+              <a:t>~4 100m</a:t>
+            </a:r>
+            <a:endParaRPr lang="en-US" sz="1400" dirty="0"/>
+          </a:p>
+        </p:txBody>
+      </p:sp>
+      <p:sp>
+        <p:nvSpPr>
+          <p:cNvPr id="32" name="Shape 30"/>
+          <p:cNvSpPr/>
+          <p:nvPr/>
+        </p:nvSpPr>
+        <p:spPr>
+          <a:xfrm>
+            <a:off x="5715000" y="2651760"/>
+            <a:ext cx="1737360" cy="640080"/>
+          </a:xfrm>
+          <a:prstGeom prst="rect">
+            <a:avLst/>
+          </a:prstGeom>
+          <a:solidFill>
+            <a:srgbClr val="1C1945"/>
+          </a:solidFill>
+          <a:ln w="12700">
+            <a:solidFill>
+              <a:srgbClr val="363780"/>
+            </a:solidFill>
+            <a:prstDash val="solid"/>
+          </a:ln>
+        </p:spPr>
+      </p:sp>
+      <p:sp>
+        <p:nvSpPr>
+          <p:cNvPr id="33" name="Text 31"/>
+          <p:cNvSpPr/>
+          <p:nvPr/>
+        </p:nvSpPr>
+        <p:spPr>
+          <a:xfrm>
+            <a:off x="5715000" y="2651760"/>
+            <a:ext cx="1737360" cy="640080"/>
+          </a:xfrm>
+          <a:prstGeom prst="rect">
+            <a:avLst/>
+          </a:prstGeom>
+          <a:noFill/>
+          <a:ln/>
+        </p:spPr>
+        <p:txBody>
+          <a:bodyPr wrap="square" rtlCol="0" anchor="ctr"/>
+          <a:lstStyle/>
+          <a:p>
+            <a:pPr algn="ctr" indent="0" marL="0">
+              <a:buNone/>
+            </a:pPr>
+            <a:r>
+              <a:rPr lang="en-US" sz="1400" dirty="0">
+                <a:solidFill>
+                  <a:srgbClr val="E0E7FF"/>
+                </a:solidFill>
+                <a:latin typeface="Calibri" pitchFamily="34" charset="0"/>
+                <a:ea typeface="Calibri" pitchFamily="34" charset="-122"/>
+                <a:cs typeface="Calibri" pitchFamily="34" charset="-120"/>
+              </a:rPr>
+              <a:t>~22ms</a:t>
+            </a:r>
+            <a:endParaRPr lang="en-US" sz="1400" dirty="0"/>
+          </a:p>
+        </p:txBody>
+      </p:sp>
+      <p:sp>
+        <p:nvSpPr>
+          <p:cNvPr id="34" name="Shape 32"/>
+          <p:cNvSpPr/>
+          <p:nvPr/>
+        </p:nvSpPr>
+        <p:spPr>
+          <a:xfrm>
+            <a:off x="320040" y="3291840"/>
+            <a:ext cx="2011680" cy="640080"/>
+          </a:xfrm>
+          <a:prstGeom prst="rect">
+            <a:avLst/>
+          </a:prstGeom>
+          <a:solidFill>
+            <a:srgbClr val="1E1B4B"/>
+          </a:solidFill>
+          <a:ln w="12700">
+            <a:solidFill>
+              <a:srgbClr val="363780"/>
+            </a:solidFill>
+            <a:prstDash val="solid"/>
+          </a:ln>
+        </p:spPr>
+      </p:sp>
+      <p:sp>
+        <p:nvSpPr>
+          <p:cNvPr id="35" name="Text 33"/>
+          <p:cNvSpPr/>
+          <p:nvPr/>
+        </p:nvSpPr>
+        <p:spPr>
+          <a:xfrm>
+            <a:off x="320040" y="3291840"/>
+            <a:ext cx="2011680" cy="640080"/>
+          </a:xfrm>
+          <a:prstGeom prst="rect">
+            <a:avLst/>
+          </a:prstGeom>
+          <a:noFill/>
+          <a:ln/>
+        </p:spPr>
+        <p:txBody>
+          <a:bodyPr wrap="square" rtlCol="0" anchor="ctr"/>
+          <a:lstStyle/>
+          <a:p>
+            <a:pPr algn="l" indent="0" marL="0">
+              <a:buNone/>
+            </a:pPr>
+            <a:r>
+              <a:rPr lang="en-US" sz="1400" b="1" dirty="0">
+                <a:solidFill>
+                  <a:srgbClr val="FFD166"/>
+                </a:solidFill>
+                <a:latin typeface="Calibri" pitchFamily="34" charset="0"/>
+                <a:ea typeface="Calibri" pitchFamily="34" charset="-122"/>
+                <a:cs typeface="Calibri" pitchFamily="34" charset="-120"/>
+              </a:rPr>
+              <a:t>● Dijkstra</a:t>
+            </a:r>
+            <a:endParaRPr lang="en-US" sz="1400" dirty="0"/>
+          </a:p>
+        </p:txBody>
+      </p:sp>
+      <p:sp>
+        <p:nvSpPr>
+          <p:cNvPr id="36" name="Shape 34"/>
+          <p:cNvSpPr/>
+          <p:nvPr/>
+        </p:nvSpPr>
+        <p:spPr>
+          <a:xfrm>
+            <a:off x="2331720" y="3291840"/>
+            <a:ext cx="1645920" cy="640080"/>
+          </a:xfrm>
+          <a:prstGeom prst="rect">
+            <a:avLst/>
+          </a:prstGeom>
+          <a:solidFill>
+            <a:srgbClr val="1E1B4B"/>
+          </a:solidFill>
+          <a:ln w="12700">
+            <a:solidFill>
+              <a:srgbClr val="363780"/>
+            </a:solidFill>
+            <a:prstDash val="solid"/>
+          </a:ln>
+        </p:spPr>
+      </p:sp>
+      <p:sp>
+        <p:nvSpPr>
+          <p:cNvPr id="37" name="Text 35"/>
+          <p:cNvSpPr/>
+          <p:nvPr/>
+        </p:nvSpPr>
+        <p:spPr>
+          <a:xfrm>
+            <a:off x="2331720" y="3291840"/>
+            <a:ext cx="1645920" cy="640080"/>
+          </a:xfrm>
+          <a:prstGeom prst="rect">
+            <a:avLst/>
+          </a:prstGeom>
+          <a:noFill/>
+          <a:ln/>
+        </p:spPr>
+        <p:txBody>
+          <a:bodyPr wrap="square" rtlCol="0" anchor="ctr"/>
+          <a:lstStyle/>
+          <a:p>
+            <a:pPr algn="ctr" indent="0" marL="0">
+              <a:buNone/>
+            </a:pPr>
+            <a:r>
+              <a:rPr lang="en-US" sz="1400" dirty="0">
+                <a:solidFill>
+                  <a:srgbClr val="E0E7FF"/>
+                </a:solidFill>
+                <a:latin typeface="Calibri" pitchFamily="34" charset="0"/>
+                <a:ea typeface="Calibri" pitchFamily="34" charset="-122"/>
+                <a:cs typeface="Calibri" pitchFamily="34" charset="-120"/>
+              </a:rPr>
+              <a:t>~220</a:t>
+            </a:r>
+            <a:endParaRPr lang="en-US" sz="1400" dirty="0"/>
+          </a:p>
+        </p:txBody>
+      </p:sp>
+      <p:sp>
+        <p:nvSpPr>
+          <p:cNvPr id="38" name="Shape 36"/>
+          <p:cNvSpPr/>
+          <p:nvPr/>
+        </p:nvSpPr>
+        <p:spPr>
+          <a:xfrm>
+            <a:off x="3977640" y="3291840"/>
+            <a:ext cx="1737360" cy="640080"/>
+          </a:xfrm>
+          <a:prstGeom prst="rect">
+            <a:avLst/>
+          </a:prstGeom>
+          <a:solidFill>
+            <a:srgbClr val="1E1B4B"/>
+          </a:solidFill>
+          <a:ln w="12700">
+            <a:solidFill>
+              <a:srgbClr val="363780"/>
+            </a:solidFill>
+            <a:prstDash val="solid"/>
+          </a:ln>
+        </p:spPr>
+      </p:sp>
+      <p:sp>
+        <p:nvSpPr>
+          <p:cNvPr id="39" name="Text 37"/>
+          <p:cNvSpPr/>
+          <p:nvPr/>
+        </p:nvSpPr>
+        <p:spPr>
+          <a:xfrm>
+            <a:off x="3977640" y="3291840"/>
+            <a:ext cx="1737360" cy="640080"/>
+          </a:xfrm>
+          <a:prstGeom prst="rect">
+            <a:avLst/>
+          </a:prstGeom>
+          <a:noFill/>
+          <a:ln/>
+        </p:spPr>
+        <p:txBody>
+          <a:bodyPr wrap="square" rtlCol="0" anchor="ctr"/>
+          <a:lstStyle/>
+          <a:p>
+            <a:pPr algn="ctr" indent="0" marL="0">
+              <a:buNone/>
+            </a:pPr>
+            <a:r>
+              <a:rPr lang="en-US" sz="1400" dirty="0">
+                <a:solidFill>
+                  <a:srgbClr val="E0E7FF"/>
+                </a:solidFill>
+                <a:latin typeface="Calibri" pitchFamily="34" charset="0"/>
+                <a:ea typeface="Calibri" pitchFamily="34" charset="-122"/>
+                <a:cs typeface="Calibri" pitchFamily="34" charset="-120"/>
+              </a:rPr>
+              <a:t>~2 100m</a:t>
+            </a:r>
+            <a:endParaRPr lang="en-US" sz="1400" dirty="0"/>
+          </a:p>
+        </p:txBody>
+      </p:sp>
+      <p:sp>
+        <p:nvSpPr>
+          <p:cNvPr id="40" name="Shape 38"/>
+          <p:cNvSpPr/>
+          <p:nvPr/>
+        </p:nvSpPr>
+        <p:spPr>
+          <a:xfrm>
+            <a:off x="5715000" y="3291840"/>
+            <a:ext cx="1737360" cy="640080"/>
+          </a:xfrm>
+          <a:prstGeom prst="rect">
+            <a:avLst/>
+          </a:prstGeom>
+          <a:solidFill>
+            <a:srgbClr val="1E1B4B"/>
+          </a:solidFill>
+          <a:ln w="12700">
+            <a:solidFill>
+              <a:srgbClr val="363780"/>
+            </a:solidFill>
+            <a:prstDash val="solid"/>
+          </a:ln>
+        </p:spPr>
+      </p:sp>
+      <p:sp>
+        <p:nvSpPr>
+          <p:cNvPr id="41" name="Text 39"/>
+          <p:cNvSpPr/>
+          <p:nvPr/>
+        </p:nvSpPr>
+        <p:spPr>
+          <a:xfrm>
+            <a:off x="5715000" y="3291840"/>
+            <a:ext cx="1737360" cy="640080"/>
+          </a:xfrm>
+          <a:prstGeom prst="rect">
+            <a:avLst/>
+          </a:prstGeom>
+          <a:noFill/>
+          <a:ln/>
+        </p:spPr>
+        <p:txBody>
+          <a:bodyPr wrap="square" rtlCol="0" anchor="ctr"/>
+          <a:lstStyle/>
+          <a:p>
+            <a:pPr algn="ctr" indent="0" marL="0">
+              <a:buNone/>
+            </a:pPr>
+            <a:r>
+              <a:rPr lang="en-US" sz="1400" dirty="0">
+                <a:solidFill>
+                  <a:srgbClr val="E0E7FF"/>
+                </a:solidFill>
+                <a:latin typeface="Calibri" pitchFamily="34" charset="0"/>
+                <a:ea typeface="Calibri" pitchFamily="34" charset="-122"/>
+                <a:cs typeface="Calibri" pitchFamily="34" charset="-120"/>
+              </a:rPr>
+              <a:t>~14ms</a:t>
+            </a:r>
+            <a:endParaRPr lang="en-US" sz="1400" dirty="0"/>
+          </a:p>
+        </p:txBody>
+      </p:sp>
+      <p:sp>
+        <p:nvSpPr>
+          <p:cNvPr id="42" name="Shape 40"/>
+          <p:cNvSpPr/>
+          <p:nvPr/>
+        </p:nvSpPr>
+        <p:spPr>
+          <a:xfrm>
+            <a:off x="320040" y="3931920"/>
+            <a:ext cx="2011680" cy="640080"/>
+          </a:xfrm>
+          <a:prstGeom prst="rect">
+            <a:avLst/>
+          </a:prstGeom>
+          <a:solidFill>
+            <a:srgbClr val="1C1945"/>
+          </a:solidFill>
+          <a:ln w="12700">
+            <a:solidFill>
+              <a:srgbClr val="363780"/>
+            </a:solidFill>
+            <a:prstDash val="solid"/>
+          </a:ln>
+        </p:spPr>
+      </p:sp>
+      <p:sp>
+        <p:nvSpPr>
+          <p:cNvPr id="43" name="Text 41"/>
+          <p:cNvSpPr/>
+          <p:nvPr/>
+        </p:nvSpPr>
+        <p:spPr>
+          <a:xfrm>
+            <a:off x="320040" y="3931920"/>
+            <a:ext cx="2011680" cy="640080"/>
+          </a:xfrm>
+          <a:prstGeom prst="rect">
+            <a:avLst/>
+          </a:prstGeom>
+          <a:noFill/>
+          <a:ln/>
+        </p:spPr>
+        <p:txBody>
+          <a:bodyPr wrap="square" rtlCol="0" anchor="ctr"/>
+          <a:lstStyle/>
+          <a:p>
+            <a:pPr algn="l" indent="0" marL="0">
+              <a:buNone/>
+            </a:pPr>
+            <a:r>
+              <a:rPr lang="en-US" sz="1400" b="1" dirty="0">
+                <a:solidFill>
+                  <a:srgbClr val="06D6A0"/>
+                </a:solidFill>
+                <a:latin typeface="Calibri" pitchFamily="34" charset="0"/>
+                <a:ea typeface="Calibri" pitchFamily="34" charset="-122"/>
+                <a:cs typeface="Calibri" pitchFamily="34" charset="-120"/>
+              </a:rPr>
+              <a:t>● A*</a:t>
+            </a:r>
+            <a:endParaRPr lang="en-US" sz="1400" dirty="0"/>
+          </a:p>
+        </p:txBody>
+      </p:sp>
+      <p:sp>
+        <p:nvSpPr>
+          <p:cNvPr id="44" name="Shape 42"/>
+          <p:cNvSpPr/>
+          <p:nvPr/>
+        </p:nvSpPr>
+        <p:spPr>
+          <a:xfrm>
+            <a:off x="2331720" y="3931920"/>
+            <a:ext cx="1645920" cy="640080"/>
+          </a:xfrm>
+          <a:prstGeom prst="rect">
+            <a:avLst/>
+          </a:prstGeom>
+          <a:solidFill>
+            <a:srgbClr val="1C1945"/>
+          </a:solidFill>
+          <a:ln w="12700">
+            <a:solidFill>
+              <a:srgbClr val="363780"/>
+            </a:solidFill>
+            <a:prstDash val="solid"/>
+          </a:ln>
+        </p:spPr>
+      </p:sp>
+      <p:sp>
+        <p:nvSpPr>
+          <p:cNvPr id="45" name="Text 43"/>
+          <p:cNvSpPr/>
+          <p:nvPr/>
+        </p:nvSpPr>
+        <p:spPr>
+          <a:xfrm>
+            <a:off x="2331720" y="3931920"/>
+            <a:ext cx="1645920" cy="640080"/>
+          </a:xfrm>
+          <a:prstGeom prst="rect">
+            <a:avLst/>
+          </a:prstGeom>
+          <a:noFill/>
+          <a:ln/>
+        </p:spPr>
+        <p:txBody>
+          <a:bodyPr wrap="square" rtlCol="0" anchor="ctr"/>
+          <a:lstStyle/>
+          <a:p>
+            <a:pPr algn="ctr" indent="0" marL="0">
+              <a:buNone/>
+            </a:pPr>
+            <a:r>
+              <a:rPr lang="en-US" sz="1400" dirty="0">
+                <a:solidFill>
+                  <a:srgbClr val="E0E7FF"/>
+                </a:solidFill>
+                <a:latin typeface="Calibri" pitchFamily="34" charset="0"/>
+                <a:ea typeface="Calibri" pitchFamily="34" charset="-122"/>
+                <a:cs typeface="Calibri" pitchFamily="34" charset="-120"/>
+              </a:rPr>
+              <a:t>~95</a:t>
+            </a:r>
+            <a:endParaRPr lang="en-US" sz="1400" dirty="0"/>
+          </a:p>
+        </p:txBody>
+      </p:sp>
+      <p:sp>
+        <p:nvSpPr>
+          <p:cNvPr id="46" name="Shape 44"/>
+          <p:cNvSpPr/>
+          <p:nvPr/>
+        </p:nvSpPr>
+        <p:spPr>
+          <a:xfrm>
+            <a:off x="3977640" y="3931920"/>
+            <a:ext cx="1737360" cy="640080"/>
+          </a:xfrm>
+          <a:prstGeom prst="rect">
+            <a:avLst/>
+          </a:prstGeom>
+          <a:solidFill>
+            <a:srgbClr val="1C1945"/>
+          </a:solidFill>
+          <a:ln w="12700">
+            <a:solidFill>
+              <a:srgbClr val="363780"/>
+            </a:solidFill>
+            <a:prstDash val="solid"/>
+          </a:ln>
+        </p:spPr>
+      </p:sp>
+      <p:sp>
+        <p:nvSpPr>
+          <p:cNvPr id="47" name="Text 45"/>
+          <p:cNvSpPr/>
+          <p:nvPr/>
+        </p:nvSpPr>
+        <p:spPr>
+          <a:xfrm>
+            <a:off x="3977640" y="3931920"/>
+            <a:ext cx="1737360" cy="640080"/>
+          </a:xfrm>
+          <a:prstGeom prst="rect">
+            <a:avLst/>
+          </a:prstGeom>
+          <a:noFill/>
+          <a:ln/>
+        </p:spPr>
+        <p:txBody>
+          <a:bodyPr wrap="square" rtlCol="0" anchor="ctr"/>
+          <a:lstStyle/>
+          <a:p>
+            <a:pPr algn="ctr" indent="0" marL="0">
+              <a:buNone/>
+            </a:pPr>
+            <a:r>
+              <a:rPr lang="en-US" sz="1400" dirty="0">
+                <a:solidFill>
+                  <a:srgbClr val="E0E7FF"/>
+                </a:solidFill>
+                <a:latin typeface="Calibri" pitchFamily="34" charset="0"/>
+                <a:ea typeface="Calibri" pitchFamily="34" charset="-122"/>
+                <a:cs typeface="Calibri" pitchFamily="34" charset="-120"/>
+              </a:rPr>
+              <a:t>~2 100m</a:t>
+            </a:r>
+            <a:endParaRPr lang="en-US" sz="1400" dirty="0"/>
+          </a:p>
+        </p:txBody>
+      </p:sp>
+      <p:sp>
+        <p:nvSpPr>
+          <p:cNvPr id="48" name="Shape 46"/>
+          <p:cNvSpPr/>
+          <p:nvPr/>
+        </p:nvSpPr>
+        <p:spPr>
+          <a:xfrm>
+            <a:off x="5715000" y="3931920"/>
+            <a:ext cx="1737360" cy="640080"/>
+          </a:xfrm>
+          <a:prstGeom prst="rect">
+            <a:avLst/>
+          </a:prstGeom>
+          <a:solidFill>
+            <a:srgbClr val="1C1945"/>
+          </a:solidFill>
+          <a:ln w="12700">
+            <a:solidFill>
+              <a:srgbClr val="363780"/>
+            </a:solidFill>
+            <a:prstDash val="solid"/>
+          </a:ln>
+        </p:spPr>
+      </p:sp>
+      <p:sp>
+        <p:nvSpPr>
+          <p:cNvPr id="49" name="Text 47"/>
+          <p:cNvSpPr/>
+          <p:nvPr/>
+        </p:nvSpPr>
+        <p:spPr>
+          <a:xfrm>
+            <a:off x="5715000" y="3931920"/>
+            <a:ext cx="1737360" cy="640080"/>
+          </a:xfrm>
+          <a:prstGeom prst="rect">
+            <a:avLst/>
+          </a:prstGeom>
+          <a:noFill/>
+          <a:ln/>
+        </p:spPr>
+        <p:txBody>
+          <a:bodyPr wrap="square" rtlCol="0" anchor="ctr"/>
+          <a:lstStyle/>
+          <a:p>
+            <a:pPr algn="ctr" indent="0" marL="0">
+              <a:buNone/>
+            </a:pPr>
+            <a:r>
+              <a:rPr lang="en-US" sz="1400" dirty="0">
+                <a:solidFill>
+                  <a:srgbClr val="E0E7FF"/>
+                </a:solidFill>
+                <a:latin typeface="Calibri" pitchFamily="34" charset="0"/>
+                <a:ea typeface="Calibri" pitchFamily="34" charset="-122"/>
+                <a:cs typeface="Calibri" pitchFamily="34" charset="-120"/>
+              </a:rPr>
+              <a:t>~8ms</a:t>
+            </a:r>
+            <a:endParaRPr lang="en-US" sz="1400" dirty="0"/>
+          </a:p>
+        </p:txBody>
+      </p:sp>
+      <p:sp>
+        <p:nvSpPr>
+          <p:cNvPr id="50" name="Shape 48"/>
+          <p:cNvSpPr/>
+          <p:nvPr/>
+        </p:nvSpPr>
+        <p:spPr>
+          <a:xfrm>
+            <a:off x="7315200" y="1371600"/>
+            <a:ext cx="4572000" cy="1280160"/>
+          </a:xfrm>
+          <a:prstGeom prst="roundRect">
+            <a:avLst>
+              <a:gd name="adj" fmla="val 5714"/>
+            </a:avLst>
+          </a:prstGeom>
+          <a:solidFill>
+            <a:srgbClr val="1C1945"/>
+          </a:solidFill>
+          <a:ln w="15240">
+            <a:solidFill>
+              <a:srgbClr val="06D6A0"/>
+            </a:solidFill>
+            <a:prstDash val="solid"/>
+          </a:ln>
+        </p:spPr>
+      </p:sp>
+      <p:sp>
+        <p:nvSpPr>
+          <p:cNvPr id="51" name="Text 49"/>
+          <p:cNvSpPr/>
+          <p:nvPr/>
+        </p:nvSpPr>
+        <p:spPr>
+          <a:xfrm>
+            <a:off x="7452360" y="1463040"/>
+            <a:ext cx="4389120" cy="411480"/>
+          </a:xfrm>
+          <a:prstGeom prst="rect">
+            <a:avLst/>
+          </a:prstGeom>
+          <a:noFill/>
+          <a:ln/>
+        </p:spPr>
+        <p:txBody>
+          <a:bodyPr wrap="square" rtlCol="0" anchor="ctr"/>
+          <a:lstStyle/>
+          <a:p>
+            <a:pPr indent="0" marL="0">
+              <a:buNone/>
+            </a:pPr>
+            <a:r>
+              <a:rPr lang="en-US" sz="1300" b="1" dirty="0">
+                <a:solidFill>
+                  <a:srgbClr val="06D6A0"/>
+                </a:solidFill>
+                <a:latin typeface="Calibri" pitchFamily="34" charset="0"/>
+                <a:ea typeface="Calibri" pitchFamily="34" charset="-122"/>
+                <a:cs typeface="Calibri" pitchFamily="34" charset="-120"/>
+              </a:rPr>
+              <a:t>🏆 A* — Hiệu quả nhất</a:t>
+            </a:r>
+            <a:endParaRPr lang="en-US" sz="1300" dirty="0"/>
+          </a:p>
+        </p:txBody>
+      </p:sp>
+      <p:sp>
+        <p:nvSpPr>
+          <p:cNvPr id="52" name="Text 50"/>
+          <p:cNvSpPr/>
+          <p:nvPr/>
+        </p:nvSpPr>
+        <p:spPr>
+          <a:xfrm>
+            <a:off x="7452360" y="1874520"/>
+            <a:ext cx="4389120" cy="658368"/>
+          </a:xfrm>
+          <a:prstGeom prst="rect">
+            <a:avLst/>
+          </a:prstGeom>
+          <a:noFill/>
+          <a:ln/>
+        </p:spPr>
+        <p:txBody>
+          <a:bodyPr wrap="square" rtlCol="0" anchor="ctr"/>
+          <a:lstStyle/>
+          <a:p>
+            <a:pPr indent="0" marL="0">
+              <a:buNone/>
+            </a:pPr>
+            <a:r>
+              <a:rPr lang="en-US" sz="1150" dirty="0">
+                <a:solidFill>
+                  <a:srgbClr val="6B7AB8"/>
+                </a:solidFill>
+                <a:latin typeface="Calibri" pitchFamily="34" charset="0"/>
+                <a:ea typeface="Calibri" pitchFamily="34" charset="-122"/>
+                <a:cs typeface="Calibri" pitchFamily="34" charset="-120"/>
+              </a:rPr>
+              <a:t>Duyệt ít nút nhất (~95) nhờ heuristic. Nhanh gấp ~1.75× Dijkstra, cùng độ dài tối ưu.</a:t>
+            </a:r>
+            <a:endParaRPr lang="en-US" sz="1150" dirty="0"/>
+          </a:p>
+        </p:txBody>
+      </p:sp>
+      <p:sp>
+        <p:nvSpPr>
+          <p:cNvPr id="53" name="Shape 51"/>
+          <p:cNvSpPr/>
+          <p:nvPr/>
+        </p:nvSpPr>
+        <p:spPr>
+          <a:xfrm>
+            <a:off x="7315200" y="2743200"/>
+            <a:ext cx="4572000" cy="1280160"/>
+          </a:xfrm>
+          <a:prstGeom prst="roundRect">
+            <a:avLst>
+              <a:gd name="adj" fmla="val 5714"/>
+            </a:avLst>
+          </a:prstGeom>
+          <a:solidFill>
+            <a:srgbClr val="1C1945"/>
+          </a:solidFill>
+          <a:ln w="15240">
+            <a:solidFill>
+              <a:srgbClr val="FFD166"/>
+            </a:solidFill>
+            <a:prstDash val="solid"/>
+          </a:ln>
+        </p:spPr>
+      </p:sp>
+      <p:sp>
+        <p:nvSpPr>
+          <p:cNvPr id="54" name="Text 52"/>
+          <p:cNvSpPr/>
+          <p:nvPr/>
+        </p:nvSpPr>
+        <p:spPr>
+          <a:xfrm>
+            <a:off x="7452360" y="2834640"/>
+            <a:ext cx="4389120" cy="411480"/>
+          </a:xfrm>
+          <a:prstGeom prst="rect">
+            <a:avLst/>
+          </a:prstGeom>
+          <a:noFill/>
+          <a:ln/>
+        </p:spPr>
+        <p:txBody>
+          <a:bodyPr wrap="square" rtlCol="0" anchor="ctr"/>
+          <a:lstStyle/>
+          <a:p>
+            <a:pPr indent="0" marL="0">
+              <a:buNone/>
+            </a:pPr>
+            <a:r>
+              <a:rPr lang="en-US" sz="1300" b="1" dirty="0">
+                <a:solidFill>
+                  <a:srgbClr val="FFD166"/>
+                </a:solidFill>
+                <a:latin typeface="Calibri" pitchFamily="34" charset="0"/>
+                <a:ea typeface="Calibri" pitchFamily="34" charset="-122"/>
+                <a:cs typeface="Calibri" pitchFamily="34" charset="-120"/>
+              </a:rPr>
+              <a:t>✓ Dijkstra — Tối ưu đảm bảo</a:t>
+            </a:r>
+            <a:endParaRPr lang="en-US" sz="1300" dirty="0"/>
+          </a:p>
+        </p:txBody>
+      </p:sp>
+      <p:sp>
+        <p:nvSpPr>
+          <p:cNvPr id="55" name="Text 53"/>
+          <p:cNvSpPr/>
+          <p:nvPr/>
+        </p:nvSpPr>
+        <p:spPr>
+          <a:xfrm>
+            <a:off x="7452360" y="3246120"/>
+            <a:ext cx="4389120" cy="658368"/>
+          </a:xfrm>
+          <a:prstGeom prst="rect">
+            <a:avLst/>
+          </a:prstGeom>
+          <a:noFill/>
+          <a:ln/>
+        </p:spPr>
+        <p:txBody>
+          <a:bodyPr wrap="square" rtlCol="0" anchor="ctr"/>
+          <a:lstStyle/>
+          <a:p>
+            <a:pPr indent="0" marL="0">
+              <a:buNone/>
+            </a:pPr>
+            <a:r>
+              <a:rPr lang="en-US" sz="1150" dirty="0">
+                <a:solidFill>
+                  <a:srgbClr val="6B7AB8"/>
+                </a:solidFill>
+                <a:latin typeface="Calibri" pitchFamily="34" charset="0"/>
+                <a:ea typeface="Calibri" pitchFamily="34" charset="-122"/>
+                <a:cs typeface="Calibri" pitchFamily="34" charset="-120"/>
+              </a:rPr>
+              <a:t>Đường ngắn nhất tuyệt đối. Chậm hơn A* vì không có định hướng.</a:t>
+            </a:r>
+            <a:endParaRPr lang="en-US" sz="1150" dirty="0"/>
+          </a:p>
+        </p:txBody>
+      </p:sp>
+      <p:sp>
+        <p:nvSpPr>
+          <p:cNvPr id="56" name="Shape 54"/>
+          <p:cNvSpPr/>
+          <p:nvPr/>
+        </p:nvSpPr>
+        <p:spPr>
+          <a:xfrm>
+            <a:off x="7315200" y="4114800"/>
+            <a:ext cx="4572000" cy="1280160"/>
+          </a:xfrm>
+          <a:prstGeom prst="roundRect">
+            <a:avLst>
+              <a:gd name="adj" fmla="val 5714"/>
+            </a:avLst>
+          </a:prstGeom>
+          <a:solidFill>
+            <a:srgbClr val="1C1945"/>
+          </a:solidFill>
+          <a:ln w="15240">
+            <a:solidFill>
+              <a:srgbClr val="4ECDC4"/>
+            </a:solidFill>
+            <a:prstDash val="solid"/>
+          </a:ln>
+        </p:spPr>
+      </p:sp>
+      <p:sp>
+        <p:nvSpPr>
+          <p:cNvPr id="57" name="Text 55"/>
+          <p:cNvSpPr/>
+          <p:nvPr/>
+        </p:nvSpPr>
+        <p:spPr>
+          <a:xfrm>
+            <a:off x="7452360" y="4206240"/>
+            <a:ext cx="4389120" cy="411480"/>
+          </a:xfrm>
+          <a:prstGeom prst="rect">
+            <a:avLst/>
+          </a:prstGeom>
+          <a:noFill/>
+          <a:ln/>
+        </p:spPr>
+        <p:txBody>
+          <a:bodyPr wrap="square" rtlCol="0" anchor="ctr"/>
+          <a:lstStyle/>
+          <a:p>
+            <a:pPr indent="0" marL="0">
+              <a:buNone/>
+            </a:pPr>
+            <a:r>
+              <a:rPr lang="en-US" sz="1300" b="1" dirty="0">
+                <a:solidFill>
+                  <a:srgbClr val="4ECDC4"/>
+                </a:solidFill>
+                <a:latin typeface="Calibri" pitchFamily="34" charset="0"/>
+                <a:ea typeface="Calibri" pitchFamily="34" charset="-122"/>
+                <a:cs typeface="Calibri" pitchFamily="34" charset="-120"/>
+              </a:rPr>
+              <a:t>≈ BFS — Ít bước nhất</a:t>
+            </a:r>
+            <a:endParaRPr lang="en-US" sz="1300" dirty="0"/>
+          </a:p>
+        </p:txBody>
+      </p:sp>
+      <p:sp>
+        <p:nvSpPr>
+          <p:cNvPr id="58" name="Text 56"/>
+          <p:cNvSpPr/>
+          <p:nvPr/>
+        </p:nvSpPr>
+        <p:spPr>
+          <a:xfrm>
+            <a:off x="7452360" y="4617720"/>
+            <a:ext cx="4389120" cy="658368"/>
+          </a:xfrm>
+          <a:prstGeom prst="rect">
+            <a:avLst/>
+          </a:prstGeom>
+          <a:noFill/>
+          <a:ln/>
+        </p:spPr>
+        <p:txBody>
+          <a:bodyPr wrap="square" rtlCol="0" anchor="ctr"/>
+          <a:lstStyle/>
+          <a:p>
+            <a:pPr indent="0" marL="0">
+              <a:buNone/>
+            </a:pPr>
+            <a:r>
+              <a:rPr lang="en-US" sz="1150" dirty="0">
+                <a:solidFill>
+                  <a:srgbClr val="6B7AB8"/>
+                </a:solidFill>
+                <a:latin typeface="Calibri" pitchFamily="34" charset="0"/>
+                <a:ea typeface="Calibri" pitchFamily="34" charset="-122"/>
+                <a:cs typeface="Calibri" pitchFamily="34" charset="-120"/>
+              </a:rPr>
+              <a:t>Tìm đường ít cạnh nhất, không tính trọng số. Dài hơn ~14% so với Dijkstra.</a:t>
+            </a:r>
+            <a:endParaRPr lang="en-US" sz="1150" dirty="0"/>
+          </a:p>
+        </p:txBody>
+      </p:sp>
+      <p:sp>
+        <p:nvSpPr>
+          <p:cNvPr id="59" name="Shape 57"/>
+          <p:cNvSpPr/>
+          <p:nvPr/>
+        </p:nvSpPr>
+        <p:spPr>
+          <a:xfrm>
+            <a:off x="7315200" y="5486400"/>
+            <a:ext cx="4572000" cy="1280160"/>
+          </a:xfrm>
+          <a:prstGeom prst="roundRect">
+            <a:avLst>
+              <a:gd name="adj" fmla="val 5714"/>
+            </a:avLst>
+          </a:prstGeom>
+          <a:solidFill>
+            <a:srgbClr val="1C1945"/>
+          </a:solidFill>
+          <a:ln w="15240">
+            <a:solidFill>
+              <a:srgbClr val="FF6B6B"/>
+            </a:solidFill>
+            <a:prstDash val="solid"/>
+          </a:ln>
+        </p:spPr>
+      </p:sp>
+      <p:sp>
+        <p:nvSpPr>
+          <p:cNvPr id="60" name="Text 58"/>
+          <p:cNvSpPr/>
+          <p:nvPr/>
+        </p:nvSpPr>
+        <p:spPr>
+          <a:xfrm>
+            <a:off x="7452360" y="5577840"/>
+            <a:ext cx="4389120" cy="411480"/>
+          </a:xfrm>
+          <a:prstGeom prst="rect">
+            <a:avLst/>
+          </a:prstGeom>
+          <a:noFill/>
+          <a:ln/>
+        </p:spPr>
+        <p:txBody>
+          <a:bodyPr wrap="square" rtlCol="0" anchor="ctr"/>
+          <a:lstStyle/>
+          <a:p>
+            <a:pPr indent="0" marL="0">
+              <a:buNone/>
+            </a:pPr>
+            <a:r>
+              <a:rPr lang="en-US" sz="1300" b="1" dirty="0">
+                <a:solidFill>
+                  <a:srgbClr val="FF6B6B"/>
+                </a:solidFill>
+                <a:latin typeface="Calibri" pitchFamily="34" charset="0"/>
+                <a:ea typeface="Calibri" pitchFamily="34" charset="-122"/>
+                <a:cs typeface="Calibri" pitchFamily="34" charset="-120"/>
+              </a:rPr>
+              <a:t>✗ DFS — Kém nhất</a:t>
+            </a:r>
+            <a:endParaRPr lang="en-US" sz="1300" dirty="0"/>
+          </a:p>
+        </p:txBody>
+      </p:sp>
+      <p:sp>
+        <p:nvSpPr>
+          <p:cNvPr id="61" name="Text 59"/>
+          <p:cNvSpPr/>
+          <p:nvPr/>
+        </p:nvSpPr>
+        <p:spPr>
+          <a:xfrm>
+            <a:off x="7452360" y="5989320"/>
+            <a:ext cx="4389120" cy="658368"/>
+          </a:xfrm>
+          <a:prstGeom prst="rect">
+            <a:avLst/>
+          </a:prstGeom>
+          <a:noFill/>
+          <a:ln/>
+        </p:spPr>
+        <p:txBody>
+          <a:bodyPr wrap="square" rtlCol="0" anchor="ctr"/>
+          <a:lstStyle/>
+          <a:p>
+            <a:pPr indent="0" marL="0">
+              <a:buNone/>
+            </a:pPr>
+            <a:r>
+              <a:rPr lang="en-US" sz="1150" dirty="0">
+                <a:solidFill>
+                  <a:srgbClr val="6B7AB8"/>
+                </a:solidFill>
+                <a:latin typeface="Calibri" pitchFamily="34" charset="0"/>
+                <a:ea typeface="Calibri" pitchFamily="34" charset="-122"/>
+                <a:cs typeface="Calibri" pitchFamily="34" charset="-120"/>
+              </a:rPr>
+              <a:t>Duyệt nhiều nút nhất, đường dài nhất (~4 100m). Không phù hợp tìm đường tối ưu.</a:t>
+            </a:r>
+            <a:endParaRPr lang="en-US" sz="1150" dirty="0"/>
           </a:p>
         </p:txBody>
       </p:sp>

</xml_diff>

<commit_message>
feat: slide 11 kết luận, slide 12 tài liệu tham khảo (mới), slide 13 cảm ơn — hoàn thành 13 slide
</commit_message>
<xml_diff>
--- a/ThuyetTrinh_PathFinderAI.pptx
+++ b/ThuyetTrinh_PathFinderAI.pptx
@@ -15,9 +15,12 @@
     <p:sldId id="263" r:id="rId9"/>
     <p:sldId id="264" r:id="rId10"/>
     <p:sldId id="265" r:id="rId11"/>
+    <p:sldId id="266" r:id="rId12"/>
+    <p:sldId id="267" r:id="rId13"/>
+    <p:sldId id="268" r:id="rId14"/>
   </p:sldIdLst>
   <p:notesMasterIdLst>
-    <p:notesMasterId r:id="rId12"/>
+    <p:notesMasterId r:id="rId15"/>
   </p:notesMasterIdLst>
   <p:sldSz cx="12192000" cy="6858000"/>
   <p:notesSz cx="6858000" cy="12192000"/>
@@ -641,6 +644,270 @@
 </p:notes>
 </file>
 
+<file path=ppt/notesSlides/notesSlide11.xml><?xml version="1.0" encoding="utf-8"?>
+<p:notes xmlns:a="http://schemas.openxmlformats.org/drawingml/2006/main" xmlns:r="http://schemas.openxmlformats.org/officeDocument/2006/relationships" xmlns:p="http://schemas.openxmlformats.org/presentationml/2006/main">
+  <p:cSld>
+    <p:spTree>
+      <p:nvGrpSpPr>
+        <p:cNvPr id="1" name=""/>
+        <p:cNvGrpSpPr/>
+        <p:nvPr/>
+      </p:nvGrpSpPr>
+      <p:grpSpPr>
+        <a:xfrm>
+          <a:off x="0" y="0"/>
+          <a:ext cx="0" cy="0"/>
+          <a:chOff x="0" y="0"/>
+          <a:chExt cx="0" cy="0"/>
+        </a:xfrm>
+      </p:grpSpPr>
+      <p:sp>
+        <p:nvSpPr>
+          <p:cNvPr id="2" name="Slide Image Placeholder 1"/>
+          <p:cNvSpPr>
+            <a:spLocks noGrp="1" noRot="1" noChangeAspect="1"/>
+          </p:cNvSpPr>
+          <p:nvPr>
+            <p:ph type="sldImg"/>
+          </p:nvPr>
+        </p:nvSpPr>
+        <p:spPr/>
+      </p:sp>
+      <p:sp>
+        <p:nvSpPr>
+          <p:cNvPr id="3" name="Notes Placeholder 2"/>
+          <p:cNvSpPr>
+            <a:spLocks noGrp="1"/>
+          </p:cNvSpPr>
+          <p:nvPr>
+            <p:ph type="body" idx="1"/>
+          </p:nvPr>
+        </p:nvSpPr>
+        <p:spPr/>
+        <p:txBody>
+          <a:bodyPr/>
+          <a:lstStyle/>
+          <a:p>
+            <a:r>
+              <a:rPr lang="en-US" dirty="0"/>
+              <a:t/>
+            </a:r>
+            <a:endParaRPr lang="en-US" dirty="0"/>
+          </a:p>
+        </p:txBody>
+      </p:sp>
+      <p:sp>
+        <p:nvSpPr>
+          <p:cNvPr id="4" name="Slide Number Placeholder 3"/>
+          <p:cNvSpPr>
+            <a:spLocks noGrp="1"/>
+          </p:cNvSpPr>
+          <p:nvPr>
+            <p:ph type="sldNum" sz="quarter" idx="10"/>
+          </p:nvPr>
+        </p:nvSpPr>
+        <p:spPr/>
+        <p:txBody>
+          <a:bodyPr/>
+          <a:lstStyle/>
+          <a:p>
+            <a:fld id="{F7021451-1387-4CA6-816F-3879F97B5CBC}" type="slidenum">
+              <a:rPr lang="en-US"/>
+              <a:t>11</a:t>
+            </a:fld>
+            <a:endParaRPr lang="en-US"/>
+          </a:p>
+        </p:txBody>
+      </p:sp>
+    </p:spTree>
+    <p:extLst>
+      <p:ext uri="{BB962C8B-B14F-4D97-AF65-F5344CB8AC3E}">
+        <p14:creationId xmlns:p14="http://schemas.microsoft.com/office/powerpoint/2010/main" val="1024086991"/>
+      </p:ext>
+    </p:extLst>
+  </p:cSld>
+  <p:clrMapOvr>
+    <a:masterClrMapping/>
+  </p:clrMapOvr>
+</p:notes>
+</file>
+
+<file path=ppt/notesSlides/notesSlide12.xml><?xml version="1.0" encoding="utf-8"?>
+<p:notes xmlns:a="http://schemas.openxmlformats.org/drawingml/2006/main" xmlns:r="http://schemas.openxmlformats.org/officeDocument/2006/relationships" xmlns:p="http://schemas.openxmlformats.org/presentationml/2006/main">
+  <p:cSld>
+    <p:spTree>
+      <p:nvGrpSpPr>
+        <p:cNvPr id="1" name=""/>
+        <p:cNvGrpSpPr/>
+        <p:nvPr/>
+      </p:nvGrpSpPr>
+      <p:grpSpPr>
+        <a:xfrm>
+          <a:off x="0" y="0"/>
+          <a:ext cx="0" cy="0"/>
+          <a:chOff x="0" y="0"/>
+          <a:chExt cx="0" cy="0"/>
+        </a:xfrm>
+      </p:grpSpPr>
+      <p:sp>
+        <p:nvSpPr>
+          <p:cNvPr id="2" name="Slide Image Placeholder 1"/>
+          <p:cNvSpPr>
+            <a:spLocks noGrp="1" noRot="1" noChangeAspect="1"/>
+          </p:cNvSpPr>
+          <p:nvPr>
+            <p:ph type="sldImg"/>
+          </p:nvPr>
+        </p:nvSpPr>
+        <p:spPr/>
+      </p:sp>
+      <p:sp>
+        <p:nvSpPr>
+          <p:cNvPr id="3" name="Notes Placeholder 2"/>
+          <p:cNvSpPr>
+            <a:spLocks noGrp="1"/>
+          </p:cNvSpPr>
+          <p:nvPr>
+            <p:ph type="body" idx="1"/>
+          </p:nvPr>
+        </p:nvSpPr>
+        <p:spPr/>
+        <p:txBody>
+          <a:bodyPr/>
+          <a:lstStyle/>
+          <a:p>
+            <a:r>
+              <a:rPr lang="en-US" dirty="0"/>
+              <a:t/>
+            </a:r>
+            <a:endParaRPr lang="en-US" dirty="0"/>
+          </a:p>
+        </p:txBody>
+      </p:sp>
+      <p:sp>
+        <p:nvSpPr>
+          <p:cNvPr id="4" name="Slide Number Placeholder 3"/>
+          <p:cNvSpPr>
+            <a:spLocks noGrp="1"/>
+          </p:cNvSpPr>
+          <p:nvPr>
+            <p:ph type="sldNum" sz="quarter" idx="10"/>
+          </p:nvPr>
+        </p:nvSpPr>
+        <p:spPr/>
+        <p:txBody>
+          <a:bodyPr/>
+          <a:lstStyle/>
+          <a:p>
+            <a:fld id="{F7021451-1387-4CA6-816F-3879F97B5CBC}" type="slidenum">
+              <a:rPr lang="en-US"/>
+              <a:t>12</a:t>
+            </a:fld>
+            <a:endParaRPr lang="en-US"/>
+          </a:p>
+        </p:txBody>
+      </p:sp>
+    </p:spTree>
+    <p:extLst>
+      <p:ext uri="{BB962C8B-B14F-4D97-AF65-F5344CB8AC3E}">
+        <p14:creationId xmlns:p14="http://schemas.microsoft.com/office/powerpoint/2010/main" val="1024086991"/>
+      </p:ext>
+    </p:extLst>
+  </p:cSld>
+  <p:clrMapOvr>
+    <a:masterClrMapping/>
+  </p:clrMapOvr>
+</p:notes>
+</file>
+
+<file path=ppt/notesSlides/notesSlide13.xml><?xml version="1.0" encoding="utf-8"?>
+<p:notes xmlns:a="http://schemas.openxmlformats.org/drawingml/2006/main" xmlns:r="http://schemas.openxmlformats.org/officeDocument/2006/relationships" xmlns:p="http://schemas.openxmlformats.org/presentationml/2006/main">
+  <p:cSld>
+    <p:spTree>
+      <p:nvGrpSpPr>
+        <p:cNvPr id="1" name=""/>
+        <p:cNvGrpSpPr/>
+        <p:nvPr/>
+      </p:nvGrpSpPr>
+      <p:grpSpPr>
+        <a:xfrm>
+          <a:off x="0" y="0"/>
+          <a:ext cx="0" cy="0"/>
+          <a:chOff x="0" y="0"/>
+          <a:chExt cx="0" cy="0"/>
+        </a:xfrm>
+      </p:grpSpPr>
+      <p:sp>
+        <p:nvSpPr>
+          <p:cNvPr id="2" name="Slide Image Placeholder 1"/>
+          <p:cNvSpPr>
+            <a:spLocks noGrp="1" noRot="1" noChangeAspect="1"/>
+          </p:cNvSpPr>
+          <p:nvPr>
+            <p:ph type="sldImg"/>
+          </p:nvPr>
+        </p:nvSpPr>
+        <p:spPr/>
+      </p:sp>
+      <p:sp>
+        <p:nvSpPr>
+          <p:cNvPr id="3" name="Notes Placeholder 2"/>
+          <p:cNvSpPr>
+            <a:spLocks noGrp="1"/>
+          </p:cNvSpPr>
+          <p:nvPr>
+            <p:ph type="body" idx="1"/>
+          </p:nvPr>
+        </p:nvSpPr>
+        <p:spPr/>
+        <p:txBody>
+          <a:bodyPr/>
+          <a:lstStyle/>
+          <a:p>
+            <a:r>
+              <a:rPr lang="en-US" dirty="0"/>
+              <a:t/>
+            </a:r>
+            <a:endParaRPr lang="en-US" dirty="0"/>
+          </a:p>
+        </p:txBody>
+      </p:sp>
+      <p:sp>
+        <p:nvSpPr>
+          <p:cNvPr id="4" name="Slide Number Placeholder 3"/>
+          <p:cNvSpPr>
+            <a:spLocks noGrp="1"/>
+          </p:cNvSpPr>
+          <p:nvPr>
+            <p:ph type="sldNum" sz="quarter" idx="10"/>
+          </p:nvPr>
+        </p:nvSpPr>
+        <p:spPr/>
+        <p:txBody>
+          <a:bodyPr/>
+          <a:lstStyle/>
+          <a:p>
+            <a:fld id="{F7021451-1387-4CA6-816F-3879F97B5CBC}" type="slidenum">
+              <a:rPr lang="en-US"/>
+              <a:t>13</a:t>
+            </a:fld>
+            <a:endParaRPr lang="en-US"/>
+          </a:p>
+        </p:txBody>
+      </p:sp>
+    </p:spTree>
+    <p:extLst>
+      <p:ext uri="{BB962C8B-B14F-4D97-AF65-F5344CB8AC3E}">
+        <p14:creationId xmlns:p14="http://schemas.microsoft.com/office/powerpoint/2010/main" val="1024086991"/>
+      </p:ext>
+    </p:extLst>
+  </p:cSld>
+  <p:clrMapOvr>
+    <a:masterClrMapping/>
+  </p:clrMapOvr>
+</p:notes>
+</file>
+
 <file path=ppt/notesSlides/notesSlide2.xml><?xml version="1.0" encoding="utf-8"?>
 <p:notes xmlns:a="http://schemas.openxmlformats.org/drawingml/2006/main" xmlns:r="http://schemas.openxmlformats.org/officeDocument/2006/relationships" xmlns:p="http://schemas.openxmlformats.org/presentationml/2006/main">
   <p:cSld>
@@ -3801,6 +4068,2047 @@
               <a:t>start==end, không có đường, node không tồn tại</a:t>
             </a:r>
             <a:endParaRPr lang="en-US" sz="1200" dirty="0"/>
+          </a:p>
+        </p:txBody>
+      </p:sp>
+    </p:spTree>
+  </p:cSld>
+  <p:clrMapOvr>
+    <a:masterClrMapping/>
+  </p:clrMapOvr>
+</p:sld>
+</file>
+
+<file path=ppt/slides/slide11.xml><?xml version="1.0" encoding="utf-8"?>
+<p:sld xmlns:a="http://schemas.openxmlformats.org/drawingml/2006/main" xmlns:r="http://schemas.openxmlformats.org/officeDocument/2006/relationships" xmlns:p="http://schemas.openxmlformats.org/presentationml/2006/main">
+  <p:cSld name="Slide 11">
+    <p:spTree>
+      <p:nvGrpSpPr>
+        <p:cNvPr id="1" name=""/>
+        <p:cNvGrpSpPr/>
+        <p:nvPr/>
+      </p:nvGrpSpPr>
+      <p:grpSpPr>
+        <a:xfrm>
+          <a:off x="0" y="0"/>
+          <a:ext cx="0" cy="0"/>
+          <a:chOff x="0" y="0"/>
+          <a:chExt cx="0" cy="0"/>
+        </a:xfrm>
+      </p:grpSpPr>
+      <p:sp>
+        <p:nvSpPr>
+          <p:cNvPr id="2" name="Shape 0"/>
+          <p:cNvSpPr/>
+          <p:nvPr/>
+        </p:nvSpPr>
+        <p:spPr>
+          <a:xfrm>
+            <a:off x="0" y="0"/>
+            <a:ext cx="12188952" cy="6858000"/>
+          </a:xfrm>
+          <a:prstGeom prst="rect">
+            <a:avLst/>
+          </a:prstGeom>
+          <a:solidFill>
+            <a:srgbClr val="0F0C29"/>
+          </a:solidFill>
+          <a:ln w="12700">
+            <a:solidFill>
+              <a:srgbClr val="0F0C29"/>
+            </a:solidFill>
+            <a:prstDash val="solid"/>
+          </a:ln>
+        </p:spPr>
+      </p:sp>
+      <p:sp>
+        <p:nvSpPr>
+          <p:cNvPr id="3" name="Shape 1"/>
+          <p:cNvSpPr/>
+          <p:nvPr/>
+        </p:nvSpPr>
+        <p:spPr>
+          <a:xfrm>
+            <a:off x="0" y="0"/>
+            <a:ext cx="12188952" cy="4114800"/>
+          </a:xfrm>
+          <a:prstGeom prst="rect">
+            <a:avLst/>
+          </a:prstGeom>
+          <a:solidFill>
+            <a:srgbClr val="1E1B4B">
+              <a:alpha val="70000"/>
+            </a:srgbClr>
+          </a:solidFill>
+          <a:ln w="12700">
+            <a:solidFill>
+              <a:srgbClr val="1E1B4B">
+                <a:alpha val="70000"/>
+              </a:srgbClr>
+            </a:solidFill>
+            <a:prstDash val="solid"/>
+          </a:ln>
+        </p:spPr>
+      </p:sp>
+      <p:sp>
+        <p:nvSpPr>
+          <p:cNvPr id="4" name="Shape 2"/>
+          <p:cNvSpPr/>
+          <p:nvPr/>
+        </p:nvSpPr>
+        <p:spPr>
+          <a:xfrm>
+            <a:off x="5486400" y="0"/>
+            <a:ext cx="6702552" cy="6858000"/>
+          </a:xfrm>
+          <a:prstGeom prst="rect">
+            <a:avLst/>
+          </a:prstGeom>
+          <a:solidFill>
+            <a:srgbClr val="312E81">
+              <a:alpha val="50000"/>
+            </a:srgbClr>
+          </a:solidFill>
+          <a:ln w="12700">
+            <a:solidFill>
+              <a:srgbClr val="312E81">
+                <a:alpha val="50000"/>
+              </a:srgbClr>
+            </a:solidFill>
+            <a:prstDash val="solid"/>
+          </a:ln>
+        </p:spPr>
+      </p:sp>
+      <p:sp>
+        <p:nvSpPr>
+          <p:cNvPr id="5" name="Shape 3"/>
+          <p:cNvSpPr/>
+          <p:nvPr/>
+        </p:nvSpPr>
+        <p:spPr>
+          <a:xfrm>
+            <a:off x="0" y="0"/>
+            <a:ext cx="54864" cy="3429000"/>
+          </a:xfrm>
+          <a:prstGeom prst="rect">
+            <a:avLst/>
+          </a:prstGeom>
+          <a:solidFill>
+            <a:srgbClr val="818CF8"/>
+          </a:solidFill>
+          <a:ln w="12700">
+            <a:solidFill>
+              <a:srgbClr val="818CF8"/>
+            </a:solidFill>
+            <a:prstDash val="solid"/>
+          </a:ln>
+        </p:spPr>
+      </p:sp>
+      <p:sp>
+        <p:nvSpPr>
+          <p:cNvPr id="6" name="Shape 4"/>
+          <p:cNvSpPr/>
+          <p:nvPr/>
+        </p:nvSpPr>
+        <p:spPr>
+          <a:xfrm>
+            <a:off x="0" y="3429000"/>
+            <a:ext cx="54864" cy="3429000"/>
+          </a:xfrm>
+          <a:prstGeom prst="rect">
+            <a:avLst/>
+          </a:prstGeom>
+          <a:solidFill>
+            <a:srgbClr val="34D399"/>
+          </a:solidFill>
+          <a:ln w="12700">
+            <a:solidFill>
+              <a:srgbClr val="34D399"/>
+            </a:solidFill>
+            <a:prstDash val="solid"/>
+          </a:ln>
+        </p:spPr>
+      </p:sp>
+      <p:sp>
+        <p:nvSpPr>
+          <p:cNvPr id="7" name="Text 5"/>
+          <p:cNvSpPr/>
+          <p:nvPr/>
+        </p:nvSpPr>
+        <p:spPr>
+          <a:xfrm>
+            <a:off x="365760" y="274320"/>
+            <a:ext cx="11430000" cy="548640"/>
+          </a:xfrm>
+          <a:prstGeom prst="rect">
+            <a:avLst/>
+          </a:prstGeom>
+          <a:noFill/>
+          <a:ln/>
+        </p:spPr>
+        <p:txBody>
+          <a:bodyPr wrap="square" rtlCol="0" anchor="ctr"/>
+          <a:lstStyle/>
+          <a:p>
+            <a:pPr algn="l" indent="0" marL="0">
+              <a:buNone/>
+            </a:pPr>
+            <a:r>
+              <a:rPr lang="en-US" sz="2600" b="1" dirty="0">
+                <a:solidFill>
+                  <a:srgbClr val="6B7AB8"/>
+                </a:solidFill>
+                <a:latin typeface="Calibri" pitchFamily="34" charset="0"/>
+                <a:ea typeface="Calibri" pitchFamily="34" charset="-122"/>
+                <a:cs typeface="Calibri" pitchFamily="34" charset="-120"/>
+              </a:rPr>
+              <a:t>09. Kết Luận</a:t>
+            </a:r>
+            <a:endParaRPr lang="en-US" sz="2600" dirty="0"/>
+          </a:p>
+        </p:txBody>
+      </p:sp>
+      <p:sp>
+        <p:nvSpPr>
+          <p:cNvPr id="8" name="Shape 6"/>
+          <p:cNvSpPr/>
+          <p:nvPr/>
+        </p:nvSpPr>
+        <p:spPr>
+          <a:xfrm>
+            <a:off x="365760" y="868680"/>
+            <a:ext cx="11430000" cy="27432"/>
+          </a:xfrm>
+          <a:prstGeom prst="rect">
+            <a:avLst/>
+          </a:prstGeom>
+          <a:solidFill>
+            <a:srgbClr val="6B7AB8"/>
+          </a:solidFill>
+          <a:ln w="12700">
+            <a:solidFill>
+              <a:srgbClr val="6B7AB8"/>
+            </a:solidFill>
+            <a:prstDash val="solid"/>
+          </a:ln>
+        </p:spPr>
+      </p:sp>
+      <p:sp>
+        <p:nvSpPr>
+          <p:cNvPr id="9" name="Shape 7"/>
+          <p:cNvSpPr/>
+          <p:nvPr/>
+        </p:nvSpPr>
+        <p:spPr>
+          <a:xfrm>
+            <a:off x="320040" y="1051560"/>
+            <a:ext cx="5486400" cy="5486400"/>
+          </a:xfrm>
+          <a:prstGeom prst="roundRect">
+            <a:avLst>
+              <a:gd name="adj" fmla="val 1333"/>
+            </a:avLst>
+          </a:prstGeom>
+          <a:solidFill>
+            <a:srgbClr val="1C1945"/>
+          </a:solidFill>
+          <a:ln w="15240">
+            <a:solidFill>
+              <a:srgbClr val="06D6A0"/>
+            </a:solidFill>
+            <a:prstDash val="solid"/>
+          </a:ln>
+        </p:spPr>
+      </p:sp>
+      <p:sp>
+        <p:nvSpPr>
+          <p:cNvPr id="10" name="Text 8"/>
+          <p:cNvSpPr/>
+          <p:nvPr/>
+        </p:nvSpPr>
+        <p:spPr>
+          <a:xfrm>
+            <a:off x="320040" y="1051560"/>
+            <a:ext cx="5486400" cy="548640"/>
+          </a:xfrm>
+          <a:prstGeom prst="rect">
+            <a:avLst/>
+          </a:prstGeom>
+          <a:noFill/>
+          <a:ln/>
+        </p:spPr>
+        <p:txBody>
+          <a:bodyPr wrap="square" rtlCol="0" anchor="ctr"/>
+          <a:lstStyle/>
+          <a:p>
+            <a:pPr algn="ctr" indent="0" marL="0">
+              <a:buNone/>
+            </a:pPr>
+            <a:r>
+              <a:rPr lang="en-US" sz="1600" b="1" dirty="0">
+                <a:solidFill>
+                  <a:srgbClr val="06D6A0"/>
+                </a:solidFill>
+                <a:latin typeface="Calibri" pitchFamily="34" charset="0"/>
+                <a:ea typeface="Calibri" pitchFamily="34" charset="-122"/>
+                <a:cs typeface="Calibri" pitchFamily="34" charset="-120"/>
+              </a:rPr>
+              <a:t>✔  Kết quả đạt được</a:t>
+            </a:r>
+            <a:endParaRPr lang="en-US" sz="1600" dirty="0"/>
+          </a:p>
+        </p:txBody>
+      </p:sp>
+      <p:sp>
+        <p:nvSpPr>
+          <p:cNvPr id="11" name="Text 9"/>
+          <p:cNvSpPr/>
+          <p:nvPr/>
+        </p:nvSpPr>
+        <p:spPr>
+          <a:xfrm>
+            <a:off x="548640" y="1783080"/>
+            <a:ext cx="5029200" cy="658368"/>
+          </a:xfrm>
+          <a:prstGeom prst="rect">
+            <a:avLst/>
+          </a:prstGeom>
+          <a:noFill/>
+          <a:ln/>
+        </p:spPr>
+        <p:txBody>
+          <a:bodyPr wrap="square" rtlCol="0" anchor="ctr"/>
+          <a:lstStyle/>
+          <a:p>
+            <a:pPr indent="0" marL="0">
+              <a:buNone/>
+            </a:pPr>
+            <a:r>
+              <a:rPr lang="en-US" sz="1400" dirty="0">
+                <a:solidFill>
+                  <a:srgbClr val="E0E7FF"/>
+                </a:solidFill>
+                <a:latin typeface="Calibri" pitchFamily="34" charset="0"/>
+                <a:ea typeface="Calibri" pitchFamily="34" charset="-122"/>
+                <a:cs typeface="Calibri" pitchFamily="34" charset="-120"/>
+              </a:rPr>
+              <a:t>•  Trực quan hóa 4 thuật toán đồng thời</a:t>
+            </a:r>
+            <a:endParaRPr lang="en-US" sz="1400" dirty="0"/>
+          </a:p>
+        </p:txBody>
+      </p:sp>
+      <p:sp>
+        <p:nvSpPr>
+          <p:cNvPr id="12" name="Text 10"/>
+          <p:cNvSpPr/>
+          <p:nvPr/>
+        </p:nvSpPr>
+        <p:spPr>
+          <a:xfrm>
+            <a:off x="548640" y="2532888"/>
+            <a:ext cx="5029200" cy="658368"/>
+          </a:xfrm>
+          <a:prstGeom prst="rect">
+            <a:avLst/>
+          </a:prstGeom>
+          <a:noFill/>
+          <a:ln/>
+        </p:spPr>
+        <p:txBody>
+          <a:bodyPr wrap="square" rtlCol="0" anchor="ctr"/>
+          <a:lstStyle/>
+          <a:p>
+            <a:pPr indent="0" marL="0">
+              <a:buNone/>
+            </a:pPr>
+            <a:r>
+              <a:rPr lang="en-US" sz="1400" dirty="0">
+                <a:solidFill>
+                  <a:srgbClr val="E0E7FF"/>
+                </a:solidFill>
+                <a:latin typeface="Calibri" pitchFamily="34" charset="0"/>
+                <a:ea typeface="Calibri" pitchFamily="34" charset="-122"/>
+                <a:cs typeface="Calibri" pitchFamily="34" charset="-120"/>
+              </a:rPr>
+              <a:t>•  Bản đồ thực Hà Đông 1 007 nút</a:t>
+            </a:r>
+            <a:endParaRPr lang="en-US" sz="1400" dirty="0"/>
+          </a:p>
+        </p:txBody>
+      </p:sp>
+      <p:sp>
+        <p:nvSpPr>
+          <p:cNvPr id="13" name="Text 11"/>
+          <p:cNvSpPr/>
+          <p:nvPr/>
+        </p:nvSpPr>
+        <p:spPr>
+          <a:xfrm>
+            <a:off x="548640" y="3282696"/>
+            <a:ext cx="5029200" cy="658368"/>
+          </a:xfrm>
+          <a:prstGeom prst="rect">
+            <a:avLst/>
+          </a:prstGeom>
+          <a:noFill/>
+          <a:ln/>
+        </p:spPr>
+        <p:txBody>
+          <a:bodyPr wrap="square" rtlCol="0" anchor="ctr"/>
+          <a:lstStyle/>
+          <a:p>
+            <a:pPr indent="0" marL="0">
+              <a:buNone/>
+            </a:pPr>
+            <a:r>
+              <a:rPr lang="en-US" sz="1400" dirty="0">
+                <a:solidFill>
+                  <a:srgbClr val="E0E7FF"/>
+                </a:solidFill>
+                <a:latin typeface="Calibri" pitchFamily="34" charset="0"/>
+                <a:ea typeface="Calibri" pitchFamily="34" charset="-122"/>
+                <a:cs typeface="Calibri" pitchFamily="34" charset="-120"/>
+              </a:rPr>
+              <a:t>•  Hoạt ảnh, toggle, điều chỉnh tốc độ</a:t>
+            </a:r>
+            <a:endParaRPr lang="en-US" sz="1400" dirty="0"/>
+          </a:p>
+        </p:txBody>
+      </p:sp>
+      <p:sp>
+        <p:nvSpPr>
+          <p:cNvPr id="14" name="Text 12"/>
+          <p:cNvSpPr/>
+          <p:nvPr/>
+        </p:nvSpPr>
+        <p:spPr>
+          <a:xfrm>
+            <a:off x="548640" y="4032504"/>
+            <a:ext cx="5029200" cy="658368"/>
+          </a:xfrm>
+          <a:prstGeom prst="rect">
+            <a:avLst/>
+          </a:prstGeom>
+          <a:noFill/>
+          <a:ln/>
+        </p:spPr>
+        <p:txBody>
+          <a:bodyPr wrap="square" rtlCol="0" anchor="ctr"/>
+          <a:lstStyle/>
+          <a:p>
+            <a:pPr indent="0" marL="0">
+              <a:buNone/>
+            </a:pPr>
+            <a:r>
+              <a:rPr lang="en-US" sz="1400" dirty="0">
+                <a:solidFill>
+                  <a:srgbClr val="E0E7FF"/>
+                </a:solidFill>
+                <a:latin typeface="Calibri" pitchFamily="34" charset="0"/>
+                <a:ea typeface="Calibri" pitchFamily="34" charset="-122"/>
+                <a:cs typeface="Calibri" pitchFamily="34" charset="-120"/>
+              </a:rPr>
+              <a:t>•  Concentric Rings — thấy cả 4 màu</a:t>
+            </a:r>
+            <a:endParaRPr lang="en-US" sz="1400" dirty="0"/>
+          </a:p>
+        </p:txBody>
+      </p:sp>
+      <p:sp>
+        <p:nvSpPr>
+          <p:cNvPr id="15" name="Text 13"/>
+          <p:cNvSpPr/>
+          <p:nvPr/>
+        </p:nvSpPr>
+        <p:spPr>
+          <a:xfrm>
+            <a:off x="548640" y="4782312"/>
+            <a:ext cx="5029200" cy="658368"/>
+          </a:xfrm>
+          <a:prstGeom prst="rect">
+            <a:avLst/>
+          </a:prstGeom>
+          <a:noFill/>
+          <a:ln/>
+        </p:spPr>
+        <p:txBody>
+          <a:bodyPr wrap="square" rtlCol="0" anchor="ctr"/>
+          <a:lstStyle/>
+          <a:p>
+            <a:pPr indent="0" marL="0">
+              <a:buNone/>
+            </a:pPr>
+            <a:r>
+              <a:rPr lang="en-US" sz="1400" dirty="0">
+                <a:solidFill>
+                  <a:srgbClr val="E0E7FF"/>
+                </a:solidFill>
+                <a:latin typeface="Calibri" pitchFamily="34" charset="0"/>
+                <a:ea typeface="Calibri" pitchFamily="34" charset="-122"/>
+                <a:cs typeface="Calibri" pitchFamily="34" charset="-120"/>
+              </a:rPr>
+              <a:t>•  34 unit test, tất cả pass</a:t>
+            </a:r>
+            <a:endParaRPr lang="en-US" sz="1400" dirty="0"/>
+          </a:p>
+        </p:txBody>
+      </p:sp>
+      <p:sp>
+        <p:nvSpPr>
+          <p:cNvPr id="16" name="Text 14"/>
+          <p:cNvSpPr/>
+          <p:nvPr/>
+        </p:nvSpPr>
+        <p:spPr>
+          <a:xfrm>
+            <a:off x="548640" y="5532120"/>
+            <a:ext cx="5029200" cy="658368"/>
+          </a:xfrm>
+          <a:prstGeom prst="rect">
+            <a:avLst/>
+          </a:prstGeom>
+          <a:noFill/>
+          <a:ln/>
+        </p:spPr>
+        <p:txBody>
+          <a:bodyPr wrap="square" rtlCol="0" anchor="ctr"/>
+          <a:lstStyle/>
+          <a:p>
+            <a:pPr indent="0" marL="0">
+              <a:buNone/>
+            </a:pPr>
+            <a:r>
+              <a:rPr lang="en-US" sz="1400" dirty="0">
+                <a:solidFill>
+                  <a:srgbClr val="E0E7FF"/>
+                </a:solidFill>
+                <a:latin typeface="Calibri" pitchFamily="34" charset="0"/>
+                <a:ea typeface="Calibri" pitchFamily="34" charset="-122"/>
+                <a:cs typeface="Calibri" pitchFamily="34" charset="-120"/>
+              </a:rPr>
+              <a:t>•  README + GitHub public repo</a:t>
+            </a:r>
+            <a:endParaRPr lang="en-US" sz="1400" dirty="0"/>
+          </a:p>
+        </p:txBody>
+      </p:sp>
+      <p:sp>
+        <p:nvSpPr>
+          <p:cNvPr id="17" name="Shape 15"/>
+          <p:cNvSpPr/>
+          <p:nvPr/>
+        </p:nvSpPr>
+        <p:spPr>
+          <a:xfrm>
+            <a:off x="6263640" y="1051560"/>
+            <a:ext cx="5623560" cy="5486400"/>
+          </a:xfrm>
+          <a:prstGeom prst="roundRect">
+            <a:avLst>
+              <a:gd name="adj" fmla="val 1333"/>
+            </a:avLst>
+          </a:prstGeom>
+          <a:solidFill>
+            <a:srgbClr val="1C1945"/>
+          </a:solidFill>
+          <a:ln w="15240">
+            <a:solidFill>
+              <a:srgbClr val="FFD166"/>
+            </a:solidFill>
+            <a:prstDash val="solid"/>
+          </a:ln>
+        </p:spPr>
+      </p:sp>
+      <p:sp>
+        <p:nvSpPr>
+          <p:cNvPr id="18" name="Text 16"/>
+          <p:cNvSpPr/>
+          <p:nvPr/>
+        </p:nvSpPr>
+        <p:spPr>
+          <a:xfrm>
+            <a:off x="6263640" y="1051560"/>
+            <a:ext cx="5623560" cy="548640"/>
+          </a:xfrm>
+          <a:prstGeom prst="rect">
+            <a:avLst/>
+          </a:prstGeom>
+          <a:noFill/>
+          <a:ln/>
+        </p:spPr>
+        <p:txBody>
+          <a:bodyPr wrap="square" rtlCol="0" anchor="ctr"/>
+          <a:lstStyle/>
+          <a:p>
+            <a:pPr algn="ctr" indent="0" marL="0">
+              <a:buNone/>
+            </a:pPr>
+            <a:r>
+              <a:rPr lang="en-US" sz="1600" b="1" dirty="0">
+                <a:solidFill>
+                  <a:srgbClr val="FFD166"/>
+                </a:solidFill>
+                <a:latin typeface="Calibri" pitchFamily="34" charset="0"/>
+                <a:ea typeface="Calibri" pitchFamily="34" charset="-122"/>
+                <a:cs typeface="Calibri" pitchFamily="34" charset="-120"/>
+              </a:rPr>
+              <a:t>→  Hướng phát triển</a:t>
+            </a:r>
+            <a:endParaRPr lang="en-US" sz="1600" dirty="0"/>
+          </a:p>
+        </p:txBody>
+      </p:sp>
+      <p:sp>
+        <p:nvSpPr>
+          <p:cNvPr id="19" name="Text 17"/>
+          <p:cNvSpPr/>
+          <p:nvPr/>
+        </p:nvSpPr>
+        <p:spPr>
+          <a:xfrm>
+            <a:off x="6492240" y="1783080"/>
+            <a:ext cx="5166360" cy="658368"/>
+          </a:xfrm>
+          <a:prstGeom prst="rect">
+            <a:avLst/>
+          </a:prstGeom>
+          <a:noFill/>
+          <a:ln/>
+        </p:spPr>
+        <p:txBody>
+          <a:bodyPr wrap="square" rtlCol="0" anchor="ctr"/>
+          <a:lstStyle/>
+          <a:p>
+            <a:pPr indent="0" marL="0">
+              <a:buNone/>
+            </a:pPr>
+            <a:r>
+              <a:rPr lang="en-US" sz="1400" dirty="0">
+                <a:solidFill>
+                  <a:srgbClr val="E0E7FF"/>
+                </a:solidFill>
+                <a:latin typeface="Calibri" pitchFamily="34" charset="0"/>
+                <a:ea typeface="Calibri" pitchFamily="34" charset="-122"/>
+                <a:cs typeface="Calibri" pitchFamily="34" charset="-120"/>
+              </a:rPr>
+              <a:t>•  Mở rộng toàn Hà Nội</a:t>
+            </a:r>
+            <a:endParaRPr lang="en-US" sz="1400" dirty="0"/>
+          </a:p>
+        </p:txBody>
+      </p:sp>
+      <p:sp>
+        <p:nvSpPr>
+          <p:cNvPr id="20" name="Text 18"/>
+          <p:cNvSpPr/>
+          <p:nvPr/>
+        </p:nvSpPr>
+        <p:spPr>
+          <a:xfrm>
+            <a:off x="6492240" y="2532888"/>
+            <a:ext cx="5166360" cy="658368"/>
+          </a:xfrm>
+          <a:prstGeom prst="rect">
+            <a:avLst/>
+          </a:prstGeom>
+          <a:noFill/>
+          <a:ln/>
+        </p:spPr>
+        <p:txBody>
+          <a:bodyPr wrap="square" rtlCol="0" anchor="ctr"/>
+          <a:lstStyle/>
+          <a:p>
+            <a:pPr indent="0" marL="0">
+              <a:buNone/>
+            </a:pPr>
+            <a:r>
+              <a:rPr lang="en-US" sz="1400" dirty="0">
+                <a:solidFill>
+                  <a:srgbClr val="E0E7FF"/>
+                </a:solidFill>
+                <a:latin typeface="Calibri" pitchFamily="34" charset="0"/>
+                <a:ea typeface="Calibri" pitchFamily="34" charset="-122"/>
+                <a:cs typeface="Calibri" pitchFamily="34" charset="-120"/>
+              </a:rPr>
+              <a:t>•  Thêm Bellman-Ford, Bidirectional A*</a:t>
+            </a:r>
+            <a:endParaRPr lang="en-US" sz="1400" dirty="0"/>
+          </a:p>
+        </p:txBody>
+      </p:sp>
+      <p:sp>
+        <p:nvSpPr>
+          <p:cNvPr id="21" name="Text 19"/>
+          <p:cNvSpPr/>
+          <p:nvPr/>
+        </p:nvSpPr>
+        <p:spPr>
+          <a:xfrm>
+            <a:off x="6492240" y="3282696"/>
+            <a:ext cx="5166360" cy="658368"/>
+          </a:xfrm>
+          <a:prstGeom prst="rect">
+            <a:avLst/>
+          </a:prstGeom>
+          <a:noFill/>
+          <a:ln/>
+        </p:spPr>
+        <p:txBody>
+          <a:bodyPr wrap="square" rtlCol="0" anchor="ctr"/>
+          <a:lstStyle/>
+          <a:p>
+            <a:pPr indent="0" marL="0">
+              <a:buNone/>
+            </a:pPr>
+            <a:r>
+              <a:rPr lang="en-US" sz="1400" dirty="0">
+                <a:solidFill>
+                  <a:srgbClr val="E0E7FF"/>
+                </a:solidFill>
+                <a:latin typeface="Calibri" pitchFamily="34" charset="0"/>
+                <a:ea typeface="Calibri" pitchFamily="34" charset="-122"/>
+                <a:cs typeface="Calibri" pitchFamily="34" charset="-120"/>
+              </a:rPr>
+              <a:t>•  Cho phép chỉnh sửa đồ thị trực tiếp</a:t>
+            </a:r>
+            <a:endParaRPr lang="en-US" sz="1400" dirty="0"/>
+          </a:p>
+        </p:txBody>
+      </p:sp>
+      <p:sp>
+        <p:nvSpPr>
+          <p:cNvPr id="22" name="Text 20"/>
+          <p:cNvSpPr/>
+          <p:nvPr/>
+        </p:nvSpPr>
+        <p:spPr>
+          <a:xfrm>
+            <a:off x="6492240" y="4032504"/>
+            <a:ext cx="5166360" cy="658368"/>
+          </a:xfrm>
+          <a:prstGeom prst="rect">
+            <a:avLst/>
+          </a:prstGeom>
+          <a:noFill/>
+          <a:ln/>
+        </p:spPr>
+        <p:txBody>
+          <a:bodyPr wrap="square" rtlCol="0" anchor="ctr"/>
+          <a:lstStyle/>
+          <a:p>
+            <a:pPr indent="0" marL="0">
+              <a:buNone/>
+            </a:pPr>
+            <a:r>
+              <a:rPr lang="en-US" sz="1400" dirty="0">
+                <a:solidFill>
+                  <a:srgbClr val="E0E7FF"/>
+                </a:solidFill>
+                <a:latin typeface="Calibri" pitchFamily="34" charset="0"/>
+                <a:ea typeface="Calibri" pitchFamily="34" charset="-122"/>
+                <a:cs typeface="Calibri" pitchFamily="34" charset="-120"/>
+              </a:rPr>
+              <a:t>•  Export kết quả PDF / ảnh</a:t>
+            </a:r>
+            <a:endParaRPr lang="en-US" sz="1400" dirty="0"/>
+          </a:p>
+        </p:txBody>
+      </p:sp>
+      <p:sp>
+        <p:nvSpPr>
+          <p:cNvPr id="23" name="Text 21"/>
+          <p:cNvSpPr/>
+          <p:nvPr/>
+        </p:nvSpPr>
+        <p:spPr>
+          <a:xfrm>
+            <a:off x="6492240" y="4782312"/>
+            <a:ext cx="5166360" cy="658368"/>
+          </a:xfrm>
+          <a:prstGeom prst="rect">
+            <a:avLst/>
+          </a:prstGeom>
+          <a:noFill/>
+          <a:ln/>
+        </p:spPr>
+        <p:txBody>
+          <a:bodyPr wrap="square" rtlCol="0" anchor="ctr"/>
+          <a:lstStyle/>
+          <a:p>
+            <a:pPr indent="0" marL="0">
+              <a:buNone/>
+            </a:pPr>
+            <a:r>
+              <a:rPr lang="en-US" sz="1400" dirty="0">
+                <a:solidFill>
+                  <a:srgbClr val="E0E7FF"/>
+                </a:solidFill>
+                <a:latin typeface="Calibri" pitchFamily="34" charset="0"/>
+                <a:ea typeface="Calibri" pitchFamily="34" charset="-122"/>
+                <a:cs typeface="Calibri" pitchFamily="34" charset="-120"/>
+              </a:rPr>
+              <a:t>•  So sánh side-by-side</a:t>
+            </a:r>
+            <a:endParaRPr lang="en-US" sz="1400" dirty="0"/>
+          </a:p>
+        </p:txBody>
+      </p:sp>
+      <p:sp>
+        <p:nvSpPr>
+          <p:cNvPr id="24" name="Text 22"/>
+          <p:cNvSpPr/>
+          <p:nvPr/>
+        </p:nvSpPr>
+        <p:spPr>
+          <a:xfrm>
+            <a:off x="6492240" y="5532120"/>
+            <a:ext cx="5166360" cy="658368"/>
+          </a:xfrm>
+          <a:prstGeom prst="rect">
+            <a:avLst/>
+          </a:prstGeom>
+          <a:noFill/>
+          <a:ln/>
+        </p:spPr>
+        <p:txBody>
+          <a:bodyPr wrap="square" rtlCol="0" anchor="ctr"/>
+          <a:lstStyle/>
+          <a:p>
+            <a:pPr indent="0" marL="0">
+              <a:buNone/>
+            </a:pPr>
+            <a:r>
+              <a:rPr lang="en-US" sz="1400" dirty="0">
+                <a:solidFill>
+                  <a:srgbClr val="E0E7FF"/>
+                </a:solidFill>
+                <a:latin typeface="Calibri" pitchFamily="34" charset="0"/>
+                <a:ea typeface="Calibri" pitchFamily="34" charset="-122"/>
+                <a:cs typeface="Calibri" pitchFamily="34" charset="-120"/>
+              </a:rPr>
+              <a:t>•  Tích hợp dữ liệu giao thông thực</a:t>
+            </a:r>
+            <a:endParaRPr lang="en-US" sz="1400" dirty="0"/>
+          </a:p>
+        </p:txBody>
+      </p:sp>
+    </p:spTree>
+  </p:cSld>
+  <p:clrMapOvr>
+    <a:masterClrMapping/>
+  </p:clrMapOvr>
+</p:sld>
+</file>
+
+<file path=ppt/slides/slide12.xml><?xml version="1.0" encoding="utf-8"?>
+<p:sld xmlns:a="http://schemas.openxmlformats.org/drawingml/2006/main" xmlns:r="http://schemas.openxmlformats.org/officeDocument/2006/relationships" xmlns:p="http://schemas.openxmlformats.org/presentationml/2006/main">
+  <p:cSld name="Slide 12">
+    <p:spTree>
+      <p:nvGrpSpPr>
+        <p:cNvPr id="1" name=""/>
+        <p:cNvGrpSpPr/>
+        <p:nvPr/>
+      </p:nvGrpSpPr>
+      <p:grpSpPr>
+        <a:xfrm>
+          <a:off x="0" y="0"/>
+          <a:ext cx="0" cy="0"/>
+          <a:chOff x="0" y="0"/>
+          <a:chExt cx="0" cy="0"/>
+        </a:xfrm>
+      </p:grpSpPr>
+      <p:sp>
+        <p:nvSpPr>
+          <p:cNvPr id="2" name="Shape 0"/>
+          <p:cNvSpPr/>
+          <p:nvPr/>
+        </p:nvSpPr>
+        <p:spPr>
+          <a:xfrm>
+            <a:off x="0" y="0"/>
+            <a:ext cx="12188952" cy="6858000"/>
+          </a:xfrm>
+          <a:prstGeom prst="rect">
+            <a:avLst/>
+          </a:prstGeom>
+          <a:solidFill>
+            <a:srgbClr val="0F0C29"/>
+          </a:solidFill>
+          <a:ln w="12700">
+            <a:solidFill>
+              <a:srgbClr val="0F0C29"/>
+            </a:solidFill>
+            <a:prstDash val="solid"/>
+          </a:ln>
+        </p:spPr>
+      </p:sp>
+      <p:sp>
+        <p:nvSpPr>
+          <p:cNvPr id="3" name="Shape 1"/>
+          <p:cNvSpPr/>
+          <p:nvPr/>
+        </p:nvSpPr>
+        <p:spPr>
+          <a:xfrm>
+            <a:off x="0" y="0"/>
+            <a:ext cx="12188952" cy="4114800"/>
+          </a:xfrm>
+          <a:prstGeom prst="rect">
+            <a:avLst/>
+          </a:prstGeom>
+          <a:solidFill>
+            <a:srgbClr val="1E1B4B">
+              <a:alpha val="70000"/>
+            </a:srgbClr>
+          </a:solidFill>
+          <a:ln w="12700">
+            <a:solidFill>
+              <a:srgbClr val="1E1B4B">
+                <a:alpha val="70000"/>
+              </a:srgbClr>
+            </a:solidFill>
+            <a:prstDash val="solid"/>
+          </a:ln>
+        </p:spPr>
+      </p:sp>
+      <p:sp>
+        <p:nvSpPr>
+          <p:cNvPr id="4" name="Shape 2"/>
+          <p:cNvSpPr/>
+          <p:nvPr/>
+        </p:nvSpPr>
+        <p:spPr>
+          <a:xfrm>
+            <a:off x="5486400" y="0"/>
+            <a:ext cx="6702552" cy="6858000"/>
+          </a:xfrm>
+          <a:prstGeom prst="rect">
+            <a:avLst/>
+          </a:prstGeom>
+          <a:solidFill>
+            <a:srgbClr val="312E81">
+              <a:alpha val="50000"/>
+            </a:srgbClr>
+          </a:solidFill>
+          <a:ln w="12700">
+            <a:solidFill>
+              <a:srgbClr val="312E81">
+                <a:alpha val="50000"/>
+              </a:srgbClr>
+            </a:solidFill>
+            <a:prstDash val="solid"/>
+          </a:ln>
+        </p:spPr>
+      </p:sp>
+      <p:sp>
+        <p:nvSpPr>
+          <p:cNvPr id="5" name="Shape 3"/>
+          <p:cNvSpPr/>
+          <p:nvPr/>
+        </p:nvSpPr>
+        <p:spPr>
+          <a:xfrm>
+            <a:off x="0" y="0"/>
+            <a:ext cx="54864" cy="3429000"/>
+          </a:xfrm>
+          <a:prstGeom prst="rect">
+            <a:avLst/>
+          </a:prstGeom>
+          <a:solidFill>
+            <a:srgbClr val="818CF8"/>
+          </a:solidFill>
+          <a:ln w="12700">
+            <a:solidFill>
+              <a:srgbClr val="818CF8"/>
+            </a:solidFill>
+            <a:prstDash val="solid"/>
+          </a:ln>
+        </p:spPr>
+      </p:sp>
+      <p:sp>
+        <p:nvSpPr>
+          <p:cNvPr id="6" name="Shape 4"/>
+          <p:cNvSpPr/>
+          <p:nvPr/>
+        </p:nvSpPr>
+        <p:spPr>
+          <a:xfrm>
+            <a:off x="0" y="3429000"/>
+            <a:ext cx="54864" cy="3429000"/>
+          </a:xfrm>
+          <a:prstGeom prst="rect">
+            <a:avLst/>
+          </a:prstGeom>
+          <a:solidFill>
+            <a:srgbClr val="34D399"/>
+          </a:solidFill>
+          <a:ln w="12700">
+            <a:solidFill>
+              <a:srgbClr val="34D399"/>
+            </a:solidFill>
+            <a:prstDash val="solid"/>
+          </a:ln>
+        </p:spPr>
+      </p:sp>
+      <p:sp>
+        <p:nvSpPr>
+          <p:cNvPr id="7" name="Text 5"/>
+          <p:cNvSpPr/>
+          <p:nvPr/>
+        </p:nvSpPr>
+        <p:spPr>
+          <a:xfrm>
+            <a:off x="365760" y="274320"/>
+            <a:ext cx="11430000" cy="548640"/>
+          </a:xfrm>
+          <a:prstGeom prst="rect">
+            <a:avLst/>
+          </a:prstGeom>
+          <a:noFill/>
+          <a:ln/>
+        </p:spPr>
+        <p:txBody>
+          <a:bodyPr wrap="square" rtlCol="0" anchor="ctr"/>
+          <a:lstStyle/>
+          <a:p>
+            <a:pPr algn="l" indent="0" marL="0">
+              <a:buNone/>
+            </a:pPr>
+            <a:r>
+              <a:rPr lang="en-US" sz="2600" b="1" dirty="0">
+                <a:solidFill>
+                  <a:srgbClr val="A5B4FC"/>
+                </a:solidFill>
+                <a:latin typeface="Calibri" pitchFamily="34" charset="0"/>
+                <a:ea typeface="Calibri" pitchFamily="34" charset="-122"/>
+                <a:cs typeface="Calibri" pitchFamily="34" charset="-120"/>
+              </a:rPr>
+              <a:t>10. Tài Liệu Tham Khảo</a:t>
+            </a:r>
+            <a:endParaRPr lang="en-US" sz="2600" dirty="0"/>
+          </a:p>
+        </p:txBody>
+      </p:sp>
+      <p:sp>
+        <p:nvSpPr>
+          <p:cNvPr id="8" name="Shape 6"/>
+          <p:cNvSpPr/>
+          <p:nvPr/>
+        </p:nvSpPr>
+        <p:spPr>
+          <a:xfrm>
+            <a:off x="365760" y="868680"/>
+            <a:ext cx="11430000" cy="27432"/>
+          </a:xfrm>
+          <a:prstGeom prst="rect">
+            <a:avLst/>
+          </a:prstGeom>
+          <a:solidFill>
+            <a:srgbClr val="A5B4FC"/>
+          </a:solidFill>
+          <a:ln w="12700">
+            <a:solidFill>
+              <a:srgbClr val="A5B4FC"/>
+            </a:solidFill>
+            <a:prstDash val="solid"/>
+          </a:ln>
+        </p:spPr>
+      </p:sp>
+      <p:sp>
+        <p:nvSpPr>
+          <p:cNvPr id="9" name="Shape 7"/>
+          <p:cNvSpPr/>
+          <p:nvPr/>
+        </p:nvSpPr>
+        <p:spPr>
+          <a:xfrm>
+            <a:off x="320040" y="1097280"/>
+            <a:ext cx="11521440" cy="896112"/>
+          </a:xfrm>
+          <a:prstGeom prst="roundRect">
+            <a:avLst>
+              <a:gd name="adj" fmla="val 8163"/>
+            </a:avLst>
+          </a:prstGeom>
+          <a:solidFill>
+            <a:srgbClr val="1C1945"/>
+          </a:solidFill>
+          <a:ln w="15240">
+            <a:solidFill>
+              <a:srgbClr val="363780"/>
+            </a:solidFill>
+            <a:prstDash val="solid"/>
+          </a:ln>
+        </p:spPr>
+      </p:sp>
+      <p:sp>
+        <p:nvSpPr>
+          <p:cNvPr id="10" name="Text 8"/>
+          <p:cNvSpPr/>
+          <p:nvPr/>
+        </p:nvSpPr>
+        <p:spPr>
+          <a:xfrm>
+            <a:off x="411480" y="1097280"/>
+            <a:ext cx="640080" cy="896112"/>
+          </a:xfrm>
+          <a:prstGeom prst="rect">
+            <a:avLst/>
+          </a:prstGeom>
+          <a:noFill/>
+          <a:ln/>
+        </p:spPr>
+        <p:txBody>
+          <a:bodyPr wrap="square" rtlCol="0" anchor="ctr"/>
+          <a:lstStyle/>
+          <a:p>
+            <a:pPr algn="ctr" indent="0" marL="0">
+              <a:buNone/>
+            </a:pPr>
+            <a:r>
+              <a:rPr lang="en-US" sz="1600" b="1" dirty="0">
+                <a:solidFill>
+                  <a:srgbClr val="818CF8"/>
+                </a:solidFill>
+                <a:latin typeface="Calibri" pitchFamily="34" charset="0"/>
+                <a:ea typeface="Calibri" pitchFamily="34" charset="-122"/>
+                <a:cs typeface="Calibri" pitchFamily="34" charset="-120"/>
+              </a:rPr>
+              <a:t>[1]</a:t>
+            </a:r>
+            <a:endParaRPr lang="en-US" sz="1600" dirty="0"/>
+          </a:p>
+        </p:txBody>
+      </p:sp>
+      <p:sp>
+        <p:nvSpPr>
+          <p:cNvPr id="11" name="Text 9"/>
+          <p:cNvSpPr/>
+          <p:nvPr/>
+        </p:nvSpPr>
+        <p:spPr>
+          <a:xfrm>
+            <a:off x="1143000" y="1097280"/>
+            <a:ext cx="10561320" cy="896112"/>
+          </a:xfrm>
+          <a:prstGeom prst="rect">
+            <a:avLst/>
+          </a:prstGeom>
+          <a:noFill/>
+          <a:ln/>
+        </p:spPr>
+        <p:txBody>
+          <a:bodyPr wrap="square" rtlCol="0" anchor="ctr"/>
+          <a:lstStyle/>
+          <a:p>
+            <a:pPr indent="0" marL="0">
+              <a:buNone/>
+            </a:pPr>
+            <a:r>
+              <a:rPr lang="en-US" sz="1300" dirty="0">
+                <a:solidFill>
+                  <a:srgbClr val="E0E7FF"/>
+                </a:solidFill>
+                <a:latin typeface="Calibri" pitchFamily="34" charset="0"/>
+                <a:ea typeface="Calibri" pitchFamily="34" charset="-122"/>
+                <a:cs typeface="Calibri" pitchFamily="34" charset="-120"/>
+              </a:rPr>
+              <a:t>Russell, S. &amp; Norvig, P. — Artificial Intelligence: A Modern Approach, 4th ed., Prentice Hall, 2020</a:t>
+            </a:r>
+            <a:endParaRPr lang="en-US" sz="1300" dirty="0"/>
+          </a:p>
+        </p:txBody>
+      </p:sp>
+      <p:sp>
+        <p:nvSpPr>
+          <p:cNvPr id="12" name="Shape 10"/>
+          <p:cNvSpPr/>
+          <p:nvPr/>
+        </p:nvSpPr>
+        <p:spPr>
+          <a:xfrm>
+            <a:off x="320040" y="2121408"/>
+            <a:ext cx="11521440" cy="896112"/>
+          </a:xfrm>
+          <a:prstGeom prst="roundRect">
+            <a:avLst>
+              <a:gd name="adj" fmla="val 8163"/>
+            </a:avLst>
+          </a:prstGeom>
+          <a:solidFill>
+            <a:srgbClr val="1C1945"/>
+          </a:solidFill>
+          <a:ln w="15240">
+            <a:solidFill>
+              <a:srgbClr val="363780"/>
+            </a:solidFill>
+            <a:prstDash val="solid"/>
+          </a:ln>
+        </p:spPr>
+      </p:sp>
+      <p:sp>
+        <p:nvSpPr>
+          <p:cNvPr id="13" name="Text 11"/>
+          <p:cNvSpPr/>
+          <p:nvPr/>
+        </p:nvSpPr>
+        <p:spPr>
+          <a:xfrm>
+            <a:off x="411480" y="2121408"/>
+            <a:ext cx="640080" cy="896112"/>
+          </a:xfrm>
+          <a:prstGeom prst="rect">
+            <a:avLst/>
+          </a:prstGeom>
+          <a:noFill/>
+          <a:ln/>
+        </p:spPr>
+        <p:txBody>
+          <a:bodyPr wrap="square" rtlCol="0" anchor="ctr"/>
+          <a:lstStyle/>
+          <a:p>
+            <a:pPr algn="ctr" indent="0" marL="0">
+              <a:buNone/>
+            </a:pPr>
+            <a:r>
+              <a:rPr lang="en-US" sz="1600" b="1" dirty="0">
+                <a:solidFill>
+                  <a:srgbClr val="818CF8"/>
+                </a:solidFill>
+                <a:latin typeface="Calibri" pitchFamily="34" charset="0"/>
+                <a:ea typeface="Calibri" pitchFamily="34" charset="-122"/>
+                <a:cs typeface="Calibri" pitchFamily="34" charset="-120"/>
+              </a:rPr>
+              <a:t>[2]</a:t>
+            </a:r>
+            <a:endParaRPr lang="en-US" sz="1600" dirty="0"/>
+          </a:p>
+        </p:txBody>
+      </p:sp>
+      <p:sp>
+        <p:nvSpPr>
+          <p:cNvPr id="14" name="Text 12"/>
+          <p:cNvSpPr/>
+          <p:nvPr/>
+        </p:nvSpPr>
+        <p:spPr>
+          <a:xfrm>
+            <a:off x="1143000" y="2121408"/>
+            <a:ext cx="10561320" cy="896112"/>
+          </a:xfrm>
+          <a:prstGeom prst="rect">
+            <a:avLst/>
+          </a:prstGeom>
+          <a:noFill/>
+          <a:ln/>
+        </p:spPr>
+        <p:txBody>
+          <a:bodyPr wrap="square" rtlCol="0" anchor="ctr"/>
+          <a:lstStyle/>
+          <a:p>
+            <a:pPr indent="0" marL="0">
+              <a:buNone/>
+            </a:pPr>
+            <a:r>
+              <a:rPr lang="en-US" sz="1300" dirty="0">
+                <a:solidFill>
+                  <a:srgbClr val="E0E7FF"/>
+                </a:solidFill>
+                <a:latin typeface="Calibri" pitchFamily="34" charset="0"/>
+                <a:ea typeface="Calibri" pitchFamily="34" charset="-122"/>
+                <a:cs typeface="Calibri" pitchFamily="34" charset="-120"/>
+              </a:rPr>
+              <a:t>OpenStreetMap contributors — openstreetmap.org (dữ liệu bản đồ Hà Đông, Hà Nội)</a:t>
+            </a:r>
+            <a:endParaRPr lang="en-US" sz="1300" dirty="0"/>
+          </a:p>
+        </p:txBody>
+      </p:sp>
+      <p:sp>
+        <p:nvSpPr>
+          <p:cNvPr id="15" name="Shape 13"/>
+          <p:cNvSpPr/>
+          <p:nvPr/>
+        </p:nvSpPr>
+        <p:spPr>
+          <a:xfrm>
+            <a:off x="320040" y="3145536"/>
+            <a:ext cx="11521440" cy="896112"/>
+          </a:xfrm>
+          <a:prstGeom prst="roundRect">
+            <a:avLst>
+              <a:gd name="adj" fmla="val 8163"/>
+            </a:avLst>
+          </a:prstGeom>
+          <a:solidFill>
+            <a:srgbClr val="1C1945"/>
+          </a:solidFill>
+          <a:ln w="15240">
+            <a:solidFill>
+              <a:srgbClr val="363780"/>
+            </a:solidFill>
+            <a:prstDash val="solid"/>
+          </a:ln>
+        </p:spPr>
+      </p:sp>
+      <p:sp>
+        <p:nvSpPr>
+          <p:cNvPr id="16" name="Text 14"/>
+          <p:cNvSpPr/>
+          <p:nvPr/>
+        </p:nvSpPr>
+        <p:spPr>
+          <a:xfrm>
+            <a:off x="411480" y="3145536"/>
+            <a:ext cx="640080" cy="896112"/>
+          </a:xfrm>
+          <a:prstGeom prst="rect">
+            <a:avLst/>
+          </a:prstGeom>
+          <a:noFill/>
+          <a:ln/>
+        </p:spPr>
+        <p:txBody>
+          <a:bodyPr wrap="square" rtlCol="0" anchor="ctr"/>
+          <a:lstStyle/>
+          <a:p>
+            <a:pPr algn="ctr" indent="0" marL="0">
+              <a:buNone/>
+            </a:pPr>
+            <a:r>
+              <a:rPr lang="en-US" sz="1600" b="1" dirty="0">
+                <a:solidFill>
+                  <a:srgbClr val="818CF8"/>
+                </a:solidFill>
+                <a:latin typeface="Calibri" pitchFamily="34" charset="0"/>
+                <a:ea typeface="Calibri" pitchFamily="34" charset="-122"/>
+                <a:cs typeface="Calibri" pitchFamily="34" charset="-120"/>
+              </a:rPr>
+              <a:t>[3]</a:t>
+            </a:r>
+            <a:endParaRPr lang="en-US" sz="1600" dirty="0"/>
+          </a:p>
+        </p:txBody>
+      </p:sp>
+      <p:sp>
+        <p:nvSpPr>
+          <p:cNvPr id="17" name="Text 15"/>
+          <p:cNvSpPr/>
+          <p:nvPr/>
+        </p:nvSpPr>
+        <p:spPr>
+          <a:xfrm>
+            <a:off x="1143000" y="3145536"/>
+            <a:ext cx="10561320" cy="896112"/>
+          </a:xfrm>
+          <a:prstGeom prst="rect">
+            <a:avLst/>
+          </a:prstGeom>
+          <a:noFill/>
+          <a:ln/>
+        </p:spPr>
+        <p:txBody>
+          <a:bodyPr wrap="square" rtlCol="0" anchor="ctr"/>
+          <a:lstStyle/>
+          <a:p>
+            <a:pPr indent="0" marL="0">
+              <a:buNone/>
+            </a:pPr>
+            <a:r>
+              <a:rPr lang="en-US" sz="1300" dirty="0">
+                <a:solidFill>
+                  <a:srgbClr val="E0E7FF"/>
+                </a:solidFill>
+                <a:latin typeface="Calibri" pitchFamily="34" charset="0"/>
+                <a:ea typeface="Calibri" pitchFamily="34" charset="-122"/>
+                <a:cs typeface="Calibri" pitchFamily="34" charset="-120"/>
+              </a:rPr>
+              <a:t>Boeing, G. — OSMnx: New Methods for Acquiring, Constructing, Analyzing, and Visualizing Complex Street Networks. Computers, Environment and Urban Systems, 2017</a:t>
+            </a:r>
+            <a:endParaRPr lang="en-US" sz="1300" dirty="0"/>
+          </a:p>
+        </p:txBody>
+      </p:sp>
+      <p:sp>
+        <p:nvSpPr>
+          <p:cNvPr id="18" name="Shape 16"/>
+          <p:cNvSpPr/>
+          <p:nvPr/>
+        </p:nvSpPr>
+        <p:spPr>
+          <a:xfrm>
+            <a:off x="320040" y="4169664"/>
+            <a:ext cx="11521440" cy="896112"/>
+          </a:xfrm>
+          <a:prstGeom prst="roundRect">
+            <a:avLst>
+              <a:gd name="adj" fmla="val 8163"/>
+            </a:avLst>
+          </a:prstGeom>
+          <a:solidFill>
+            <a:srgbClr val="1C1945"/>
+          </a:solidFill>
+          <a:ln w="15240">
+            <a:solidFill>
+              <a:srgbClr val="363780"/>
+            </a:solidFill>
+            <a:prstDash val="solid"/>
+          </a:ln>
+        </p:spPr>
+      </p:sp>
+      <p:sp>
+        <p:nvSpPr>
+          <p:cNvPr id="19" name="Text 17"/>
+          <p:cNvSpPr/>
+          <p:nvPr/>
+        </p:nvSpPr>
+        <p:spPr>
+          <a:xfrm>
+            <a:off x="411480" y="4169664"/>
+            <a:ext cx="640080" cy="896112"/>
+          </a:xfrm>
+          <a:prstGeom prst="rect">
+            <a:avLst/>
+          </a:prstGeom>
+          <a:noFill/>
+          <a:ln/>
+        </p:spPr>
+        <p:txBody>
+          <a:bodyPr wrap="square" rtlCol="0" anchor="ctr"/>
+          <a:lstStyle/>
+          <a:p>
+            <a:pPr algn="ctr" indent="0" marL="0">
+              <a:buNone/>
+            </a:pPr>
+            <a:r>
+              <a:rPr lang="en-US" sz="1600" b="1" dirty="0">
+                <a:solidFill>
+                  <a:srgbClr val="818CF8"/>
+                </a:solidFill>
+                <a:latin typeface="Calibri" pitchFamily="34" charset="0"/>
+                <a:ea typeface="Calibri" pitchFamily="34" charset="-122"/>
+                <a:cs typeface="Calibri" pitchFamily="34" charset="-120"/>
+              </a:rPr>
+              <a:t>[4]</a:t>
+            </a:r>
+            <a:endParaRPr lang="en-US" sz="1600" dirty="0"/>
+          </a:p>
+        </p:txBody>
+      </p:sp>
+      <p:sp>
+        <p:nvSpPr>
+          <p:cNvPr id="20" name="Text 18"/>
+          <p:cNvSpPr/>
+          <p:nvPr/>
+        </p:nvSpPr>
+        <p:spPr>
+          <a:xfrm>
+            <a:off x="1143000" y="4169664"/>
+            <a:ext cx="10561320" cy="896112"/>
+          </a:xfrm>
+          <a:prstGeom prst="rect">
+            <a:avLst/>
+          </a:prstGeom>
+          <a:noFill/>
+          <a:ln/>
+        </p:spPr>
+        <p:txBody>
+          <a:bodyPr wrap="square" rtlCol="0" anchor="ctr"/>
+          <a:lstStyle/>
+          <a:p>
+            <a:pPr indent="0" marL="0">
+              <a:buNone/>
+            </a:pPr>
+            <a:r>
+              <a:rPr lang="en-US" sz="1300" dirty="0">
+                <a:solidFill>
+                  <a:srgbClr val="E0E7FF"/>
+                </a:solidFill>
+                <a:latin typeface="Calibri" pitchFamily="34" charset="0"/>
+                <a:ea typeface="Calibri" pitchFamily="34" charset="-122"/>
+                <a:cs typeface="Calibri" pitchFamily="34" charset="-120"/>
+              </a:rPr>
+              <a:t>Leaflet.js — leafletjs.com · FastAPI — fastapi.tiangolo.com · PptxGenJS — gitbrent.github.io/PptxGenJS</a:t>
+            </a:r>
+            <a:endParaRPr lang="en-US" sz="1300" dirty="0"/>
+          </a:p>
+        </p:txBody>
+      </p:sp>
+      <p:sp>
+        <p:nvSpPr>
+          <p:cNvPr id="21" name="Shape 19"/>
+          <p:cNvSpPr/>
+          <p:nvPr/>
+        </p:nvSpPr>
+        <p:spPr>
+          <a:xfrm>
+            <a:off x="320040" y="5193792"/>
+            <a:ext cx="11521440" cy="896112"/>
+          </a:xfrm>
+          <a:prstGeom prst="roundRect">
+            <a:avLst>
+              <a:gd name="adj" fmla="val 8163"/>
+            </a:avLst>
+          </a:prstGeom>
+          <a:solidFill>
+            <a:srgbClr val="1C1945"/>
+          </a:solidFill>
+          <a:ln w="15240">
+            <a:solidFill>
+              <a:srgbClr val="363780"/>
+            </a:solidFill>
+            <a:prstDash val="solid"/>
+          </a:ln>
+        </p:spPr>
+      </p:sp>
+      <p:sp>
+        <p:nvSpPr>
+          <p:cNvPr id="22" name="Text 20"/>
+          <p:cNvSpPr/>
+          <p:nvPr/>
+        </p:nvSpPr>
+        <p:spPr>
+          <a:xfrm>
+            <a:off x="411480" y="5193792"/>
+            <a:ext cx="640080" cy="896112"/>
+          </a:xfrm>
+          <a:prstGeom prst="rect">
+            <a:avLst/>
+          </a:prstGeom>
+          <a:noFill/>
+          <a:ln/>
+        </p:spPr>
+        <p:txBody>
+          <a:bodyPr wrap="square" rtlCol="0" anchor="ctr"/>
+          <a:lstStyle/>
+          <a:p>
+            <a:pPr algn="ctr" indent="0" marL="0">
+              <a:buNone/>
+            </a:pPr>
+            <a:r>
+              <a:rPr lang="en-US" sz="1600" b="1" dirty="0">
+                <a:solidFill>
+                  <a:srgbClr val="818CF8"/>
+                </a:solidFill>
+                <a:latin typeface="Calibri" pitchFamily="34" charset="0"/>
+                <a:ea typeface="Calibri" pitchFamily="34" charset="-122"/>
+                <a:cs typeface="Calibri" pitchFamily="34" charset="-120"/>
+              </a:rPr>
+              <a:t>[5]</a:t>
+            </a:r>
+            <a:endParaRPr lang="en-US" sz="1600" dirty="0"/>
+          </a:p>
+        </p:txBody>
+      </p:sp>
+      <p:sp>
+        <p:nvSpPr>
+          <p:cNvPr id="23" name="Text 21"/>
+          <p:cNvSpPr/>
+          <p:nvPr/>
+        </p:nvSpPr>
+        <p:spPr>
+          <a:xfrm>
+            <a:off x="1143000" y="5193792"/>
+            <a:ext cx="10561320" cy="896112"/>
+          </a:xfrm>
+          <a:prstGeom prst="rect">
+            <a:avLst/>
+          </a:prstGeom>
+          <a:noFill/>
+          <a:ln/>
+        </p:spPr>
+        <p:txBody>
+          <a:bodyPr wrap="square" rtlCol="0" anchor="ctr"/>
+          <a:lstStyle/>
+          <a:p>
+            <a:pPr indent="0" marL="0">
+              <a:buNone/>
+            </a:pPr>
+            <a:r>
+              <a:rPr lang="en-US" sz="1300" dirty="0">
+                <a:solidFill>
+                  <a:srgbClr val="E0E7FF"/>
+                </a:solidFill>
+                <a:latin typeface="Calibri" pitchFamily="34" charset="0"/>
+                <a:ea typeface="Calibri" pitchFamily="34" charset="-122"/>
+                <a:cs typeface="Calibri" pitchFamily="34" charset="-120"/>
+              </a:rPr>
+              <a:t>Hart, P. E., Nilsson, N. J., &amp; Raphael, B. — A Formal Basis for the Heuristic Determination of Minimum Cost Paths. IEEE TSSC, 1968</a:t>
+            </a:r>
+            <a:endParaRPr lang="en-US" sz="1300" dirty="0"/>
+          </a:p>
+        </p:txBody>
+      </p:sp>
+    </p:spTree>
+  </p:cSld>
+  <p:clrMapOvr>
+    <a:masterClrMapping/>
+  </p:clrMapOvr>
+</p:sld>
+</file>
+
+<file path=ppt/slides/slide13.xml><?xml version="1.0" encoding="utf-8"?>
+<p:sld xmlns:a="http://schemas.openxmlformats.org/drawingml/2006/main" xmlns:r="http://schemas.openxmlformats.org/officeDocument/2006/relationships" xmlns:p="http://schemas.openxmlformats.org/presentationml/2006/main">
+  <p:cSld name="Slide 13">
+    <p:spTree>
+      <p:nvGrpSpPr>
+        <p:cNvPr id="1" name=""/>
+        <p:cNvGrpSpPr/>
+        <p:nvPr/>
+      </p:nvGrpSpPr>
+      <p:grpSpPr>
+        <a:xfrm>
+          <a:off x="0" y="0"/>
+          <a:ext cx="0" cy="0"/>
+          <a:chOff x="0" y="0"/>
+          <a:chExt cx="0" cy="0"/>
+        </a:xfrm>
+      </p:grpSpPr>
+      <p:sp>
+        <p:nvSpPr>
+          <p:cNvPr id="2" name="Shape 0"/>
+          <p:cNvSpPr/>
+          <p:nvPr/>
+        </p:nvSpPr>
+        <p:spPr>
+          <a:xfrm>
+            <a:off x="0" y="0"/>
+            <a:ext cx="12188952" cy="6858000"/>
+          </a:xfrm>
+          <a:prstGeom prst="rect">
+            <a:avLst/>
+          </a:prstGeom>
+          <a:solidFill>
+            <a:srgbClr val="0F0C29"/>
+          </a:solidFill>
+          <a:ln w="12700">
+            <a:solidFill>
+              <a:srgbClr val="0F0C29"/>
+            </a:solidFill>
+            <a:prstDash val="solid"/>
+          </a:ln>
+        </p:spPr>
+      </p:sp>
+      <p:sp>
+        <p:nvSpPr>
+          <p:cNvPr id="3" name="Shape 1"/>
+          <p:cNvSpPr/>
+          <p:nvPr/>
+        </p:nvSpPr>
+        <p:spPr>
+          <a:xfrm>
+            <a:off x="0" y="0"/>
+            <a:ext cx="12188952" cy="4114800"/>
+          </a:xfrm>
+          <a:prstGeom prst="rect">
+            <a:avLst/>
+          </a:prstGeom>
+          <a:solidFill>
+            <a:srgbClr val="1E1B4B">
+              <a:alpha val="70000"/>
+            </a:srgbClr>
+          </a:solidFill>
+          <a:ln w="12700">
+            <a:solidFill>
+              <a:srgbClr val="1E1B4B">
+                <a:alpha val="70000"/>
+              </a:srgbClr>
+            </a:solidFill>
+            <a:prstDash val="solid"/>
+          </a:ln>
+        </p:spPr>
+      </p:sp>
+      <p:sp>
+        <p:nvSpPr>
+          <p:cNvPr id="4" name="Shape 2"/>
+          <p:cNvSpPr/>
+          <p:nvPr/>
+        </p:nvSpPr>
+        <p:spPr>
+          <a:xfrm>
+            <a:off x="5486400" y="0"/>
+            <a:ext cx="6702552" cy="6858000"/>
+          </a:xfrm>
+          <a:prstGeom prst="rect">
+            <a:avLst/>
+          </a:prstGeom>
+          <a:solidFill>
+            <a:srgbClr val="312E81">
+              <a:alpha val="50000"/>
+            </a:srgbClr>
+          </a:solidFill>
+          <a:ln w="12700">
+            <a:solidFill>
+              <a:srgbClr val="312E81">
+                <a:alpha val="50000"/>
+              </a:srgbClr>
+            </a:solidFill>
+            <a:prstDash val="solid"/>
+          </a:ln>
+        </p:spPr>
+      </p:sp>
+      <p:sp>
+        <p:nvSpPr>
+          <p:cNvPr id="5" name="Shape 3"/>
+          <p:cNvSpPr/>
+          <p:nvPr/>
+        </p:nvSpPr>
+        <p:spPr>
+          <a:xfrm>
+            <a:off x="0" y="0"/>
+            <a:ext cx="54864" cy="3429000"/>
+          </a:xfrm>
+          <a:prstGeom prst="rect">
+            <a:avLst/>
+          </a:prstGeom>
+          <a:solidFill>
+            <a:srgbClr val="818CF8"/>
+          </a:solidFill>
+          <a:ln w="12700">
+            <a:solidFill>
+              <a:srgbClr val="818CF8"/>
+            </a:solidFill>
+            <a:prstDash val="solid"/>
+          </a:ln>
+        </p:spPr>
+      </p:sp>
+      <p:sp>
+        <p:nvSpPr>
+          <p:cNvPr id="6" name="Shape 4"/>
+          <p:cNvSpPr/>
+          <p:nvPr/>
+        </p:nvSpPr>
+        <p:spPr>
+          <a:xfrm>
+            <a:off x="0" y="3429000"/>
+            <a:ext cx="54864" cy="3429000"/>
+          </a:xfrm>
+          <a:prstGeom prst="rect">
+            <a:avLst/>
+          </a:prstGeom>
+          <a:solidFill>
+            <a:srgbClr val="34D399"/>
+          </a:solidFill>
+          <a:ln w="12700">
+            <a:solidFill>
+              <a:srgbClr val="34D399"/>
+            </a:solidFill>
+            <a:prstDash val="solid"/>
+          </a:ln>
+        </p:spPr>
+      </p:sp>
+      <p:sp>
+        <p:nvSpPr>
+          <p:cNvPr id="7" name="Shape 5"/>
+          <p:cNvSpPr/>
+          <p:nvPr/>
+        </p:nvSpPr>
+        <p:spPr>
+          <a:xfrm>
+            <a:off x="8229600" y="-1371600"/>
+            <a:ext cx="5486400" cy="5486400"/>
+          </a:xfrm>
+          <a:prstGeom prst="ellipse">
+            <a:avLst/>
+          </a:prstGeom>
+          <a:solidFill>
+            <a:srgbClr val="818CF8">
+              <a:alpha val="18000"/>
+            </a:srgbClr>
+          </a:solidFill>
+          <a:ln w="12700">
+            <a:solidFill>
+              <a:srgbClr val="818CF8">
+                <a:alpha val="18000"/>
+              </a:srgbClr>
+            </a:solidFill>
+            <a:prstDash val="solid"/>
+          </a:ln>
+        </p:spPr>
+      </p:sp>
+      <p:sp>
+        <p:nvSpPr>
+          <p:cNvPr id="8" name="Shape 6"/>
+          <p:cNvSpPr/>
+          <p:nvPr/>
+        </p:nvSpPr>
+        <p:spPr>
+          <a:xfrm>
+            <a:off x="-1371600" y="3657600"/>
+            <a:ext cx="4572000" cy="4572000"/>
+          </a:xfrm>
+          <a:prstGeom prst="ellipse">
+            <a:avLst/>
+          </a:prstGeom>
+          <a:solidFill>
+            <a:srgbClr val="34D399">
+              <a:alpha val="15000"/>
+            </a:srgbClr>
+          </a:solidFill>
+          <a:ln w="12700">
+            <a:solidFill>
+              <a:srgbClr val="34D399">
+                <a:alpha val="15000"/>
+              </a:srgbClr>
+            </a:solidFill>
+            <a:prstDash val="solid"/>
+          </a:ln>
+        </p:spPr>
+      </p:sp>
+      <p:sp>
+        <p:nvSpPr>
+          <p:cNvPr id="9" name="Shape 7"/>
+          <p:cNvSpPr/>
+          <p:nvPr/>
+        </p:nvSpPr>
+        <p:spPr>
+          <a:xfrm>
+            <a:off x="0" y="0"/>
+            <a:ext cx="54864" cy="6858000"/>
+          </a:xfrm>
+          <a:prstGeom prst="rect">
+            <a:avLst/>
+          </a:prstGeom>
+          <a:solidFill>
+            <a:srgbClr val="818CF8"/>
+          </a:solidFill>
+          <a:ln w="12700">
+            <a:solidFill>
+              <a:srgbClr val="818CF8"/>
+            </a:solidFill>
+            <a:prstDash val="solid"/>
+          </a:ln>
+        </p:spPr>
+      </p:sp>
+      <p:sp>
+        <p:nvSpPr>
+          <p:cNvPr id="10" name="Shape 8"/>
+          <p:cNvSpPr/>
+          <p:nvPr/>
+        </p:nvSpPr>
+        <p:spPr>
+          <a:xfrm>
+            <a:off x="12134088" y="0"/>
+            <a:ext cx="54864" cy="6858000"/>
+          </a:xfrm>
+          <a:prstGeom prst="rect">
+            <a:avLst/>
+          </a:prstGeom>
+          <a:solidFill>
+            <a:srgbClr val="34D399"/>
+          </a:solidFill>
+          <a:ln w="12700">
+            <a:solidFill>
+              <a:srgbClr val="34D399"/>
+            </a:solidFill>
+            <a:prstDash val="solid"/>
+          </a:ln>
+        </p:spPr>
+      </p:sp>
+      <p:sp>
+        <p:nvSpPr>
+          <p:cNvPr id="11" name="Text 9"/>
+          <p:cNvSpPr/>
+          <p:nvPr/>
+        </p:nvSpPr>
+        <p:spPr>
+          <a:xfrm>
+            <a:off x="365760" y="1828800"/>
+            <a:ext cx="11457432" cy="1188720"/>
+          </a:xfrm>
+          <a:prstGeom prst="rect">
+            <a:avLst/>
+          </a:prstGeom>
+          <a:noFill/>
+          <a:ln/>
+        </p:spPr>
+        <p:txBody>
+          <a:bodyPr wrap="square" rtlCol="0" anchor="ctr"/>
+          <a:lstStyle/>
+          <a:p>
+            <a:pPr algn="ctr" indent="0" marL="0">
+              <a:buNone/>
+            </a:pPr>
+            <a:r>
+              <a:rPr lang="en-US" sz="4600" b="1" dirty="0">
+                <a:solidFill>
+                  <a:srgbClr val="E0E7FF"/>
+                </a:solidFill>
+                <a:latin typeface="Calibri" pitchFamily="34" charset="0"/>
+                <a:ea typeface="Calibri" pitchFamily="34" charset="-122"/>
+                <a:cs typeface="Calibri" pitchFamily="34" charset="-120"/>
+              </a:rPr>
+              <a:t>Xin chân thành cảm ơn!</a:t>
+            </a:r>
+            <a:endParaRPr lang="en-US" sz="4600" dirty="0"/>
+          </a:p>
+        </p:txBody>
+      </p:sp>
+      <p:sp>
+        <p:nvSpPr>
+          <p:cNvPr id="12" name="Shape 10"/>
+          <p:cNvSpPr/>
+          <p:nvPr/>
+        </p:nvSpPr>
+        <p:spPr>
+          <a:xfrm>
+            <a:off x="3200400" y="3154680"/>
+            <a:ext cx="2880360" cy="45720"/>
+          </a:xfrm>
+          <a:prstGeom prst="rect">
+            <a:avLst/>
+          </a:prstGeom>
+          <a:solidFill>
+            <a:srgbClr val="818CF8"/>
+          </a:solidFill>
+          <a:ln w="12700">
+            <a:solidFill>
+              <a:srgbClr val="818CF8"/>
+            </a:solidFill>
+            <a:prstDash val="solid"/>
+          </a:ln>
+        </p:spPr>
+      </p:sp>
+      <p:sp>
+        <p:nvSpPr>
+          <p:cNvPr id="13" name="Shape 11"/>
+          <p:cNvSpPr/>
+          <p:nvPr/>
+        </p:nvSpPr>
+        <p:spPr>
+          <a:xfrm>
+            <a:off x="6108192" y="3154680"/>
+            <a:ext cx="2880360" cy="45720"/>
+          </a:xfrm>
+          <a:prstGeom prst="rect">
+            <a:avLst/>
+          </a:prstGeom>
+          <a:solidFill>
+            <a:srgbClr val="34D399"/>
+          </a:solidFill>
+          <a:ln w="12700">
+            <a:solidFill>
+              <a:srgbClr val="34D399"/>
+            </a:solidFill>
+            <a:prstDash val="solid"/>
+          </a:ln>
+        </p:spPr>
+      </p:sp>
+      <p:sp>
+        <p:nvSpPr>
+          <p:cNvPr id="14" name="Text 12"/>
+          <p:cNvSpPr/>
+          <p:nvPr/>
+        </p:nvSpPr>
+        <p:spPr>
+          <a:xfrm>
+            <a:off x="365760" y="3337560"/>
+            <a:ext cx="11457432" cy="594360"/>
+          </a:xfrm>
+          <a:prstGeom prst="rect">
+            <a:avLst/>
+          </a:prstGeom>
+          <a:noFill/>
+          <a:ln/>
+        </p:spPr>
+        <p:txBody>
+          <a:bodyPr wrap="square" rtlCol="0" anchor="ctr"/>
+          <a:lstStyle/>
+          <a:p>
+            <a:pPr algn="ctr" indent="0" marL="0">
+              <a:buNone/>
+            </a:pPr>
+            <a:r>
+              <a:rPr lang="en-US" sz="2000" dirty="0">
+                <a:solidFill>
+                  <a:srgbClr val="A5B4FC"/>
+                </a:solidFill>
+                <a:latin typeface="Calibri" pitchFamily="34" charset="0"/>
+                <a:ea typeface="Calibri" pitchFamily="34" charset="-122"/>
+                <a:cs typeface="Calibri" pitchFamily="34" charset="-120"/>
+              </a:rPr>
+              <a:t>PathFinder AI — BFS · DFS · Dijkstra · A*</a:t>
+            </a:r>
+            <a:endParaRPr lang="en-US" sz="2000" dirty="0"/>
+          </a:p>
+        </p:txBody>
+      </p:sp>
+      <p:sp>
+        <p:nvSpPr>
+          <p:cNvPr id="15" name="Text 13"/>
+          <p:cNvSpPr/>
+          <p:nvPr/>
+        </p:nvSpPr>
+        <p:spPr>
+          <a:xfrm>
+            <a:off x="365760" y="4069080"/>
+            <a:ext cx="11457432" cy="457200"/>
+          </a:xfrm>
+          <a:prstGeom prst="rect">
+            <a:avLst/>
+          </a:prstGeom>
+          <a:noFill/>
+          <a:ln/>
+        </p:spPr>
+        <p:txBody>
+          <a:bodyPr wrap="square" rtlCol="0" anchor="ctr"/>
+          <a:lstStyle/>
+          <a:p>
+            <a:pPr algn="ctr" indent="0" marL="0">
+              <a:buNone/>
+            </a:pPr>
+            <a:r>
+              <a:rPr lang="en-US" sz="1600" dirty="0">
+                <a:solidFill>
+                  <a:srgbClr val="6B7AB8"/>
+                </a:solidFill>
+                <a:latin typeface="Calibri" pitchFamily="34" charset="0"/>
+                <a:ea typeface="Calibri" pitchFamily="34" charset="-122"/>
+                <a:cs typeface="Calibri" pitchFamily="34" charset="-120"/>
+              </a:rPr>
+              <a:t>Đồ án Nhập Môn Trí Tuệ Nhân Tạo — PTIT 2025</a:t>
+            </a:r>
+            <a:endParaRPr lang="en-US" sz="1600" dirty="0"/>
+          </a:p>
+        </p:txBody>
+      </p:sp>
+      <p:sp>
+        <p:nvSpPr>
+          <p:cNvPr id="16" name="Text 14"/>
+          <p:cNvSpPr/>
+          <p:nvPr/>
+        </p:nvSpPr>
+        <p:spPr>
+          <a:xfrm>
+            <a:off x="365760" y="4663440"/>
+            <a:ext cx="11457432" cy="411480"/>
+          </a:xfrm>
+          <a:prstGeom prst="rect">
+            <a:avLst/>
+          </a:prstGeom>
+          <a:noFill/>
+          <a:ln/>
+        </p:spPr>
+        <p:txBody>
+          <a:bodyPr wrap="square" rtlCol="0" anchor="ctr"/>
+          <a:lstStyle/>
+          <a:p>
+            <a:pPr algn="ctr" indent="0" marL="0">
+              <a:buNone/>
+            </a:pPr>
+            <a:r>
+              <a:rPr lang="en-US" sz="1400" i="1" dirty="0">
+                <a:solidFill>
+                  <a:srgbClr val="4ECDC4"/>
+                </a:solidFill>
+                <a:latin typeface="Calibri" pitchFamily="34" charset="0"/>
+                <a:ea typeface="Calibri" pitchFamily="34" charset="-122"/>
+                <a:cs typeface="Calibri" pitchFamily="34" charset="-120"/>
+              </a:rPr>
+              <a:t>github.com/huuvietnguyen72/NhapMonAI_PathFinder</a:t>
+            </a:r>
+            <a:endParaRPr lang="en-US" sz="1400" dirty="0"/>
           </a:p>
         </p:txBody>
       </p:sp>

</xml_diff>